<commit_message>
Pôster mais visual: menos texto, hidrograma do teste 8h e espaço para QR code
Co-Authored-By: Claude Opus 5.5 <noreply@anthropic.com>
Claude-Session: https://claude.ai/code/session_01ESHSCPaB7QsPMssmHM5HK7
</commit_message>
<xml_diff>
--- a/poster_vend_2026/poster_VEND_Santa_Tereza_ALT.pptx
+++ b/poster_vend_2026/poster_VEND_Santa_Tereza_ALT.pptx
@@ -3876,7 +3876,7 @@
         <p:spPr>
           <a:xfrm>
             <a:off x="1080000" y="9756000"/>
-            <a:ext cx="9360000" cy="2448000"/>
+            <a:ext cx="9360000" cy="1728000"/>
           </a:xfrm>
           <a:prstGeom prst="rect">
             <a:avLst/>
@@ -3904,7 +3904,7 @@
                 </a:solidFill>
                 <a:latin typeface="Arial"/>
               </a:rPr>
-              <a:t>As cheias de 2023 e 2024 na bacia do Taquari-Antas mostraram a necessidade de previsões de nível com antecedência útil para o alerta. Este trabalho aplica </a:t>
+              <a:t>Previsão do nível do rio Taquari em </a:t>
             </a:r>
             <a:r>
               <a:rPr sz="2400" b="1" i="0">
@@ -3913,7 +3913,7 @@
                 </a:solidFill>
                 <a:latin typeface="Arial"/>
               </a:rPr>
-              <a:t>Redes Neurais Artificiais</a:t>
+              <a:t>Santa Tereza (RS)</a:t>
             </a:r>
             <a:r>
               <a:rPr sz="2400" b="0" i="0">
@@ -3922,7 +3922,7 @@
                 </a:solidFill>
                 <a:latin typeface="Arial"/>
               </a:rPr>
-              <a:t> do tipo Perceptron Multicamadas (MLP) para prever o nível do rio Taquari em </a:t>
+              <a:t> com RNA do tipo MLP, </a:t>
             </a:r>
             <a:r>
               <a:rPr sz="2400" b="1" i="0">
@@ -3931,7 +3931,7 @@
                 </a:solidFill>
                 <a:latin typeface="Arial"/>
               </a:rPr>
-              <a:t>Santa Tereza</a:t>
+              <a:t>2, 4 e 8 h</a:t>
             </a:r>
             <a:r>
               <a:rPr sz="2400" b="0" i="0">
@@ -3940,16 +3940,34 @@
                 </a:solidFill>
                 <a:latin typeface="Arial"/>
               </a:rPr>
-              <a:t> com </a:t>
+              <a:t> à frente. Na </a:t>
             </a:r>
             <a:r>
               <a:rPr sz="2400" b="1" i="0">
                 <a:solidFill>
+                  <a:srgbClr val="D9661F"/>
+                </a:solidFill>
+                <a:latin typeface="Arial"/>
+              </a:rPr>
+              <a:t>abordagem alternativa (ALT)</a:t>
+            </a:r>
+            <a:r>
+              <a:rPr sz="2400" b="0" i="0">
+                <a:solidFill>
                   <a:srgbClr val="1F2633"/>
                 </a:solidFill>
                 <a:latin typeface="Arial"/>
               </a:rPr>
-              <a:t>2, 4 e 8 horas</a:t>
+              <a:t> a rede prevê só a </a:t>
+            </a:r>
+            <a:r>
+              <a:rPr sz="2400" b="1" i="0">
+                <a:solidFill>
+                  <a:srgbClr val="1F2633"/>
+                </a:solidFill>
+                <a:latin typeface="Arial"/>
+              </a:rPr>
+              <a:t>variação</a:t>
             </a:r>
             <a:r>
               <a:rPr sz="2400" b="0" i="0">
@@ -3958,47 +3976,29 @@
                 </a:solidFill>
                 <a:latin typeface="Arial"/>
               </a:rPr>
-              <a:t> de antecedência, pela </a:t>
-            </a:r>
-            <a:r>
-              <a:rPr sz="2400" b="1" i="0">
-                <a:solidFill>
-                  <a:srgbClr val="D9661F"/>
-                </a:solidFill>
-                <a:latin typeface="Arial"/>
-              </a:rPr>
-              <a:t>abordagem alternativa (ALT)</a:t>
-            </a:r>
-            <a:r>
-              <a:rPr sz="2400" b="0" i="0">
-                <a:solidFill>
-                  <a:srgbClr val="1F2633"/>
-                </a:solidFill>
-                <a:latin typeface="Arial"/>
-              </a:rPr>
-              <a:t>: a RNA prevê só a variação do nível.</a:t>
-            </a:r>
-          </a:p>
-        </p:txBody>
-      </p:sp>
-      <p:sp>
-        <p:nvSpPr>
-          <p:cNvPr id="20" name="Secao ÁREA DE ESTUDO E DADOS"/>
+              <a:t> do nível.</a:t>
+            </a:r>
+          </a:p>
+        </p:txBody>
+      </p:sp>
+      <p:sp>
+        <p:nvSpPr>
+          <p:cNvPr id="20" name="Dado 1"/>
           <p:cNvSpPr/>
           <p:nvPr/>
         </p:nvSpPr>
         <p:spPr>
           <a:xfrm>
-            <a:off x="1080000" y="12348000"/>
-            <a:ext cx="6652800" cy="504000"/>
+            <a:off x="1080000" y="11664000"/>
+            <a:ext cx="2928000" cy="1656000"/>
           </a:xfrm>
           <a:prstGeom prst="roundRect">
             <a:avLst>
-              <a:gd name="adj" fmla="val 50000"/>
+              <a:gd name="adj" fmla="val 12000"/>
             </a:avLst>
           </a:prstGeom>
           <a:solidFill>
-            <a:srgbClr val="2A378D"/>
+            <a:srgbClr val="E6EEF5"/>
           </a:solidFill>
           <a:ln>
             <a:noFill/>
@@ -4020,219 +4020,52 @@
           </a:fontRef>
         </p:style>
         <p:txBody>
-          <a:bodyPr rtlCol="0" anchor="ctr" wrap="none" lIns="252000" rIns="252000" tIns="0" bIns="0"/>
-          <a:lstStyle/>
-          <a:p>
-            <a:pPr algn="l"/>
+          <a:bodyPr rtlCol="0" anchor="ctr" wrap="square" lIns="108000" rIns="108000" tIns="36000" bIns="36000"/>
+          <a:lstStyle/>
+          <a:p>
+            <a:pPr algn="ctr"/>
             <a:r>
               <a:rPr sz="3000" b="1" i="0">
                 <a:solidFill>
-                  <a:srgbClr val="FFFFFF"/>
+                  <a:srgbClr val="2A378D"/>
                 </a:solidFill>
                 <a:latin typeface="Arial"/>
               </a:rPr>
-              <a:t>ÁREA DE ESTUDO E DADOS</a:t>
-            </a:r>
-          </a:p>
-        </p:txBody>
-      </p:sp>
-      <p:sp>
-        <p:nvSpPr>
-          <p:cNvPr id="21" name="Texto area de estudo"/>
-          <p:cNvSpPr txBox="1"/>
-          <p:nvPr/>
-        </p:nvSpPr>
-        <p:spPr>
-          <a:xfrm>
-            <a:off x="1080000" y="13032000"/>
-            <a:ext cx="9360000" cy="1872000"/>
-          </a:xfrm>
-          <a:prstGeom prst="rect">
-            <a:avLst/>
-          </a:prstGeom>
-          <a:noFill/>
-        </p:spPr>
-        <p:txBody>
-          <a:bodyPr wrap="square" lIns="0" rIns="0" tIns="0" bIns="0" anchor="t">
-            <a:spAutoFit/>
-          </a:bodyPr>
-          <a:lstStyle/>
-          <a:p>
-            <a:pPr algn="l" marL="252000" indent="-252000">
-              <a:lnSpc>
-                <a:spcPct val="108000"/>
-              </a:lnSpc>
-              <a:spcAft>
-                <a:spcPts val="600"/>
-              </a:spcAft>
-              <a:buClr>
-                <a:srgbClr val="D9661F"/>
-              </a:buClr>
-              <a:buFont typeface="Arial"/>
-              <a:buChar char="■"/>
-            </a:pPr>
-            <a:r>
-              <a:rPr sz="2400" b="0" i="0">
+              <a:t>15.800 km²</a:t>
+            </a:r>
+          </a:p>
+          <a:p>
+            <a:pPr algn="ctr"/>
+            <a:r>
+              <a:rPr sz="1800" b="0" i="0">
                 <a:solidFill>
                   <a:srgbClr val="1F2633"/>
                 </a:solidFill>
                 <a:latin typeface="Arial"/>
               </a:rPr>
-              <a:t>Bacia do rio Taquari até a estação 86472600 (≈15.800 km²)</a:t>
-            </a:r>
-          </a:p>
-          <a:p>
-            <a:pPr algn="l" marL="252000" indent="-252000">
-              <a:lnSpc>
-                <a:spcPct val="108000"/>
-              </a:lnSpc>
-              <a:spcAft>
-                <a:spcPts val="600"/>
-              </a:spcAft>
-              <a:buClr>
-                <a:srgbClr val="D9661F"/>
-              </a:buClr>
-              <a:buFont typeface="Arial"/>
-              <a:buChar char="■"/>
-            </a:pPr>
-            <a:r>
-              <a:rPr sz="2400" b="0" i="0">
-                <a:solidFill>
-                  <a:srgbClr val="1F2633"/>
-                </a:solidFill>
-                <a:latin typeface="Arial"/>
-              </a:rPr>
-              <a:t>Dados horários de nível e chuva (2022–2025) do portal HidroTelemetria (ANA/SGB)</a:t>
-            </a:r>
-          </a:p>
-          <a:p>
-            <a:pPr algn="l" marL="252000" indent="-252000">
-              <a:lnSpc>
-                <a:spcPct val="108000"/>
-              </a:lnSpc>
-              <a:spcAft>
-                <a:spcPts val="600"/>
-              </a:spcAft>
-              <a:buClr>
-                <a:srgbClr val="D9661F"/>
-              </a:buClr>
-              <a:buFont typeface="Arial"/>
-              <a:buChar char="■"/>
-            </a:pPr>
-            <a:r>
-              <a:rPr sz="2400" b="0" i="0">
-                <a:solidFill>
-                  <a:srgbClr val="1F2633"/>
-                </a:solidFill>
-                <a:latin typeface="Arial"/>
-              </a:rPr>
-              <a:t>Amostras agrupadas por </a:t>
-            </a:r>
-            <a:r>
-              <a:rPr sz="2400" b="1" i="0">
-                <a:solidFill>
-                  <a:srgbClr val="1F2633"/>
-                </a:solidFill>
-                <a:latin typeface="Arial"/>
-              </a:rPr>
-              <a:t>eventos de cheia</a:t>
-            </a:r>
-            <a:r>
-              <a:rPr sz="2400" b="0" i="0">
-                <a:solidFill>
-                  <a:srgbClr val="1F2633"/>
-                </a:solidFill>
-                <a:latin typeface="Arial"/>
-              </a:rPr>
-              <a:t>, separados em treino, validação e teste</a:t>
-            </a:r>
-          </a:p>
-        </p:txBody>
-      </p:sp>
-      <p:pic>
-        <p:nvPicPr>
-          <p:cNvPr id="22" name="Mapa da bacia" descr="mapa.png"/>
-          <p:cNvPicPr>
-            <a:picLocks noChangeAspect="1"/>
-          </p:cNvPicPr>
-          <p:nvPr/>
-        </p:nvPicPr>
-        <p:blipFill>
-          <a:blip r:embed="rId9"/>
-          <a:stretch>
-            <a:fillRect/>
-          </a:stretch>
-        </p:blipFill>
-        <p:spPr>
-          <a:xfrm>
-            <a:off x="11448000" y="9072000"/>
-            <a:ext cx="8352000" cy="5720358"/>
-          </a:xfrm>
-          <a:prstGeom prst="rect">
-            <a:avLst/>
-          </a:prstGeom>
-        </p:spPr>
-      </p:pic>
-      <p:sp>
-        <p:nvSpPr>
-          <p:cNvPr id="23" name="Legenda mapa"/>
-          <p:cNvSpPr txBox="1"/>
-          <p:nvPr/>
-        </p:nvSpPr>
-        <p:spPr>
-          <a:xfrm>
-            <a:off x="10944000" y="14864358"/>
-            <a:ext cx="9360000" cy="288000"/>
-          </a:xfrm>
-          <a:prstGeom prst="rect">
-            <a:avLst/>
-          </a:prstGeom>
-          <a:noFill/>
-        </p:spPr>
-        <p:txBody>
-          <a:bodyPr wrap="square" lIns="0" rIns="0" tIns="0" bIns="0" anchor="t">
-            <a:spAutoFit/>
-          </a:bodyPr>
-          <a:lstStyle/>
-          <a:p>
-            <a:pPr algn="l">
-              <a:lnSpc>
-                <a:spcPct val="108000"/>
-              </a:lnSpc>
-              <a:spcAft>
-                <a:spcPts val="600"/>
-              </a:spcAft>
-            </a:pPr>
-            <a:r>
-              <a:rPr sz="1800" b="0" i="0">
-                <a:solidFill>
-                  <a:srgbClr val="5B6573"/>
-                </a:solidFill>
-                <a:latin typeface="Arial"/>
-              </a:rPr>
-              <a:t>Figura 1 – Bacia do rio Taquari até Santa Tereza e postos fluviométricos.</a:t>
-            </a:r>
-          </a:p>
-        </p:txBody>
-      </p:sp>
-      <p:sp>
-        <p:nvSpPr>
-          <p:cNvPr id="24" name="Secao METODOLOGIA: ABORDAGEM ALTERNATIVA (ALT)"/>
+              <a:t>bacia até Santa Tereza</a:t>
+            </a:r>
+          </a:p>
+        </p:txBody>
+      </p:sp>
+      <p:sp>
+        <p:nvSpPr>
+          <p:cNvPr id="21" name="Dado 2"/>
           <p:cNvSpPr/>
           <p:nvPr/>
         </p:nvSpPr>
         <p:spPr>
           <a:xfrm>
-            <a:off x="1080000" y="15408000"/>
-            <a:ext cx="11448000" cy="504000"/>
+            <a:off x="4296000" y="11664000"/>
+            <a:ext cx="2928000" cy="1656000"/>
           </a:xfrm>
           <a:prstGeom prst="roundRect">
             <a:avLst>
-              <a:gd name="adj" fmla="val 50000"/>
+              <a:gd name="adj" fmla="val 12000"/>
             </a:avLst>
           </a:prstGeom>
           <a:solidFill>
-            <a:srgbClr val="2A378D"/>
+            <a:srgbClr val="E6EEF5"/>
           </a:solidFill>
           <a:ln>
             <a:noFill/>
@@ -4254,32 +4087,44 @@
           </a:fontRef>
         </p:style>
         <p:txBody>
-          <a:bodyPr rtlCol="0" anchor="ctr" wrap="none" lIns="252000" rIns="252000" tIns="0" bIns="0"/>
-          <a:lstStyle/>
-          <a:p>
-            <a:pPr algn="l"/>
+          <a:bodyPr rtlCol="0" anchor="ctr" wrap="square" lIns="108000" rIns="108000" tIns="36000" bIns="36000"/>
+          <a:lstStyle/>
+          <a:p>
+            <a:pPr algn="ctr"/>
             <a:r>
               <a:rPr sz="3000" b="1" i="0">
                 <a:solidFill>
-                  <a:srgbClr val="FFFFFF"/>
+                  <a:srgbClr val="2A378D"/>
                 </a:solidFill>
                 <a:latin typeface="Arial"/>
               </a:rPr>
-              <a:t>METODOLOGIA: ABORDAGEM ALTERNATIVA (ALT)</a:t>
-            </a:r>
-          </a:p>
-        </p:txBody>
-      </p:sp>
-      <p:sp>
-        <p:nvSpPr>
-          <p:cNvPr id="25" name="Etapa 1"/>
+              <a:t>2022–2025</a:t>
+            </a:r>
+          </a:p>
+          <a:p>
+            <a:pPr algn="ctr"/>
+            <a:r>
+              <a:rPr sz="1800" b="0" i="0">
+                <a:solidFill>
+                  <a:srgbClr val="1F2633"/>
+                </a:solidFill>
+                <a:latin typeface="Arial"/>
+              </a:rPr>
+              <a:t>dados horários ANA/SGB</a:t>
+            </a:r>
+          </a:p>
+        </p:txBody>
+      </p:sp>
+      <p:sp>
+        <p:nvSpPr>
+          <p:cNvPr id="22" name="Dado 3"/>
           <p:cNvSpPr/>
           <p:nvPr/>
         </p:nvSpPr>
         <p:spPr>
           <a:xfrm>
-            <a:off x="1080000" y="16128000"/>
-            <a:ext cx="4248000" cy="1584000"/>
+            <a:off x="7512000" y="11664000"/>
+            <a:ext cx="2928000" cy="1656000"/>
           </a:xfrm>
           <a:prstGeom prst="roundRect">
             <a:avLst>
@@ -4309,18 +4154,18 @@
           </a:fontRef>
         </p:style>
         <p:txBody>
-          <a:bodyPr rtlCol="0" anchor="ctr" wrap="square" lIns="144000" rIns="144000" tIns="72000" bIns="72000"/>
+          <a:bodyPr rtlCol="0" anchor="ctr" wrap="square" lIns="108000" rIns="108000" tIns="36000" bIns="36000"/>
           <a:lstStyle/>
           <a:p>
             <a:pPr algn="ctr"/>
             <a:r>
-              <a:rPr sz="2400" b="1" i="0">
-                <a:solidFill>
-                  <a:srgbClr val="D9661F"/>
+              <a:rPr sz="3000" b="1" i="0">
+                <a:solidFill>
+                  <a:srgbClr val="2A378D"/>
                 </a:solidFill>
                 <a:latin typeface="Arial"/>
               </a:rPr>
-              <a:t>Entradas</a:t>
+              <a:t>3 grupos</a:t>
             </a:r>
           </a:p>
           <a:p>
@@ -4332,27 +4177,95 @@
                 </a:solidFill>
                 <a:latin typeface="Arial"/>
               </a:rPr>
-              <a:t>níveis, diferenças e acelerações em Santa Tereza e a montante; chuva acumulada</a:t>
-            </a:r>
-          </a:p>
-        </p:txBody>
-      </p:sp>
-      <p:sp>
-        <p:nvSpPr>
-          <p:cNvPr id="26" name="Seta 1"/>
+              <a:t>eventos de cheia: treino, validação e teste</a:t>
+            </a:r>
+          </a:p>
+        </p:txBody>
+      </p:sp>
+      <p:pic>
+        <p:nvPicPr>
+          <p:cNvPr id="23" name="Mapa da bacia" descr="mapa.png"/>
+          <p:cNvPicPr>
+            <a:picLocks noChangeAspect="1"/>
+          </p:cNvPicPr>
+          <p:nvPr/>
+        </p:nvPicPr>
+        <p:blipFill>
+          <a:blip r:embed="rId9"/>
+          <a:stretch>
+            <a:fillRect/>
+          </a:stretch>
+        </p:blipFill>
+        <p:spPr>
+          <a:xfrm>
+            <a:off x="11934000" y="9072000"/>
+            <a:ext cx="7380000" cy="5054627"/>
+          </a:xfrm>
+          <a:prstGeom prst="rect">
+            <a:avLst/>
+          </a:prstGeom>
+        </p:spPr>
+      </p:pic>
+      <p:sp>
+        <p:nvSpPr>
+          <p:cNvPr id="24" name="Legenda mapa"/>
+          <p:cNvSpPr txBox="1"/>
+          <p:nvPr/>
+        </p:nvSpPr>
+        <p:spPr>
+          <a:xfrm>
+            <a:off x="10944000" y="14198627"/>
+            <a:ext cx="9360000" cy="288000"/>
+          </a:xfrm>
+          <a:prstGeom prst="rect">
+            <a:avLst/>
+          </a:prstGeom>
+          <a:noFill/>
+        </p:spPr>
+        <p:txBody>
+          <a:bodyPr wrap="square" lIns="0" rIns="0" tIns="0" bIns="0" anchor="t">
+            <a:spAutoFit/>
+          </a:bodyPr>
+          <a:lstStyle/>
+          <a:p>
+            <a:pPr algn="ctr">
+              <a:lnSpc>
+                <a:spcPct val="108000"/>
+              </a:lnSpc>
+              <a:spcAft>
+                <a:spcPts val="600"/>
+              </a:spcAft>
+            </a:pPr>
+            <a:r>
+              <a:rPr sz="1800" b="0" i="0">
+                <a:solidFill>
+                  <a:srgbClr val="5B6573"/>
+                </a:solidFill>
+                <a:latin typeface="Arial"/>
+              </a:rPr>
+              <a:t>Figura 1 – Bacia do rio Taquari até Santa Tereza e postos fluviométricos.</a:t>
+            </a:r>
+          </a:p>
+        </p:txBody>
+      </p:sp>
+      <p:sp>
+        <p:nvSpPr>
+          <p:cNvPr id="25" name="Secao ABORDAGEM ALTERNATIVA (ALT)"/>
           <p:cNvSpPr/>
           <p:nvPr/>
         </p:nvSpPr>
         <p:spPr>
           <a:xfrm>
-            <a:off x="5436000" y="16704000"/>
-            <a:ext cx="504000" cy="432000"/>
-          </a:xfrm>
-          <a:prstGeom prst="rightArrow">
-            <a:avLst/>
+            <a:off x="1080000" y="14760000"/>
+            <a:ext cx="7984800" cy="504000"/>
+          </a:xfrm>
+          <a:prstGeom prst="roundRect">
+            <a:avLst>
+              <a:gd name="adj" fmla="val 50000"/>
+            </a:avLst>
           </a:prstGeom>
           <a:solidFill>
-            <a:srgbClr val="D9661F"/>
+            <a:srgbClr val="2A378D"/>
           </a:solidFill>
           <a:ln>
             <a:noFill/>
@@ -4374,22 +4287,31 @@
           </a:fontRef>
         </p:style>
         <p:txBody>
-          <a:bodyPr rtlCol="0" anchor="ctr"/>
-          <a:lstStyle/>
-          <a:p>
-            <a:pPr algn="ctr"/>
-          </a:p>
-        </p:txBody>
-      </p:sp>
-      <p:sp>
-        <p:nvSpPr>
-          <p:cNvPr id="27" name="Etapa 2"/>
+          <a:bodyPr rtlCol="0" anchor="ctr" wrap="none" lIns="252000" rIns="252000" tIns="0" bIns="0"/>
+          <a:lstStyle/>
+          <a:p>
+            <a:pPr algn="l"/>
+            <a:r>
+              <a:rPr sz="3000" b="1" i="0">
+                <a:solidFill>
+                  <a:srgbClr val="FFFFFF"/>
+                </a:solidFill>
+                <a:latin typeface="Arial"/>
+              </a:rPr>
+              <a:t>ABORDAGEM ALTERNATIVA (ALT)</a:t>
+            </a:r>
+          </a:p>
+        </p:txBody>
+      </p:sp>
+      <p:sp>
+        <p:nvSpPr>
+          <p:cNvPr id="26" name="Etapa 1"/>
           <p:cNvSpPr/>
           <p:nvPr/>
         </p:nvSpPr>
         <p:spPr>
           <a:xfrm>
-            <a:off x="6048000" y="16128000"/>
+            <a:off x="1080000" y="15480000"/>
             <a:ext cx="4248000" cy="1584000"/>
           </a:xfrm>
           <a:prstGeom prst="roundRect">
@@ -4425,38 +4347,38 @@
           <a:p>
             <a:pPr algn="ctr"/>
             <a:r>
-              <a:rPr sz="2400" b="1" i="0">
+              <a:rPr sz="2600" b="1" i="0">
                 <a:solidFill>
                   <a:srgbClr val="D9661F"/>
                 </a:solidFill>
                 <a:latin typeface="Arial"/>
               </a:rPr>
-              <a:t>RNA MLP</a:t>
+              <a:t>Entradas</a:t>
             </a:r>
           </a:p>
           <a:p>
             <a:pPr algn="ctr"/>
             <a:r>
-              <a:rPr sz="1800" b="0" i="0">
+              <a:rPr sz="1900" b="0" i="0">
                 <a:solidFill>
                   <a:srgbClr val="1F2633"/>
                 </a:solidFill>
                 <a:latin typeface="Arial"/>
               </a:rPr>
-              <a:t>1 camada oculta · sigmoide · retropropagação com gradiente adaptativo</a:t>
-            </a:r>
-          </a:p>
-        </p:txBody>
-      </p:sp>
-      <p:sp>
-        <p:nvSpPr>
-          <p:cNvPr id="28" name="Seta 2"/>
+              <a:t>níveis, diferenças e acelerações (local e montante) + chuva</a:t>
+            </a:r>
+          </a:p>
+        </p:txBody>
+      </p:sp>
+      <p:sp>
+        <p:nvSpPr>
+          <p:cNvPr id="27" name="Seta 1"/>
           <p:cNvSpPr/>
           <p:nvPr/>
         </p:nvSpPr>
         <p:spPr>
           <a:xfrm>
-            <a:off x="10404000" y="16704000"/>
+            <a:off x="5436000" y="16056000"/>
             <a:ext cx="504000" cy="432000"/>
           </a:xfrm>
           <a:prstGeom prst="rightArrow">
@@ -4494,13 +4416,13 @@
       </p:sp>
       <p:sp>
         <p:nvSpPr>
-          <p:cNvPr id="29" name="Etapa 3"/>
+          <p:cNvPr id="28" name="Etapa 2"/>
           <p:cNvSpPr/>
           <p:nvPr/>
         </p:nvSpPr>
         <p:spPr>
           <a:xfrm>
-            <a:off x="11016000" y="16128000"/>
+            <a:off x="6048000" y="15480000"/>
             <a:ext cx="4248000" cy="1584000"/>
           </a:xfrm>
           <a:prstGeom prst="roundRect">
@@ -4536,38 +4458,38 @@
           <a:p>
             <a:pPr algn="ctr"/>
             <a:r>
-              <a:rPr sz="2400" b="1" i="0">
+              <a:rPr sz="2600" b="1" i="0">
                 <a:solidFill>
                   <a:srgbClr val="D9661F"/>
                 </a:solidFill>
                 <a:latin typeface="Arial"/>
               </a:rPr>
-              <a:t>Saída da RNA</a:t>
+              <a:t>RNA MLP</a:t>
             </a:r>
           </a:p>
           <a:p>
             <a:pPr algn="ctr"/>
             <a:r>
-              <a:rPr sz="1800" b="0" i="0">
+              <a:rPr sz="1900" b="0" i="0">
                 <a:solidFill>
                   <a:srgbClr val="1F2633"/>
                 </a:solidFill>
                 <a:latin typeface="Arial"/>
               </a:rPr>
-              <a:t>variação do nível ΔH = H(t+h) − H(t)</a:t>
-            </a:r>
-          </a:p>
-        </p:txBody>
-      </p:sp>
-      <p:sp>
-        <p:nvSpPr>
-          <p:cNvPr id="30" name="Seta 3"/>
+              <a:t>1 camada oculta · sigmoide · retropropagação</a:t>
+            </a:r>
+          </a:p>
+        </p:txBody>
+      </p:sp>
+      <p:sp>
+        <p:nvSpPr>
+          <p:cNvPr id="29" name="Seta 2"/>
           <p:cNvSpPr/>
           <p:nvPr/>
         </p:nvSpPr>
         <p:spPr>
           <a:xfrm>
-            <a:off x="15372000" y="16704000"/>
+            <a:off x="10404000" y="16056000"/>
             <a:ext cx="504000" cy="432000"/>
           </a:xfrm>
           <a:prstGeom prst="rightArrow">
@@ -4605,13 +4527,13 @@
       </p:sp>
       <p:sp>
         <p:nvSpPr>
-          <p:cNvPr id="31" name="Etapa 4"/>
+          <p:cNvPr id="30" name="Etapa 3"/>
           <p:cNvSpPr/>
           <p:nvPr/>
         </p:nvSpPr>
         <p:spPr>
           <a:xfrm>
-            <a:off x="15984000" y="16128000"/>
+            <a:off x="11016000" y="15480000"/>
             <a:ext cx="4248000" cy="1584000"/>
           </a:xfrm>
           <a:prstGeom prst="roundRect">
@@ -4620,7 +4542,7 @@
             </a:avLst>
           </a:prstGeom>
           <a:solidFill>
-            <a:srgbClr val="2A378D"/>
+            <a:srgbClr val="E6EEF5"/>
           </a:solidFill>
           <a:ln>
             <a:noFill/>
@@ -4647,546 +4569,45 @@
           <a:p>
             <a:pPr algn="ctr"/>
             <a:r>
-              <a:rPr sz="2400" b="1" i="0">
-                <a:solidFill>
-                  <a:srgbClr val="FFFFFF"/>
+              <a:rPr sz="2600" b="1" i="0">
+                <a:solidFill>
+                  <a:srgbClr val="D9661F"/>
                 </a:solidFill>
                 <a:latin typeface="Arial"/>
               </a:rPr>
-              <a:t>Nível previsto</a:t>
+              <a:t>Saída da RNA</a:t>
             </a:r>
           </a:p>
           <a:p>
             <a:pPr algn="ctr"/>
             <a:r>
-              <a:rPr sz="1800" b="0" i="0">
-                <a:solidFill>
-                  <a:srgbClr val="FFFFFF"/>
+              <a:rPr sz="1900" b="0" i="0">
+                <a:solidFill>
+                  <a:srgbClr val="1F2633"/>
                 </a:solidFill>
                 <a:latin typeface="Arial"/>
               </a:rPr>
-              <a:t>Ĥ(t+h) = H(t) + ΔH</a:t>
-            </a:r>
-          </a:p>
-        </p:txBody>
-      </p:sp>
-      <p:sp>
-        <p:nvSpPr>
-          <p:cNvPr id="32" name="Texto metodologia"/>
-          <p:cNvSpPr txBox="1"/>
+              <a:t>ΔH = H(t+h) − H(t)</a:t>
+            </a:r>
+          </a:p>
+        </p:txBody>
+      </p:sp>
+      <p:sp>
+        <p:nvSpPr>
+          <p:cNvPr id="31" name="Seta 3"/>
+          <p:cNvSpPr/>
           <p:nvPr/>
         </p:nvSpPr>
         <p:spPr>
           <a:xfrm>
-            <a:off x="1080000" y="18036000"/>
-            <a:ext cx="9360000" cy="2232000"/>
-          </a:xfrm>
-          <a:prstGeom prst="rect">
+            <a:off x="15372000" y="16056000"/>
+            <a:ext cx="504000" cy="432000"/>
+          </a:xfrm>
+          <a:prstGeom prst="rightArrow">
             <a:avLst/>
           </a:prstGeom>
-          <a:noFill/>
-        </p:spPr>
-        <p:txBody>
-          <a:bodyPr wrap="square" lIns="0" rIns="0" tIns="0" bIns="0" anchor="t">
-            <a:spAutoFit/>
-          </a:bodyPr>
-          <a:lstStyle/>
-          <a:p>
-            <a:pPr algn="l" marL="252000" indent="-252000">
-              <a:lnSpc>
-                <a:spcPct val="108000"/>
-              </a:lnSpc>
-              <a:spcAft>
-                <a:spcPts val="400"/>
-              </a:spcAft>
-              <a:buClr>
-                <a:srgbClr val="D9661F"/>
-              </a:buClr>
-              <a:buFont typeface="Arial"/>
-              <a:buChar char="■"/>
-            </a:pPr>
-            <a:r>
-              <a:rPr sz="2000" b="0" i="0">
-                <a:solidFill>
-                  <a:srgbClr val="1F2633"/>
-                </a:solidFill>
-                <a:latin typeface="Arial"/>
-              </a:rPr>
-              <a:t>Neurônios ocultos ≈ 2 × nº de entradas; 10 inicializações por rede</a:t>
-            </a:r>
-          </a:p>
-          <a:p>
-            <a:pPr algn="l" marL="252000" indent="-252000">
-              <a:lnSpc>
-                <a:spcPct val="108000"/>
-              </a:lnSpc>
-              <a:spcAft>
-                <a:spcPts val="400"/>
-              </a:spcAft>
-              <a:buClr>
-                <a:srgbClr val="D9661F"/>
-              </a:buClr>
-              <a:buFont typeface="Arial"/>
-              <a:buChar char="■"/>
-            </a:pPr>
-            <a:r>
-              <a:rPr sz="2000" b="0" i="0">
-                <a:solidFill>
-                  <a:srgbClr val="1F2633"/>
-                </a:solidFill>
-                <a:latin typeface="Arial"/>
-              </a:rPr>
-              <a:t>Entradas escolhidas por algoritmo de busca em Python; redes treinadas no MATLAB</a:t>
-            </a:r>
-          </a:p>
-          <a:p>
-            <a:pPr algn="l" marL="252000" indent="-252000">
-              <a:lnSpc>
-                <a:spcPct val="108000"/>
-              </a:lnSpc>
-              <a:spcAft>
-                <a:spcPts val="400"/>
-              </a:spcAft>
-              <a:buClr>
-                <a:srgbClr val="D9661F"/>
-              </a:buClr>
-              <a:buFont typeface="Arial"/>
-              <a:buChar char="■"/>
-            </a:pPr>
-            <a:r>
-              <a:rPr sz="2000" b="0" i="0">
-                <a:solidFill>
-                  <a:srgbClr val="1F2633"/>
-                </a:solidFill>
-                <a:latin typeface="Arial"/>
-              </a:rPr>
-              <a:t>Avaliação: NSE, PME (ganho sobre a persistência), EAM e E95 (erro não superado em 95%)</a:t>
-            </a:r>
-          </a:p>
-        </p:txBody>
-      </p:sp>
-      <p:graphicFrame>
-        <p:nvGraphicFramePr>
-          <p:cNvPr id="33" name="Tabela configuracao"/>
-          <p:cNvGraphicFramePr>
-            <a:graphicFrameLocks noGrp="1"/>
-          </p:cNvGraphicFramePr>
-          <p:nvPr/>
-        </p:nvGraphicFramePr>
-        <p:xfrm>
-          <a:off x="10944000" y="18036000"/>
-          <a:ext cx="9360000" cy="1800000"/>
-        </p:xfrm>
-        <a:graphic>
-          <a:graphicData uri="http://schemas.openxmlformats.org/drawingml/2006/table">
-            <a:tbl>
-              <a:tblPr firstRow="0" bandRow="0">
-                <a:tableStyleId>{5C22544A-7EE6-4342-B048-85BDC9FD1C3A}</a:tableStyleId>
-              </a:tblPr>
-              <a:tblGrid>
-                <a:gridCol w="1376471"/>
-                <a:gridCol w="1445294"/>
-                <a:gridCol w="1582941"/>
-                <a:gridCol w="4955294"/>
-              </a:tblGrid>
-              <a:tr h="450000">
-                <a:tc>
-                  <a:txBody>
-                    <a:bodyPr wrap="square"/>
-                    <a:lstStyle/>
-                    <a:p>
-                      <a:pPr algn="l"/>
-                      <a:r>
-                        <a:rPr sz="1900" b="1" i="0">
-                          <a:solidFill>
-                            <a:srgbClr val="FFFFFF"/>
-                          </a:solidFill>
-                          <a:latin typeface="Arial"/>
-                        </a:rPr>
-                        <a:t>Modelo</a:t>
-                      </a:r>
-                    </a:p>
-                  </a:txBody>
-                  <a:tcPr marL="90000" marR="90000" marT="36000" marB="36000" anchor="ctr">
-                    <a:solidFill>
-                      <a:srgbClr val="2A378D"/>
-                    </a:solidFill>
-                  </a:tcPr>
-                </a:tc>
-                <a:tc>
-                  <a:txBody>
-                    <a:bodyPr wrap="square"/>
-                    <a:lstStyle/>
-                    <a:p>
-                      <a:pPr algn="ctr"/>
-                      <a:r>
-                        <a:rPr sz="1900" b="1" i="0">
-                          <a:solidFill>
-                            <a:srgbClr val="FFFFFF"/>
-                          </a:solidFill>
-                          <a:latin typeface="Arial"/>
-                        </a:rPr>
-                        <a:t>Entradas</a:t>
-                      </a:r>
-                    </a:p>
-                  </a:txBody>
-                  <a:tcPr marL="90000" marR="90000" marT="36000" marB="36000" anchor="ctr">
-                    <a:solidFill>
-                      <a:srgbClr val="2A378D"/>
-                    </a:solidFill>
-                  </a:tcPr>
-                </a:tc>
-                <a:tc>
-                  <a:txBody>
-                    <a:bodyPr wrap="square"/>
-                    <a:lstStyle/>
-                    <a:p>
-                      <a:pPr algn="ctr"/>
-                      <a:r>
-                        <a:rPr sz="1900" b="1" i="0">
-                          <a:solidFill>
-                            <a:srgbClr val="FFFFFF"/>
-                          </a:solidFill>
-                          <a:latin typeface="Arial"/>
-                        </a:rPr>
-                        <a:t>Neurônios</a:t>
-                      </a:r>
-                    </a:p>
-                  </a:txBody>
-                  <a:tcPr marL="90000" marR="90000" marT="36000" marB="36000" anchor="ctr">
-                    <a:solidFill>
-                      <a:srgbClr val="2A378D"/>
-                    </a:solidFill>
-                  </a:tcPr>
-                </a:tc>
-                <a:tc>
-                  <a:txBody>
-                    <a:bodyPr wrap="square"/>
-                    <a:lstStyle/>
-                    <a:p>
-                      <a:pPr algn="ctr"/>
-                      <a:r>
-                        <a:rPr sz="1900" b="1" i="0">
-                          <a:solidFill>
-                            <a:srgbClr val="FFFFFF"/>
-                          </a:solidFill>
-                          <a:latin typeface="Arial"/>
-                        </a:rPr>
-                        <a:t>Variáveis de entrada</a:t>
-                      </a:r>
-                    </a:p>
-                  </a:txBody>
-                  <a:tcPr marL="90000" marR="90000" marT="36000" marB="36000" anchor="ctr">
-                    <a:solidFill>
-                      <a:srgbClr val="2A378D"/>
-                    </a:solidFill>
-                  </a:tcPr>
-                </a:tc>
-              </a:tr>
-              <a:tr h="450000">
-                <a:tc>
-                  <a:txBody>
-                    <a:bodyPr wrap="square"/>
-                    <a:lstStyle/>
-                    <a:p>
-                      <a:pPr algn="l"/>
-                      <a:r>
-                        <a:rPr sz="1900" b="1" i="0">
-                          <a:solidFill>
-                            <a:srgbClr val="1F2633"/>
-                          </a:solidFill>
-                          <a:latin typeface="Arial"/>
-                        </a:rPr>
-                        <a:t>ALT 2h</a:t>
-                      </a:r>
-                    </a:p>
-                  </a:txBody>
-                  <a:tcPr marL="90000" marR="90000" marT="36000" marB="36000" anchor="ctr">
-                    <a:solidFill>
-                      <a:srgbClr val="FFFFFF"/>
-                    </a:solidFill>
-                  </a:tcPr>
-                </a:tc>
-                <a:tc>
-                  <a:txBody>
-                    <a:bodyPr wrap="square"/>
-                    <a:lstStyle/>
-                    <a:p>
-                      <a:pPr algn="ctr"/>
-                      <a:r>
-                        <a:rPr sz="1900" b="0" i="0">
-                          <a:solidFill>
-                            <a:srgbClr val="1F2633"/>
-                          </a:solidFill>
-                          <a:latin typeface="Arial"/>
-                        </a:rPr>
-                        <a:t>15</a:t>
-                      </a:r>
-                    </a:p>
-                  </a:txBody>
-                  <a:tcPr marL="90000" marR="90000" marT="36000" marB="36000" anchor="ctr">
-                    <a:solidFill>
-                      <a:srgbClr val="FFFFFF"/>
-                    </a:solidFill>
-                  </a:tcPr>
-                </a:tc>
-                <a:tc>
-                  <a:txBody>
-                    <a:bodyPr wrap="square"/>
-                    <a:lstStyle/>
-                    <a:p>
-                      <a:pPr algn="ctr"/>
-                      <a:r>
-                        <a:rPr sz="1900" b="0" i="0">
-                          <a:solidFill>
-                            <a:srgbClr val="1F2633"/>
-                          </a:solidFill>
-                          <a:latin typeface="Arial"/>
-                        </a:rPr>
-                        <a:t>30</a:t>
-                      </a:r>
-                    </a:p>
-                  </a:txBody>
-                  <a:tcPr marL="90000" marR="90000" marT="36000" marB="36000" anchor="ctr">
-                    <a:solidFill>
-                      <a:srgbClr val="FFFFFF"/>
-                    </a:solidFill>
-                  </a:tcPr>
-                </a:tc>
-                <a:tc>
-                  <a:txBody>
-                    <a:bodyPr wrap="square"/>
-                    <a:lstStyle/>
-                    <a:p>
-                      <a:pPr algn="l"/>
-                      <a:r>
-                        <a:rPr sz="1900" b="0" i="0">
-                          <a:solidFill>
-                            <a:srgbClr val="1F2633"/>
-                          </a:solidFill>
-                          <a:latin typeface="Arial"/>
-                        </a:rPr>
-                        <a:t>Santa Tereza e Linha José Júlio</a:t>
-                      </a:r>
-                    </a:p>
-                  </a:txBody>
-                  <a:tcPr marL="90000" marR="90000" marT="36000" marB="36000" anchor="ctr">
-                    <a:solidFill>
-                      <a:srgbClr val="FFFFFF"/>
-                    </a:solidFill>
-                  </a:tcPr>
-                </a:tc>
-              </a:tr>
-              <a:tr h="450000">
-                <a:tc>
-                  <a:txBody>
-                    <a:bodyPr wrap="square"/>
-                    <a:lstStyle/>
-                    <a:p>
-                      <a:pPr algn="l"/>
-                      <a:r>
-                        <a:rPr sz="1900" b="1" i="0">
-                          <a:solidFill>
-                            <a:srgbClr val="1F2633"/>
-                          </a:solidFill>
-                          <a:latin typeface="Arial"/>
-                        </a:rPr>
-                        <a:t>ALT 4h</a:t>
-                      </a:r>
-                    </a:p>
-                  </a:txBody>
-                  <a:tcPr marL="90000" marR="90000" marT="36000" marB="36000" anchor="ctr">
-                    <a:solidFill>
-                      <a:srgbClr val="E6EEF5"/>
-                    </a:solidFill>
-                  </a:tcPr>
-                </a:tc>
-                <a:tc>
-                  <a:txBody>
-                    <a:bodyPr wrap="square"/>
-                    <a:lstStyle/>
-                    <a:p>
-                      <a:pPr algn="ctr"/>
-                      <a:r>
-                        <a:rPr sz="1900" b="0" i="0">
-                          <a:solidFill>
-                            <a:srgbClr val="1F2633"/>
-                          </a:solidFill>
-                          <a:latin typeface="Arial"/>
-                        </a:rPr>
-                        <a:t>26</a:t>
-                      </a:r>
-                    </a:p>
-                  </a:txBody>
-                  <a:tcPr marL="90000" marR="90000" marT="36000" marB="36000" anchor="ctr">
-                    <a:solidFill>
-                      <a:srgbClr val="E6EEF5"/>
-                    </a:solidFill>
-                  </a:tcPr>
-                </a:tc>
-                <a:tc>
-                  <a:txBody>
-                    <a:bodyPr wrap="square"/>
-                    <a:lstStyle/>
-                    <a:p>
-                      <a:pPr algn="ctr"/>
-                      <a:r>
-                        <a:rPr sz="1900" b="0" i="0">
-                          <a:solidFill>
-                            <a:srgbClr val="1F2633"/>
-                          </a:solidFill>
-                          <a:latin typeface="Arial"/>
-                        </a:rPr>
-                        <a:t>52</a:t>
-                      </a:r>
-                    </a:p>
-                  </a:txBody>
-                  <a:tcPr marL="90000" marR="90000" marT="36000" marB="36000" anchor="ctr">
-                    <a:solidFill>
-                      <a:srgbClr val="E6EEF5"/>
-                    </a:solidFill>
-                  </a:tcPr>
-                </a:tc>
-                <a:tc>
-                  <a:txBody>
-                    <a:bodyPr wrap="square"/>
-                    <a:lstStyle/>
-                    <a:p>
-                      <a:pPr algn="l"/>
-                      <a:r>
-                        <a:rPr sz="1900" b="0" i="0">
-                          <a:solidFill>
-                            <a:srgbClr val="1F2633"/>
-                          </a:solidFill>
-                          <a:latin typeface="Arial"/>
-                        </a:rPr>
-                        <a:t>+ 2 postos a montante</a:t>
-                      </a:r>
-                    </a:p>
-                  </a:txBody>
-                  <a:tcPr marL="90000" marR="90000" marT="36000" marB="36000" anchor="ctr">
-                    <a:solidFill>
-                      <a:srgbClr val="E6EEF5"/>
-                    </a:solidFill>
-                  </a:tcPr>
-                </a:tc>
-              </a:tr>
-              <a:tr h="450000">
-                <a:tc>
-                  <a:txBody>
-                    <a:bodyPr wrap="square"/>
-                    <a:lstStyle/>
-                    <a:p>
-                      <a:pPr algn="l"/>
-                      <a:r>
-                        <a:rPr sz="1900" b="1" i="0">
-                          <a:solidFill>
-                            <a:srgbClr val="1F2633"/>
-                          </a:solidFill>
-                          <a:latin typeface="Arial"/>
-                        </a:rPr>
-                        <a:t>ALT 8h</a:t>
-                      </a:r>
-                    </a:p>
-                  </a:txBody>
-                  <a:tcPr marL="90000" marR="90000" marT="36000" marB="36000" anchor="ctr">
-                    <a:solidFill>
-                      <a:srgbClr val="FFFFFF"/>
-                    </a:solidFill>
-                  </a:tcPr>
-                </a:tc>
-                <a:tc>
-                  <a:txBody>
-                    <a:bodyPr wrap="square"/>
-                    <a:lstStyle/>
-                    <a:p>
-                      <a:pPr algn="ctr"/>
-                      <a:r>
-                        <a:rPr sz="1900" b="0" i="0">
-                          <a:solidFill>
-                            <a:srgbClr val="1F2633"/>
-                          </a:solidFill>
-                          <a:latin typeface="Arial"/>
-                        </a:rPr>
-                        <a:t>31</a:t>
-                      </a:r>
-                    </a:p>
-                  </a:txBody>
-                  <a:tcPr marL="90000" marR="90000" marT="36000" marB="36000" anchor="ctr">
-                    <a:solidFill>
-                      <a:srgbClr val="FFFFFF"/>
-                    </a:solidFill>
-                  </a:tcPr>
-                </a:tc>
-                <a:tc>
-                  <a:txBody>
-                    <a:bodyPr wrap="square"/>
-                    <a:lstStyle/>
-                    <a:p>
-                      <a:pPr algn="ctr"/>
-                      <a:r>
-                        <a:rPr sz="1900" b="0" i="0">
-                          <a:solidFill>
-                            <a:srgbClr val="1F2633"/>
-                          </a:solidFill>
-                          <a:latin typeface="Arial"/>
-                        </a:rPr>
-                        <a:t>63</a:t>
-                      </a:r>
-                    </a:p>
-                  </a:txBody>
-                  <a:tcPr marL="90000" marR="90000" marT="36000" marB="36000" anchor="ctr">
-                    <a:solidFill>
-                      <a:srgbClr val="FFFFFF"/>
-                    </a:solidFill>
-                  </a:tcPr>
-                </a:tc>
-                <a:tc>
-                  <a:txBody>
-                    <a:bodyPr wrap="square"/>
-                    <a:lstStyle/>
-                    <a:p>
-                      <a:pPr algn="l"/>
-                      <a:r>
-                        <a:rPr sz="1900" b="0" i="0">
-                          <a:solidFill>
-                            <a:srgbClr val="1F2633"/>
-                          </a:solidFill>
-                          <a:latin typeface="Arial"/>
-                        </a:rPr>
-                        <a:t>7 postos fluviométricos + chuva</a:t>
-                      </a:r>
-                    </a:p>
-                  </a:txBody>
-                  <a:tcPr marL="90000" marR="90000" marT="36000" marB="36000" anchor="ctr">
-                    <a:solidFill>
-                      <a:srgbClr val="FFFFFF"/>
-                    </a:solidFill>
-                  </a:tcPr>
-                </a:tc>
-              </a:tr>
-            </a:tbl>
-          </a:graphicData>
-        </a:graphic>
-      </p:graphicFrame>
-      <p:sp>
-        <p:nvSpPr>
-          <p:cNvPr id="34" name="Secao RESULTADOS"/>
-          <p:cNvSpPr/>
-          <p:nvPr/>
-        </p:nvSpPr>
-        <p:spPr>
-          <a:xfrm>
-            <a:off x="1080000" y="20232000"/>
-            <a:ext cx="3456000" cy="504000"/>
-          </a:xfrm>
-          <a:prstGeom prst="roundRect">
-            <a:avLst>
-              <a:gd name="adj" fmla="val 50000"/>
-            </a:avLst>
-          </a:prstGeom>
           <a:solidFill>
-            <a:srgbClr val="2A378D"/>
+            <a:srgbClr val="D9661F"/>
           </a:solidFill>
           <a:ln>
             <a:noFill/>
@@ -5208,734 +4629,27 @@
           </a:fontRef>
         </p:style>
         <p:txBody>
-          <a:bodyPr rtlCol="0" anchor="ctr" wrap="none" lIns="252000" rIns="252000" tIns="0" bIns="0"/>
-          <a:lstStyle/>
-          <a:p>
-            <a:pPr algn="l"/>
-            <a:r>
-              <a:rPr sz="3000" b="1" i="0">
-                <a:solidFill>
-                  <a:srgbClr val="FFFFFF"/>
-                </a:solidFill>
-                <a:latin typeface="Arial"/>
-              </a:rPr>
-              <a:t>RESULTADOS</a:t>
-            </a:r>
-          </a:p>
-        </p:txBody>
-      </p:sp>
-      <p:pic>
-        <p:nvPicPr>
-          <p:cNvPr id="35" name="Dispersao previsto x observado" descr="dispersao.png"/>
-          <p:cNvPicPr>
-            <a:picLocks noChangeAspect="1"/>
-          </p:cNvPicPr>
-          <p:nvPr/>
-        </p:nvPicPr>
-        <p:blipFill>
-          <a:blip r:embed="rId10"/>
-          <a:stretch>
-            <a:fillRect/>
-          </a:stretch>
-        </p:blipFill>
-        <p:spPr>
-          <a:xfrm>
-            <a:off x="2952000" y="20844000"/>
-            <a:ext cx="15480000" cy="5110385"/>
-          </a:xfrm>
-          <a:prstGeom prst="rect">
-            <a:avLst/>
-          </a:prstGeom>
-        </p:spPr>
-      </p:pic>
-      <p:sp>
-        <p:nvSpPr>
-          <p:cNvPr id="36" name="Legenda dispersao"/>
-          <p:cNvSpPr txBox="1"/>
-          <p:nvPr/>
-        </p:nvSpPr>
-        <p:spPr>
-          <a:xfrm>
-            <a:off x="1080000" y="25990385"/>
-            <a:ext cx="19224000" cy="288000"/>
-          </a:xfrm>
-          <a:prstGeom prst="rect">
-            <a:avLst/>
-          </a:prstGeom>
-          <a:noFill/>
-        </p:spPr>
-        <p:txBody>
-          <a:bodyPr wrap="square" lIns="0" rIns="0" tIns="0" bIns="0" anchor="t">
-            <a:spAutoFit/>
-          </a:bodyPr>
-          <a:lstStyle/>
-          <a:p>
-            <a:pPr algn="l">
-              <a:lnSpc>
-                <a:spcPct val="108000"/>
-              </a:lnSpc>
-              <a:spcAft>
-                <a:spcPts val="600"/>
-              </a:spcAft>
-            </a:pPr>
-            <a:r>
-              <a:rPr sz="1800" b="0" i="0">
-                <a:solidFill>
-                  <a:srgbClr val="5B6573"/>
-                </a:solidFill>
-                <a:latin typeface="Arial"/>
-              </a:rPr>
-              <a:t>Figura 2 – Nível previsto × observado (série completa) dos modelos ALT ao vivo em Santa Tereza.</a:t>
-            </a:r>
-          </a:p>
-        </p:txBody>
-      </p:sp>
-      <p:graphicFrame>
-        <p:nvGraphicFramePr>
-          <p:cNvPr id="37" name="Tabela resultados"/>
-          <p:cNvGraphicFramePr>
-            <a:graphicFrameLocks noGrp="1"/>
-          </p:cNvGraphicFramePr>
-          <p:nvPr/>
-        </p:nvGraphicFramePr>
-        <p:xfrm>
-          <a:off x="1080000" y="26386385"/>
-          <a:ext cx="9360001" cy="1800000"/>
-        </p:xfrm>
-        <a:graphic>
-          <a:graphicData uri="http://schemas.openxmlformats.org/drawingml/2006/table">
-            <a:tbl>
-              <a:tblPr firstRow="0" bandRow="0">
-                <a:tableStyleId>{5C22544A-7EE6-4342-B048-85BDC9FD1C3A}</a:tableStyleId>
-              </a:tblPr>
-              <a:tblGrid>
-                <a:gridCol w="1429008"/>
-                <a:gridCol w="1429008"/>
-                <a:gridCol w="1429008"/>
-                <a:gridCol w="1500458"/>
-                <a:gridCol w="1357557"/>
-                <a:gridCol w="2214962"/>
-              </a:tblGrid>
-              <a:tr h="450000">
-                <a:tc>
-                  <a:txBody>
-                    <a:bodyPr wrap="square"/>
-                    <a:lstStyle/>
-                    <a:p>
-                      <a:pPr algn="l"/>
-                      <a:r>
-                        <a:rPr sz="1900" b="1" i="0">
-                          <a:solidFill>
-                            <a:srgbClr val="FFFFFF"/>
-                          </a:solidFill>
-                          <a:latin typeface="Arial"/>
-                        </a:rPr>
-                        <a:t>Teste</a:t>
-                      </a:r>
-                    </a:p>
-                  </a:txBody>
-                  <a:tcPr marL="90000" marR="90000" marT="36000" marB="36000" anchor="ctr">
-                    <a:solidFill>
-                      <a:srgbClr val="2A378D"/>
-                    </a:solidFill>
-                  </a:tcPr>
-                </a:tc>
-                <a:tc>
-                  <a:txBody>
-                    <a:bodyPr wrap="square"/>
-                    <a:lstStyle/>
-                    <a:p>
-                      <a:pPr algn="ctr"/>
-                      <a:r>
-                        <a:rPr sz="1900" b="1" i="0">
-                          <a:solidFill>
-                            <a:srgbClr val="FFFFFF"/>
-                          </a:solidFill>
-                          <a:latin typeface="Arial"/>
-                        </a:rPr>
-                        <a:t>NSE</a:t>
-                      </a:r>
-                    </a:p>
-                  </a:txBody>
-                  <a:tcPr marL="90000" marR="90000" marT="36000" marB="36000" anchor="ctr">
-                    <a:solidFill>
-                      <a:srgbClr val="2A378D"/>
-                    </a:solidFill>
-                  </a:tcPr>
-                </a:tc>
-                <a:tc>
-                  <a:txBody>
-                    <a:bodyPr wrap="square"/>
-                    <a:lstStyle/>
-                    <a:p>
-                      <a:pPr algn="ctr"/>
-                      <a:r>
-                        <a:rPr sz="1900" b="1" i="0">
-                          <a:solidFill>
-                            <a:srgbClr val="FFFFFF"/>
-                          </a:solidFill>
-                          <a:latin typeface="Arial"/>
-                        </a:rPr>
-                        <a:t>PME</a:t>
-                      </a:r>
-                    </a:p>
-                  </a:txBody>
-                  <a:tcPr marL="90000" marR="90000" marT="36000" marB="36000" anchor="ctr">
-                    <a:solidFill>
-                      <a:srgbClr val="2A378D"/>
-                    </a:solidFill>
-                  </a:tcPr>
-                </a:tc>
-                <a:tc>
-                  <a:txBody>
-                    <a:bodyPr wrap="square"/>
-                    <a:lstStyle/>
-                    <a:p>
-                      <a:pPr algn="ctr"/>
-                      <a:r>
-                        <a:rPr sz="1900" b="1" i="0">
-                          <a:solidFill>
-                            <a:srgbClr val="FFFFFF"/>
-                          </a:solidFill>
-                          <a:latin typeface="Arial"/>
-                        </a:rPr>
-                        <a:t>EAM</a:t>
-                      </a:r>
-                    </a:p>
-                  </a:txBody>
-                  <a:tcPr marL="90000" marR="90000" marT="36000" marB="36000" anchor="ctr">
-                    <a:solidFill>
-                      <a:srgbClr val="2A378D"/>
-                    </a:solidFill>
-                  </a:tcPr>
-                </a:tc>
-                <a:tc>
-                  <a:txBody>
-                    <a:bodyPr wrap="square"/>
-                    <a:lstStyle/>
-                    <a:p>
-                      <a:pPr algn="ctr"/>
-                      <a:r>
-                        <a:rPr sz="1900" b="1" i="0">
-                          <a:solidFill>
-                            <a:srgbClr val="FFFFFF"/>
-                          </a:solidFill>
-                          <a:latin typeface="Arial"/>
-                        </a:rPr>
-                        <a:t>E95</a:t>
-                      </a:r>
-                    </a:p>
-                  </a:txBody>
-                  <a:tcPr marL="90000" marR="90000" marT="36000" marB="36000" anchor="ctr">
-                    <a:solidFill>
-                      <a:srgbClr val="2A378D"/>
-                    </a:solidFill>
-                  </a:tcPr>
-                </a:tc>
-                <a:tc>
-                  <a:txBody>
-                    <a:bodyPr wrap="square"/>
-                    <a:lstStyle/>
-                    <a:p>
-                      <a:pPr algn="ctr"/>
-                      <a:r>
-                        <a:rPr sz="1900" b="1" i="0">
-                          <a:solidFill>
-                            <a:srgbClr val="FFFFFF"/>
-                          </a:solidFill>
-                          <a:latin typeface="Arial"/>
-                        </a:rPr>
-                        <a:t>EAM × persist.</a:t>
-                      </a:r>
-                    </a:p>
-                  </a:txBody>
-                  <a:tcPr marL="90000" marR="90000" marT="36000" marB="36000" anchor="ctr">
-                    <a:solidFill>
-                      <a:srgbClr val="2A378D"/>
-                    </a:solidFill>
-                  </a:tcPr>
-                </a:tc>
-              </a:tr>
-              <a:tr h="450000">
-                <a:tc>
-                  <a:txBody>
-                    <a:bodyPr wrap="square"/>
-                    <a:lstStyle/>
-                    <a:p>
-                      <a:pPr algn="l"/>
-                      <a:r>
-                        <a:rPr sz="1900" b="1" i="0">
-                          <a:solidFill>
-                            <a:srgbClr val="1F2633"/>
-                          </a:solidFill>
-                          <a:latin typeface="Arial"/>
-                        </a:rPr>
-                        <a:t>ALT 2h</a:t>
-                      </a:r>
-                    </a:p>
-                  </a:txBody>
-                  <a:tcPr marL="90000" marR="90000" marT="36000" marB="36000" anchor="ctr">
-                    <a:solidFill>
-                      <a:srgbClr val="FFFFFF"/>
-                    </a:solidFill>
-                  </a:tcPr>
-                </a:tc>
-                <a:tc>
-                  <a:txBody>
-                    <a:bodyPr wrap="square"/>
-                    <a:lstStyle/>
-                    <a:p>
-                      <a:pPr algn="ctr"/>
-                      <a:r>
-                        <a:rPr sz="1900" b="0" i="0">
-                          <a:solidFill>
-                            <a:srgbClr val="1F2633"/>
-                          </a:solidFill>
-                          <a:latin typeface="Arial"/>
-                        </a:rPr>
-                        <a:t>0,996</a:t>
-                      </a:r>
-                    </a:p>
-                  </a:txBody>
-                  <a:tcPr marL="90000" marR="90000" marT="36000" marB="36000" anchor="ctr">
-                    <a:solidFill>
-                      <a:srgbClr val="FFFFFF"/>
-                    </a:solidFill>
-                  </a:tcPr>
-                </a:tc>
-                <a:tc>
-                  <a:txBody>
-                    <a:bodyPr wrap="square"/>
-                    <a:lstStyle/>
-                    <a:p>
-                      <a:pPr algn="ctr"/>
-                      <a:r>
-                        <a:rPr sz="1900" b="0" i="0">
-                          <a:solidFill>
-                            <a:srgbClr val="1F2633"/>
-                          </a:solidFill>
-                          <a:latin typeface="Arial"/>
-                        </a:rPr>
-                        <a:t>0,969</a:t>
-                      </a:r>
-                    </a:p>
-                  </a:txBody>
-                  <a:tcPr marL="90000" marR="90000" marT="36000" marB="36000" anchor="ctr">
-                    <a:solidFill>
-                      <a:srgbClr val="FFFFFF"/>
-                    </a:solidFill>
-                  </a:tcPr>
-                </a:tc>
-                <a:tc>
-                  <a:txBody>
-                    <a:bodyPr wrap="square"/>
-                    <a:lstStyle/>
-                    <a:p>
-                      <a:pPr algn="ctr"/>
-                      <a:r>
-                        <a:rPr sz="1900" b="0" i="0">
-                          <a:solidFill>
-                            <a:srgbClr val="1F2633"/>
-                          </a:solidFill>
-                          <a:latin typeface="Arial"/>
-                        </a:rPr>
-                        <a:t>3,5 cm</a:t>
-                      </a:r>
-                    </a:p>
-                  </a:txBody>
-                  <a:tcPr marL="90000" marR="90000" marT="36000" marB="36000" anchor="ctr">
-                    <a:solidFill>
-                      <a:srgbClr val="FFFFFF"/>
-                    </a:solidFill>
-                  </a:tcPr>
-                </a:tc>
-                <a:tc>
-                  <a:txBody>
-                    <a:bodyPr wrap="square"/>
-                    <a:lstStyle/>
-                    <a:p>
-                      <a:pPr algn="ctr"/>
-                      <a:r>
-                        <a:rPr sz="1900" b="0" i="0">
-                          <a:solidFill>
-                            <a:srgbClr val="1F2633"/>
-                          </a:solidFill>
-                          <a:latin typeface="Arial"/>
-                        </a:rPr>
-                        <a:t>10 cm</a:t>
-                      </a:r>
-                    </a:p>
-                  </a:txBody>
-                  <a:tcPr marL="90000" marR="90000" marT="36000" marB="36000" anchor="ctr">
-                    <a:solidFill>
-                      <a:srgbClr val="FFFFFF"/>
-                    </a:solidFill>
-                  </a:tcPr>
-                </a:tc>
-                <a:tc>
-                  <a:txBody>
-                    <a:bodyPr wrap="square"/>
-                    <a:lstStyle/>
-                    <a:p>
-                      <a:pPr algn="ctr"/>
-                      <a:r>
-                        <a:rPr sz="1900" b="0" i="0">
-                          <a:solidFill>
-                            <a:srgbClr val="1F2633"/>
-                          </a:solidFill>
-                          <a:latin typeface="Arial"/>
-                        </a:rPr>
-                        <a:t>−81%</a:t>
-                      </a:r>
-                    </a:p>
-                  </a:txBody>
-                  <a:tcPr marL="90000" marR="90000" marT="36000" marB="36000" anchor="ctr">
-                    <a:solidFill>
-                      <a:srgbClr val="FFFFFF"/>
-                    </a:solidFill>
-                  </a:tcPr>
-                </a:tc>
-              </a:tr>
-              <a:tr h="450000">
-                <a:tc>
-                  <a:txBody>
-                    <a:bodyPr wrap="square"/>
-                    <a:lstStyle/>
-                    <a:p>
-                      <a:pPr algn="l"/>
-                      <a:r>
-                        <a:rPr sz="1900" b="1" i="0">
-                          <a:solidFill>
-                            <a:srgbClr val="1F2633"/>
-                          </a:solidFill>
-                          <a:latin typeface="Arial"/>
-                        </a:rPr>
-                        <a:t>ALT 4h</a:t>
-                      </a:r>
-                    </a:p>
-                  </a:txBody>
-                  <a:tcPr marL="90000" marR="90000" marT="36000" marB="36000" anchor="ctr">
-                    <a:solidFill>
-                      <a:srgbClr val="E6EEF5"/>
-                    </a:solidFill>
-                  </a:tcPr>
-                </a:tc>
-                <a:tc>
-                  <a:txBody>
-                    <a:bodyPr wrap="square"/>
-                    <a:lstStyle/>
-                    <a:p>
-                      <a:pPr algn="ctr"/>
-                      <a:r>
-                        <a:rPr sz="1900" b="0" i="0">
-                          <a:solidFill>
-                            <a:srgbClr val="1F2633"/>
-                          </a:solidFill>
-                          <a:latin typeface="Arial"/>
-                        </a:rPr>
-                        <a:t>0,993</a:t>
-                      </a:r>
-                    </a:p>
-                  </a:txBody>
-                  <a:tcPr marL="90000" marR="90000" marT="36000" marB="36000" anchor="ctr">
-                    <a:solidFill>
-                      <a:srgbClr val="E6EEF5"/>
-                    </a:solidFill>
-                  </a:tcPr>
-                </a:tc>
-                <a:tc>
-                  <a:txBody>
-                    <a:bodyPr wrap="square"/>
-                    <a:lstStyle/>
-                    <a:p>
-                      <a:pPr algn="ctr"/>
-                      <a:r>
-                        <a:rPr sz="1900" b="0" i="0">
-                          <a:solidFill>
-                            <a:srgbClr val="1F2633"/>
-                          </a:solidFill>
-                          <a:latin typeface="Arial"/>
-                        </a:rPr>
-                        <a:t>0,878</a:t>
-                      </a:r>
-                    </a:p>
-                  </a:txBody>
-                  <a:tcPr marL="90000" marR="90000" marT="36000" marB="36000" anchor="ctr">
-                    <a:solidFill>
-                      <a:srgbClr val="E6EEF5"/>
-                    </a:solidFill>
-                  </a:tcPr>
-                </a:tc>
-                <a:tc>
-                  <a:txBody>
-                    <a:bodyPr wrap="square"/>
-                    <a:lstStyle/>
-                    <a:p>
-                      <a:pPr algn="ctr"/>
-                      <a:r>
-                        <a:rPr sz="1900" b="0" i="0">
-                          <a:solidFill>
-                            <a:srgbClr val="1F2633"/>
-                          </a:solidFill>
-                          <a:latin typeface="Arial"/>
-                        </a:rPr>
-                        <a:t>14,0 cm</a:t>
-                      </a:r>
-                    </a:p>
-                  </a:txBody>
-                  <a:tcPr marL="90000" marR="90000" marT="36000" marB="36000" anchor="ctr">
-                    <a:solidFill>
-                      <a:srgbClr val="E6EEF5"/>
-                    </a:solidFill>
-                  </a:tcPr>
-                </a:tc>
-                <a:tc>
-                  <a:txBody>
-                    <a:bodyPr wrap="square"/>
-                    <a:lstStyle/>
-                    <a:p>
-                      <a:pPr algn="ctr"/>
-                      <a:r>
-                        <a:rPr sz="1900" b="0" i="0">
-                          <a:solidFill>
-                            <a:srgbClr val="1F2633"/>
-                          </a:solidFill>
-                          <a:latin typeface="Arial"/>
-                        </a:rPr>
-                        <a:t>59 cm</a:t>
-                      </a:r>
-                    </a:p>
-                  </a:txBody>
-                  <a:tcPr marL="90000" marR="90000" marT="36000" marB="36000" anchor="ctr">
-                    <a:solidFill>
-                      <a:srgbClr val="E6EEF5"/>
-                    </a:solidFill>
-                  </a:tcPr>
-                </a:tc>
-                <a:tc>
-                  <a:txBody>
-                    <a:bodyPr wrap="square"/>
-                    <a:lstStyle/>
-                    <a:p>
-                      <a:pPr algn="ctr"/>
-                      <a:r>
-                        <a:rPr sz="1900" b="0" i="0">
-                          <a:solidFill>
-                            <a:srgbClr val="1F2633"/>
-                          </a:solidFill>
-                          <a:latin typeface="Arial"/>
-                        </a:rPr>
-                        <a:t>−65%</a:t>
-                      </a:r>
-                    </a:p>
-                  </a:txBody>
-                  <a:tcPr marL="90000" marR="90000" marT="36000" marB="36000" anchor="ctr">
-                    <a:solidFill>
-                      <a:srgbClr val="E6EEF5"/>
-                    </a:solidFill>
-                  </a:tcPr>
-                </a:tc>
-              </a:tr>
-              <a:tr h="450000">
-                <a:tc>
-                  <a:txBody>
-                    <a:bodyPr wrap="square"/>
-                    <a:lstStyle/>
-                    <a:p>
-                      <a:pPr algn="l"/>
-                      <a:r>
-                        <a:rPr sz="1900" b="1" i="0">
-                          <a:solidFill>
-                            <a:srgbClr val="1F2633"/>
-                          </a:solidFill>
-                          <a:latin typeface="Arial"/>
-                        </a:rPr>
-                        <a:t>ALT 8h</a:t>
-                      </a:r>
-                    </a:p>
-                  </a:txBody>
-                  <a:tcPr marL="90000" marR="90000" marT="36000" marB="36000" anchor="ctr">
-                    <a:solidFill>
-                      <a:srgbClr val="FFFFFF"/>
-                    </a:solidFill>
-                  </a:tcPr>
-                </a:tc>
-                <a:tc>
-                  <a:txBody>
-                    <a:bodyPr wrap="square"/>
-                    <a:lstStyle/>
-                    <a:p>
-                      <a:pPr algn="ctr"/>
-                      <a:r>
-                        <a:rPr sz="1900" b="0" i="0">
-                          <a:solidFill>
-                            <a:srgbClr val="1F2633"/>
-                          </a:solidFill>
-                          <a:latin typeface="Arial"/>
-                        </a:rPr>
-                        <a:t>0,979</a:t>
-                      </a:r>
-                    </a:p>
-                  </a:txBody>
-                  <a:tcPr marL="90000" marR="90000" marT="36000" marB="36000" anchor="ctr">
-                    <a:solidFill>
-                      <a:srgbClr val="FFFFFF"/>
-                    </a:solidFill>
-                  </a:tcPr>
-                </a:tc>
-                <a:tc>
-                  <a:txBody>
-                    <a:bodyPr wrap="square"/>
-                    <a:lstStyle/>
-                    <a:p>
-                      <a:pPr algn="ctr"/>
-                      <a:r>
-                        <a:rPr sz="1900" b="0" i="0">
-                          <a:solidFill>
-                            <a:srgbClr val="1F2633"/>
-                          </a:solidFill>
-                          <a:latin typeface="Arial"/>
-                        </a:rPr>
-                        <a:t>0,927</a:t>
-                      </a:r>
-                    </a:p>
-                  </a:txBody>
-                  <a:tcPr marL="90000" marR="90000" marT="36000" marB="36000" anchor="ctr">
-                    <a:solidFill>
-                      <a:srgbClr val="FFFFFF"/>
-                    </a:solidFill>
-                  </a:tcPr>
-                </a:tc>
-                <a:tc>
-                  <a:txBody>
-                    <a:bodyPr wrap="square"/>
-                    <a:lstStyle/>
-                    <a:p>
-                      <a:pPr algn="ctr"/>
-                      <a:r>
-                        <a:rPr sz="1900" b="0" i="0">
-                          <a:solidFill>
-                            <a:srgbClr val="1F2633"/>
-                          </a:solidFill>
-                          <a:latin typeface="Arial"/>
-                        </a:rPr>
-                        <a:t>23,3 cm</a:t>
-                      </a:r>
-                    </a:p>
-                  </a:txBody>
-                  <a:tcPr marL="90000" marR="90000" marT="36000" marB="36000" anchor="ctr">
-                    <a:solidFill>
-                      <a:srgbClr val="FFFFFF"/>
-                    </a:solidFill>
-                  </a:tcPr>
-                </a:tc>
-                <a:tc>
-                  <a:txBody>
-                    <a:bodyPr wrap="square"/>
-                    <a:lstStyle/>
-                    <a:p>
-                      <a:pPr algn="ctr"/>
-                      <a:r>
-                        <a:rPr sz="1900" b="0" i="0">
-                          <a:solidFill>
-                            <a:srgbClr val="1F2633"/>
-                          </a:solidFill>
-                          <a:latin typeface="Arial"/>
-                        </a:rPr>
-                        <a:t>64 cm</a:t>
-                      </a:r>
-                    </a:p>
-                  </a:txBody>
-                  <a:tcPr marL="90000" marR="90000" marT="36000" marB="36000" anchor="ctr">
-                    <a:solidFill>
-                      <a:srgbClr val="FFFFFF"/>
-                    </a:solidFill>
-                  </a:tcPr>
-                </a:tc>
-                <a:tc>
-                  <a:txBody>
-                    <a:bodyPr wrap="square"/>
-                    <a:lstStyle/>
-                    <a:p>
-                      <a:pPr algn="ctr"/>
-                      <a:r>
-                        <a:rPr sz="1900" b="0" i="0">
-                          <a:solidFill>
-                            <a:srgbClr val="1F2633"/>
-                          </a:solidFill>
-                          <a:latin typeface="Arial"/>
-                        </a:rPr>
-                        <a:t>−69%</a:t>
-                      </a:r>
-                    </a:p>
-                  </a:txBody>
-                  <a:tcPr marL="90000" marR="90000" marT="36000" marB="36000" anchor="ctr">
-                    <a:solidFill>
-                      <a:srgbClr val="FFFFFF"/>
-                    </a:solidFill>
-                  </a:tcPr>
-                </a:tc>
-              </a:tr>
-            </a:tbl>
-          </a:graphicData>
-        </a:graphic>
-      </p:graphicFrame>
-      <p:sp>
-        <p:nvSpPr>
-          <p:cNvPr id="38" name="Legenda tabela"/>
-          <p:cNvSpPr txBox="1"/>
-          <p:nvPr/>
-        </p:nvSpPr>
-        <p:spPr>
-          <a:xfrm>
-            <a:off x="1080000" y="28258385"/>
-            <a:ext cx="9360000" cy="288000"/>
-          </a:xfrm>
-          <a:prstGeom prst="rect">
-            <a:avLst/>
-          </a:prstGeom>
-          <a:noFill/>
-        </p:spPr>
-        <p:txBody>
-          <a:bodyPr wrap="square" lIns="0" rIns="0" tIns="0" bIns="0" anchor="t">
-            <a:spAutoFit/>
-          </a:bodyPr>
-          <a:lstStyle/>
-          <a:p>
-            <a:pPr algn="l">
-              <a:lnSpc>
-                <a:spcPct val="108000"/>
-              </a:lnSpc>
-              <a:spcAft>
-                <a:spcPts val="600"/>
-              </a:spcAft>
-            </a:pPr>
-            <a:r>
-              <a:rPr sz="1800" b="0" i="0">
-                <a:solidFill>
-                  <a:srgbClr val="5B6573"/>
-                </a:solidFill>
-                <a:latin typeface="Arial"/>
-              </a:rPr>
-              <a:t>Tabela 1 – Desempenho no conjunto de teste (eventos não usados no treinamento).</a:t>
-            </a:r>
-          </a:p>
-        </p:txBody>
-      </p:sp>
-      <p:sp>
-        <p:nvSpPr>
-          <p:cNvPr id="39" name="Secao CONCLUSÕES"/>
+          <a:bodyPr rtlCol="0" anchor="ctr"/>
+          <a:lstStyle/>
+          <a:p>
+            <a:pPr algn="ctr"/>
+          </a:p>
+        </p:txBody>
+      </p:sp>
+      <p:sp>
+        <p:nvSpPr>
+          <p:cNvPr id="32" name="Etapa 4"/>
           <p:cNvSpPr/>
           <p:nvPr/>
         </p:nvSpPr>
         <p:spPr>
           <a:xfrm>
-            <a:off x="1080000" y="28690385"/>
-            <a:ext cx="3456000" cy="504000"/>
+            <a:off x="15984000" y="15480000"/>
+            <a:ext cx="4248000" cy="1584000"/>
           </a:xfrm>
           <a:prstGeom prst="roundRect">
             <a:avLst>
-              <a:gd name="adj" fmla="val 50000"/>
+              <a:gd name="adj" fmla="val 12000"/>
             </a:avLst>
           </a:prstGeom>
           <a:solidFill>
@@ -5961,171 +4675,52 @@
           </a:fontRef>
         </p:style>
         <p:txBody>
-          <a:bodyPr rtlCol="0" anchor="ctr" wrap="none" lIns="252000" rIns="252000" tIns="0" bIns="0"/>
-          <a:lstStyle/>
-          <a:p>
-            <a:pPr algn="l"/>
-            <a:r>
-              <a:rPr sz="3000" b="1" i="0">
+          <a:bodyPr rtlCol="0" anchor="ctr" wrap="square" lIns="144000" rIns="144000" tIns="72000" bIns="72000"/>
+          <a:lstStyle/>
+          <a:p>
+            <a:pPr algn="ctr"/>
+            <a:r>
+              <a:rPr sz="2600" b="1" i="0">
                 <a:solidFill>
                   <a:srgbClr val="FFFFFF"/>
                 </a:solidFill>
                 <a:latin typeface="Arial"/>
               </a:rPr>
-              <a:t>CONCLUSÕES</a:t>
-            </a:r>
-          </a:p>
-        </p:txBody>
-      </p:sp>
-      <p:sp>
-        <p:nvSpPr>
-          <p:cNvPr id="40" name="Texto conclusoes"/>
-          <p:cNvSpPr txBox="1"/>
-          <p:nvPr/>
-        </p:nvSpPr>
-        <p:spPr>
-          <a:xfrm>
-            <a:off x="1080000" y="29374385"/>
-            <a:ext cx="9360000" cy="3960000"/>
-          </a:xfrm>
-          <a:prstGeom prst="rect">
-            <a:avLst/>
-          </a:prstGeom>
-          <a:noFill/>
-        </p:spPr>
-        <p:txBody>
-          <a:bodyPr wrap="square" lIns="0" rIns="0" tIns="0" bIns="0" anchor="t">
-            <a:spAutoFit/>
-          </a:bodyPr>
-          <a:lstStyle/>
-          <a:p>
-            <a:pPr algn="l" marL="252000" indent="-252000">
-              <a:lnSpc>
-                <a:spcPct val="108000"/>
-              </a:lnSpc>
-              <a:spcAft>
-                <a:spcPts val="500"/>
-              </a:spcAft>
-              <a:buClr>
-                <a:srgbClr val="D9661F"/>
-              </a:buClr>
-              <a:buFont typeface="Arial"/>
-              <a:buChar char="■"/>
-            </a:pPr>
-            <a:r>
-              <a:rPr sz="2000" b="0" i="0">
-                <a:solidFill>
-                  <a:srgbClr val="1F2633"/>
+              <a:t>Nível previsto</a:t>
+            </a:r>
+          </a:p>
+          <a:p>
+            <a:pPr algn="ctr"/>
+            <a:r>
+              <a:rPr sz="1900" b="0" i="0">
+                <a:solidFill>
+                  <a:srgbClr val="FFFFFF"/>
                 </a:solidFill>
                 <a:latin typeface="Arial"/>
               </a:rPr>
-              <a:t>Nos três horizontes, a abordagem ALT alcançou </a:t>
-            </a:r>
-            <a:r>
-              <a:rPr sz="2000" b="1" i="0">
-                <a:solidFill>
-                  <a:srgbClr val="1F2633"/>
-                </a:solidFill>
-                <a:latin typeface="Arial"/>
-              </a:rPr>
-              <a:t>NSE ≥ 0,979</a:t>
-            </a:r>
-            <a:r>
-              <a:rPr sz="2000" b="0" i="0">
-                <a:solidFill>
-                  <a:srgbClr val="1F2633"/>
-                </a:solidFill>
-                <a:latin typeface="Arial"/>
-              </a:rPr>
-              <a:t> e </a:t>
-            </a:r>
-            <a:r>
-              <a:rPr sz="2000" b="1" i="0">
-                <a:solidFill>
-                  <a:srgbClr val="1F2633"/>
-                </a:solidFill>
-                <a:latin typeface="Arial"/>
-              </a:rPr>
-              <a:t>PME de 0,88 a 0,97</a:t>
-            </a:r>
-            <a:r>
-              <a:rPr sz="2000" b="0" i="0">
-                <a:solidFill>
-                  <a:srgbClr val="1F2633"/>
-                </a:solidFill>
-                <a:latin typeface="Arial"/>
-              </a:rPr>
-              <a:t> no teste.</a:t>
-            </a:r>
-          </a:p>
-          <a:p>
-            <a:pPr algn="l" marL="252000" indent="-252000">
-              <a:lnSpc>
-                <a:spcPct val="108000"/>
-              </a:lnSpc>
-              <a:spcAft>
-                <a:spcPts val="500"/>
-              </a:spcAft>
-              <a:buClr>
-                <a:srgbClr val="D9661F"/>
-              </a:buClr>
-              <a:buFont typeface="Arial"/>
-              <a:buChar char="■"/>
-            </a:pPr>
-            <a:r>
-              <a:rPr sz="2000" b="0" i="0">
-                <a:solidFill>
-                  <a:srgbClr val="1F2633"/>
-                </a:solidFill>
-                <a:latin typeface="Arial"/>
-              </a:rPr>
-              <a:t>O erro médio cai 65–81% frente à persistência e cresce com a antecedência (de 3,5 a 23 cm).</a:t>
-            </a:r>
-          </a:p>
-          <a:p>
-            <a:pPr algn="l" marL="252000" indent="-252000">
-              <a:lnSpc>
-                <a:spcPct val="108000"/>
-              </a:lnSpc>
-              <a:spcAft>
-                <a:spcPts val="500"/>
-              </a:spcAft>
-              <a:buClr>
-                <a:srgbClr val="D9661F"/>
-              </a:buClr>
-              <a:buFont typeface="Arial"/>
-              <a:buChar char="■"/>
-            </a:pPr>
-            <a:r>
-              <a:rPr sz="2000" b="0" i="0">
-                <a:solidFill>
-                  <a:srgbClr val="1F2633"/>
-                </a:solidFill>
-                <a:latin typeface="Arial"/>
-              </a:rPr>
-              <a:t>Em tempo real, o modelo 2h acompanhou a cheia de set/2026 com erro médio de 9 cm: potencial de uso operacional no alerta de Santa Tereza.</a:t>
-            </a:r>
-          </a:p>
-        </p:txBody>
-      </p:sp>
-      <p:sp>
-        <p:nvSpPr>
-          <p:cNvPr id="41" name="Secao OPERAÇÃO EM TEMPO REAL"/>
+              <a:t>Ĥ(t+h) = H(t) + ΔH</a:t>
+            </a:r>
+          </a:p>
+        </p:txBody>
+      </p:sp>
+      <p:sp>
+        <p:nvSpPr>
+          <p:cNvPr id="33" name="Config 2h"/>
           <p:cNvSpPr/>
           <p:nvPr/>
         </p:nvSpPr>
         <p:spPr>
           <a:xfrm>
-            <a:off x="10944000" y="26386385"/>
-            <a:ext cx="6652800" cy="504000"/>
+            <a:off x="1080000" y="17316000"/>
+            <a:ext cx="6168000" cy="504000"/>
           </a:xfrm>
           <a:prstGeom prst="roundRect">
             <a:avLst>
-              <a:gd name="adj" fmla="val 50000"/>
+              <a:gd name="adj" fmla="val 12000"/>
             </a:avLst>
           </a:prstGeom>
           <a:solidFill>
-            <a:srgbClr val="2A378D"/>
+            <a:srgbClr val="FFFFFF"/>
           </a:solidFill>
           <a:ln>
             <a:noFill/>
@@ -6147,6 +4742,360 @@
           </a:fontRef>
         </p:style>
         <p:txBody>
+          <a:bodyPr rtlCol="0" anchor="ctr" wrap="square" lIns="108000" rIns="108000" tIns="36000" bIns="36000"/>
+          <a:lstStyle/>
+          <a:p>
+            <a:pPr algn="ctr"/>
+            <a:r>
+              <a:rPr sz="4000" b="1" i="0">
+                <a:solidFill>
+                  <a:srgbClr val="2A378D"/>
+                </a:solidFill>
+                <a:latin typeface="Arial"/>
+              </a:rPr>
+              <a:t/>
+            </a:r>
+          </a:p>
+          <a:p>
+            <a:pPr algn="ctr"/>
+            <a:r>
+              <a:rPr sz="1800" b="0" i="0">
+                <a:solidFill>
+                  <a:srgbClr val="1F2633"/>
+                </a:solidFill>
+                <a:latin typeface="Arial"/>
+              </a:rPr>
+              <a:t/>
+            </a:r>
+          </a:p>
+        </p:txBody>
+      </p:sp>
+      <p:sp>
+        <p:nvSpPr>
+          <p:cNvPr id="34" name="Texto config 2h"/>
+          <p:cNvSpPr txBox="1"/>
+          <p:nvPr/>
+        </p:nvSpPr>
+        <p:spPr>
+          <a:xfrm>
+            <a:off x="1080000" y="17388000"/>
+            <a:ext cx="6168000" cy="360000"/>
+          </a:xfrm>
+          <a:prstGeom prst="rect">
+            <a:avLst/>
+          </a:prstGeom>
+          <a:noFill/>
+        </p:spPr>
+        <p:txBody>
+          <a:bodyPr wrap="square" lIns="0" rIns="0" tIns="0" bIns="0" anchor="t">
+            <a:spAutoFit/>
+          </a:bodyPr>
+          <a:lstStyle/>
+          <a:p>
+            <a:pPr algn="ctr">
+              <a:lnSpc>
+                <a:spcPct val="108000"/>
+              </a:lnSpc>
+              <a:spcAft>
+                <a:spcPts val="600"/>
+              </a:spcAft>
+            </a:pPr>
+            <a:r>
+              <a:rPr sz="2100" b="1" i="0">
+                <a:solidFill>
+                  <a:srgbClr val="2A378D"/>
+                </a:solidFill>
+                <a:latin typeface="Arial"/>
+              </a:rPr>
+              <a:t>ALT 2h: </a:t>
+            </a:r>
+            <a:r>
+              <a:rPr sz="2100" b="0" i="0">
+                <a:solidFill>
+                  <a:srgbClr val="1F2633"/>
+                </a:solidFill>
+                <a:latin typeface="Arial"/>
+              </a:rPr>
+              <a:t>15 entradas · 30 neurônios</a:t>
+            </a:r>
+          </a:p>
+        </p:txBody>
+      </p:sp>
+      <p:sp>
+        <p:nvSpPr>
+          <p:cNvPr id="35" name="Config 4h"/>
+          <p:cNvSpPr/>
+          <p:nvPr/>
+        </p:nvSpPr>
+        <p:spPr>
+          <a:xfrm>
+            <a:off x="7608000" y="17316000"/>
+            <a:ext cx="6168000" cy="504000"/>
+          </a:xfrm>
+          <a:prstGeom prst="roundRect">
+            <a:avLst>
+              <a:gd name="adj" fmla="val 12000"/>
+            </a:avLst>
+          </a:prstGeom>
+          <a:solidFill>
+            <a:srgbClr val="FFFFFF"/>
+          </a:solidFill>
+          <a:ln>
+            <a:noFill/>
+          </a:ln>
+          <a:effectLst/>
+        </p:spPr>
+        <p:style>
+          <a:lnRef idx="1">
+            <a:schemeClr val="accent1"/>
+          </a:lnRef>
+          <a:fillRef idx="3">
+            <a:schemeClr val="accent1"/>
+          </a:fillRef>
+          <a:effectRef idx="2">
+            <a:schemeClr val="accent1"/>
+          </a:effectRef>
+          <a:fontRef idx="minor">
+            <a:schemeClr val="lt1"/>
+          </a:fontRef>
+        </p:style>
+        <p:txBody>
+          <a:bodyPr rtlCol="0" anchor="ctr" wrap="square" lIns="108000" rIns="108000" tIns="36000" bIns="36000"/>
+          <a:lstStyle/>
+          <a:p>
+            <a:pPr algn="ctr"/>
+            <a:r>
+              <a:rPr sz="4000" b="1" i="0">
+                <a:solidFill>
+                  <a:srgbClr val="2A378D"/>
+                </a:solidFill>
+                <a:latin typeface="Arial"/>
+              </a:rPr>
+              <a:t/>
+            </a:r>
+          </a:p>
+          <a:p>
+            <a:pPr algn="ctr"/>
+            <a:r>
+              <a:rPr sz="1800" b="0" i="0">
+                <a:solidFill>
+                  <a:srgbClr val="1F2633"/>
+                </a:solidFill>
+                <a:latin typeface="Arial"/>
+              </a:rPr>
+              <a:t/>
+            </a:r>
+          </a:p>
+        </p:txBody>
+      </p:sp>
+      <p:sp>
+        <p:nvSpPr>
+          <p:cNvPr id="36" name="Texto config 4h"/>
+          <p:cNvSpPr txBox="1"/>
+          <p:nvPr/>
+        </p:nvSpPr>
+        <p:spPr>
+          <a:xfrm>
+            <a:off x="7608000" y="17388000"/>
+            <a:ext cx="6168000" cy="360000"/>
+          </a:xfrm>
+          <a:prstGeom prst="rect">
+            <a:avLst/>
+          </a:prstGeom>
+          <a:noFill/>
+        </p:spPr>
+        <p:txBody>
+          <a:bodyPr wrap="square" lIns="0" rIns="0" tIns="0" bIns="0" anchor="t">
+            <a:spAutoFit/>
+          </a:bodyPr>
+          <a:lstStyle/>
+          <a:p>
+            <a:pPr algn="ctr">
+              <a:lnSpc>
+                <a:spcPct val="108000"/>
+              </a:lnSpc>
+              <a:spcAft>
+                <a:spcPts val="600"/>
+              </a:spcAft>
+            </a:pPr>
+            <a:r>
+              <a:rPr sz="2100" b="1" i="0">
+                <a:solidFill>
+                  <a:srgbClr val="2A378D"/>
+                </a:solidFill>
+                <a:latin typeface="Arial"/>
+              </a:rPr>
+              <a:t>ALT 4h: </a:t>
+            </a:r>
+            <a:r>
+              <a:rPr sz="2100" b="0" i="0">
+                <a:solidFill>
+                  <a:srgbClr val="1F2633"/>
+                </a:solidFill>
+                <a:latin typeface="Arial"/>
+              </a:rPr>
+              <a:t>26 entradas · 52 neurônios</a:t>
+            </a:r>
+          </a:p>
+        </p:txBody>
+      </p:sp>
+      <p:sp>
+        <p:nvSpPr>
+          <p:cNvPr id="37" name="Config 8h"/>
+          <p:cNvSpPr/>
+          <p:nvPr/>
+        </p:nvSpPr>
+        <p:spPr>
+          <a:xfrm>
+            <a:off x="14136000" y="17316000"/>
+            <a:ext cx="6168000" cy="504000"/>
+          </a:xfrm>
+          <a:prstGeom prst="roundRect">
+            <a:avLst>
+              <a:gd name="adj" fmla="val 12000"/>
+            </a:avLst>
+          </a:prstGeom>
+          <a:solidFill>
+            <a:srgbClr val="FFFFFF"/>
+          </a:solidFill>
+          <a:ln>
+            <a:noFill/>
+          </a:ln>
+          <a:effectLst/>
+        </p:spPr>
+        <p:style>
+          <a:lnRef idx="1">
+            <a:schemeClr val="accent1"/>
+          </a:lnRef>
+          <a:fillRef idx="3">
+            <a:schemeClr val="accent1"/>
+          </a:fillRef>
+          <a:effectRef idx="2">
+            <a:schemeClr val="accent1"/>
+          </a:effectRef>
+          <a:fontRef idx="minor">
+            <a:schemeClr val="lt1"/>
+          </a:fontRef>
+        </p:style>
+        <p:txBody>
+          <a:bodyPr rtlCol="0" anchor="ctr" wrap="square" lIns="108000" rIns="108000" tIns="36000" bIns="36000"/>
+          <a:lstStyle/>
+          <a:p>
+            <a:pPr algn="ctr"/>
+            <a:r>
+              <a:rPr sz="4000" b="1" i="0">
+                <a:solidFill>
+                  <a:srgbClr val="2A378D"/>
+                </a:solidFill>
+                <a:latin typeface="Arial"/>
+              </a:rPr>
+              <a:t/>
+            </a:r>
+          </a:p>
+          <a:p>
+            <a:pPr algn="ctr"/>
+            <a:r>
+              <a:rPr sz="1800" b="0" i="0">
+                <a:solidFill>
+                  <a:srgbClr val="1F2633"/>
+                </a:solidFill>
+                <a:latin typeface="Arial"/>
+              </a:rPr>
+              <a:t/>
+            </a:r>
+          </a:p>
+        </p:txBody>
+      </p:sp>
+      <p:sp>
+        <p:nvSpPr>
+          <p:cNvPr id="38" name="Texto config 8h"/>
+          <p:cNvSpPr txBox="1"/>
+          <p:nvPr/>
+        </p:nvSpPr>
+        <p:spPr>
+          <a:xfrm>
+            <a:off x="14136000" y="17388000"/>
+            <a:ext cx="6168000" cy="360000"/>
+          </a:xfrm>
+          <a:prstGeom prst="rect">
+            <a:avLst/>
+          </a:prstGeom>
+          <a:noFill/>
+        </p:spPr>
+        <p:txBody>
+          <a:bodyPr wrap="square" lIns="0" rIns="0" tIns="0" bIns="0" anchor="t">
+            <a:spAutoFit/>
+          </a:bodyPr>
+          <a:lstStyle/>
+          <a:p>
+            <a:pPr algn="ctr">
+              <a:lnSpc>
+                <a:spcPct val="108000"/>
+              </a:lnSpc>
+              <a:spcAft>
+                <a:spcPts val="600"/>
+              </a:spcAft>
+            </a:pPr>
+            <a:r>
+              <a:rPr sz="2100" b="1" i="0">
+                <a:solidFill>
+                  <a:srgbClr val="2A378D"/>
+                </a:solidFill>
+                <a:latin typeface="Arial"/>
+              </a:rPr>
+              <a:t>ALT 8h: </a:t>
+            </a:r>
+            <a:r>
+              <a:rPr sz="2100" b="0" i="0">
+                <a:solidFill>
+                  <a:srgbClr val="1F2633"/>
+                </a:solidFill>
+                <a:latin typeface="Arial"/>
+              </a:rPr>
+              <a:t>31 entradas · 63 neurônios</a:t>
+            </a:r>
+          </a:p>
+        </p:txBody>
+      </p:sp>
+      <p:sp>
+        <p:nvSpPr>
+          <p:cNvPr id="39" name="Secao RESULTADOS NO TESTE"/>
+          <p:cNvSpPr/>
+          <p:nvPr/>
+        </p:nvSpPr>
+        <p:spPr>
+          <a:xfrm>
+            <a:off x="1080000" y="18252000"/>
+            <a:ext cx="5853600" cy="504000"/>
+          </a:xfrm>
+          <a:prstGeom prst="roundRect">
+            <a:avLst>
+              <a:gd name="adj" fmla="val 50000"/>
+            </a:avLst>
+          </a:prstGeom>
+          <a:solidFill>
+            <a:srgbClr val="2A378D"/>
+          </a:solidFill>
+          <a:ln>
+            <a:noFill/>
+          </a:ln>
+          <a:effectLst/>
+        </p:spPr>
+        <p:style>
+          <a:lnRef idx="1">
+            <a:schemeClr val="accent1"/>
+          </a:lnRef>
+          <a:fillRef idx="3">
+            <a:schemeClr val="accent1"/>
+          </a:fillRef>
+          <a:effectRef idx="2">
+            <a:schemeClr val="accent1"/>
+          </a:effectRef>
+          <a:fontRef idx="minor">
+            <a:schemeClr val="lt1"/>
+          </a:fontRef>
+        </p:style>
+        <p:txBody>
           <a:bodyPr rtlCol="0" anchor="ctr" wrap="none" lIns="252000" rIns="252000" tIns="0" bIns="0"/>
           <a:lstStyle/>
           <a:p>
@@ -6158,14 +5107,135 @@
                 </a:solidFill>
                 <a:latin typeface="Arial"/>
               </a:rPr>
-              <a:t>OPERAÇÃO EM TEMPO REAL</a:t>
+              <a:t>RESULTADOS NO TESTE</a:t>
             </a:r>
           </a:p>
         </p:txBody>
       </p:sp>
       <p:pic>
         <p:nvPicPr>
-          <p:cNvPr id="42" name="Operacao ao vivo 2h" descr="ao_vivo_2h.png"/>
+          <p:cNvPr id="40" name="Dispersao previsto x observado" descr="dispersao.png"/>
+          <p:cNvPicPr>
+            <a:picLocks noChangeAspect="1"/>
+          </p:cNvPicPr>
+          <p:nvPr/>
+        </p:nvPicPr>
+        <p:blipFill>
+          <a:blip r:embed="rId10"/>
+          <a:stretch>
+            <a:fillRect/>
+          </a:stretch>
+        </p:blipFill>
+        <p:spPr>
+          <a:xfrm>
+            <a:off x="2502000" y="18864000"/>
+            <a:ext cx="16380000" cy="6195000"/>
+          </a:xfrm>
+          <a:prstGeom prst="rect">
+            <a:avLst/>
+          </a:prstGeom>
+        </p:spPr>
+      </p:pic>
+      <p:sp>
+        <p:nvSpPr>
+          <p:cNvPr id="41" name="Legenda dispersao"/>
+          <p:cNvSpPr txBox="1"/>
+          <p:nvPr/>
+        </p:nvSpPr>
+        <p:spPr>
+          <a:xfrm>
+            <a:off x="1080000" y="25095000"/>
+            <a:ext cx="19224000" cy="288000"/>
+          </a:xfrm>
+          <a:prstGeom prst="rect">
+            <a:avLst/>
+          </a:prstGeom>
+          <a:noFill/>
+        </p:spPr>
+        <p:txBody>
+          <a:bodyPr wrap="square" lIns="0" rIns="0" tIns="0" bIns="0" anchor="t">
+            <a:spAutoFit/>
+          </a:bodyPr>
+          <a:lstStyle/>
+          <a:p>
+            <a:pPr algn="ctr">
+              <a:lnSpc>
+                <a:spcPct val="108000"/>
+              </a:lnSpc>
+              <a:spcAft>
+                <a:spcPts val="600"/>
+              </a:spcAft>
+            </a:pPr>
+            <a:r>
+              <a:rPr sz="1800" b="0" i="0">
+                <a:solidFill>
+                  <a:srgbClr val="5B6573"/>
+                </a:solidFill>
+                <a:latin typeface="Arial"/>
+              </a:rPr>
+              <a:t>Figura 2 – Nível previsto × observado. Métricas no conjunto de teste (eventos não usados no treino).</a:t>
+            </a:r>
+          </a:p>
+        </p:txBody>
+      </p:sp>
+      <p:sp>
+        <p:nvSpPr>
+          <p:cNvPr id="42" name="Secao CHEIA DE JUL/2023 · 8 h"/>
+          <p:cNvSpPr/>
+          <p:nvPr/>
+        </p:nvSpPr>
+        <p:spPr>
+          <a:xfrm>
+            <a:off x="1080000" y="25527000"/>
+            <a:ext cx="6919200" cy="504000"/>
+          </a:xfrm>
+          <a:prstGeom prst="roundRect">
+            <a:avLst>
+              <a:gd name="adj" fmla="val 50000"/>
+            </a:avLst>
+          </a:prstGeom>
+          <a:solidFill>
+            <a:srgbClr val="2A378D"/>
+          </a:solidFill>
+          <a:ln>
+            <a:noFill/>
+          </a:ln>
+          <a:effectLst/>
+        </p:spPr>
+        <p:style>
+          <a:lnRef idx="1">
+            <a:schemeClr val="accent1"/>
+          </a:lnRef>
+          <a:fillRef idx="3">
+            <a:schemeClr val="accent1"/>
+          </a:fillRef>
+          <a:effectRef idx="2">
+            <a:schemeClr val="accent1"/>
+          </a:effectRef>
+          <a:fontRef idx="minor">
+            <a:schemeClr val="lt1"/>
+          </a:fontRef>
+        </p:style>
+        <p:txBody>
+          <a:bodyPr rtlCol="0" anchor="ctr" wrap="none" lIns="252000" rIns="252000" tIns="0" bIns="0"/>
+          <a:lstStyle/>
+          <a:p>
+            <a:pPr algn="l"/>
+            <a:r>
+              <a:rPr sz="3000" b="1" i="0">
+                <a:solidFill>
+                  <a:srgbClr val="FFFFFF"/>
+                </a:solidFill>
+                <a:latin typeface="Arial"/>
+              </a:rPr>
+              <a:t>CHEIA DE JUL/2023 · 8 h</a:t>
+            </a:r>
+          </a:p>
+        </p:txBody>
+      </p:sp>
+      <p:pic>
+        <p:nvPicPr>
+          <p:cNvPr id="43" name="Evento de teste 8h" descr="teste_8h.png"/>
           <p:cNvPicPr>
             <a:picLocks noChangeAspect="1"/>
           </p:cNvPicPr>
@@ -6179,8 +5249,8 @@
         </p:blipFill>
         <p:spPr>
           <a:xfrm>
-            <a:off x="10944000" y="27034385"/>
-            <a:ext cx="8496000" cy="4099814"/>
+            <a:off x="1080000" y="26175000"/>
+            <a:ext cx="9360000" cy="4516744"/>
           </a:xfrm>
           <a:prstGeom prst="rect">
             <a:avLst/>
@@ -6189,13 +5259,13 @@
       </p:pic>
       <p:sp>
         <p:nvSpPr>
-          <p:cNvPr id="43" name="Legenda ao vivo"/>
+          <p:cNvPr id="44" name="Legenda teste 8h"/>
           <p:cNvSpPr txBox="1"/>
           <p:nvPr/>
         </p:nvSpPr>
         <p:spPr>
           <a:xfrm>
-            <a:off x="10944000" y="31170199"/>
+            <a:off x="1080000" y="30727744"/>
             <a:ext cx="9360000" cy="288000"/>
           </a:xfrm>
           <a:prstGeom prst="rect">
@@ -6224,21 +5294,100 @@
                 </a:solidFill>
                 <a:latin typeface="Arial"/>
               </a:rPr>
-              <a:t>Figura 3 – Previsão ao vivo 2h × telemetria (25/09 a 05/10/2026).</a:t>
-            </a:r>
-          </a:p>
-        </p:txBody>
-      </p:sp>
-      <p:sp>
-        <p:nvSpPr>
-          <p:cNvPr id="44" name="Texto ao vivo"/>
+              <a:t>Figura 3 – A RNA antecipa a subida; a persistência chega 8 h atrasada.</a:t>
+            </a:r>
+          </a:p>
+        </p:txBody>
+      </p:sp>
+      <p:sp>
+        <p:nvSpPr>
+          <p:cNvPr id="45" name="Secao AO VIVO · SET/2026 · 2 h"/>
+          <p:cNvSpPr/>
+          <p:nvPr/>
+        </p:nvSpPr>
+        <p:spPr>
+          <a:xfrm>
+            <a:off x="10944000" y="25527000"/>
+            <a:ext cx="7185600" cy="504000"/>
+          </a:xfrm>
+          <a:prstGeom prst="roundRect">
+            <a:avLst>
+              <a:gd name="adj" fmla="val 50000"/>
+            </a:avLst>
+          </a:prstGeom>
+          <a:solidFill>
+            <a:srgbClr val="2A378D"/>
+          </a:solidFill>
+          <a:ln>
+            <a:noFill/>
+          </a:ln>
+          <a:effectLst/>
+        </p:spPr>
+        <p:style>
+          <a:lnRef idx="1">
+            <a:schemeClr val="accent1"/>
+          </a:lnRef>
+          <a:fillRef idx="3">
+            <a:schemeClr val="accent1"/>
+          </a:fillRef>
+          <a:effectRef idx="2">
+            <a:schemeClr val="accent1"/>
+          </a:effectRef>
+          <a:fontRef idx="minor">
+            <a:schemeClr val="lt1"/>
+          </a:fontRef>
+        </p:style>
+        <p:txBody>
+          <a:bodyPr rtlCol="0" anchor="ctr" wrap="none" lIns="252000" rIns="252000" tIns="0" bIns="0"/>
+          <a:lstStyle/>
+          <a:p>
+            <a:pPr algn="l"/>
+            <a:r>
+              <a:rPr sz="3000" b="1" i="0">
+                <a:solidFill>
+                  <a:srgbClr val="FFFFFF"/>
+                </a:solidFill>
+                <a:latin typeface="Arial"/>
+              </a:rPr>
+              <a:t>AO VIVO · SET/2026 · 2 h</a:t>
+            </a:r>
+          </a:p>
+        </p:txBody>
+      </p:sp>
+      <p:pic>
+        <p:nvPicPr>
+          <p:cNvPr id="46" name="Operacao ao vivo 2h" descr="ao_vivo_2h.png"/>
+          <p:cNvPicPr>
+            <a:picLocks noChangeAspect="1"/>
+          </p:cNvPicPr>
+          <p:nvPr/>
+        </p:nvPicPr>
+        <p:blipFill>
+          <a:blip r:embed="rId12"/>
+          <a:stretch>
+            <a:fillRect/>
+          </a:stretch>
+        </p:blipFill>
+        <p:spPr>
+          <a:xfrm>
+            <a:off x="10944000" y="26175000"/>
+            <a:ext cx="9360000" cy="4516744"/>
+          </a:xfrm>
+          <a:prstGeom prst="rect">
+            <a:avLst/>
+          </a:prstGeom>
+        </p:spPr>
+      </p:pic>
+      <p:sp>
+        <p:nvSpPr>
+          <p:cNvPr id="47" name="Legenda ao vivo"/>
           <p:cNvSpPr txBox="1"/>
           <p:nvPr/>
         </p:nvSpPr>
         <p:spPr>
           <a:xfrm>
-            <a:off x="10944000" y="31530199"/>
-            <a:ext cx="9360000" cy="1440000"/>
+            <a:off x="10944000" y="30727744"/>
+            <a:ext cx="9360000" cy="288000"/>
           </a:xfrm>
           <a:prstGeom prst="rect">
             <a:avLst/>
@@ -6260,81 +5409,317 @@
               </a:spcAft>
             </a:pPr>
             <a:r>
-              <a:rPr sz="2000" b="0" i="0">
-                <a:solidFill>
-                  <a:srgbClr val="1F2633"/>
+              <a:rPr sz="1800" b="0" i="0">
+                <a:solidFill>
+                  <a:srgbClr val="5B6573"/>
                 </a:solidFill>
                 <a:latin typeface="Arial"/>
               </a:rPr>
-              <a:t>Robô horário com telemetria do SGB/ANA, em teste paralelo ao alerta oficial. Em </a:t>
-            </a:r>
-            <a:r>
-              <a:rPr sz="2000" b="1" i="0">
-                <a:solidFill>
-                  <a:srgbClr val="1F2633"/>
+              <a:t>Figura 4 – 230 previsões auditadas: EAM 9,2 cm (persistência 27,2 cm).</a:t>
+            </a:r>
+          </a:p>
+        </p:txBody>
+      </p:sp>
+      <p:sp>
+        <p:nvSpPr>
+          <p:cNvPr id="48" name="Secao CONCLUSÕES"/>
+          <p:cNvSpPr/>
+          <p:nvPr/>
+        </p:nvSpPr>
+        <p:spPr>
+          <a:xfrm>
+            <a:off x="1080000" y="31195744"/>
+            <a:ext cx="3456000" cy="504000"/>
+          </a:xfrm>
+          <a:prstGeom prst="roundRect">
+            <a:avLst>
+              <a:gd name="adj" fmla="val 50000"/>
+            </a:avLst>
+          </a:prstGeom>
+          <a:solidFill>
+            <a:srgbClr val="2A378D"/>
+          </a:solidFill>
+          <a:ln>
+            <a:noFill/>
+          </a:ln>
+          <a:effectLst/>
+        </p:spPr>
+        <p:style>
+          <a:lnRef idx="1">
+            <a:schemeClr val="accent1"/>
+          </a:lnRef>
+          <a:fillRef idx="3">
+            <a:schemeClr val="accent1"/>
+          </a:fillRef>
+          <a:effectRef idx="2">
+            <a:schemeClr val="accent1"/>
+          </a:effectRef>
+          <a:fontRef idx="minor">
+            <a:schemeClr val="lt1"/>
+          </a:fontRef>
+        </p:style>
+        <p:txBody>
+          <a:bodyPr rtlCol="0" anchor="ctr" wrap="none" lIns="252000" rIns="252000" tIns="0" bIns="0"/>
+          <a:lstStyle/>
+          <a:p>
+            <a:pPr algn="l"/>
+            <a:r>
+              <a:rPr sz="3000" b="1" i="0">
+                <a:solidFill>
+                  <a:srgbClr val="FFFFFF"/>
                 </a:solidFill>
                 <a:latin typeface="Arial"/>
               </a:rPr>
-              <a:t>230 previsões auditadas</a:t>
-            </a:r>
-            <a:r>
-              <a:rPr sz="2000" b="0" i="0">
-                <a:solidFill>
-                  <a:srgbClr val="1F2633"/>
-                </a:solidFill>
-                <a:latin typeface="Arial"/>
-              </a:rPr>
-              <a:t> (pico de </a:t>
-            </a:r>
-            <a:r>
-              <a:rPr sz="2000" b="1" i="0">
-                <a:solidFill>
-                  <a:srgbClr val="1F2633"/>
-                </a:solidFill>
-                <a:latin typeface="Arial"/>
-              </a:rPr>
-              <a:t>13,3 m</a:t>
-            </a:r>
-            <a:r>
-              <a:rPr sz="2000" b="0" i="0">
-                <a:solidFill>
-                  <a:srgbClr val="1F2633"/>
-                </a:solidFill>
-                <a:latin typeface="Arial"/>
-              </a:rPr>
-              <a:t>), o modelo 2h teve </a:t>
-            </a:r>
-            <a:r>
-              <a:rPr sz="2000" b="1" i="0">
-                <a:solidFill>
-                  <a:srgbClr val="D9661F"/>
-                </a:solidFill>
-                <a:latin typeface="Arial"/>
-              </a:rPr>
-              <a:t>EAM de 9,2 cm</a:t>
-            </a:r>
-            <a:r>
-              <a:rPr sz="2000" b="0" i="0">
-                <a:solidFill>
-                  <a:srgbClr val="1F2633"/>
-                </a:solidFill>
-                <a:latin typeface="Arial"/>
-              </a:rPr>
-              <a:t> (persistência: 27,2 cm).</a:t>
-            </a:r>
-          </a:p>
-        </p:txBody>
-      </p:sp>
-      <p:sp>
-        <p:nvSpPr>
-          <p:cNvPr id="45" name="Referencias e agradecimentos"/>
+              <a:t>CONCLUSÕES</a:t>
+            </a:r>
+          </a:p>
+        </p:txBody>
+      </p:sp>
+      <p:sp>
+        <p:nvSpPr>
+          <p:cNvPr id="49" name="Texto conclusoes"/>
           <p:cNvSpPr txBox="1"/>
           <p:nvPr/>
         </p:nvSpPr>
         <p:spPr>
           <a:xfrm>
-            <a:off x="1080000" y="32868000"/>
-            <a:ext cx="19224000" cy="432000"/>
+            <a:off x="1080000" y="31879744"/>
+            <a:ext cx="13680000" cy="1656000"/>
+          </a:xfrm>
+          <a:prstGeom prst="rect">
+            <a:avLst/>
+          </a:prstGeom>
+          <a:noFill/>
+        </p:spPr>
+        <p:txBody>
+          <a:bodyPr wrap="square" lIns="0" rIns="0" tIns="0" bIns="0" anchor="t">
+            <a:spAutoFit/>
+          </a:bodyPr>
+          <a:lstStyle/>
+          <a:p>
+            <a:pPr algn="l" marL="252000" indent="-252000">
+              <a:lnSpc>
+                <a:spcPct val="108000"/>
+              </a:lnSpc>
+              <a:spcAft>
+                <a:spcPts val="600"/>
+              </a:spcAft>
+              <a:buClr>
+                <a:srgbClr val="D9661F"/>
+              </a:buClr>
+              <a:buFont typeface="Arial"/>
+              <a:buChar char="■"/>
+            </a:pPr>
+            <a:r>
+              <a:rPr sz="2400" b="1" i="0">
+                <a:solidFill>
+                  <a:srgbClr val="1F2633"/>
+                </a:solidFill>
+                <a:latin typeface="Arial"/>
+              </a:rPr>
+              <a:t>NSE ≥ 0,98</a:t>
+            </a:r>
+            <a:r>
+              <a:rPr sz="2400" b="0" i="0">
+                <a:solidFill>
+                  <a:srgbClr val="1F2633"/>
+                </a:solidFill>
+                <a:latin typeface="Arial"/>
+              </a:rPr>
+              <a:t> e erro </a:t>
+            </a:r>
+            <a:r>
+              <a:rPr sz="2400" b="1" i="0">
+                <a:solidFill>
+                  <a:srgbClr val="1F2633"/>
+                </a:solidFill>
+                <a:latin typeface="Arial"/>
+              </a:rPr>
+              <a:t>65–81% menor</a:t>
+            </a:r>
+            <a:r>
+              <a:rPr sz="2400" b="0" i="0">
+                <a:solidFill>
+                  <a:srgbClr val="1F2633"/>
+                </a:solidFill>
+                <a:latin typeface="Arial"/>
+              </a:rPr>
+              <a:t> que a persistência nos três horizontes.</a:t>
+            </a:r>
+          </a:p>
+          <a:p>
+            <a:pPr algn="l" marL="252000" indent="-252000">
+              <a:lnSpc>
+                <a:spcPct val="108000"/>
+              </a:lnSpc>
+              <a:spcAft>
+                <a:spcPts val="600"/>
+              </a:spcAft>
+              <a:buClr>
+                <a:srgbClr val="D9661F"/>
+              </a:buClr>
+              <a:buFont typeface="Arial"/>
+              <a:buChar char="■"/>
+            </a:pPr>
+            <a:r>
+              <a:rPr sz="2400" b="0" i="0">
+                <a:solidFill>
+                  <a:srgbClr val="1F2633"/>
+                </a:solidFill>
+                <a:latin typeface="Arial"/>
+              </a:rPr>
+              <a:t>Em operação, o modelo 2h acompanhou a cheia de set/2026 com </a:t>
+            </a:r>
+            <a:r>
+              <a:rPr sz="2400" b="1" i="0">
+                <a:solidFill>
+                  <a:srgbClr val="D9661F"/>
+                </a:solidFill>
+                <a:latin typeface="Arial"/>
+              </a:rPr>
+              <a:t>erro médio de 9 cm</a:t>
+            </a:r>
+            <a:r>
+              <a:rPr sz="2400" b="0" i="0">
+                <a:solidFill>
+                  <a:srgbClr val="1F2633"/>
+                </a:solidFill>
+                <a:latin typeface="Arial"/>
+              </a:rPr>
+              <a:t>.</a:t>
+            </a:r>
+          </a:p>
+        </p:txBody>
+      </p:sp>
+      <p:sp>
+        <p:nvSpPr>
+          <p:cNvPr id="50" name="Espaco QR code"/>
+          <p:cNvSpPr/>
+          <p:nvPr/>
+        </p:nvSpPr>
+        <p:spPr>
+          <a:xfrm>
+            <a:off x="18216000" y="31195744"/>
+            <a:ext cx="2088000" cy="2088000"/>
+          </a:xfrm>
+          <a:prstGeom prst="roundRect">
+            <a:avLst>
+              <a:gd name="adj" fmla="val 6000"/>
+            </a:avLst>
+          </a:prstGeom>
+          <a:solidFill>
+            <a:srgbClr val="FFFFFF"/>
+          </a:solidFill>
+          <a:ln w="31750">
+            <a:solidFill>
+              <a:srgbClr val="2A378D"/>
+            </a:solidFill>
+            <a:prstDash val="dash"/>
+          </a:ln>
+          <a:effectLst/>
+        </p:spPr>
+        <p:style>
+          <a:lnRef idx="1">
+            <a:schemeClr val="accent1"/>
+          </a:lnRef>
+          <a:fillRef idx="3">
+            <a:schemeClr val="accent1"/>
+          </a:fillRef>
+          <a:effectRef idx="2">
+            <a:schemeClr val="accent1"/>
+          </a:effectRef>
+          <a:fontRef idx="minor">
+            <a:schemeClr val="lt1"/>
+          </a:fontRef>
+        </p:style>
+        <p:txBody>
+          <a:bodyPr rtlCol="0" anchor="ctr"/>
+          <a:lstStyle/>
+          <a:p>
+            <a:pPr algn="ctr"/>
+            <a:r>
+              <a:rPr sz="2200" b="1" i="0">
+                <a:solidFill>
+                  <a:srgbClr val="5B6573"/>
+                </a:solidFill>
+                <a:latin typeface="Arial"/>
+              </a:rPr>
+              <a:t>QR CODE</a:t>
+            </a:r>
+          </a:p>
+        </p:txBody>
+      </p:sp>
+      <p:sp>
+        <p:nvSpPr>
+          <p:cNvPr id="51" name="Chamada QR code"/>
+          <p:cNvSpPr txBox="1"/>
+          <p:nvPr/>
+        </p:nvSpPr>
+        <p:spPr>
+          <a:xfrm>
+            <a:off x="14904000" y="31627744"/>
+            <a:ext cx="3096000" cy="1296000"/>
+          </a:xfrm>
+          <a:prstGeom prst="rect">
+            <a:avLst/>
+          </a:prstGeom>
+          <a:noFill/>
+        </p:spPr>
+        <p:txBody>
+          <a:bodyPr wrap="square" lIns="0" rIns="0" tIns="0" bIns="0" anchor="t">
+            <a:spAutoFit/>
+          </a:bodyPr>
+          <a:lstStyle/>
+          <a:p>
+            <a:pPr algn="r">
+              <a:lnSpc>
+                <a:spcPct val="108000"/>
+              </a:lnSpc>
+              <a:spcAft>
+                <a:spcPts val="600"/>
+              </a:spcAft>
+            </a:pPr>
+            <a:r>
+              <a:rPr sz="2800" b="1" i="0">
+                <a:solidFill>
+                  <a:srgbClr val="2A378D"/>
+                </a:solidFill>
+                <a:latin typeface="Arial"/>
+              </a:rPr>
+              <a:t>Dashboard</a:t>
+            </a:r>
+          </a:p>
+          <a:p>
+            <a:pPr algn="r">
+              <a:lnSpc>
+                <a:spcPct val="108000"/>
+              </a:lnSpc>
+              <a:spcAft>
+                <a:spcPts val="600"/>
+              </a:spcAft>
+            </a:pPr>
+            <a:r>
+              <a:rPr sz="2800" b="1" i="0">
+                <a:solidFill>
+                  <a:srgbClr val="D9661F"/>
+                </a:solidFill>
+                <a:latin typeface="Arial"/>
+              </a:rPr>
+              <a:t>em tempo real →</a:t>
+            </a:r>
+          </a:p>
+        </p:txBody>
+      </p:sp>
+      <p:sp>
+        <p:nvSpPr>
+          <p:cNvPr id="52" name="Referencias e agradecimentos"/>
+          <p:cNvSpPr txBox="1"/>
+          <p:nvPr/>
+        </p:nvSpPr>
+        <p:spPr>
+          <a:xfrm>
+            <a:off x="1080000" y="32796000"/>
+            <a:ext cx="16920000" cy="504000"/>
           </a:xfrm>
           <a:prstGeom prst="rect">
             <a:avLst/>

</xml_diff>

<commit_message>
Revisão do pôster: logos UFRGS/FAPERGS, QR, correções e eventos de teste
Parte da versão editada pela autora: corrige a tabela de configuração do 2h,
a gramática da introdução e a legenda do mapa; alinha os títulos; reorganiza
o bloco ao vivo com o QR ao lado; detalha os eventos de teste; acrescenta a
limitação nas conclusões e leva logos e referências para a área branca.

Co-Authored-By: Claude Opus 5.5 <noreply@anthropic.com>
Claude-Session: https://claude.ai/code/session_01ESHSCPaB7QsPMssmHM5HK7
</commit_message>
<xml_diff>
--- a/poster_vend_2026/poster_VEND_Santa_Tereza_ALT.pptx
+++ b/poster_vend_2026/poster_VEND_Santa_Tereza_ALT.pptx
@@ -11,18 +11,14 @@
   <p:notesSz cx="6858000" cy="9144000"/>
   <p:embeddedFontLst>
     <p:embeddedFont>
-      <p:font typeface="Montaser Arabic" panose="020B0604020202020204" charset="-78"/>
+      <p:font typeface="Montserrat Bold" panose="020B0604020202020204" charset="0"/>
       <p:regular r:id="rId3"/>
-    </p:embeddedFont>
-    <p:embeddedFont>
-      <p:font typeface="Montserrat Bold" panose="020B0604020202020204" charset="0"/>
-      <p:regular r:id="rId4"/>
-      <p:bold r:id="rId5"/>
+      <p:bold r:id="rId4"/>
     </p:embeddedFont>
     <p:embeddedFont>
       <p:font typeface="Montserrat Medium" panose="00000600000000000000" pitchFamily="2" charset="0"/>
-      <p:regular r:id="rId6"/>
-      <p:italic r:id="rId7"/>
+      <p:regular r:id="rId5"/>
+      <p:italic r:id="rId6"/>
     </p:embeddedFont>
   </p:embeddedFontLst>
   <p:defaultTextStyle>
@@ -319,7 +315,7 @@
             <a:fld id="{1D8BD707-D9CF-40AE-B4C6-C98DA3205C09}" type="datetimeFigureOut">
               <a:rPr lang="en-US" smtClean="0"/>
               <a:pPr/>
-              <a:t>10/2/2026</a:t>
+              <a:t>10/5/2026</a:t>
             </a:fld>
             <a:endParaRPr lang="en-US"/>
           </a:p>
@@ -484,7 +480,7 @@
             <a:fld id="{1D8BD707-D9CF-40AE-B4C6-C98DA3205C09}" type="datetimeFigureOut">
               <a:rPr lang="en-US" smtClean="0"/>
               <a:pPr/>
-              <a:t>10/2/2026</a:t>
+              <a:t>10/5/2026</a:t>
             </a:fld>
             <a:endParaRPr lang="en-US"/>
           </a:p>
@@ -659,7 +655,7 @@
             <a:fld id="{1D8BD707-D9CF-40AE-B4C6-C98DA3205C09}" type="datetimeFigureOut">
               <a:rPr lang="en-US" smtClean="0"/>
               <a:pPr/>
-              <a:t>10/2/2026</a:t>
+              <a:t>10/5/2026</a:t>
             </a:fld>
             <a:endParaRPr lang="en-US"/>
           </a:p>
@@ -824,7 +820,7 @@
             <a:fld id="{1D8BD707-D9CF-40AE-B4C6-C98DA3205C09}" type="datetimeFigureOut">
               <a:rPr lang="en-US" smtClean="0"/>
               <a:pPr/>
-              <a:t>10/2/2026</a:t>
+              <a:t>10/5/2026</a:t>
             </a:fld>
             <a:endParaRPr lang="en-US"/>
           </a:p>
@@ -1066,7 +1062,7 @@
             <a:fld id="{1D8BD707-D9CF-40AE-B4C6-C98DA3205C09}" type="datetimeFigureOut">
               <a:rPr lang="en-US" smtClean="0"/>
               <a:pPr/>
-              <a:t>10/2/2026</a:t>
+              <a:t>10/5/2026</a:t>
             </a:fld>
             <a:endParaRPr lang="en-US"/>
           </a:p>
@@ -1348,7 +1344,7 @@
             <a:fld id="{1D8BD707-D9CF-40AE-B4C6-C98DA3205C09}" type="datetimeFigureOut">
               <a:rPr lang="en-US" smtClean="0"/>
               <a:pPr/>
-              <a:t>10/2/2026</a:t>
+              <a:t>10/5/2026</a:t>
             </a:fld>
             <a:endParaRPr lang="en-US"/>
           </a:p>
@@ -1764,7 +1760,7 @@
             <a:fld id="{1D8BD707-D9CF-40AE-B4C6-C98DA3205C09}" type="datetimeFigureOut">
               <a:rPr lang="en-US" smtClean="0"/>
               <a:pPr/>
-              <a:t>10/2/2026</a:t>
+              <a:t>10/5/2026</a:t>
             </a:fld>
             <a:endParaRPr lang="en-US"/>
           </a:p>
@@ -1878,7 +1874,7 @@
             <a:fld id="{1D8BD707-D9CF-40AE-B4C6-C98DA3205C09}" type="datetimeFigureOut">
               <a:rPr lang="en-US" smtClean="0"/>
               <a:pPr/>
-              <a:t>10/2/2026</a:t>
+              <a:t>10/5/2026</a:t>
             </a:fld>
             <a:endParaRPr lang="en-US"/>
           </a:p>
@@ -1970,7 +1966,7 @@
             <a:fld id="{1D8BD707-D9CF-40AE-B4C6-C98DA3205C09}" type="datetimeFigureOut">
               <a:rPr lang="en-US" smtClean="0"/>
               <a:pPr/>
-              <a:t>10/2/2026</a:t>
+              <a:t>10/5/2026</a:t>
             </a:fld>
             <a:endParaRPr lang="en-US"/>
           </a:p>
@@ -2242,7 +2238,7 @@
             <a:fld id="{1D8BD707-D9CF-40AE-B4C6-C98DA3205C09}" type="datetimeFigureOut">
               <a:rPr lang="en-US" smtClean="0"/>
               <a:pPr/>
-              <a:t>10/2/2026</a:t>
+              <a:t>10/5/2026</a:t>
             </a:fld>
             <a:endParaRPr lang="en-US"/>
           </a:p>
@@ -2491,7 +2487,7 @@
             <a:fld id="{1D8BD707-D9CF-40AE-B4C6-C98DA3205C09}" type="datetimeFigureOut">
               <a:rPr lang="en-US" smtClean="0"/>
               <a:pPr/>
-              <a:t>10/2/2026</a:t>
+              <a:t>10/5/2026</a:t>
             </a:fld>
             <a:endParaRPr lang="en-US"/>
           </a:p>
@@ -2699,7 +2695,7 @@
             <a:fld id="{1D8BD707-D9CF-40AE-B4C6-C98DA3205C09}" type="datetimeFigureOut">
               <a:rPr lang="en-US" smtClean="0"/>
               <a:pPr/>
-              <a:t>10/2/2026</a:t>
+              <a:t>10/5/2026</a:t>
             </a:fld>
             <a:endParaRPr lang="en-US"/>
           </a:p>
@@ -3270,7 +3266,7 @@
         </p:nvSpPr>
         <p:spPr>
           <a:xfrm>
-            <a:off x="1090612" y="5904177"/>
+            <a:off x="1103812" y="5402413"/>
             <a:ext cx="19202399" cy="1477328"/>
           </a:xfrm>
           <a:prstGeom prst="rect">
@@ -3318,7 +3314,7 @@
         </p:nvSpPr>
         <p:spPr>
           <a:xfrm>
-            <a:off x="1080000" y="7632000"/>
+            <a:off x="1103812" y="6992298"/>
             <a:ext cx="19224000" cy="764376"/>
           </a:xfrm>
           <a:prstGeom prst="rect">
@@ -3333,7 +3329,7 @@
           <a:p>
             <a:pPr algn="ctr"/>
             <a:r>
-              <a:rPr lang="en-US" sz="2800" dirty="0" b="0" i="0">
+              <a:rPr lang="en-US" sz="2800" b="0" i="0" dirty="0">
                 <a:solidFill>
                   <a:srgbClr val="003C64"/>
                 </a:solidFill>
@@ -3349,13 +3345,112 @@
               </a:spcBef>
             </a:pPr>
             <a:r>
-              <a:rPr sz="1900" b="0" i="0">
+              <a:rPr sz="1900" b="0" i="0" dirty="0" err="1">
                 <a:solidFill>
                   <a:srgbClr val="5B6573"/>
                 </a:solidFill>
                 <a:latin typeface="Arial"/>
               </a:rPr>
-              <a:t>Universidade Federal do Rio Grande do Sul (UFRGS) – Centro Estadual de Pesquisas em Sensoriamento Remoto e Meteorologia (CEPSRM)  ·  julianacarolinoreis@gmail.com</a:t>
+              <a:t>Universidade</a:t>
+            </a:r>
+            <a:r>
+              <a:rPr sz="1900" b="0" i="0" dirty="0">
+                <a:solidFill>
+                  <a:srgbClr val="5B6573"/>
+                </a:solidFill>
+                <a:latin typeface="Arial"/>
+              </a:rPr>
+              <a:t> Federal do Rio Grande do Sul (UFRGS) – Centro Estadual de </a:t>
+            </a:r>
+            <a:r>
+              <a:rPr sz="1900" b="0" i="0" dirty="0" err="1">
+                <a:solidFill>
+                  <a:srgbClr val="5B6573"/>
+                </a:solidFill>
+                <a:latin typeface="Arial"/>
+              </a:rPr>
+              <a:t>Pesquisas</a:t>
+            </a:r>
+            <a:r>
+              <a:rPr sz="1900" b="0" i="0" dirty="0">
+                <a:solidFill>
+                  <a:srgbClr val="5B6573"/>
+                </a:solidFill>
+                <a:latin typeface="Arial"/>
+              </a:rPr>
+              <a:t> </a:t>
+            </a:r>
+            <a:r>
+              <a:rPr sz="1900" b="0" i="0" dirty="0" err="1">
+                <a:solidFill>
+                  <a:srgbClr val="5B6573"/>
+                </a:solidFill>
+                <a:latin typeface="Arial"/>
+              </a:rPr>
+              <a:t>em</a:t>
+            </a:r>
+            <a:r>
+              <a:rPr sz="1900" b="0" i="0" dirty="0">
+                <a:solidFill>
+                  <a:srgbClr val="5B6573"/>
+                </a:solidFill>
+                <a:latin typeface="Arial"/>
+              </a:rPr>
+              <a:t> </a:t>
+            </a:r>
+            <a:r>
+              <a:rPr sz="1900" b="0" i="0" dirty="0" err="1">
+                <a:solidFill>
+                  <a:srgbClr val="5B6573"/>
+                </a:solidFill>
+                <a:latin typeface="Arial"/>
+              </a:rPr>
+              <a:t>Sensoriamento</a:t>
+            </a:r>
+            <a:r>
+              <a:rPr sz="1900" b="0" i="0" dirty="0">
+                <a:solidFill>
+                  <a:srgbClr val="5B6573"/>
+                </a:solidFill>
+                <a:latin typeface="Arial"/>
+              </a:rPr>
+              <a:t> </a:t>
+            </a:r>
+            <a:r>
+              <a:rPr sz="1900" b="0" i="0" dirty="0" err="1">
+                <a:solidFill>
+                  <a:srgbClr val="5B6573"/>
+                </a:solidFill>
+                <a:latin typeface="Arial"/>
+              </a:rPr>
+              <a:t>Remoto</a:t>
+            </a:r>
+            <a:r>
+              <a:rPr sz="1900" b="0" i="0" dirty="0">
+                <a:solidFill>
+                  <a:srgbClr val="5B6573"/>
+                </a:solidFill>
+                <a:latin typeface="Arial"/>
+              </a:rPr>
+              <a:t> e </a:t>
+            </a:r>
+            <a:r>
+              <a:rPr sz="1900" b="0" i="0" dirty="0" err="1">
+                <a:solidFill>
+                  <a:srgbClr val="5B6573"/>
+                </a:solidFill>
+                <a:latin typeface="Arial"/>
+              </a:rPr>
+              <a:t>Meteorologia</a:t>
+            </a:r>
+            <a:r>
+              <a:rPr sz="1900" b="0" i="0" dirty="0">
+                <a:solidFill>
+                  <a:srgbClr val="5B6573"/>
+                </a:solidFill>
+                <a:latin typeface="Arial"/>
+              </a:rPr>
+              <a:t> (CEPSRM)  ·  julianacarolinoreis@gmail.com</a:t>
             </a:r>
           </a:p>
         </p:txBody>
@@ -3820,7 +3915,7 @@
         </p:nvSpPr>
         <p:spPr>
           <a:xfrm>
-            <a:off x="1080000" y="9072000"/>
+            <a:off x="1080000" y="8462818"/>
             <a:ext cx="3456000" cy="504000"/>
           </a:xfrm>
           <a:prstGeom prst="roundRect">
@@ -3851,12 +3946,12 @@
           </a:fontRef>
         </p:style>
         <p:txBody>
-          <a:bodyPr rtlCol="0" anchor="ctr" wrap="none" lIns="252000" rIns="252000" tIns="0" bIns="0"/>
+          <a:bodyPr wrap="none" lIns="252000" tIns="0" rIns="252000" bIns="0" rtlCol="0" anchor="ctr"/>
           <a:lstStyle/>
           <a:p>
             <a:pPr algn="l"/>
             <a:r>
-              <a:rPr sz="3000" b="1" i="0">
+              <a:rPr sz="3000" b="1" i="0" dirty="0">
                 <a:solidFill>
                   <a:srgbClr val="FFFFFF"/>
                 </a:solidFill>
@@ -3875,8 +3970,8 @@
         </p:nvSpPr>
         <p:spPr>
           <a:xfrm>
-            <a:off x="1080000" y="9756000"/>
-            <a:ext cx="9360000" cy="1728000"/>
+            <a:off x="1080000" y="9206844"/>
+            <a:ext cx="9360000" cy="2585323"/>
           </a:xfrm>
           <a:prstGeom prst="rect">
             <a:avLst/>
@@ -3884,15 +3979,12 @@
           <a:noFill/>
         </p:spPr>
         <p:txBody>
-          <a:bodyPr wrap="square" lIns="0" rIns="0" tIns="0" bIns="0" anchor="t">
+          <a:bodyPr wrap="square" lIns="0" tIns="0" rIns="0" bIns="0" anchor="t">
             <a:spAutoFit/>
           </a:bodyPr>
           <a:lstStyle/>
           <a:p>
             <a:pPr algn="l">
-              <a:lnSpc>
-                <a:spcPct val="108000"/>
-              </a:lnSpc>
               <a:spcAft>
                 <a:spcPts val="600"/>
               </a:spcAft>
@@ -3904,7 +3996,7 @@
                 </a:solidFill>
                 <a:latin typeface="Arial"/>
               </a:rPr>
-              <a:t>Previsão do nível do rio Taquari em </a:t>
+              <a:t>As cheias de 2023 e 2024 na bacia do Taquari-Antas mostraram a necessidade de previsões de nível com antecedência útil para o alerta. Este trabalho aplica </a:t>
             </a:r>
             <a:r>
               <a:rPr sz="2400" b="1" i="0">
@@ -3913,7 +4005,7 @@
                 </a:solidFill>
                 <a:latin typeface="Arial"/>
               </a:rPr>
-              <a:t>Santa Tereza (RS)</a:t>
+              <a:t>Redes Neurais Artificiais</a:t>
             </a:r>
             <a:r>
               <a:rPr sz="2400" b="0" i="0">
@@ -3922,7 +4014,7 @@
                 </a:solidFill>
                 <a:latin typeface="Arial"/>
               </a:rPr>
-              <a:t> com RNA do tipo MLP, </a:t>
+              <a:t> do tipo Perceptron Multicamadas (MLP) para prever o nível do rio Taquari em </a:t>
             </a:r>
             <a:r>
               <a:rPr sz="2400" b="1" i="0">
@@ -3931,7 +4023,7 @@
                 </a:solidFill>
                 <a:latin typeface="Arial"/>
               </a:rPr>
-              <a:t>2, 4 e 8 h</a:t>
+              <a:t>Santa Tereza</a:t>
             </a:r>
             <a:r>
               <a:rPr sz="2400" b="0" i="0">
@@ -3940,11 +4032,29 @@
                 </a:solidFill>
                 <a:latin typeface="Arial"/>
               </a:rPr>
-              <a:t> à frente. Na </a:t>
+              <a:t> com </a:t>
             </a:r>
             <a:r>
               <a:rPr sz="2400" b="1" i="0">
                 <a:solidFill>
+                  <a:srgbClr val="1F2633"/>
+                </a:solidFill>
+                <a:latin typeface="Arial"/>
+              </a:rPr>
+              <a:t>2, 4 e 8 horas</a:t>
+            </a:r>
+            <a:r>
+              <a:rPr sz="2400" b="0" i="0">
+                <a:solidFill>
+                  <a:srgbClr val="1F2633"/>
+                </a:solidFill>
+                <a:latin typeface="Arial"/>
+              </a:rPr>
+              <a:t> de antecedência, na </a:t>
+            </a:r>
+            <a:r>
+              <a:rPr sz="2400" b="1" i="0">
+                <a:solidFill>
                   <a:srgbClr val="D9661F"/>
                 </a:solidFill>
                 <a:latin typeface="Arial"/>
@@ -3958,306 +4068,28 @@
                 </a:solidFill>
                 <a:latin typeface="Arial"/>
               </a:rPr>
-              <a:t> a rede prevê só a </a:t>
-            </a:r>
-            <a:r>
-              <a:rPr sz="2400" b="1" i="0">
-                <a:solidFill>
-                  <a:srgbClr val="1F2633"/>
-                </a:solidFill>
-                <a:latin typeface="Arial"/>
-              </a:rPr>
-              <a:t>variação</a:t>
-            </a:r>
-            <a:r>
-              <a:rPr sz="2400" b="0" i="0">
-                <a:solidFill>
-                  <a:srgbClr val="1F2633"/>
-                </a:solidFill>
-                <a:latin typeface="Arial"/>
-              </a:rPr>
-              <a:t> do nível.</a:t>
-            </a:r>
-          </a:p>
-        </p:txBody>
-      </p:sp>
-      <p:sp>
-        <p:nvSpPr>
-          <p:cNvPr id="20" name="Dado 1"/>
+              <a:t>: a RNA tem como variável dependente a diferença de nível no horizonte de previsão.</a:t>
+            </a:r>
+            <a:endParaRPr sz="2400" b="0" i="0" dirty="0">
+              <a:solidFill>
+                <a:srgbClr val="1F2633"/>
+              </a:solidFill>
+              <a:latin typeface="Arial" panose="020B0604020202020204" pitchFamily="34" charset="0"/>
+              <a:cs typeface="Arial" panose="020B0604020202020204" pitchFamily="34" charset="0"/>
+            </a:endParaRPr>
+          </a:p>
+        </p:txBody>
+      </p:sp>
+      <p:sp>
+        <p:nvSpPr>
+          <p:cNvPr id="20" name="Secao ÁREA DE ESTUDO E DADOS"/>
           <p:cNvSpPr/>
           <p:nvPr/>
         </p:nvSpPr>
         <p:spPr>
           <a:xfrm>
-            <a:off x="1080000" y="11664000"/>
-            <a:ext cx="2928000" cy="1656000"/>
-          </a:xfrm>
-          <a:prstGeom prst="roundRect">
-            <a:avLst>
-              <a:gd name="adj" fmla="val 12000"/>
-            </a:avLst>
-          </a:prstGeom>
-          <a:solidFill>
-            <a:srgbClr val="E6EEF5"/>
-          </a:solidFill>
-          <a:ln>
-            <a:noFill/>
-          </a:ln>
-          <a:effectLst/>
-        </p:spPr>
-        <p:style>
-          <a:lnRef idx="1">
-            <a:schemeClr val="accent1"/>
-          </a:lnRef>
-          <a:fillRef idx="3">
-            <a:schemeClr val="accent1"/>
-          </a:fillRef>
-          <a:effectRef idx="2">
-            <a:schemeClr val="accent1"/>
-          </a:effectRef>
-          <a:fontRef idx="minor">
-            <a:schemeClr val="lt1"/>
-          </a:fontRef>
-        </p:style>
-        <p:txBody>
-          <a:bodyPr rtlCol="0" anchor="ctr" wrap="square" lIns="108000" rIns="108000" tIns="36000" bIns="36000"/>
-          <a:lstStyle/>
-          <a:p>
-            <a:pPr algn="ctr"/>
-            <a:r>
-              <a:rPr sz="3000" b="1" i="0">
-                <a:solidFill>
-                  <a:srgbClr val="2A378D"/>
-                </a:solidFill>
-                <a:latin typeface="Arial"/>
-              </a:rPr>
-              <a:t>15.800 km²</a:t>
-            </a:r>
-          </a:p>
-          <a:p>
-            <a:pPr algn="ctr"/>
-            <a:r>
-              <a:rPr sz="1800" b="0" i="0">
-                <a:solidFill>
-                  <a:srgbClr val="1F2633"/>
-                </a:solidFill>
-                <a:latin typeface="Arial"/>
-              </a:rPr>
-              <a:t>bacia até Santa Tereza</a:t>
-            </a:r>
-          </a:p>
-        </p:txBody>
-      </p:sp>
-      <p:sp>
-        <p:nvSpPr>
-          <p:cNvPr id="21" name="Dado 2"/>
-          <p:cNvSpPr/>
-          <p:nvPr/>
-        </p:nvSpPr>
-        <p:spPr>
-          <a:xfrm>
-            <a:off x="4296000" y="11664000"/>
-            <a:ext cx="2928000" cy="1656000"/>
-          </a:xfrm>
-          <a:prstGeom prst="roundRect">
-            <a:avLst>
-              <a:gd name="adj" fmla="val 12000"/>
-            </a:avLst>
-          </a:prstGeom>
-          <a:solidFill>
-            <a:srgbClr val="E6EEF5"/>
-          </a:solidFill>
-          <a:ln>
-            <a:noFill/>
-          </a:ln>
-          <a:effectLst/>
-        </p:spPr>
-        <p:style>
-          <a:lnRef idx="1">
-            <a:schemeClr val="accent1"/>
-          </a:lnRef>
-          <a:fillRef idx="3">
-            <a:schemeClr val="accent1"/>
-          </a:fillRef>
-          <a:effectRef idx="2">
-            <a:schemeClr val="accent1"/>
-          </a:effectRef>
-          <a:fontRef idx="minor">
-            <a:schemeClr val="lt1"/>
-          </a:fontRef>
-        </p:style>
-        <p:txBody>
-          <a:bodyPr rtlCol="0" anchor="ctr" wrap="square" lIns="108000" rIns="108000" tIns="36000" bIns="36000"/>
-          <a:lstStyle/>
-          <a:p>
-            <a:pPr algn="ctr"/>
-            <a:r>
-              <a:rPr sz="3000" b="1" i="0">
-                <a:solidFill>
-                  <a:srgbClr val="2A378D"/>
-                </a:solidFill>
-                <a:latin typeface="Arial"/>
-              </a:rPr>
-              <a:t>2022–2025</a:t>
-            </a:r>
-          </a:p>
-          <a:p>
-            <a:pPr algn="ctr"/>
-            <a:r>
-              <a:rPr sz="1800" b="0" i="0">
-                <a:solidFill>
-                  <a:srgbClr val="1F2633"/>
-                </a:solidFill>
-                <a:latin typeface="Arial"/>
-              </a:rPr>
-              <a:t>dados horários ANA/SGB</a:t>
-            </a:r>
-          </a:p>
-        </p:txBody>
-      </p:sp>
-      <p:sp>
-        <p:nvSpPr>
-          <p:cNvPr id="22" name="Dado 3"/>
-          <p:cNvSpPr/>
-          <p:nvPr/>
-        </p:nvSpPr>
-        <p:spPr>
-          <a:xfrm>
-            <a:off x="7512000" y="11664000"/>
-            <a:ext cx="2928000" cy="1656000"/>
-          </a:xfrm>
-          <a:prstGeom prst="roundRect">
-            <a:avLst>
-              <a:gd name="adj" fmla="val 12000"/>
-            </a:avLst>
-          </a:prstGeom>
-          <a:solidFill>
-            <a:srgbClr val="E6EEF5"/>
-          </a:solidFill>
-          <a:ln>
-            <a:noFill/>
-          </a:ln>
-          <a:effectLst/>
-        </p:spPr>
-        <p:style>
-          <a:lnRef idx="1">
-            <a:schemeClr val="accent1"/>
-          </a:lnRef>
-          <a:fillRef idx="3">
-            <a:schemeClr val="accent1"/>
-          </a:fillRef>
-          <a:effectRef idx="2">
-            <a:schemeClr val="accent1"/>
-          </a:effectRef>
-          <a:fontRef idx="minor">
-            <a:schemeClr val="lt1"/>
-          </a:fontRef>
-        </p:style>
-        <p:txBody>
-          <a:bodyPr rtlCol="0" anchor="ctr" wrap="square" lIns="108000" rIns="108000" tIns="36000" bIns="36000"/>
-          <a:lstStyle/>
-          <a:p>
-            <a:pPr algn="ctr"/>
-            <a:r>
-              <a:rPr sz="3000" b="1" i="0">
-                <a:solidFill>
-                  <a:srgbClr val="2A378D"/>
-                </a:solidFill>
-                <a:latin typeface="Arial"/>
-              </a:rPr>
-              <a:t>3 grupos</a:t>
-            </a:r>
-          </a:p>
-          <a:p>
-            <a:pPr algn="ctr"/>
-            <a:r>
-              <a:rPr sz="1800" b="0" i="0">
-                <a:solidFill>
-                  <a:srgbClr val="1F2633"/>
-                </a:solidFill>
-                <a:latin typeface="Arial"/>
-              </a:rPr>
-              <a:t>eventos de cheia: treino, validação e teste</a:t>
-            </a:r>
-          </a:p>
-        </p:txBody>
-      </p:sp>
-      <p:pic>
-        <p:nvPicPr>
-          <p:cNvPr id="23" name="Mapa da bacia" descr="mapa.png"/>
-          <p:cNvPicPr>
-            <a:picLocks noChangeAspect="1"/>
-          </p:cNvPicPr>
-          <p:nvPr/>
-        </p:nvPicPr>
-        <p:blipFill>
-          <a:blip r:embed="rId9"/>
-          <a:stretch>
-            <a:fillRect/>
-          </a:stretch>
-        </p:blipFill>
-        <p:spPr>
-          <a:xfrm>
-            <a:off x="11934000" y="9072000"/>
-            <a:ext cx="7380000" cy="5054627"/>
-          </a:xfrm>
-          <a:prstGeom prst="rect">
-            <a:avLst/>
-          </a:prstGeom>
-        </p:spPr>
-      </p:pic>
-      <p:sp>
-        <p:nvSpPr>
-          <p:cNvPr id="24" name="Legenda mapa"/>
-          <p:cNvSpPr txBox="1"/>
-          <p:nvPr/>
-        </p:nvSpPr>
-        <p:spPr>
-          <a:xfrm>
-            <a:off x="10944000" y="14198627"/>
-            <a:ext cx="9360000" cy="288000"/>
-          </a:xfrm>
-          <a:prstGeom prst="rect">
-            <a:avLst/>
-          </a:prstGeom>
-          <a:noFill/>
-        </p:spPr>
-        <p:txBody>
-          <a:bodyPr wrap="square" lIns="0" rIns="0" tIns="0" bIns="0" anchor="t">
-            <a:spAutoFit/>
-          </a:bodyPr>
-          <a:lstStyle/>
-          <a:p>
-            <a:pPr algn="ctr">
-              <a:lnSpc>
-                <a:spcPct val="108000"/>
-              </a:lnSpc>
-              <a:spcAft>
-                <a:spcPts val="600"/>
-              </a:spcAft>
-            </a:pPr>
-            <a:r>
-              <a:rPr sz="1800" b="0" i="0">
-                <a:solidFill>
-                  <a:srgbClr val="5B6573"/>
-                </a:solidFill>
-                <a:latin typeface="Arial"/>
-              </a:rPr>
-              <a:t>Figura 1 – Bacia do rio Taquari até Santa Tereza e postos fluviométricos.</a:t>
-            </a:r>
-          </a:p>
-        </p:txBody>
-      </p:sp>
-      <p:sp>
-        <p:nvSpPr>
-          <p:cNvPr id="25" name="Secao ABORDAGEM ALTERNATIVA (ALT)"/>
-          <p:cNvSpPr/>
-          <p:nvPr/>
-        </p:nvSpPr>
-        <p:spPr>
-          <a:xfrm>
-            <a:off x="1080000" y="14760000"/>
-            <a:ext cx="7984800" cy="504000"/>
+            <a:off x="1080000" y="12348000"/>
+            <a:ext cx="6652800" cy="504000"/>
           </a:xfrm>
           <a:prstGeom prst="roundRect">
             <a:avLst>
@@ -4287,7 +4119,7 @@
           </a:fontRef>
         </p:style>
         <p:txBody>
-          <a:bodyPr rtlCol="0" anchor="ctr" wrap="none" lIns="252000" rIns="252000" tIns="0" bIns="0"/>
+          <a:bodyPr wrap="none" lIns="252000" tIns="0" rIns="252000" bIns="0" rtlCol="0" anchor="ctr"/>
           <a:lstStyle/>
           <a:p>
             <a:pPr algn="l"/>
@@ -4298,20 +4130,515 @@
                 </a:solidFill>
                 <a:latin typeface="Arial"/>
               </a:rPr>
-              <a:t>ABORDAGEM ALTERNATIVA (ALT)</a:t>
-            </a:r>
-          </a:p>
-        </p:txBody>
-      </p:sp>
-      <p:sp>
-        <p:nvSpPr>
-          <p:cNvPr id="26" name="Etapa 1"/>
+              <a:t>ÁREA DE ESTUDO E DADOS</a:t>
+            </a:r>
+          </a:p>
+        </p:txBody>
+      </p:sp>
+      <p:sp>
+        <p:nvSpPr>
+          <p:cNvPr id="21" name="Texto area de estudo"/>
+          <p:cNvSpPr txBox="1"/>
+          <p:nvPr/>
+        </p:nvSpPr>
+        <p:spPr>
+          <a:xfrm>
+            <a:off x="1080000" y="13032000"/>
+            <a:ext cx="9360000" cy="1872000"/>
+          </a:xfrm>
+          <a:prstGeom prst="rect">
+            <a:avLst/>
+          </a:prstGeom>
+          <a:noFill/>
+        </p:spPr>
+        <p:txBody>
+          <a:bodyPr wrap="square" lIns="0" tIns="0" rIns="0" bIns="0" anchor="t">
+            <a:spAutoFit/>
+          </a:bodyPr>
+          <a:lstStyle/>
+          <a:p>
+            <a:pPr marL="252000" indent="-252000" algn="l">
+              <a:lnSpc>
+                <a:spcPct val="108000"/>
+              </a:lnSpc>
+              <a:spcAft>
+                <a:spcPts val="600"/>
+              </a:spcAft>
+              <a:buClr>
+                <a:srgbClr val="D9661F"/>
+              </a:buClr>
+              <a:buFont typeface="Arial"/>
+              <a:buChar char="■"/>
+            </a:pPr>
+            <a:r>
+              <a:rPr sz="2400" b="0" i="0" dirty="0">
+                <a:solidFill>
+                  <a:srgbClr val="1F2633"/>
+                </a:solidFill>
+                <a:latin typeface="Arial"/>
+              </a:rPr>
+              <a:t>Bacia do </a:t>
+            </a:r>
+            <a:r>
+              <a:rPr sz="2400" b="0" i="0" dirty="0" err="1">
+                <a:solidFill>
+                  <a:srgbClr val="1F2633"/>
+                </a:solidFill>
+                <a:latin typeface="Arial"/>
+              </a:rPr>
+              <a:t>rio</a:t>
+            </a:r>
+            <a:r>
+              <a:rPr sz="2400" b="0" i="0" dirty="0">
+                <a:solidFill>
+                  <a:srgbClr val="1F2633"/>
+                </a:solidFill>
+                <a:latin typeface="Arial"/>
+              </a:rPr>
+              <a:t> Taquari </a:t>
+            </a:r>
+            <a:r>
+              <a:rPr sz="2400" b="0" i="0" dirty="0" err="1">
+                <a:solidFill>
+                  <a:srgbClr val="1F2633"/>
+                </a:solidFill>
+                <a:latin typeface="Arial"/>
+              </a:rPr>
+              <a:t>até</a:t>
+            </a:r>
+            <a:r>
+              <a:rPr sz="2400" b="0" i="0" dirty="0">
+                <a:solidFill>
+                  <a:srgbClr val="1F2633"/>
+                </a:solidFill>
+                <a:latin typeface="Arial"/>
+              </a:rPr>
+              <a:t> a </a:t>
+            </a:r>
+            <a:r>
+              <a:rPr sz="2400" b="0" i="0" dirty="0" err="1">
+                <a:solidFill>
+                  <a:srgbClr val="1F2633"/>
+                </a:solidFill>
+                <a:latin typeface="Arial"/>
+              </a:rPr>
+              <a:t>estação</a:t>
+            </a:r>
+            <a:r>
+              <a:rPr sz="2400" b="0" i="0" dirty="0">
+                <a:solidFill>
+                  <a:srgbClr val="1F2633"/>
+                </a:solidFill>
+                <a:latin typeface="Arial"/>
+              </a:rPr>
+              <a:t> 86472600 (≈15.800 km²)</a:t>
+            </a:r>
+          </a:p>
+          <a:p>
+            <a:pPr marL="252000" indent="-252000" algn="l">
+              <a:lnSpc>
+                <a:spcPct val="108000"/>
+              </a:lnSpc>
+              <a:spcAft>
+                <a:spcPts val="600"/>
+              </a:spcAft>
+              <a:buClr>
+                <a:srgbClr val="D9661F"/>
+              </a:buClr>
+              <a:buFont typeface="Arial"/>
+              <a:buChar char="■"/>
+            </a:pPr>
+            <a:r>
+              <a:rPr sz="2400" b="0" i="0" dirty="0">
+                <a:solidFill>
+                  <a:srgbClr val="1F2633"/>
+                </a:solidFill>
+                <a:latin typeface="Arial"/>
+              </a:rPr>
+              <a:t>Dados </a:t>
+            </a:r>
+            <a:r>
+              <a:rPr sz="2400" b="0" i="0" dirty="0" err="1">
+                <a:solidFill>
+                  <a:srgbClr val="1F2633"/>
+                </a:solidFill>
+                <a:latin typeface="Arial"/>
+              </a:rPr>
+              <a:t>horários</a:t>
+            </a:r>
+            <a:r>
+              <a:rPr sz="2400" b="0" i="0" dirty="0">
+                <a:solidFill>
+                  <a:srgbClr val="1F2633"/>
+                </a:solidFill>
+                <a:latin typeface="Arial"/>
+              </a:rPr>
+              <a:t> de </a:t>
+            </a:r>
+            <a:r>
+              <a:rPr sz="2400" b="0" i="0" dirty="0" err="1">
+                <a:solidFill>
+                  <a:srgbClr val="1F2633"/>
+                </a:solidFill>
+                <a:latin typeface="Arial"/>
+              </a:rPr>
+              <a:t>nível</a:t>
+            </a:r>
+            <a:r>
+              <a:rPr sz="2400" b="0" i="0" dirty="0">
+                <a:solidFill>
+                  <a:srgbClr val="1F2633"/>
+                </a:solidFill>
+                <a:latin typeface="Arial"/>
+              </a:rPr>
+              <a:t> e </a:t>
+            </a:r>
+            <a:r>
+              <a:rPr sz="2400" b="0" i="0" dirty="0" err="1">
+                <a:solidFill>
+                  <a:srgbClr val="1F2633"/>
+                </a:solidFill>
+                <a:latin typeface="Arial"/>
+              </a:rPr>
+              <a:t>chuva</a:t>
+            </a:r>
+            <a:r>
+              <a:rPr sz="2400" b="0" i="0" dirty="0">
+                <a:solidFill>
+                  <a:srgbClr val="1F2633"/>
+                </a:solidFill>
+                <a:latin typeface="Arial"/>
+              </a:rPr>
+              <a:t> (2022–2025) do portal </a:t>
+            </a:r>
+            <a:r>
+              <a:rPr sz="2400" b="0" i="0" dirty="0" err="1">
+                <a:solidFill>
+                  <a:srgbClr val="1F2633"/>
+                </a:solidFill>
+                <a:latin typeface="Arial"/>
+              </a:rPr>
+              <a:t>HidroTelemetria</a:t>
+            </a:r>
+            <a:r>
+              <a:rPr sz="2400" b="0" i="0" dirty="0">
+                <a:solidFill>
+                  <a:srgbClr val="1F2633"/>
+                </a:solidFill>
+                <a:latin typeface="Arial"/>
+              </a:rPr>
+              <a:t> (ANA/SGB)</a:t>
+            </a:r>
+          </a:p>
+          <a:p>
+            <a:pPr marL="252000" indent="-252000" algn="l">
+              <a:lnSpc>
+                <a:spcPct val="108000"/>
+              </a:lnSpc>
+              <a:spcAft>
+                <a:spcPts val="600"/>
+              </a:spcAft>
+              <a:buClr>
+                <a:srgbClr val="D9661F"/>
+              </a:buClr>
+              <a:buFont typeface="Arial"/>
+              <a:buChar char="■"/>
+            </a:pPr>
+            <a:r>
+              <a:rPr sz="2400" b="0" i="0" dirty="0" err="1">
+                <a:solidFill>
+                  <a:srgbClr val="1F2633"/>
+                </a:solidFill>
+                <a:latin typeface="Arial"/>
+              </a:rPr>
+              <a:t>Amostras</a:t>
+            </a:r>
+            <a:r>
+              <a:rPr sz="2400" b="0" i="0" dirty="0">
+                <a:solidFill>
+                  <a:srgbClr val="1F2633"/>
+                </a:solidFill>
+                <a:latin typeface="Arial"/>
+              </a:rPr>
+              <a:t> </a:t>
+            </a:r>
+            <a:r>
+              <a:rPr sz="2400" b="0" i="0" dirty="0" err="1">
+                <a:solidFill>
+                  <a:srgbClr val="1F2633"/>
+                </a:solidFill>
+                <a:latin typeface="Arial"/>
+              </a:rPr>
+              <a:t>agrupadas</a:t>
+            </a:r>
+            <a:r>
+              <a:rPr sz="2400" b="0" i="0" dirty="0">
+                <a:solidFill>
+                  <a:srgbClr val="1F2633"/>
+                </a:solidFill>
+                <a:latin typeface="Arial"/>
+              </a:rPr>
+              <a:t> </a:t>
+            </a:r>
+            <a:r>
+              <a:rPr sz="2400" b="0" i="0" dirty="0" err="1">
+                <a:solidFill>
+                  <a:srgbClr val="1F2633"/>
+                </a:solidFill>
+                <a:latin typeface="Arial"/>
+              </a:rPr>
+              <a:t>por</a:t>
+            </a:r>
+            <a:r>
+              <a:rPr sz="2400" b="0" i="0" dirty="0">
+                <a:solidFill>
+                  <a:srgbClr val="1F2633"/>
+                </a:solidFill>
+                <a:latin typeface="Arial"/>
+              </a:rPr>
+              <a:t> </a:t>
+            </a:r>
+            <a:r>
+              <a:rPr sz="2400" b="1" i="0" dirty="0" err="1">
+                <a:solidFill>
+                  <a:srgbClr val="1F2633"/>
+                </a:solidFill>
+                <a:latin typeface="Arial"/>
+              </a:rPr>
+              <a:t>eventos</a:t>
+            </a:r>
+            <a:r>
+              <a:rPr sz="2400" b="1" i="0" dirty="0">
+                <a:solidFill>
+                  <a:srgbClr val="1F2633"/>
+                </a:solidFill>
+                <a:latin typeface="Arial"/>
+              </a:rPr>
+              <a:t> de </a:t>
+            </a:r>
+            <a:r>
+              <a:rPr sz="2400" b="1" i="0" dirty="0" err="1">
+                <a:solidFill>
+                  <a:srgbClr val="1F2633"/>
+                </a:solidFill>
+                <a:latin typeface="Arial"/>
+              </a:rPr>
+              <a:t>cheia</a:t>
+            </a:r>
+            <a:r>
+              <a:rPr sz="2400" b="0" i="0" dirty="0">
+                <a:solidFill>
+                  <a:srgbClr val="1F2633"/>
+                </a:solidFill>
+                <a:latin typeface="Arial"/>
+              </a:rPr>
+              <a:t>, </a:t>
+            </a:r>
+            <a:r>
+              <a:rPr sz="2400" b="0" i="0" dirty="0" err="1">
+                <a:solidFill>
+                  <a:srgbClr val="1F2633"/>
+                </a:solidFill>
+                <a:latin typeface="Arial"/>
+              </a:rPr>
+              <a:t>separados</a:t>
+            </a:r>
+            <a:r>
+              <a:rPr sz="2400" b="0" i="0" dirty="0">
+                <a:solidFill>
+                  <a:srgbClr val="1F2633"/>
+                </a:solidFill>
+                <a:latin typeface="Arial"/>
+              </a:rPr>
+              <a:t> </a:t>
+            </a:r>
+            <a:r>
+              <a:rPr sz="2400" b="0" i="0" dirty="0" err="1">
+                <a:solidFill>
+                  <a:srgbClr val="1F2633"/>
+                </a:solidFill>
+                <a:latin typeface="Arial"/>
+              </a:rPr>
+              <a:t>em</a:t>
+            </a:r>
+            <a:r>
+              <a:rPr sz="2400" b="0" i="0" dirty="0">
+                <a:solidFill>
+                  <a:srgbClr val="1F2633"/>
+                </a:solidFill>
+                <a:latin typeface="Arial"/>
+              </a:rPr>
+              <a:t> </a:t>
+            </a:r>
+            <a:r>
+              <a:rPr sz="2400" b="0" i="0" dirty="0" err="1">
+                <a:solidFill>
+                  <a:srgbClr val="1F2633"/>
+                </a:solidFill>
+                <a:latin typeface="Arial"/>
+              </a:rPr>
+              <a:t>treino</a:t>
+            </a:r>
+            <a:r>
+              <a:rPr sz="2400" b="0" i="0" dirty="0">
+                <a:solidFill>
+                  <a:srgbClr val="1F2633"/>
+                </a:solidFill>
+                <a:latin typeface="Arial"/>
+              </a:rPr>
+              <a:t>, </a:t>
+            </a:r>
+            <a:r>
+              <a:rPr sz="2400" b="0" i="0" dirty="0" err="1">
+                <a:solidFill>
+                  <a:srgbClr val="1F2633"/>
+                </a:solidFill>
+                <a:latin typeface="Arial"/>
+              </a:rPr>
+              <a:t>validação</a:t>
+            </a:r>
+            <a:r>
+              <a:rPr sz="2400" b="0" i="0" dirty="0">
+                <a:solidFill>
+                  <a:srgbClr val="1F2633"/>
+                </a:solidFill>
+                <a:latin typeface="Arial"/>
+              </a:rPr>
+              <a:t> e teste</a:t>
+            </a:r>
+          </a:p>
+        </p:txBody>
+      </p:sp>
+      <p:pic>
+        <p:nvPicPr>
+          <p:cNvPr id="22" name="Mapa da bacia" descr="mapa.png"/>
+          <p:cNvPicPr>
+            <a:picLocks noChangeAspect="1"/>
+          </p:cNvPicPr>
+          <p:nvPr/>
+        </p:nvPicPr>
+        <p:blipFill>
+          <a:blip r:embed="rId9"/>
+          <a:stretch>
+            <a:fillRect/>
+          </a:stretch>
+        </p:blipFill>
+        <p:spPr>
+          <a:xfrm>
+            <a:off x="11683471" y="8446160"/>
+            <a:ext cx="8352000" cy="5720358"/>
+          </a:xfrm>
+          <a:prstGeom prst="rect">
+            <a:avLst/>
+          </a:prstGeom>
+        </p:spPr>
+      </p:pic>
+      <p:sp>
+        <p:nvSpPr>
+          <p:cNvPr id="23" name="Legenda mapa"/>
+          <p:cNvSpPr txBox="1"/>
+          <p:nvPr/>
+        </p:nvSpPr>
+        <p:spPr>
+          <a:xfrm>
+            <a:off x="11700000" y="14307931"/>
+            <a:ext cx="8352000" cy="288000"/>
+          </a:xfrm>
+          <a:prstGeom prst="rect">
+            <a:avLst/>
+          </a:prstGeom>
+          <a:noFill/>
+        </p:spPr>
+        <p:txBody>
+          <a:bodyPr wrap="square" lIns="0" tIns="0" rIns="0" bIns="0" anchor="t">
+            <a:spAutoFit/>
+          </a:bodyPr>
+          <a:lstStyle/>
+          <a:p>
+            <a:pPr algn="l">
+              <a:lnSpc>
+                <a:spcPct val="108000"/>
+              </a:lnSpc>
+              <a:spcAft>
+                <a:spcPts val="600"/>
+              </a:spcAft>
+            </a:pPr>
+            <a:r>
+              <a:rPr sz="1800" b="0" i="0">
+                <a:solidFill>
+                  <a:srgbClr val="5B6573"/>
+                </a:solidFill>
+                <a:latin typeface="Arial"/>
+              </a:rPr>
+              <a:t>Figura 1 – Bacia do rio Taquari-Antas até Santa Tereza e postos fluviométricos.</a:t>
+            </a:r>
+          </a:p>
+        </p:txBody>
+      </p:sp>
+      <p:sp>
+        <p:nvSpPr>
+          <p:cNvPr id="24" name="Secao METODOLOGIA: ABORDAGEM ALTERNATIVA (ALT)"/>
           <p:cNvSpPr/>
           <p:nvPr/>
         </p:nvSpPr>
         <p:spPr>
           <a:xfrm>
-            <a:off x="1080000" y="15480000"/>
+            <a:off x="1080000" y="15402633"/>
+            <a:ext cx="11448000" cy="504000"/>
+          </a:xfrm>
+          <a:prstGeom prst="roundRect">
+            <a:avLst>
+              <a:gd name="adj" fmla="val 50000"/>
+            </a:avLst>
+          </a:prstGeom>
+          <a:solidFill>
+            <a:srgbClr val="2A378D"/>
+          </a:solidFill>
+          <a:ln>
+            <a:noFill/>
+          </a:ln>
+          <a:effectLst/>
+        </p:spPr>
+        <p:style>
+          <a:lnRef idx="1">
+            <a:schemeClr val="accent1"/>
+          </a:lnRef>
+          <a:fillRef idx="3">
+            <a:schemeClr val="accent1"/>
+          </a:fillRef>
+          <a:effectRef idx="2">
+            <a:schemeClr val="accent1"/>
+          </a:effectRef>
+          <a:fontRef idx="minor">
+            <a:schemeClr val="lt1"/>
+          </a:fontRef>
+        </p:style>
+        <p:txBody>
+          <a:bodyPr wrap="none" lIns="252000" tIns="0" rIns="252000" bIns="0" rtlCol="0" anchor="ctr"/>
+          <a:lstStyle/>
+          <a:p>
+            <a:pPr algn="l"/>
+            <a:r>
+              <a:rPr sz="3000" b="1" i="0" dirty="0">
+                <a:solidFill>
+                  <a:srgbClr val="FFFFFF"/>
+                </a:solidFill>
+                <a:latin typeface="Arial"/>
+              </a:rPr>
+              <a:t>METODOLOGIA: ABORDAGEM ALTERNATIVA (ALT)</a:t>
+            </a:r>
+          </a:p>
+        </p:txBody>
+      </p:sp>
+      <p:sp>
+        <p:nvSpPr>
+          <p:cNvPr id="25" name="Etapa 1"/>
+          <p:cNvSpPr/>
+          <p:nvPr/>
+        </p:nvSpPr>
+        <p:spPr>
+          <a:xfrm>
+            <a:off x="1080000" y="16128000"/>
             <a:ext cx="4248000" cy="1584000"/>
           </a:xfrm>
           <a:prstGeom prst="roundRect">
@@ -4342,12 +4669,12 @@
           </a:fontRef>
         </p:style>
         <p:txBody>
-          <a:bodyPr rtlCol="0" anchor="ctr" wrap="square" lIns="144000" rIns="144000" tIns="72000" bIns="72000"/>
+          <a:bodyPr wrap="square" lIns="144000" tIns="72000" rIns="144000" bIns="72000" rtlCol="0" anchor="ctr"/>
           <a:lstStyle/>
           <a:p>
             <a:pPr algn="ctr"/>
             <a:r>
-              <a:rPr sz="2600" b="1" i="0">
+              <a:rPr sz="2400" b="1" i="0">
                 <a:solidFill>
                   <a:srgbClr val="D9661F"/>
                 </a:solidFill>
@@ -4359,26 +4686,26 @@
           <a:p>
             <a:pPr algn="ctr"/>
             <a:r>
-              <a:rPr sz="1900" b="0" i="0">
+              <a:rPr sz="1800" b="0" i="0">
                 <a:solidFill>
                   <a:srgbClr val="1F2633"/>
                 </a:solidFill>
                 <a:latin typeface="Arial"/>
               </a:rPr>
-              <a:t>níveis, diferenças e acelerações (local e montante) + chuva</a:t>
-            </a:r>
-          </a:p>
-        </p:txBody>
-      </p:sp>
-      <p:sp>
-        <p:nvSpPr>
-          <p:cNvPr id="27" name="Seta 1"/>
+              <a:t>níveis, diferenças e acelerações em Santa Tereza e a montante; chuva acumulada</a:t>
+            </a:r>
+          </a:p>
+        </p:txBody>
+      </p:sp>
+      <p:sp>
+        <p:nvSpPr>
+          <p:cNvPr id="26" name="Seta 1"/>
           <p:cNvSpPr/>
           <p:nvPr/>
         </p:nvSpPr>
         <p:spPr>
           <a:xfrm>
-            <a:off x="5436000" y="16056000"/>
+            <a:off x="5436000" y="16704000"/>
             <a:ext cx="504000" cy="432000"/>
           </a:xfrm>
           <a:prstGeom prst="rightArrow">
@@ -4411,18 +4738,19 @@
           <a:lstStyle/>
           <a:p>
             <a:pPr algn="ctr"/>
-          </a:p>
-        </p:txBody>
-      </p:sp>
-      <p:sp>
-        <p:nvSpPr>
-          <p:cNvPr id="28" name="Etapa 2"/>
+            <a:endParaRPr/>
+          </a:p>
+        </p:txBody>
+      </p:sp>
+      <p:sp>
+        <p:nvSpPr>
+          <p:cNvPr id="27" name="Etapa 2"/>
           <p:cNvSpPr/>
           <p:nvPr/>
         </p:nvSpPr>
         <p:spPr>
           <a:xfrm>
-            <a:off x="6048000" y="15480000"/>
+            <a:off x="6048000" y="16128000"/>
             <a:ext cx="4248000" cy="1584000"/>
           </a:xfrm>
           <a:prstGeom prst="roundRect">
@@ -4453,12 +4781,12 @@
           </a:fontRef>
         </p:style>
         <p:txBody>
-          <a:bodyPr rtlCol="0" anchor="ctr" wrap="square" lIns="144000" rIns="144000" tIns="72000" bIns="72000"/>
+          <a:bodyPr wrap="square" lIns="144000" tIns="72000" rIns="144000" bIns="72000" rtlCol="0" anchor="ctr"/>
           <a:lstStyle/>
           <a:p>
             <a:pPr algn="ctr"/>
             <a:r>
-              <a:rPr sz="2600" b="1" i="0">
+              <a:rPr sz="2400" b="1" i="0">
                 <a:solidFill>
                   <a:srgbClr val="D9661F"/>
                 </a:solidFill>
@@ -4470,26 +4798,26 @@
           <a:p>
             <a:pPr algn="ctr"/>
             <a:r>
-              <a:rPr sz="1900" b="0" i="0">
+              <a:rPr sz="1800" b="0" i="0">
                 <a:solidFill>
                   <a:srgbClr val="1F2633"/>
                 </a:solidFill>
                 <a:latin typeface="Arial"/>
               </a:rPr>
-              <a:t>1 camada oculta · sigmoide · retropropagação</a:t>
-            </a:r>
-          </a:p>
-        </p:txBody>
-      </p:sp>
-      <p:sp>
-        <p:nvSpPr>
-          <p:cNvPr id="29" name="Seta 2"/>
+              <a:t>1 camada oculta · sigmoide · retropropagação com gradiente adaptativo</a:t>
+            </a:r>
+          </a:p>
+        </p:txBody>
+      </p:sp>
+      <p:sp>
+        <p:nvSpPr>
+          <p:cNvPr id="28" name="Seta 2"/>
           <p:cNvSpPr/>
           <p:nvPr/>
         </p:nvSpPr>
         <p:spPr>
           <a:xfrm>
-            <a:off x="10404000" y="16056000"/>
+            <a:off x="10404000" y="16704000"/>
             <a:ext cx="504000" cy="432000"/>
           </a:xfrm>
           <a:prstGeom prst="rightArrow">
@@ -4522,18 +4850,19 @@
           <a:lstStyle/>
           <a:p>
             <a:pPr algn="ctr"/>
-          </a:p>
-        </p:txBody>
-      </p:sp>
-      <p:sp>
-        <p:nvSpPr>
-          <p:cNvPr id="30" name="Etapa 3"/>
+            <a:endParaRPr/>
+          </a:p>
+        </p:txBody>
+      </p:sp>
+      <p:sp>
+        <p:nvSpPr>
+          <p:cNvPr id="29" name="Etapa 3"/>
           <p:cNvSpPr/>
           <p:nvPr/>
         </p:nvSpPr>
         <p:spPr>
           <a:xfrm>
-            <a:off x="11016000" y="15480000"/>
+            <a:off x="11016000" y="16128000"/>
             <a:ext cx="4248000" cy="1584000"/>
           </a:xfrm>
           <a:prstGeom prst="roundRect">
@@ -4564,12 +4893,12 @@
           </a:fontRef>
         </p:style>
         <p:txBody>
-          <a:bodyPr rtlCol="0" anchor="ctr" wrap="square" lIns="144000" rIns="144000" tIns="72000" bIns="72000"/>
+          <a:bodyPr wrap="square" lIns="144000" tIns="72000" rIns="144000" bIns="72000" rtlCol="0" anchor="ctr"/>
           <a:lstStyle/>
           <a:p>
             <a:pPr algn="ctr"/>
             <a:r>
-              <a:rPr sz="2600" b="1" i="0">
+              <a:rPr sz="2400" b="1" i="0">
                 <a:solidFill>
                   <a:srgbClr val="D9661F"/>
                 </a:solidFill>
@@ -4581,26 +4910,26 @@
           <a:p>
             <a:pPr algn="ctr"/>
             <a:r>
-              <a:rPr sz="1900" b="0" i="0">
+              <a:rPr sz="1800" b="0" i="0">
                 <a:solidFill>
                   <a:srgbClr val="1F2633"/>
                 </a:solidFill>
                 <a:latin typeface="Arial"/>
               </a:rPr>
-              <a:t>ΔH = H(t+h) − H(t)</a:t>
-            </a:r>
-          </a:p>
-        </p:txBody>
-      </p:sp>
-      <p:sp>
-        <p:nvSpPr>
-          <p:cNvPr id="31" name="Seta 3"/>
+              <a:t>variação do nível ΔH = H(t+h) − H(t)</a:t>
+            </a:r>
+          </a:p>
+        </p:txBody>
+      </p:sp>
+      <p:sp>
+        <p:nvSpPr>
+          <p:cNvPr id="30" name="Seta 3"/>
           <p:cNvSpPr/>
           <p:nvPr/>
         </p:nvSpPr>
         <p:spPr>
           <a:xfrm>
-            <a:off x="15372000" y="16056000"/>
+            <a:off x="15372000" y="16704000"/>
             <a:ext cx="504000" cy="432000"/>
           </a:xfrm>
           <a:prstGeom prst="rightArrow">
@@ -4633,18 +4962,19 @@
           <a:lstStyle/>
           <a:p>
             <a:pPr algn="ctr"/>
-          </a:p>
-        </p:txBody>
-      </p:sp>
-      <p:sp>
-        <p:nvSpPr>
-          <p:cNvPr id="32" name="Etapa 4"/>
+            <a:endParaRPr/>
+          </a:p>
+        </p:txBody>
+      </p:sp>
+      <p:sp>
+        <p:nvSpPr>
+          <p:cNvPr id="31" name="Etapa 4"/>
           <p:cNvSpPr/>
           <p:nvPr/>
         </p:nvSpPr>
         <p:spPr>
           <a:xfrm>
-            <a:off x="15984000" y="15480000"/>
+            <a:off x="15984000" y="16128000"/>
             <a:ext cx="4248000" cy="1584000"/>
           </a:xfrm>
           <a:prstGeom prst="roundRect">
@@ -4675,12 +5005,12 @@
           </a:fontRef>
         </p:style>
         <p:txBody>
-          <a:bodyPr rtlCol="0" anchor="ctr" wrap="square" lIns="144000" rIns="144000" tIns="72000" bIns="72000"/>
+          <a:bodyPr wrap="square" lIns="144000" tIns="72000" rIns="144000" bIns="72000" rtlCol="0" anchor="ctr"/>
           <a:lstStyle/>
           <a:p>
             <a:pPr algn="ctr"/>
             <a:r>
-              <a:rPr sz="2600" b="1" i="0">
+              <a:rPr sz="2400" b="1" i="0">
                 <a:solidFill>
                   <a:srgbClr val="FFFFFF"/>
                 </a:solidFill>
@@ -4692,7 +5022,7 @@
           <a:p>
             <a:pPr algn="ctr"/>
             <a:r>
-              <a:rPr sz="1900" b="0" i="0">
+              <a:rPr sz="1800" b="0" i="0">
                 <a:solidFill>
                   <a:srgbClr val="FFFFFF"/>
                 </a:solidFill>
@@ -4705,81 +5035,14 @@
       </p:sp>
       <p:sp>
         <p:nvSpPr>
-          <p:cNvPr id="33" name="Config 2h"/>
-          <p:cNvSpPr/>
+          <p:cNvPr id="32" name="Texto metodologia"/>
+          <p:cNvSpPr txBox="1"/>
           <p:nvPr/>
         </p:nvSpPr>
         <p:spPr>
           <a:xfrm>
-            <a:off x="1080000" y="17316000"/>
-            <a:ext cx="6168000" cy="504000"/>
-          </a:xfrm>
-          <a:prstGeom prst="roundRect">
-            <a:avLst>
-              <a:gd name="adj" fmla="val 12000"/>
-            </a:avLst>
-          </a:prstGeom>
-          <a:solidFill>
-            <a:srgbClr val="FFFFFF"/>
-          </a:solidFill>
-          <a:ln>
-            <a:noFill/>
-          </a:ln>
-          <a:effectLst/>
-        </p:spPr>
-        <p:style>
-          <a:lnRef idx="1">
-            <a:schemeClr val="accent1"/>
-          </a:lnRef>
-          <a:fillRef idx="3">
-            <a:schemeClr val="accent1"/>
-          </a:fillRef>
-          <a:effectRef idx="2">
-            <a:schemeClr val="accent1"/>
-          </a:effectRef>
-          <a:fontRef idx="minor">
-            <a:schemeClr val="lt1"/>
-          </a:fontRef>
-        </p:style>
-        <p:txBody>
-          <a:bodyPr rtlCol="0" anchor="ctr" wrap="square" lIns="108000" rIns="108000" tIns="36000" bIns="36000"/>
-          <a:lstStyle/>
-          <a:p>
-            <a:pPr algn="ctr"/>
-            <a:r>
-              <a:rPr sz="4000" b="1" i="0">
-                <a:solidFill>
-                  <a:srgbClr val="2A378D"/>
-                </a:solidFill>
-                <a:latin typeface="Arial"/>
-              </a:rPr>
-              <a:t/>
-            </a:r>
-          </a:p>
-          <a:p>
-            <a:pPr algn="ctr"/>
-            <a:r>
-              <a:rPr sz="1800" b="0" i="0">
-                <a:solidFill>
-                  <a:srgbClr val="1F2633"/>
-                </a:solidFill>
-                <a:latin typeface="Arial"/>
-              </a:rPr>
-              <a:t/>
-            </a:r>
-          </a:p>
-        </p:txBody>
-      </p:sp>
-      <p:sp>
-        <p:nvSpPr>
-          <p:cNvPr id="34" name="Texto config 2h"/>
-          <p:cNvSpPr txBox="1"/>
-          <p:nvPr/>
-        </p:nvSpPr>
-        <p:spPr>
-          <a:xfrm>
-            <a:off x="1080000" y="17388000"/>
-            <a:ext cx="6168000" cy="360000"/>
+            <a:off x="1080000" y="18036000"/>
+            <a:ext cx="9360000" cy="2232000"/>
           </a:xfrm>
           <a:prstGeom prst="rect">
             <a:avLst/>
@@ -4787,648 +5050,631 @@
           <a:noFill/>
         </p:spPr>
         <p:txBody>
-          <a:bodyPr wrap="square" lIns="0" rIns="0" tIns="0" bIns="0" anchor="t">
+          <a:bodyPr wrap="square" lIns="0" tIns="0" rIns="0" bIns="0" anchor="t">
             <a:spAutoFit/>
           </a:bodyPr>
           <a:lstStyle/>
           <a:p>
-            <a:pPr algn="ctr">
+            <a:pPr marL="252000" indent="-252000" algn="l">
               <a:lnSpc>
                 <a:spcPct val="108000"/>
               </a:lnSpc>
               <a:spcAft>
-                <a:spcPts val="600"/>
+                <a:spcPts val="400"/>
               </a:spcAft>
+              <a:buClr>
+                <a:srgbClr val="D9661F"/>
+              </a:buClr>
+              <a:buFont typeface="Arial"/>
+              <a:buChar char="■"/>
             </a:pPr>
             <a:r>
-              <a:rPr sz="2100" b="1" i="0">
-                <a:solidFill>
-                  <a:srgbClr val="2A378D"/>
-                </a:solidFill>
-                <a:latin typeface="Arial"/>
-              </a:rPr>
-              <a:t>ALT 2h: </a:t>
-            </a:r>
-            <a:r>
-              <a:rPr sz="2100" b="0" i="0">
+              <a:rPr sz="2000" b="0" i="0">
                 <a:solidFill>
                   <a:srgbClr val="1F2633"/>
                 </a:solidFill>
                 <a:latin typeface="Arial"/>
               </a:rPr>
-              <a:t>15 entradas · 30 neurônios</a:t>
-            </a:r>
-          </a:p>
-        </p:txBody>
-      </p:sp>
-      <p:sp>
-        <p:nvSpPr>
-          <p:cNvPr id="35" name="Config 4h"/>
-          <p:cNvSpPr/>
-          <p:nvPr/>
-        </p:nvSpPr>
-        <p:spPr>
-          <a:xfrm>
-            <a:off x="7608000" y="17316000"/>
-            <a:ext cx="6168000" cy="504000"/>
-          </a:xfrm>
-          <a:prstGeom prst="roundRect">
-            <a:avLst>
-              <a:gd name="adj" fmla="val 12000"/>
-            </a:avLst>
-          </a:prstGeom>
-          <a:solidFill>
-            <a:srgbClr val="FFFFFF"/>
-          </a:solidFill>
-          <a:ln>
-            <a:noFill/>
-          </a:ln>
-          <a:effectLst/>
-        </p:spPr>
-        <p:style>
-          <a:lnRef idx="1">
-            <a:schemeClr val="accent1"/>
-          </a:lnRef>
-          <a:fillRef idx="3">
-            <a:schemeClr val="accent1"/>
-          </a:fillRef>
-          <a:effectRef idx="2">
-            <a:schemeClr val="accent1"/>
-          </a:effectRef>
-          <a:fontRef idx="minor">
-            <a:schemeClr val="lt1"/>
-          </a:fontRef>
-        </p:style>
-        <p:txBody>
-          <a:bodyPr rtlCol="0" anchor="ctr" wrap="square" lIns="108000" rIns="108000" tIns="36000" bIns="36000"/>
-          <a:lstStyle/>
-          <a:p>
-            <a:pPr algn="ctr"/>
-            <a:r>
-              <a:rPr sz="4000" b="1" i="0">
-                <a:solidFill>
-                  <a:srgbClr val="2A378D"/>
-                </a:solidFill>
-                <a:latin typeface="Arial"/>
-              </a:rPr>
-              <a:t/>
-            </a:r>
-          </a:p>
-          <a:p>
-            <a:pPr algn="ctr"/>
-            <a:r>
-              <a:rPr sz="1800" b="0" i="0">
-                <a:solidFill>
-                  <a:srgbClr val="1F2633"/>
-                </a:solidFill>
-                <a:latin typeface="Arial"/>
-              </a:rPr>
-              <a:t/>
-            </a:r>
-          </a:p>
-        </p:txBody>
-      </p:sp>
-      <p:sp>
-        <p:nvSpPr>
-          <p:cNvPr id="36" name="Texto config 4h"/>
-          <p:cNvSpPr txBox="1"/>
-          <p:nvPr/>
-        </p:nvSpPr>
-        <p:spPr>
-          <a:xfrm>
-            <a:off x="7608000" y="17388000"/>
-            <a:ext cx="6168000" cy="360000"/>
-          </a:xfrm>
-          <a:prstGeom prst="rect">
-            <a:avLst/>
-          </a:prstGeom>
-          <a:noFill/>
-        </p:spPr>
-        <p:txBody>
-          <a:bodyPr wrap="square" lIns="0" rIns="0" tIns="0" bIns="0" anchor="t">
-            <a:spAutoFit/>
-          </a:bodyPr>
-          <a:lstStyle/>
-          <a:p>
-            <a:pPr algn="ctr">
+              <a:t>Neurônios ocultos ≈ 2 × nº de entradas; 10 inicializações por rede</a:t>
+            </a:r>
+          </a:p>
+          <a:p>
+            <a:pPr marL="252000" indent="-252000" algn="l">
               <a:lnSpc>
                 <a:spcPct val="108000"/>
               </a:lnSpc>
               <a:spcAft>
-                <a:spcPts val="600"/>
+                <a:spcPts val="400"/>
               </a:spcAft>
+              <a:buClr>
+                <a:srgbClr val="D9661F"/>
+              </a:buClr>
+              <a:buFont typeface="Arial"/>
+              <a:buChar char="■"/>
             </a:pPr>
             <a:r>
-              <a:rPr sz="2100" b="1" i="0">
-                <a:solidFill>
-                  <a:srgbClr val="2A378D"/>
-                </a:solidFill>
-                <a:latin typeface="Arial"/>
-              </a:rPr>
-              <a:t>ALT 4h: </a:t>
-            </a:r>
-            <a:r>
-              <a:rPr sz="2100" b="0" i="0">
+              <a:rPr sz="2000" b="0" i="0">
                 <a:solidFill>
                   <a:srgbClr val="1F2633"/>
                 </a:solidFill>
                 <a:latin typeface="Arial"/>
               </a:rPr>
-              <a:t>26 entradas · 52 neurônios</a:t>
-            </a:r>
-          </a:p>
-        </p:txBody>
-      </p:sp>
-      <p:sp>
-        <p:nvSpPr>
-          <p:cNvPr id="37" name="Config 8h"/>
-          <p:cNvSpPr/>
-          <p:nvPr/>
-        </p:nvSpPr>
-        <p:spPr>
-          <a:xfrm>
-            <a:off x="14136000" y="17316000"/>
-            <a:ext cx="6168000" cy="504000"/>
-          </a:xfrm>
-          <a:prstGeom prst="roundRect">
-            <a:avLst>
-              <a:gd name="adj" fmla="val 12000"/>
-            </a:avLst>
-          </a:prstGeom>
-          <a:solidFill>
-            <a:srgbClr val="FFFFFF"/>
-          </a:solidFill>
-          <a:ln>
-            <a:noFill/>
-          </a:ln>
-          <a:effectLst/>
-        </p:spPr>
-        <p:style>
-          <a:lnRef idx="1">
-            <a:schemeClr val="accent1"/>
-          </a:lnRef>
-          <a:fillRef idx="3">
-            <a:schemeClr val="accent1"/>
-          </a:fillRef>
-          <a:effectRef idx="2">
-            <a:schemeClr val="accent1"/>
-          </a:effectRef>
-          <a:fontRef idx="minor">
-            <a:schemeClr val="lt1"/>
-          </a:fontRef>
-        </p:style>
-        <p:txBody>
-          <a:bodyPr rtlCol="0" anchor="ctr" wrap="square" lIns="108000" rIns="108000" tIns="36000" bIns="36000"/>
-          <a:lstStyle/>
-          <a:p>
-            <a:pPr algn="ctr"/>
-            <a:r>
-              <a:rPr sz="4000" b="1" i="0">
-                <a:solidFill>
-                  <a:srgbClr val="2A378D"/>
-                </a:solidFill>
-                <a:latin typeface="Arial"/>
-              </a:rPr>
-              <a:t/>
-            </a:r>
-          </a:p>
-          <a:p>
-            <a:pPr algn="ctr"/>
-            <a:r>
-              <a:rPr sz="1800" b="0" i="0">
-                <a:solidFill>
-                  <a:srgbClr val="1F2633"/>
-                </a:solidFill>
-                <a:latin typeface="Arial"/>
-              </a:rPr>
-              <a:t/>
-            </a:r>
-          </a:p>
-        </p:txBody>
-      </p:sp>
-      <p:sp>
-        <p:nvSpPr>
-          <p:cNvPr id="38" name="Texto config 8h"/>
-          <p:cNvSpPr txBox="1"/>
-          <p:nvPr/>
-        </p:nvSpPr>
-        <p:spPr>
-          <a:xfrm>
-            <a:off x="14136000" y="17388000"/>
-            <a:ext cx="6168000" cy="360000"/>
-          </a:xfrm>
-          <a:prstGeom prst="rect">
-            <a:avLst/>
-          </a:prstGeom>
-          <a:noFill/>
-        </p:spPr>
-        <p:txBody>
-          <a:bodyPr wrap="square" lIns="0" rIns="0" tIns="0" bIns="0" anchor="t">
-            <a:spAutoFit/>
-          </a:bodyPr>
-          <a:lstStyle/>
-          <a:p>
-            <a:pPr algn="ctr">
+              <a:t>Entradas escolhidas por algoritmo de busca em Python; redes treinadas no MATLAB</a:t>
+            </a:r>
+          </a:p>
+          <a:p>
+            <a:pPr marL="252000" indent="-252000" algn="l">
               <a:lnSpc>
                 <a:spcPct val="108000"/>
               </a:lnSpc>
               <a:spcAft>
-                <a:spcPts val="600"/>
+                <a:spcPts val="400"/>
               </a:spcAft>
+              <a:buClr>
+                <a:srgbClr val="D9661F"/>
+              </a:buClr>
+              <a:buFont typeface="Arial"/>
+              <a:buChar char="■"/>
             </a:pPr>
             <a:r>
-              <a:rPr sz="2100" b="1" i="0">
-                <a:solidFill>
-                  <a:srgbClr val="2A378D"/>
-                </a:solidFill>
-                <a:latin typeface="Arial"/>
-              </a:rPr>
-              <a:t>ALT 8h: </a:t>
-            </a:r>
-            <a:r>
-              <a:rPr sz="2100" b="0" i="0">
+              <a:rPr sz="2000" b="0" i="0">
                 <a:solidFill>
                   <a:srgbClr val="1F2633"/>
                 </a:solidFill>
                 <a:latin typeface="Arial"/>
               </a:rPr>
-              <a:t>31 entradas · 63 neurônios</a:t>
-            </a:r>
-          </a:p>
-        </p:txBody>
-      </p:sp>
-      <p:sp>
-        <p:nvSpPr>
-          <p:cNvPr id="39" name="Secao RESULTADOS NO TESTE"/>
+              <a:t>Avaliação: NSE, PME (ganho sobre a persistência), EAM e E95 (erro não superado em 95%)</a:t>
+            </a:r>
+          </a:p>
+        </p:txBody>
+      </p:sp>
+      <p:graphicFrame>
+        <p:nvGraphicFramePr>
+          <p:cNvPr id="33" name="Tabela configuracao"/>
+          <p:cNvGraphicFramePr>
+            <a:graphicFrameLocks noGrp="1"/>
+          </p:cNvGraphicFramePr>
+          <p:nvPr>
+            <p:extLst>
+              <p:ext uri="{D42A27DB-BD31-4B8C-83A1-F6EECF244321}">
+                <p14:modId xmlns:p14="http://schemas.microsoft.com/office/powerpoint/2010/main" val="3241285846"/>
+              </p:ext>
+            </p:extLst>
+          </p:nvPr>
+        </p:nvGraphicFramePr>
+        <p:xfrm>
+          <a:off x="10944000" y="18036000"/>
+          <a:ext cx="9360000" cy="1800000"/>
+        </p:xfrm>
+        <a:graphic>
+          <a:graphicData uri="http://schemas.openxmlformats.org/drawingml/2006/table">
+            <a:tbl>
+              <a:tblPr>
+                <a:tableStyleId>{5C22544A-7EE6-4342-B048-85BDC9FD1C3A}</a:tableStyleId>
+              </a:tblPr>
+              <a:tblGrid>
+                <a:gridCol w="1376471">
+                  <a:extLst>
+                    <a:ext uri="{9D8B030D-6E8A-4147-A177-3AD203B41FA5}">
+                      <a16:colId xmlns:a16="http://schemas.microsoft.com/office/drawing/2014/main" val="20000"/>
+                    </a:ext>
+                  </a:extLst>
+                </a:gridCol>
+                <a:gridCol w="1445294">
+                  <a:extLst>
+                    <a:ext uri="{9D8B030D-6E8A-4147-A177-3AD203B41FA5}">
+                      <a16:colId xmlns:a16="http://schemas.microsoft.com/office/drawing/2014/main" val="20001"/>
+                    </a:ext>
+                  </a:extLst>
+                </a:gridCol>
+                <a:gridCol w="1582941">
+                  <a:extLst>
+                    <a:ext uri="{9D8B030D-6E8A-4147-A177-3AD203B41FA5}">
+                      <a16:colId xmlns:a16="http://schemas.microsoft.com/office/drawing/2014/main" val="20002"/>
+                    </a:ext>
+                  </a:extLst>
+                </a:gridCol>
+                <a:gridCol w="4955294">
+                  <a:extLst>
+                    <a:ext uri="{9D8B030D-6E8A-4147-A177-3AD203B41FA5}">
+                      <a16:colId xmlns:a16="http://schemas.microsoft.com/office/drawing/2014/main" val="20003"/>
+                    </a:ext>
+                  </a:extLst>
+                </a:gridCol>
+              </a:tblGrid>
+              <a:tr h="450000">
+                <a:tc>
+                  <a:txBody>
+                    <a:bodyPr/>
+                    <a:lstStyle/>
+                    <a:p>
+                      <a:pPr algn="l"/>
+                      <a:r>
+                        <a:rPr sz="1900" b="1" i="0">
+                          <a:solidFill>
+                            <a:srgbClr val="FFFFFF"/>
+                          </a:solidFill>
+                          <a:latin typeface="Arial"/>
+                        </a:rPr>
+                        <a:t>Modelo</a:t>
+                      </a:r>
+                    </a:p>
+                  </a:txBody>
+                  <a:tcPr marL="90000" marR="90000" marT="36000" marB="36000" anchor="ctr">
+                    <a:solidFill>
+                      <a:srgbClr val="2A378D"/>
+                    </a:solidFill>
+                  </a:tcPr>
+                </a:tc>
+                <a:tc>
+                  <a:txBody>
+                    <a:bodyPr/>
+                    <a:lstStyle/>
+                    <a:p>
+                      <a:pPr algn="ctr"/>
+                      <a:r>
+                        <a:rPr sz="1900" b="1" i="0">
+                          <a:solidFill>
+                            <a:srgbClr val="FFFFFF"/>
+                          </a:solidFill>
+                          <a:latin typeface="Arial"/>
+                        </a:rPr>
+                        <a:t>Entradas</a:t>
+                      </a:r>
+                    </a:p>
+                  </a:txBody>
+                  <a:tcPr marL="90000" marR="90000" marT="36000" marB="36000" anchor="ctr">
+                    <a:solidFill>
+                      <a:srgbClr val="2A378D"/>
+                    </a:solidFill>
+                  </a:tcPr>
+                </a:tc>
+                <a:tc>
+                  <a:txBody>
+                    <a:bodyPr/>
+                    <a:lstStyle/>
+                    <a:p>
+                      <a:pPr algn="ctr"/>
+                      <a:r>
+                        <a:rPr sz="1900" b="1" i="0">
+                          <a:solidFill>
+                            <a:srgbClr val="FFFFFF"/>
+                          </a:solidFill>
+                          <a:latin typeface="Arial"/>
+                        </a:rPr>
+                        <a:t>Neurônios</a:t>
+                      </a:r>
+                    </a:p>
+                  </a:txBody>
+                  <a:tcPr marL="90000" marR="90000" marT="36000" marB="36000" anchor="ctr">
+                    <a:solidFill>
+                      <a:srgbClr val="2A378D"/>
+                    </a:solidFill>
+                  </a:tcPr>
+                </a:tc>
+                <a:tc>
+                  <a:txBody>
+                    <a:bodyPr/>
+                    <a:lstStyle/>
+                    <a:p>
+                      <a:pPr algn="ctr"/>
+                      <a:r>
+                        <a:rPr sz="1900" b="1" i="0">
+                          <a:solidFill>
+                            <a:srgbClr val="FFFFFF"/>
+                          </a:solidFill>
+                          <a:latin typeface="Arial"/>
+                        </a:rPr>
+                        <a:t>Variáveis de entrada</a:t>
+                      </a:r>
+                    </a:p>
+                  </a:txBody>
+                  <a:tcPr marL="90000" marR="90000" marT="36000" marB="36000" anchor="ctr">
+                    <a:solidFill>
+                      <a:srgbClr val="2A378D"/>
+                    </a:solidFill>
+                  </a:tcPr>
+                </a:tc>
+                <a:extLst>
+                  <a:ext uri="{0D108BD9-81ED-4DB2-BD59-A6C34878D82A}">
+                    <a16:rowId xmlns:a16="http://schemas.microsoft.com/office/drawing/2014/main" val="10000"/>
+                  </a:ext>
+                </a:extLst>
+              </a:tr>
+              <a:tr h="450000">
+                <a:tc>
+                  <a:txBody>
+                    <a:bodyPr/>
+                    <a:lstStyle/>
+                    <a:p>
+                      <a:pPr algn="l"/>
+                      <a:r>
+                        <a:rPr sz="1900" b="1" i="0">
+                          <a:solidFill>
+                            <a:srgbClr val="1F2633"/>
+                          </a:solidFill>
+                          <a:latin typeface="Arial"/>
+                        </a:rPr>
+                        <a:t>ALT 2h</a:t>
+                      </a:r>
+                    </a:p>
+                  </a:txBody>
+                  <a:tcPr marL="90000" marR="90000" marT="36000" marB="36000" anchor="ctr">
+                    <a:solidFill>
+                      <a:srgbClr val="FFFFFF"/>
+                    </a:solidFill>
+                  </a:tcPr>
+                </a:tc>
+                <a:tc>
+                  <a:txBody>
+                    <a:bodyPr/>
+                    <a:lstStyle/>
+                    <a:p>
+                      <a:pPr algn="ctr"/>
+                      <a:r>
+                        <a:rPr sz="1900" b="0" i="0">
+                          <a:solidFill>
+                            <a:srgbClr val="1F2633"/>
+                          </a:solidFill>
+                          <a:latin typeface="Arial"/>
+                        </a:rPr>
+                        <a:t>15</a:t>
+                      </a:r>
+                    </a:p>
+                  </a:txBody>
+                  <a:tcPr marL="90000" marR="90000" marT="36000" marB="36000" anchor="ctr">
+                    <a:solidFill>
+                      <a:srgbClr val="FFFFFF"/>
+                    </a:solidFill>
+                  </a:tcPr>
+                </a:tc>
+                <a:tc>
+                  <a:txBody>
+                    <a:bodyPr/>
+                    <a:lstStyle/>
+                    <a:p>
+                      <a:pPr algn="ctr"/>
+                      <a:r>
+                        <a:rPr sz="1900" b="0" i="0">
+                          <a:solidFill>
+                            <a:srgbClr val="1F2633"/>
+                          </a:solidFill>
+                          <a:latin typeface="Arial"/>
+                        </a:rPr>
+                        <a:t>30</a:t>
+                      </a:r>
+                    </a:p>
+                  </a:txBody>
+                  <a:tcPr marL="90000" marR="90000" marT="36000" marB="36000" anchor="ctr">
+                    <a:solidFill>
+                      <a:srgbClr val="FFFFFF"/>
+                    </a:solidFill>
+                  </a:tcPr>
+                </a:tc>
+                <a:tc>
+                  <a:txBody>
+                    <a:bodyPr/>
+                    <a:lstStyle/>
+                    <a:p>
+                      <a:pPr algn="l"/>
+                      <a:r>
+                        <a:rPr lang="pt-BR" sz="1900" b="0" i="0" dirty="0">
+                          <a:solidFill>
+                            <a:srgbClr val="1F2633"/>
+                          </a:solidFill>
+                          <a:latin typeface="Arial"/>
+                        </a:rPr>
+                        <a:t>Santa Tereza e Linha José Júlio</a:t>
+                      </a:r>
+                    </a:p>
+                  </a:txBody>
+                  <a:tcPr marL="90000" marR="90000" marT="36000" marB="36000" anchor="ctr">
+                    <a:solidFill>
+                      <a:srgbClr val="FFFFFF"/>
+                    </a:solidFill>
+                  </a:tcPr>
+                </a:tc>
+                <a:extLst>
+                  <a:ext uri="{0D108BD9-81ED-4DB2-BD59-A6C34878D82A}">
+                    <a16:rowId xmlns:a16="http://schemas.microsoft.com/office/drawing/2014/main" val="10001"/>
+                  </a:ext>
+                </a:extLst>
+              </a:tr>
+              <a:tr h="450000">
+                <a:tc>
+                  <a:txBody>
+                    <a:bodyPr/>
+                    <a:lstStyle/>
+                    <a:p>
+                      <a:pPr algn="l"/>
+                      <a:r>
+                        <a:rPr sz="1900" b="1" i="0">
+                          <a:solidFill>
+                            <a:srgbClr val="1F2633"/>
+                          </a:solidFill>
+                          <a:latin typeface="Arial"/>
+                        </a:rPr>
+                        <a:t>ALT 4h</a:t>
+                      </a:r>
+                    </a:p>
+                  </a:txBody>
+                  <a:tcPr marL="90000" marR="90000" marT="36000" marB="36000" anchor="ctr">
+                    <a:solidFill>
+                      <a:srgbClr val="E6EEF5"/>
+                    </a:solidFill>
+                  </a:tcPr>
+                </a:tc>
+                <a:tc>
+                  <a:txBody>
+                    <a:bodyPr/>
+                    <a:lstStyle/>
+                    <a:p>
+                      <a:pPr algn="ctr"/>
+                      <a:r>
+                        <a:rPr sz="1900" b="0" i="0">
+                          <a:solidFill>
+                            <a:srgbClr val="1F2633"/>
+                          </a:solidFill>
+                          <a:latin typeface="Arial"/>
+                        </a:rPr>
+                        <a:t>26</a:t>
+                      </a:r>
+                    </a:p>
+                  </a:txBody>
+                  <a:tcPr marL="90000" marR="90000" marT="36000" marB="36000" anchor="ctr">
+                    <a:solidFill>
+                      <a:srgbClr val="E6EEF5"/>
+                    </a:solidFill>
+                  </a:tcPr>
+                </a:tc>
+                <a:tc>
+                  <a:txBody>
+                    <a:bodyPr/>
+                    <a:lstStyle/>
+                    <a:p>
+                      <a:pPr algn="ctr"/>
+                      <a:r>
+                        <a:rPr sz="1900" b="0" i="0">
+                          <a:solidFill>
+                            <a:srgbClr val="1F2633"/>
+                          </a:solidFill>
+                          <a:latin typeface="Arial"/>
+                        </a:rPr>
+                        <a:t>52</a:t>
+                      </a:r>
+                    </a:p>
+                  </a:txBody>
+                  <a:tcPr marL="90000" marR="90000" marT="36000" marB="36000" anchor="ctr">
+                    <a:solidFill>
+                      <a:srgbClr val="E6EEF5"/>
+                    </a:solidFill>
+                  </a:tcPr>
+                </a:tc>
+                <a:tc>
+                  <a:txBody>
+                    <a:bodyPr/>
+                    <a:lstStyle/>
+                    <a:p>
+                      <a:pPr algn="l"/>
+                      <a:r>
+                        <a:rPr sz="1900" b="0" i="0" dirty="0">
+                          <a:solidFill>
+                            <a:srgbClr val="1F2633"/>
+                          </a:solidFill>
+                          <a:latin typeface="Arial"/>
+                        </a:rPr>
+                        <a:t>+ 2 </a:t>
+                      </a:r>
+                      <a:r>
+                        <a:rPr sz="1900" b="0" i="0" dirty="0" err="1">
+                          <a:solidFill>
+                            <a:srgbClr val="1F2633"/>
+                          </a:solidFill>
+                          <a:latin typeface="Arial"/>
+                        </a:rPr>
+                        <a:t>postos</a:t>
+                      </a:r>
+                      <a:r>
+                        <a:rPr sz="1900" b="0" i="0" dirty="0">
+                          <a:solidFill>
+                            <a:srgbClr val="1F2633"/>
+                          </a:solidFill>
+                          <a:latin typeface="Arial"/>
+                        </a:rPr>
+                        <a:t> a </a:t>
+                      </a:r>
+                      <a:r>
+                        <a:rPr sz="1900" b="0" i="0" dirty="0" err="1">
+                          <a:solidFill>
+                            <a:srgbClr val="1F2633"/>
+                          </a:solidFill>
+                          <a:latin typeface="Arial"/>
+                        </a:rPr>
+                        <a:t>montante</a:t>
+                      </a:r>
+                      <a:endParaRPr sz="1900" b="0" i="0" dirty="0">
+                        <a:solidFill>
+                          <a:srgbClr val="1F2633"/>
+                        </a:solidFill>
+                        <a:latin typeface="Arial"/>
+                      </a:endParaRPr>
+                    </a:p>
+                  </a:txBody>
+                  <a:tcPr marL="90000" marR="90000" marT="36000" marB="36000" anchor="ctr">
+                    <a:solidFill>
+                      <a:srgbClr val="E6EEF5"/>
+                    </a:solidFill>
+                  </a:tcPr>
+                </a:tc>
+                <a:extLst>
+                  <a:ext uri="{0D108BD9-81ED-4DB2-BD59-A6C34878D82A}">
+                    <a16:rowId xmlns:a16="http://schemas.microsoft.com/office/drawing/2014/main" val="10002"/>
+                  </a:ext>
+                </a:extLst>
+              </a:tr>
+              <a:tr h="450000">
+                <a:tc>
+                  <a:txBody>
+                    <a:bodyPr/>
+                    <a:lstStyle/>
+                    <a:p>
+                      <a:pPr algn="l"/>
+                      <a:r>
+                        <a:rPr sz="1900" b="1" i="0">
+                          <a:solidFill>
+                            <a:srgbClr val="1F2633"/>
+                          </a:solidFill>
+                          <a:latin typeface="Arial"/>
+                        </a:rPr>
+                        <a:t>ALT 8h</a:t>
+                      </a:r>
+                    </a:p>
+                  </a:txBody>
+                  <a:tcPr marL="90000" marR="90000" marT="36000" marB="36000" anchor="ctr">
+                    <a:solidFill>
+                      <a:srgbClr val="FFFFFF"/>
+                    </a:solidFill>
+                  </a:tcPr>
+                </a:tc>
+                <a:tc>
+                  <a:txBody>
+                    <a:bodyPr/>
+                    <a:lstStyle/>
+                    <a:p>
+                      <a:pPr algn="ctr"/>
+                      <a:r>
+                        <a:rPr sz="1900" b="0" i="0">
+                          <a:solidFill>
+                            <a:srgbClr val="1F2633"/>
+                          </a:solidFill>
+                          <a:latin typeface="Arial"/>
+                        </a:rPr>
+                        <a:t>31</a:t>
+                      </a:r>
+                    </a:p>
+                  </a:txBody>
+                  <a:tcPr marL="90000" marR="90000" marT="36000" marB="36000" anchor="ctr">
+                    <a:solidFill>
+                      <a:srgbClr val="FFFFFF"/>
+                    </a:solidFill>
+                  </a:tcPr>
+                </a:tc>
+                <a:tc>
+                  <a:txBody>
+                    <a:bodyPr/>
+                    <a:lstStyle/>
+                    <a:p>
+                      <a:pPr algn="ctr"/>
+                      <a:r>
+                        <a:rPr sz="1900" b="0" i="0">
+                          <a:solidFill>
+                            <a:srgbClr val="1F2633"/>
+                          </a:solidFill>
+                          <a:latin typeface="Arial"/>
+                        </a:rPr>
+                        <a:t>63</a:t>
+                      </a:r>
+                    </a:p>
+                  </a:txBody>
+                  <a:tcPr marL="90000" marR="90000" marT="36000" marB="36000" anchor="ctr">
+                    <a:solidFill>
+                      <a:srgbClr val="FFFFFF"/>
+                    </a:solidFill>
+                  </a:tcPr>
+                </a:tc>
+                <a:tc>
+                  <a:txBody>
+                    <a:bodyPr/>
+                    <a:lstStyle/>
+                    <a:p>
+                      <a:pPr algn="l"/>
+                      <a:r>
+                        <a:rPr sz="1900" b="0" i="0" dirty="0">
+                          <a:solidFill>
+                            <a:srgbClr val="1F2633"/>
+                          </a:solidFill>
+                          <a:latin typeface="Arial"/>
+                        </a:rPr>
+                        <a:t>7 </a:t>
+                      </a:r>
+                      <a:r>
+                        <a:rPr sz="1900" b="0" i="0" dirty="0" err="1">
+                          <a:solidFill>
+                            <a:srgbClr val="1F2633"/>
+                          </a:solidFill>
+                          <a:latin typeface="Arial"/>
+                        </a:rPr>
+                        <a:t>postos</a:t>
+                      </a:r>
+                      <a:r>
+                        <a:rPr sz="1900" b="0" i="0" dirty="0">
+                          <a:solidFill>
+                            <a:srgbClr val="1F2633"/>
+                          </a:solidFill>
+                          <a:latin typeface="Arial"/>
+                        </a:rPr>
+                        <a:t> </a:t>
+                      </a:r>
+                      <a:r>
+                        <a:rPr sz="1900" b="0" i="0" dirty="0" err="1">
+                          <a:solidFill>
+                            <a:srgbClr val="1F2633"/>
+                          </a:solidFill>
+                          <a:latin typeface="Arial"/>
+                        </a:rPr>
+                        <a:t>fluviométricos</a:t>
+                      </a:r>
+                      <a:r>
+                        <a:rPr sz="1900" b="0" i="0" dirty="0">
+                          <a:solidFill>
+                            <a:srgbClr val="1F2633"/>
+                          </a:solidFill>
+                          <a:latin typeface="Arial"/>
+                        </a:rPr>
+                        <a:t> + </a:t>
+                      </a:r>
+                      <a:r>
+                        <a:rPr sz="1900" b="0" i="0" dirty="0" err="1">
+                          <a:solidFill>
+                            <a:srgbClr val="1F2633"/>
+                          </a:solidFill>
+                          <a:latin typeface="Arial"/>
+                        </a:rPr>
+                        <a:t>chuva</a:t>
+                      </a:r>
+                      <a:endParaRPr sz="1900" b="0" i="0" dirty="0">
+                        <a:solidFill>
+                          <a:srgbClr val="1F2633"/>
+                        </a:solidFill>
+                        <a:latin typeface="Arial"/>
+                      </a:endParaRPr>
+                    </a:p>
+                  </a:txBody>
+                  <a:tcPr marL="90000" marR="90000" marT="36000" marB="36000" anchor="ctr">
+                    <a:solidFill>
+                      <a:srgbClr val="FFFFFF"/>
+                    </a:solidFill>
+                  </a:tcPr>
+                </a:tc>
+                <a:extLst>
+                  <a:ext uri="{0D108BD9-81ED-4DB2-BD59-A6C34878D82A}">
+                    <a16:rowId xmlns:a16="http://schemas.microsoft.com/office/drawing/2014/main" val="10003"/>
+                  </a:ext>
+                </a:extLst>
+              </a:tr>
+            </a:tbl>
+          </a:graphicData>
+        </a:graphic>
+      </p:graphicFrame>
+      <p:sp>
+        <p:nvSpPr>
+          <p:cNvPr id="34" name="Secao RESULTADOS"/>
           <p:cNvSpPr/>
           <p:nvPr/>
         </p:nvSpPr>
         <p:spPr>
           <a:xfrm>
-            <a:off x="1080000" y="18252000"/>
-            <a:ext cx="5853600" cy="504000"/>
-          </a:xfrm>
-          <a:prstGeom prst="roundRect">
-            <a:avLst>
-              <a:gd name="adj" fmla="val 50000"/>
-            </a:avLst>
-          </a:prstGeom>
-          <a:solidFill>
-            <a:srgbClr val="2A378D"/>
-          </a:solidFill>
-          <a:ln>
-            <a:noFill/>
-          </a:ln>
-          <a:effectLst/>
-        </p:spPr>
-        <p:style>
-          <a:lnRef idx="1">
-            <a:schemeClr val="accent1"/>
-          </a:lnRef>
-          <a:fillRef idx="3">
-            <a:schemeClr val="accent1"/>
-          </a:fillRef>
-          <a:effectRef idx="2">
-            <a:schemeClr val="accent1"/>
-          </a:effectRef>
-          <a:fontRef idx="minor">
-            <a:schemeClr val="lt1"/>
-          </a:fontRef>
-        </p:style>
-        <p:txBody>
-          <a:bodyPr rtlCol="0" anchor="ctr" wrap="none" lIns="252000" rIns="252000" tIns="0" bIns="0"/>
-          <a:lstStyle/>
-          <a:p>
-            <a:pPr algn="l"/>
-            <a:r>
-              <a:rPr sz="3000" b="1" i="0">
-                <a:solidFill>
-                  <a:srgbClr val="FFFFFF"/>
-                </a:solidFill>
-                <a:latin typeface="Arial"/>
-              </a:rPr>
-              <a:t>RESULTADOS NO TESTE</a:t>
-            </a:r>
-          </a:p>
-        </p:txBody>
-      </p:sp>
-      <p:pic>
-        <p:nvPicPr>
-          <p:cNvPr id="40" name="Dispersao previsto x observado" descr="dispersao.png"/>
-          <p:cNvPicPr>
-            <a:picLocks noChangeAspect="1"/>
-          </p:cNvPicPr>
-          <p:nvPr/>
-        </p:nvPicPr>
-        <p:blipFill>
-          <a:blip r:embed="rId10"/>
-          <a:stretch>
-            <a:fillRect/>
-          </a:stretch>
-        </p:blipFill>
-        <p:spPr>
-          <a:xfrm>
-            <a:off x="2502000" y="18864000"/>
-            <a:ext cx="16380000" cy="6195000"/>
-          </a:xfrm>
-          <a:prstGeom prst="rect">
-            <a:avLst/>
-          </a:prstGeom>
-        </p:spPr>
-      </p:pic>
-      <p:sp>
-        <p:nvSpPr>
-          <p:cNvPr id="41" name="Legenda dispersao"/>
-          <p:cNvSpPr txBox="1"/>
-          <p:nvPr/>
-        </p:nvSpPr>
-        <p:spPr>
-          <a:xfrm>
-            <a:off x="1080000" y="25095000"/>
-            <a:ext cx="19224000" cy="288000"/>
-          </a:xfrm>
-          <a:prstGeom prst="rect">
-            <a:avLst/>
-          </a:prstGeom>
-          <a:noFill/>
-        </p:spPr>
-        <p:txBody>
-          <a:bodyPr wrap="square" lIns="0" rIns="0" tIns="0" bIns="0" anchor="t">
-            <a:spAutoFit/>
-          </a:bodyPr>
-          <a:lstStyle/>
-          <a:p>
-            <a:pPr algn="ctr">
-              <a:lnSpc>
-                <a:spcPct val="108000"/>
-              </a:lnSpc>
-              <a:spcAft>
-                <a:spcPts val="600"/>
-              </a:spcAft>
-            </a:pPr>
-            <a:r>
-              <a:rPr sz="1800" b="0" i="0">
-                <a:solidFill>
-                  <a:srgbClr val="5B6573"/>
-                </a:solidFill>
-                <a:latin typeface="Arial"/>
-              </a:rPr>
-              <a:t>Figura 2 – Nível previsto × observado. Métricas no conjunto de teste (eventos não usados no treino).</a:t>
-            </a:r>
-          </a:p>
-        </p:txBody>
-      </p:sp>
-      <p:sp>
-        <p:nvSpPr>
-          <p:cNvPr id="42" name="Secao CHEIA DE JUL/2023 · 8 h"/>
-          <p:cNvSpPr/>
-          <p:nvPr/>
-        </p:nvSpPr>
-        <p:spPr>
-          <a:xfrm>
-            <a:off x="1080000" y="25527000"/>
-            <a:ext cx="6919200" cy="504000"/>
-          </a:xfrm>
-          <a:prstGeom prst="roundRect">
-            <a:avLst>
-              <a:gd name="adj" fmla="val 50000"/>
-            </a:avLst>
-          </a:prstGeom>
-          <a:solidFill>
-            <a:srgbClr val="2A378D"/>
-          </a:solidFill>
-          <a:ln>
-            <a:noFill/>
-          </a:ln>
-          <a:effectLst/>
-        </p:spPr>
-        <p:style>
-          <a:lnRef idx="1">
-            <a:schemeClr val="accent1"/>
-          </a:lnRef>
-          <a:fillRef idx="3">
-            <a:schemeClr val="accent1"/>
-          </a:fillRef>
-          <a:effectRef idx="2">
-            <a:schemeClr val="accent1"/>
-          </a:effectRef>
-          <a:fontRef idx="minor">
-            <a:schemeClr val="lt1"/>
-          </a:fontRef>
-        </p:style>
-        <p:txBody>
-          <a:bodyPr rtlCol="0" anchor="ctr" wrap="none" lIns="252000" rIns="252000" tIns="0" bIns="0"/>
-          <a:lstStyle/>
-          <a:p>
-            <a:pPr algn="l"/>
-            <a:r>
-              <a:rPr sz="3000" b="1" i="0">
-                <a:solidFill>
-                  <a:srgbClr val="FFFFFF"/>
-                </a:solidFill>
-                <a:latin typeface="Arial"/>
-              </a:rPr>
-              <a:t>CHEIA DE JUL/2023 · 8 h</a:t>
-            </a:r>
-          </a:p>
-        </p:txBody>
-      </p:sp>
-      <p:pic>
-        <p:nvPicPr>
-          <p:cNvPr id="43" name="Evento de teste 8h" descr="teste_8h.png"/>
-          <p:cNvPicPr>
-            <a:picLocks noChangeAspect="1"/>
-          </p:cNvPicPr>
-          <p:nvPr/>
-        </p:nvPicPr>
-        <p:blipFill>
-          <a:blip r:embed="rId11"/>
-          <a:stretch>
-            <a:fillRect/>
-          </a:stretch>
-        </p:blipFill>
-        <p:spPr>
-          <a:xfrm>
-            <a:off x="1080000" y="26175000"/>
-            <a:ext cx="9360000" cy="4516744"/>
-          </a:xfrm>
-          <a:prstGeom prst="rect">
-            <a:avLst/>
-          </a:prstGeom>
-        </p:spPr>
-      </p:pic>
-      <p:sp>
-        <p:nvSpPr>
-          <p:cNvPr id="44" name="Legenda teste 8h"/>
-          <p:cNvSpPr txBox="1"/>
-          <p:nvPr/>
-        </p:nvSpPr>
-        <p:spPr>
-          <a:xfrm>
-            <a:off x="1080000" y="30727744"/>
-            <a:ext cx="9360000" cy="288000"/>
-          </a:xfrm>
-          <a:prstGeom prst="rect">
-            <a:avLst/>
-          </a:prstGeom>
-          <a:noFill/>
-        </p:spPr>
-        <p:txBody>
-          <a:bodyPr wrap="square" lIns="0" rIns="0" tIns="0" bIns="0" anchor="t">
-            <a:spAutoFit/>
-          </a:bodyPr>
-          <a:lstStyle/>
-          <a:p>
-            <a:pPr algn="l">
-              <a:lnSpc>
-                <a:spcPct val="108000"/>
-              </a:lnSpc>
-              <a:spcAft>
-                <a:spcPts val="600"/>
-              </a:spcAft>
-            </a:pPr>
-            <a:r>
-              <a:rPr sz="1800" b="0" i="0">
-                <a:solidFill>
-                  <a:srgbClr val="5B6573"/>
-                </a:solidFill>
-                <a:latin typeface="Arial"/>
-              </a:rPr>
-              <a:t>Figura 3 – A RNA antecipa a subida; a persistência chega 8 h atrasada.</a:t>
-            </a:r>
-          </a:p>
-        </p:txBody>
-      </p:sp>
-      <p:sp>
-        <p:nvSpPr>
-          <p:cNvPr id="45" name="Secao AO VIVO · SET/2026 · 2 h"/>
-          <p:cNvSpPr/>
-          <p:nvPr/>
-        </p:nvSpPr>
-        <p:spPr>
-          <a:xfrm>
-            <a:off x="10944000" y="25527000"/>
-            <a:ext cx="7185600" cy="504000"/>
-          </a:xfrm>
-          <a:prstGeom prst="roundRect">
-            <a:avLst>
-              <a:gd name="adj" fmla="val 50000"/>
-            </a:avLst>
-          </a:prstGeom>
-          <a:solidFill>
-            <a:srgbClr val="2A378D"/>
-          </a:solidFill>
-          <a:ln>
-            <a:noFill/>
-          </a:ln>
-          <a:effectLst/>
-        </p:spPr>
-        <p:style>
-          <a:lnRef idx="1">
-            <a:schemeClr val="accent1"/>
-          </a:lnRef>
-          <a:fillRef idx="3">
-            <a:schemeClr val="accent1"/>
-          </a:fillRef>
-          <a:effectRef idx="2">
-            <a:schemeClr val="accent1"/>
-          </a:effectRef>
-          <a:fontRef idx="minor">
-            <a:schemeClr val="lt1"/>
-          </a:fontRef>
-        </p:style>
-        <p:txBody>
-          <a:bodyPr rtlCol="0" anchor="ctr" wrap="none" lIns="252000" rIns="252000" tIns="0" bIns="0"/>
-          <a:lstStyle/>
-          <a:p>
-            <a:pPr algn="l"/>
-            <a:r>
-              <a:rPr sz="3000" b="1" i="0">
-                <a:solidFill>
-                  <a:srgbClr val="FFFFFF"/>
-                </a:solidFill>
-                <a:latin typeface="Arial"/>
-              </a:rPr>
-              <a:t>AO VIVO · SET/2026 · 2 h</a:t>
-            </a:r>
-          </a:p>
-        </p:txBody>
-      </p:sp>
-      <p:pic>
-        <p:nvPicPr>
-          <p:cNvPr id="46" name="Operacao ao vivo 2h" descr="ao_vivo_2h.png"/>
-          <p:cNvPicPr>
-            <a:picLocks noChangeAspect="1"/>
-          </p:cNvPicPr>
-          <p:nvPr/>
-        </p:nvPicPr>
-        <p:blipFill>
-          <a:blip r:embed="rId12"/>
-          <a:stretch>
-            <a:fillRect/>
-          </a:stretch>
-        </p:blipFill>
-        <p:spPr>
-          <a:xfrm>
-            <a:off x="10944000" y="26175000"/>
-            <a:ext cx="9360000" cy="4516744"/>
-          </a:xfrm>
-          <a:prstGeom prst="rect">
-            <a:avLst/>
-          </a:prstGeom>
-        </p:spPr>
-      </p:pic>
-      <p:sp>
-        <p:nvSpPr>
-          <p:cNvPr id="47" name="Legenda ao vivo"/>
-          <p:cNvSpPr txBox="1"/>
-          <p:nvPr/>
-        </p:nvSpPr>
-        <p:spPr>
-          <a:xfrm>
-            <a:off x="10944000" y="30727744"/>
-            <a:ext cx="9360000" cy="288000"/>
-          </a:xfrm>
-          <a:prstGeom prst="rect">
-            <a:avLst/>
-          </a:prstGeom>
-          <a:noFill/>
-        </p:spPr>
-        <p:txBody>
-          <a:bodyPr wrap="square" lIns="0" rIns="0" tIns="0" bIns="0" anchor="t">
-            <a:spAutoFit/>
-          </a:bodyPr>
-          <a:lstStyle/>
-          <a:p>
-            <a:pPr algn="l">
-              <a:lnSpc>
-                <a:spcPct val="108000"/>
-              </a:lnSpc>
-              <a:spcAft>
-                <a:spcPts val="600"/>
-              </a:spcAft>
-            </a:pPr>
-            <a:r>
-              <a:rPr sz="1800" b="0" i="0">
-                <a:solidFill>
-                  <a:srgbClr val="5B6573"/>
-                </a:solidFill>
-                <a:latin typeface="Arial"/>
-              </a:rPr>
-              <a:t>Figura 4 – 230 previsões auditadas: EAM 9,2 cm (persistência 27,2 cm).</a:t>
-            </a:r>
-          </a:p>
-        </p:txBody>
-      </p:sp>
-      <p:sp>
-        <p:nvSpPr>
-          <p:cNvPr id="48" name="Secao CONCLUSÕES"/>
-          <p:cNvSpPr/>
-          <p:nvPr/>
-        </p:nvSpPr>
-        <p:spPr>
-          <a:xfrm>
-            <a:off x="1080000" y="31195744"/>
+            <a:off x="1080000" y="20052000"/>
             <a:ext cx="3456000" cy="504000"/>
           </a:xfrm>
           <a:prstGeom prst="roundRect">
@@ -5459,32 +5705,56 @@
           </a:fontRef>
         </p:style>
         <p:txBody>
-          <a:bodyPr rtlCol="0" anchor="ctr" wrap="none" lIns="252000" rIns="252000" tIns="0" bIns="0"/>
+          <a:bodyPr wrap="none" lIns="252000" tIns="0" rIns="252000" bIns="0" rtlCol="0" anchor="ctr"/>
           <a:lstStyle/>
           <a:p>
             <a:pPr algn="l"/>
             <a:r>
-              <a:rPr sz="3000" b="1" i="0">
+              <a:rPr sz="3000" b="1" i="0" dirty="0">
                 <a:solidFill>
                   <a:srgbClr val="FFFFFF"/>
                 </a:solidFill>
                 <a:latin typeface="Arial"/>
               </a:rPr>
-              <a:t>CONCLUSÕES</a:t>
-            </a:r>
-          </a:p>
-        </p:txBody>
-      </p:sp>
-      <p:sp>
-        <p:nvSpPr>
-          <p:cNvPr id="49" name="Texto conclusoes"/>
+              <a:t>RESULTADOS</a:t>
+            </a:r>
+          </a:p>
+        </p:txBody>
+      </p:sp>
+      <p:pic>
+        <p:nvPicPr>
+          <p:cNvPr id="35" name="Dispersao previsto x observado" descr="dispersao.png"/>
+          <p:cNvPicPr>
+            <a:picLocks noChangeAspect="1"/>
+          </p:cNvPicPr>
+          <p:nvPr/>
+        </p:nvPicPr>
+        <p:blipFill>
+          <a:blip r:embed="rId10"/>
+          <a:stretch>
+            <a:fillRect/>
+          </a:stretch>
+        </p:blipFill>
+        <p:spPr>
+          <a:xfrm>
+            <a:off x="3276000" y="20853110"/>
+            <a:ext cx="15480000" cy="5110385"/>
+          </a:xfrm>
+          <a:prstGeom prst="rect">
+            <a:avLst/>
+          </a:prstGeom>
+        </p:spPr>
+      </p:pic>
+      <p:sp>
+        <p:nvSpPr>
+          <p:cNvPr id="36" name="Legenda dispersao"/>
           <p:cNvSpPr txBox="1"/>
           <p:nvPr/>
         </p:nvSpPr>
         <p:spPr>
           <a:xfrm>
-            <a:off x="1080000" y="31879744"/>
-            <a:ext cx="13680000" cy="1656000"/>
+            <a:off x="1080000" y="25990385"/>
+            <a:ext cx="19224000" cy="288000"/>
           </a:xfrm>
           <a:prstGeom prst="rect">
             <a:avLst/>
@@ -5492,129 +5762,740 @@
           <a:noFill/>
         </p:spPr>
         <p:txBody>
-          <a:bodyPr wrap="square" lIns="0" rIns="0" tIns="0" bIns="0" anchor="t">
+          <a:bodyPr wrap="square" lIns="0" tIns="0" rIns="0" bIns="0" anchor="t">
             <a:spAutoFit/>
           </a:bodyPr>
           <a:lstStyle/>
           <a:p>
-            <a:pPr algn="l" marL="252000" indent="-252000">
+            <a:pPr algn="l">
               <a:lnSpc>
                 <a:spcPct val="108000"/>
               </a:lnSpc>
               <a:spcAft>
                 <a:spcPts val="600"/>
               </a:spcAft>
-              <a:buClr>
-                <a:srgbClr val="D9661F"/>
-              </a:buClr>
-              <a:buFont typeface="Arial"/>
-              <a:buChar char="■"/>
             </a:pPr>
             <a:r>
-              <a:rPr sz="2400" b="1" i="0">
-                <a:solidFill>
-                  <a:srgbClr val="1F2633"/>
-                </a:solidFill>
-                <a:latin typeface="Arial"/>
-              </a:rPr>
-              <a:t>NSE ≥ 0,98</a:t>
-            </a:r>
-            <a:r>
-              <a:rPr sz="2400" b="0" i="0">
-                <a:solidFill>
-                  <a:srgbClr val="1F2633"/>
-                </a:solidFill>
-                <a:latin typeface="Arial"/>
-              </a:rPr>
-              <a:t> e erro </a:t>
-            </a:r>
-            <a:r>
-              <a:rPr sz="2400" b="1" i="0">
-                <a:solidFill>
-                  <a:srgbClr val="1F2633"/>
-                </a:solidFill>
-                <a:latin typeface="Arial"/>
-              </a:rPr>
-              <a:t>65–81% menor</a:t>
-            </a:r>
-            <a:r>
-              <a:rPr sz="2400" b="0" i="0">
-                <a:solidFill>
-                  <a:srgbClr val="1F2633"/>
-                </a:solidFill>
-                <a:latin typeface="Arial"/>
-              </a:rPr>
-              <a:t> que a persistência nos três horizontes.</a:t>
-            </a:r>
-          </a:p>
-          <a:p>
-            <a:pPr algn="l" marL="252000" indent="-252000">
+              <a:rPr sz="1800" b="0" i="0">
+                <a:solidFill>
+                  <a:srgbClr val="5B6573"/>
+                </a:solidFill>
+                <a:latin typeface="Arial"/>
+              </a:rPr>
+              <a:t>Figura 2 – Nível previsto × observado em todas as amostras; em laranja, o conjunto de teste (NSE do título).</a:t>
+            </a:r>
+          </a:p>
+        </p:txBody>
+      </p:sp>
+      <p:graphicFrame>
+        <p:nvGraphicFramePr>
+          <p:cNvPr id="37" name="Tabela resultados"/>
+          <p:cNvGraphicFramePr>
+            <a:graphicFrameLocks noGrp="1"/>
+          </p:cNvGraphicFramePr>
+          <p:nvPr/>
+        </p:nvGraphicFramePr>
+        <p:xfrm>
+          <a:off x="1080000" y="26386385"/>
+          <a:ext cx="9360001" cy="1800000"/>
+        </p:xfrm>
+        <a:graphic>
+          <a:graphicData uri="http://schemas.openxmlformats.org/drawingml/2006/table">
+            <a:tbl>
+              <a:tblPr>
+                <a:tableStyleId>{5C22544A-7EE6-4342-B048-85BDC9FD1C3A}</a:tableStyleId>
+              </a:tblPr>
+              <a:tblGrid>
+                <a:gridCol w="1429008">
+                  <a:extLst>
+                    <a:ext uri="{9D8B030D-6E8A-4147-A177-3AD203B41FA5}">
+                      <a16:colId xmlns:a16="http://schemas.microsoft.com/office/drawing/2014/main" val="20000"/>
+                    </a:ext>
+                  </a:extLst>
+                </a:gridCol>
+                <a:gridCol w="1429008">
+                  <a:extLst>
+                    <a:ext uri="{9D8B030D-6E8A-4147-A177-3AD203B41FA5}">
+                      <a16:colId xmlns:a16="http://schemas.microsoft.com/office/drawing/2014/main" val="20001"/>
+                    </a:ext>
+                  </a:extLst>
+                </a:gridCol>
+                <a:gridCol w="1429008">
+                  <a:extLst>
+                    <a:ext uri="{9D8B030D-6E8A-4147-A177-3AD203B41FA5}">
+                      <a16:colId xmlns:a16="http://schemas.microsoft.com/office/drawing/2014/main" val="20002"/>
+                    </a:ext>
+                  </a:extLst>
+                </a:gridCol>
+                <a:gridCol w="1500458">
+                  <a:extLst>
+                    <a:ext uri="{9D8B030D-6E8A-4147-A177-3AD203B41FA5}">
+                      <a16:colId xmlns:a16="http://schemas.microsoft.com/office/drawing/2014/main" val="20003"/>
+                    </a:ext>
+                  </a:extLst>
+                </a:gridCol>
+                <a:gridCol w="1357557">
+                  <a:extLst>
+                    <a:ext uri="{9D8B030D-6E8A-4147-A177-3AD203B41FA5}">
+                      <a16:colId xmlns:a16="http://schemas.microsoft.com/office/drawing/2014/main" val="20004"/>
+                    </a:ext>
+                  </a:extLst>
+                </a:gridCol>
+                <a:gridCol w="2214962">
+                  <a:extLst>
+                    <a:ext uri="{9D8B030D-6E8A-4147-A177-3AD203B41FA5}">
+                      <a16:colId xmlns:a16="http://schemas.microsoft.com/office/drawing/2014/main" val="20005"/>
+                    </a:ext>
+                  </a:extLst>
+                </a:gridCol>
+              </a:tblGrid>
+              <a:tr h="450000">
+                <a:tc>
+                  <a:txBody>
+                    <a:bodyPr/>
+                    <a:lstStyle/>
+                    <a:p>
+                      <a:pPr algn="l"/>
+                      <a:r>
+                        <a:rPr sz="1900" b="1" i="0">
+                          <a:solidFill>
+                            <a:srgbClr val="FFFFFF"/>
+                          </a:solidFill>
+                          <a:latin typeface="Arial"/>
+                        </a:rPr>
+                        <a:t>Teste</a:t>
+                      </a:r>
+                    </a:p>
+                  </a:txBody>
+                  <a:tcPr marL="90000" marR="90000" marT="36000" marB="36000" anchor="ctr">
+                    <a:solidFill>
+                      <a:srgbClr val="2A378D"/>
+                    </a:solidFill>
+                  </a:tcPr>
+                </a:tc>
+                <a:tc>
+                  <a:txBody>
+                    <a:bodyPr/>
+                    <a:lstStyle/>
+                    <a:p>
+                      <a:pPr algn="ctr"/>
+                      <a:r>
+                        <a:rPr sz="1900" b="1" i="0">
+                          <a:solidFill>
+                            <a:srgbClr val="FFFFFF"/>
+                          </a:solidFill>
+                          <a:latin typeface="Arial"/>
+                        </a:rPr>
+                        <a:t>NSE</a:t>
+                      </a:r>
+                    </a:p>
+                  </a:txBody>
+                  <a:tcPr marL="90000" marR="90000" marT="36000" marB="36000" anchor="ctr">
+                    <a:solidFill>
+                      <a:srgbClr val="2A378D"/>
+                    </a:solidFill>
+                  </a:tcPr>
+                </a:tc>
+                <a:tc>
+                  <a:txBody>
+                    <a:bodyPr/>
+                    <a:lstStyle/>
+                    <a:p>
+                      <a:pPr algn="ctr"/>
+                      <a:r>
+                        <a:rPr sz="1900" b="1" i="0">
+                          <a:solidFill>
+                            <a:srgbClr val="FFFFFF"/>
+                          </a:solidFill>
+                          <a:latin typeface="Arial"/>
+                        </a:rPr>
+                        <a:t>PME</a:t>
+                      </a:r>
+                    </a:p>
+                  </a:txBody>
+                  <a:tcPr marL="90000" marR="90000" marT="36000" marB="36000" anchor="ctr">
+                    <a:solidFill>
+                      <a:srgbClr val="2A378D"/>
+                    </a:solidFill>
+                  </a:tcPr>
+                </a:tc>
+                <a:tc>
+                  <a:txBody>
+                    <a:bodyPr/>
+                    <a:lstStyle/>
+                    <a:p>
+                      <a:pPr algn="ctr"/>
+                      <a:r>
+                        <a:rPr sz="1900" b="1" i="0">
+                          <a:solidFill>
+                            <a:srgbClr val="FFFFFF"/>
+                          </a:solidFill>
+                          <a:latin typeface="Arial"/>
+                        </a:rPr>
+                        <a:t>EAM</a:t>
+                      </a:r>
+                    </a:p>
+                  </a:txBody>
+                  <a:tcPr marL="90000" marR="90000" marT="36000" marB="36000" anchor="ctr">
+                    <a:solidFill>
+                      <a:srgbClr val="2A378D"/>
+                    </a:solidFill>
+                  </a:tcPr>
+                </a:tc>
+                <a:tc>
+                  <a:txBody>
+                    <a:bodyPr/>
+                    <a:lstStyle/>
+                    <a:p>
+                      <a:pPr algn="ctr"/>
+                      <a:r>
+                        <a:rPr sz="1900" b="1" i="0">
+                          <a:solidFill>
+                            <a:srgbClr val="FFFFFF"/>
+                          </a:solidFill>
+                          <a:latin typeface="Arial"/>
+                        </a:rPr>
+                        <a:t>E95</a:t>
+                      </a:r>
+                    </a:p>
+                  </a:txBody>
+                  <a:tcPr marL="90000" marR="90000" marT="36000" marB="36000" anchor="ctr">
+                    <a:solidFill>
+                      <a:srgbClr val="2A378D"/>
+                    </a:solidFill>
+                  </a:tcPr>
+                </a:tc>
+                <a:tc>
+                  <a:txBody>
+                    <a:bodyPr/>
+                    <a:lstStyle/>
+                    <a:p>
+                      <a:pPr algn="ctr"/>
+                      <a:r>
+                        <a:rPr sz="1900" b="1" i="0">
+                          <a:solidFill>
+                            <a:srgbClr val="FFFFFF"/>
+                          </a:solidFill>
+                          <a:latin typeface="Arial"/>
+                        </a:rPr>
+                        <a:t>EAM × persist.</a:t>
+                      </a:r>
+                    </a:p>
+                  </a:txBody>
+                  <a:tcPr marL="90000" marR="90000" marT="36000" marB="36000" anchor="ctr">
+                    <a:solidFill>
+                      <a:srgbClr val="2A378D"/>
+                    </a:solidFill>
+                  </a:tcPr>
+                </a:tc>
+                <a:extLst>
+                  <a:ext uri="{0D108BD9-81ED-4DB2-BD59-A6C34878D82A}">
+                    <a16:rowId xmlns:a16="http://schemas.microsoft.com/office/drawing/2014/main" val="10000"/>
+                  </a:ext>
+                </a:extLst>
+              </a:tr>
+              <a:tr h="450000">
+                <a:tc>
+                  <a:txBody>
+                    <a:bodyPr/>
+                    <a:lstStyle/>
+                    <a:p>
+                      <a:pPr algn="l"/>
+                      <a:r>
+                        <a:rPr sz="1900" b="1" i="0">
+                          <a:solidFill>
+                            <a:srgbClr val="1F2633"/>
+                          </a:solidFill>
+                          <a:latin typeface="Arial"/>
+                        </a:rPr>
+                        <a:t>ALT 2h</a:t>
+                      </a:r>
+                    </a:p>
+                  </a:txBody>
+                  <a:tcPr marL="90000" marR="90000" marT="36000" marB="36000" anchor="ctr">
+                    <a:solidFill>
+                      <a:srgbClr val="FFFFFF"/>
+                    </a:solidFill>
+                  </a:tcPr>
+                </a:tc>
+                <a:tc>
+                  <a:txBody>
+                    <a:bodyPr/>
+                    <a:lstStyle/>
+                    <a:p>
+                      <a:pPr algn="ctr"/>
+                      <a:r>
+                        <a:rPr sz="1900" b="0" i="0">
+                          <a:solidFill>
+                            <a:srgbClr val="1F2633"/>
+                          </a:solidFill>
+                          <a:latin typeface="Arial"/>
+                        </a:rPr>
+                        <a:t>0,996</a:t>
+                      </a:r>
+                    </a:p>
+                  </a:txBody>
+                  <a:tcPr marL="90000" marR="90000" marT="36000" marB="36000" anchor="ctr">
+                    <a:solidFill>
+                      <a:srgbClr val="FFFFFF"/>
+                    </a:solidFill>
+                  </a:tcPr>
+                </a:tc>
+                <a:tc>
+                  <a:txBody>
+                    <a:bodyPr/>
+                    <a:lstStyle/>
+                    <a:p>
+                      <a:pPr algn="ctr"/>
+                      <a:r>
+                        <a:rPr sz="1900" b="0" i="0">
+                          <a:solidFill>
+                            <a:srgbClr val="1F2633"/>
+                          </a:solidFill>
+                          <a:latin typeface="Arial"/>
+                        </a:rPr>
+                        <a:t>0,969</a:t>
+                      </a:r>
+                    </a:p>
+                  </a:txBody>
+                  <a:tcPr marL="90000" marR="90000" marT="36000" marB="36000" anchor="ctr">
+                    <a:solidFill>
+                      <a:srgbClr val="FFFFFF"/>
+                    </a:solidFill>
+                  </a:tcPr>
+                </a:tc>
+                <a:tc>
+                  <a:txBody>
+                    <a:bodyPr/>
+                    <a:lstStyle/>
+                    <a:p>
+                      <a:pPr algn="ctr"/>
+                      <a:r>
+                        <a:rPr sz="1900" b="0" i="0">
+                          <a:solidFill>
+                            <a:srgbClr val="1F2633"/>
+                          </a:solidFill>
+                          <a:latin typeface="Arial"/>
+                        </a:rPr>
+                        <a:t>3,5 cm</a:t>
+                      </a:r>
+                    </a:p>
+                  </a:txBody>
+                  <a:tcPr marL="90000" marR="90000" marT="36000" marB="36000" anchor="ctr">
+                    <a:solidFill>
+                      <a:srgbClr val="FFFFFF"/>
+                    </a:solidFill>
+                  </a:tcPr>
+                </a:tc>
+                <a:tc>
+                  <a:txBody>
+                    <a:bodyPr/>
+                    <a:lstStyle/>
+                    <a:p>
+                      <a:pPr algn="ctr"/>
+                      <a:r>
+                        <a:rPr sz="1900" b="0" i="0">
+                          <a:solidFill>
+                            <a:srgbClr val="1F2633"/>
+                          </a:solidFill>
+                          <a:latin typeface="Arial"/>
+                        </a:rPr>
+                        <a:t>10 cm</a:t>
+                      </a:r>
+                    </a:p>
+                  </a:txBody>
+                  <a:tcPr marL="90000" marR="90000" marT="36000" marB="36000" anchor="ctr">
+                    <a:solidFill>
+                      <a:srgbClr val="FFFFFF"/>
+                    </a:solidFill>
+                  </a:tcPr>
+                </a:tc>
+                <a:tc>
+                  <a:txBody>
+                    <a:bodyPr/>
+                    <a:lstStyle/>
+                    <a:p>
+                      <a:pPr algn="ctr"/>
+                      <a:r>
+                        <a:rPr sz="1900" b="0" i="0">
+                          <a:solidFill>
+                            <a:srgbClr val="1F2633"/>
+                          </a:solidFill>
+                          <a:latin typeface="Arial"/>
+                        </a:rPr>
+                        <a:t>−81%</a:t>
+                      </a:r>
+                    </a:p>
+                  </a:txBody>
+                  <a:tcPr marL="90000" marR="90000" marT="36000" marB="36000" anchor="ctr">
+                    <a:solidFill>
+                      <a:srgbClr val="FFFFFF"/>
+                    </a:solidFill>
+                  </a:tcPr>
+                </a:tc>
+                <a:extLst>
+                  <a:ext uri="{0D108BD9-81ED-4DB2-BD59-A6C34878D82A}">
+                    <a16:rowId xmlns:a16="http://schemas.microsoft.com/office/drawing/2014/main" val="10001"/>
+                  </a:ext>
+                </a:extLst>
+              </a:tr>
+              <a:tr h="450000">
+                <a:tc>
+                  <a:txBody>
+                    <a:bodyPr/>
+                    <a:lstStyle/>
+                    <a:p>
+                      <a:pPr algn="l"/>
+                      <a:r>
+                        <a:rPr sz="1900" b="1" i="0">
+                          <a:solidFill>
+                            <a:srgbClr val="1F2633"/>
+                          </a:solidFill>
+                          <a:latin typeface="Arial"/>
+                        </a:rPr>
+                        <a:t>ALT 4h</a:t>
+                      </a:r>
+                    </a:p>
+                  </a:txBody>
+                  <a:tcPr marL="90000" marR="90000" marT="36000" marB="36000" anchor="ctr">
+                    <a:solidFill>
+                      <a:srgbClr val="E6EEF5"/>
+                    </a:solidFill>
+                  </a:tcPr>
+                </a:tc>
+                <a:tc>
+                  <a:txBody>
+                    <a:bodyPr/>
+                    <a:lstStyle/>
+                    <a:p>
+                      <a:pPr algn="ctr"/>
+                      <a:r>
+                        <a:rPr sz="1900" b="0" i="0">
+                          <a:solidFill>
+                            <a:srgbClr val="1F2633"/>
+                          </a:solidFill>
+                          <a:latin typeface="Arial"/>
+                        </a:rPr>
+                        <a:t>0,993</a:t>
+                      </a:r>
+                    </a:p>
+                  </a:txBody>
+                  <a:tcPr marL="90000" marR="90000" marT="36000" marB="36000" anchor="ctr">
+                    <a:solidFill>
+                      <a:srgbClr val="E6EEF5"/>
+                    </a:solidFill>
+                  </a:tcPr>
+                </a:tc>
+                <a:tc>
+                  <a:txBody>
+                    <a:bodyPr/>
+                    <a:lstStyle/>
+                    <a:p>
+                      <a:pPr algn="ctr"/>
+                      <a:r>
+                        <a:rPr sz="1900" b="0" i="0">
+                          <a:solidFill>
+                            <a:srgbClr val="1F2633"/>
+                          </a:solidFill>
+                          <a:latin typeface="Arial"/>
+                        </a:rPr>
+                        <a:t>0,878</a:t>
+                      </a:r>
+                    </a:p>
+                  </a:txBody>
+                  <a:tcPr marL="90000" marR="90000" marT="36000" marB="36000" anchor="ctr">
+                    <a:solidFill>
+                      <a:srgbClr val="E6EEF5"/>
+                    </a:solidFill>
+                  </a:tcPr>
+                </a:tc>
+                <a:tc>
+                  <a:txBody>
+                    <a:bodyPr/>
+                    <a:lstStyle/>
+                    <a:p>
+                      <a:pPr algn="ctr"/>
+                      <a:r>
+                        <a:rPr sz="1900" b="0" i="0">
+                          <a:solidFill>
+                            <a:srgbClr val="1F2633"/>
+                          </a:solidFill>
+                          <a:latin typeface="Arial"/>
+                        </a:rPr>
+                        <a:t>14,0 cm</a:t>
+                      </a:r>
+                    </a:p>
+                  </a:txBody>
+                  <a:tcPr marL="90000" marR="90000" marT="36000" marB="36000" anchor="ctr">
+                    <a:solidFill>
+                      <a:srgbClr val="E6EEF5"/>
+                    </a:solidFill>
+                  </a:tcPr>
+                </a:tc>
+                <a:tc>
+                  <a:txBody>
+                    <a:bodyPr/>
+                    <a:lstStyle/>
+                    <a:p>
+                      <a:pPr algn="ctr"/>
+                      <a:r>
+                        <a:rPr sz="1900" b="0" i="0">
+                          <a:solidFill>
+                            <a:srgbClr val="1F2633"/>
+                          </a:solidFill>
+                          <a:latin typeface="Arial"/>
+                        </a:rPr>
+                        <a:t>59 cm</a:t>
+                      </a:r>
+                    </a:p>
+                  </a:txBody>
+                  <a:tcPr marL="90000" marR="90000" marT="36000" marB="36000" anchor="ctr">
+                    <a:solidFill>
+                      <a:srgbClr val="E6EEF5"/>
+                    </a:solidFill>
+                  </a:tcPr>
+                </a:tc>
+                <a:tc>
+                  <a:txBody>
+                    <a:bodyPr/>
+                    <a:lstStyle/>
+                    <a:p>
+                      <a:pPr algn="ctr"/>
+                      <a:r>
+                        <a:rPr sz="1900" b="0" i="0">
+                          <a:solidFill>
+                            <a:srgbClr val="1F2633"/>
+                          </a:solidFill>
+                          <a:latin typeface="Arial"/>
+                        </a:rPr>
+                        <a:t>−65%</a:t>
+                      </a:r>
+                    </a:p>
+                  </a:txBody>
+                  <a:tcPr marL="90000" marR="90000" marT="36000" marB="36000" anchor="ctr">
+                    <a:solidFill>
+                      <a:srgbClr val="E6EEF5"/>
+                    </a:solidFill>
+                  </a:tcPr>
+                </a:tc>
+                <a:extLst>
+                  <a:ext uri="{0D108BD9-81ED-4DB2-BD59-A6C34878D82A}">
+                    <a16:rowId xmlns:a16="http://schemas.microsoft.com/office/drawing/2014/main" val="10002"/>
+                  </a:ext>
+                </a:extLst>
+              </a:tr>
+              <a:tr h="450000">
+                <a:tc>
+                  <a:txBody>
+                    <a:bodyPr/>
+                    <a:lstStyle/>
+                    <a:p>
+                      <a:pPr algn="l"/>
+                      <a:r>
+                        <a:rPr sz="1900" b="1" i="0">
+                          <a:solidFill>
+                            <a:srgbClr val="1F2633"/>
+                          </a:solidFill>
+                          <a:latin typeface="Arial"/>
+                        </a:rPr>
+                        <a:t>ALT 8h</a:t>
+                      </a:r>
+                    </a:p>
+                  </a:txBody>
+                  <a:tcPr marL="90000" marR="90000" marT="36000" marB="36000" anchor="ctr">
+                    <a:solidFill>
+                      <a:srgbClr val="FFFFFF"/>
+                    </a:solidFill>
+                  </a:tcPr>
+                </a:tc>
+                <a:tc>
+                  <a:txBody>
+                    <a:bodyPr/>
+                    <a:lstStyle/>
+                    <a:p>
+                      <a:pPr algn="ctr"/>
+                      <a:r>
+                        <a:rPr sz="1900" b="0" i="0">
+                          <a:solidFill>
+                            <a:srgbClr val="1F2633"/>
+                          </a:solidFill>
+                          <a:latin typeface="Arial"/>
+                        </a:rPr>
+                        <a:t>0,979</a:t>
+                      </a:r>
+                    </a:p>
+                  </a:txBody>
+                  <a:tcPr marL="90000" marR="90000" marT="36000" marB="36000" anchor="ctr">
+                    <a:solidFill>
+                      <a:srgbClr val="FFFFFF"/>
+                    </a:solidFill>
+                  </a:tcPr>
+                </a:tc>
+                <a:tc>
+                  <a:txBody>
+                    <a:bodyPr/>
+                    <a:lstStyle/>
+                    <a:p>
+                      <a:pPr algn="ctr"/>
+                      <a:r>
+                        <a:rPr sz="1900" b="0" i="0">
+                          <a:solidFill>
+                            <a:srgbClr val="1F2633"/>
+                          </a:solidFill>
+                          <a:latin typeface="Arial"/>
+                        </a:rPr>
+                        <a:t>0,927</a:t>
+                      </a:r>
+                    </a:p>
+                  </a:txBody>
+                  <a:tcPr marL="90000" marR="90000" marT="36000" marB="36000" anchor="ctr">
+                    <a:solidFill>
+                      <a:srgbClr val="FFFFFF"/>
+                    </a:solidFill>
+                  </a:tcPr>
+                </a:tc>
+                <a:tc>
+                  <a:txBody>
+                    <a:bodyPr/>
+                    <a:lstStyle/>
+                    <a:p>
+                      <a:pPr algn="ctr"/>
+                      <a:r>
+                        <a:rPr sz="1900" b="0" i="0">
+                          <a:solidFill>
+                            <a:srgbClr val="1F2633"/>
+                          </a:solidFill>
+                          <a:latin typeface="Arial"/>
+                        </a:rPr>
+                        <a:t>23,3 cm</a:t>
+                      </a:r>
+                    </a:p>
+                  </a:txBody>
+                  <a:tcPr marL="90000" marR="90000" marT="36000" marB="36000" anchor="ctr">
+                    <a:solidFill>
+                      <a:srgbClr val="FFFFFF"/>
+                    </a:solidFill>
+                  </a:tcPr>
+                </a:tc>
+                <a:tc>
+                  <a:txBody>
+                    <a:bodyPr/>
+                    <a:lstStyle/>
+                    <a:p>
+                      <a:pPr algn="ctr"/>
+                      <a:r>
+                        <a:rPr sz="1900" b="0" i="0">
+                          <a:solidFill>
+                            <a:srgbClr val="1F2633"/>
+                          </a:solidFill>
+                          <a:latin typeface="Arial"/>
+                        </a:rPr>
+                        <a:t>64 cm</a:t>
+                      </a:r>
+                    </a:p>
+                  </a:txBody>
+                  <a:tcPr marL="90000" marR="90000" marT="36000" marB="36000" anchor="ctr">
+                    <a:solidFill>
+                      <a:srgbClr val="FFFFFF"/>
+                    </a:solidFill>
+                  </a:tcPr>
+                </a:tc>
+                <a:tc>
+                  <a:txBody>
+                    <a:bodyPr/>
+                    <a:lstStyle/>
+                    <a:p>
+                      <a:pPr algn="ctr"/>
+                      <a:r>
+                        <a:rPr sz="1900" b="0" i="0">
+                          <a:solidFill>
+                            <a:srgbClr val="1F2633"/>
+                          </a:solidFill>
+                          <a:latin typeface="Arial"/>
+                        </a:rPr>
+                        <a:t>−69%</a:t>
+                      </a:r>
+                    </a:p>
+                  </a:txBody>
+                  <a:tcPr marL="90000" marR="90000" marT="36000" marB="36000" anchor="ctr">
+                    <a:solidFill>
+                      <a:srgbClr val="FFFFFF"/>
+                    </a:solidFill>
+                  </a:tcPr>
+                </a:tc>
+                <a:extLst>
+                  <a:ext uri="{0D108BD9-81ED-4DB2-BD59-A6C34878D82A}">
+                    <a16:rowId xmlns:a16="http://schemas.microsoft.com/office/drawing/2014/main" val="10003"/>
+                  </a:ext>
+                </a:extLst>
+              </a:tr>
+            </a:tbl>
+          </a:graphicData>
+        </a:graphic>
+      </p:graphicFrame>
+      <p:sp>
+        <p:nvSpPr>
+          <p:cNvPr id="38" name="Legenda tabela"/>
+          <p:cNvSpPr txBox="1"/>
+          <p:nvPr/>
+        </p:nvSpPr>
+        <p:spPr>
+          <a:xfrm>
+            <a:off x="1080000" y="28260000"/>
+            <a:ext cx="9360000" cy="468000"/>
+          </a:xfrm>
+          <a:prstGeom prst="rect">
+            <a:avLst/>
+          </a:prstGeom>
+          <a:noFill/>
+        </p:spPr>
+        <p:txBody>
+          <a:bodyPr wrap="square" lIns="0" tIns="0" rIns="0" bIns="0" anchor="t">
+            <a:spAutoFit/>
+          </a:bodyPr>
+          <a:lstStyle/>
+          <a:p>
+            <a:pPr algn="l">
               <a:lnSpc>
                 <a:spcPct val="108000"/>
               </a:lnSpc>
               <a:spcAft>
                 <a:spcPts val="600"/>
               </a:spcAft>
-              <a:buClr>
-                <a:srgbClr val="D9661F"/>
-              </a:buClr>
-              <a:buFont typeface="Arial"/>
-              <a:buChar char="■"/>
             </a:pPr>
             <a:r>
-              <a:rPr sz="2400" b="0" i="0">
-                <a:solidFill>
-                  <a:srgbClr val="1F2633"/>
-                </a:solidFill>
-                <a:latin typeface="Arial"/>
-              </a:rPr>
-              <a:t>Em operação, o modelo 2h acompanhou a cheia de set/2026 com </a:t>
-            </a:r>
-            <a:r>
-              <a:rPr sz="2400" b="1" i="0">
-                <a:solidFill>
-                  <a:srgbClr val="D9661F"/>
-                </a:solidFill>
-                <a:latin typeface="Arial"/>
-              </a:rPr>
-              <a:t>erro médio de 9 cm</a:t>
-            </a:r>
-            <a:r>
-              <a:rPr sz="2400" b="0" i="0">
-                <a:solidFill>
-                  <a:srgbClr val="1F2633"/>
-                </a:solidFill>
-                <a:latin typeface="Arial"/>
-              </a:rPr>
-              <a:t>.</a:t>
-            </a:r>
-          </a:p>
-        </p:txBody>
-      </p:sp>
-      <p:sp>
-        <p:nvSpPr>
-          <p:cNvPr id="50" name="Espaco QR code"/>
+              <a:rPr sz="1700" b="0" i="0">
+                <a:solidFill>
+                  <a:srgbClr val="5B6573"/>
+                </a:solidFill>
+                <a:latin typeface="Arial"/>
+              </a:rPr>
+              <a:t>Tabela 1 – Teste (eventos fora do treino): 2h – 3 eventos de out/2024 a 2025 (pico 6,2 m); 4h – cheia de jun/2025 (13,3 m); 8h – cheia de jul/2023 (12,5 m).</a:t>
+            </a:r>
+          </a:p>
+        </p:txBody>
+      </p:sp>
+      <p:sp>
+        <p:nvSpPr>
+          <p:cNvPr id="39" name="Secao CONCLUSÕES"/>
           <p:cNvSpPr/>
           <p:nvPr/>
         </p:nvSpPr>
         <p:spPr>
           <a:xfrm>
-            <a:off x="18216000" y="31195744"/>
-            <a:ext cx="2088000" cy="2088000"/>
+            <a:off x="1080000" y="28908000"/>
+            <a:ext cx="3456000" cy="504000"/>
           </a:xfrm>
           <a:prstGeom prst="roundRect">
             <a:avLst>
-              <a:gd name="adj" fmla="val 6000"/>
+              <a:gd name="adj" fmla="val 50000"/>
             </a:avLst>
           </a:prstGeom>
           <a:solidFill>
-            <a:srgbClr val="FFFFFF"/>
+            <a:srgbClr val="2A378D"/>
           </a:solidFill>
-          <a:ln w="31750">
-            <a:solidFill>
-              <a:srgbClr val="2A378D"/>
-            </a:solidFill>
-            <a:prstDash val="dash"/>
+          <a:ln>
+            <a:noFill/>
           </a:ln>
           <a:effectLst/>
         </p:spPr>
@@ -5633,32 +6514,32 @@
           </a:fontRef>
         </p:style>
         <p:txBody>
-          <a:bodyPr rtlCol="0" anchor="ctr"/>
+          <a:bodyPr wrap="none" lIns="252000" tIns="0" rIns="252000" bIns="0" rtlCol="0" anchor="ctr"/>
           <a:lstStyle/>
           <a:p>
-            <a:pPr algn="ctr"/>
-            <a:r>
-              <a:rPr sz="2200" b="1" i="0">
-                <a:solidFill>
-                  <a:srgbClr val="5B6573"/>
-                </a:solidFill>
-                <a:latin typeface="Arial"/>
-              </a:rPr>
-              <a:t>QR CODE</a:t>
-            </a:r>
-          </a:p>
-        </p:txBody>
-      </p:sp>
-      <p:sp>
-        <p:nvSpPr>
-          <p:cNvPr id="51" name="Chamada QR code"/>
+            <a:pPr algn="l"/>
+            <a:r>
+              <a:rPr sz="3000" b="1" i="0">
+                <a:solidFill>
+                  <a:srgbClr val="FFFFFF"/>
+                </a:solidFill>
+                <a:latin typeface="Arial"/>
+              </a:rPr>
+              <a:t>CONCLUSÕES</a:t>
+            </a:r>
+          </a:p>
+        </p:txBody>
+      </p:sp>
+      <p:sp>
+        <p:nvSpPr>
+          <p:cNvPr id="40" name="Texto conclusoes"/>
           <p:cNvSpPr txBox="1"/>
           <p:nvPr/>
         </p:nvSpPr>
         <p:spPr>
           <a:xfrm>
-            <a:off x="14904000" y="31627744"/>
-            <a:ext cx="3096000" cy="1296000"/>
+            <a:off x="1080000" y="29592000"/>
+            <a:ext cx="9360000" cy="2520000"/>
           </a:xfrm>
           <a:prstGeom prst="rect">
             <a:avLst/>
@@ -5666,12 +6547,240 @@
           <a:noFill/>
         </p:spPr>
         <p:txBody>
-          <a:bodyPr wrap="square" lIns="0" rIns="0" tIns="0" bIns="0" anchor="t">
+          <a:bodyPr wrap="square" lIns="0" tIns="0" rIns="0" bIns="0" anchor="t">
             <a:spAutoFit/>
           </a:bodyPr>
           <a:lstStyle/>
           <a:p>
-            <a:pPr algn="r">
+            <a:pPr marL="252000" indent="-252000" algn="l">
+              <a:lnSpc>
+                <a:spcPct val="108000"/>
+              </a:lnSpc>
+              <a:spcAft>
+                <a:spcPts val="500"/>
+              </a:spcAft>
+              <a:buClr>
+                <a:srgbClr val="D9661F"/>
+              </a:buClr>
+              <a:buFont typeface="Arial"/>
+              <a:buChar char="■"/>
+            </a:pPr>
+            <a:r>
+              <a:rPr sz="2000" b="1" i="0">
+                <a:solidFill>
+                  <a:srgbClr val="1F2633"/>
+                </a:solidFill>
+                <a:latin typeface="Arial"/>
+              </a:rPr>
+              <a:t>NSE ≥ 0,979</a:t>
+            </a:r>
+            <a:r>
+              <a:rPr sz="2000" b="0" i="0">
+                <a:solidFill>
+                  <a:srgbClr val="1F2633"/>
+                </a:solidFill>
+                <a:latin typeface="Arial"/>
+              </a:rPr>
+              <a:t> e </a:t>
+            </a:r>
+            <a:r>
+              <a:rPr sz="2000" b="1" i="0">
+                <a:solidFill>
+                  <a:srgbClr val="1F2633"/>
+                </a:solidFill>
+                <a:latin typeface="Arial"/>
+              </a:rPr>
+              <a:t>PME 0,88–0,97</a:t>
+            </a:r>
+            <a:r>
+              <a:rPr sz="2000" b="0" i="0">
+                <a:solidFill>
+                  <a:srgbClr val="1F2633"/>
+                </a:solidFill>
+                <a:latin typeface="Arial"/>
+              </a:rPr>
+              <a:t> no teste; erro médio 65–81% menor que a persistência.</a:t>
+            </a:r>
+          </a:p>
+          <a:p>
+            <a:pPr marL="252000" indent="-252000" algn="l">
+              <a:lnSpc>
+                <a:spcPct val="108000"/>
+              </a:lnSpc>
+              <a:spcAft>
+                <a:spcPts val="500"/>
+              </a:spcAft>
+              <a:buClr>
+                <a:srgbClr val="D9661F"/>
+              </a:buClr>
+              <a:buFont typeface="Arial"/>
+              <a:buChar char="■"/>
+            </a:pPr>
+            <a:r>
+              <a:rPr sz="2000" b="0" i="0">
+                <a:solidFill>
+                  <a:srgbClr val="1F2633"/>
+                </a:solidFill>
+                <a:latin typeface="Arial"/>
+              </a:rPr>
+              <a:t>Ao vivo, o 2h acompanhou a cheia de set/2026 (13,3 m) com </a:t>
+            </a:r>
+            <a:r>
+              <a:rPr sz="2000" b="1" i="0">
+                <a:solidFill>
+                  <a:srgbClr val="D9661F"/>
+                </a:solidFill>
+                <a:latin typeface="Arial"/>
+              </a:rPr>
+              <a:t>EAM de 9 cm</a:t>
+            </a:r>
+            <a:r>
+              <a:rPr sz="2000" b="0" i="0">
+                <a:solidFill>
+                  <a:srgbClr val="1F2633"/>
+                </a:solidFill>
+                <a:latin typeface="Arial"/>
+              </a:rPr>
+              <a:t>.</a:t>
+            </a:r>
+          </a:p>
+          <a:p>
+            <a:pPr marL="252000" indent="-252000" algn="l">
+              <a:lnSpc>
+                <a:spcPct val="108000"/>
+              </a:lnSpc>
+              <a:spcAft>
+                <a:spcPts val="500"/>
+              </a:spcAft>
+              <a:buClr>
+                <a:srgbClr val="D9661F"/>
+              </a:buClr>
+              <a:buFont typeface="Arial"/>
+              <a:buChar char="■"/>
+            </a:pPr>
+            <a:r>
+              <a:rPr sz="2000" b="1" i="0">
+                <a:solidFill>
+                  <a:srgbClr val="1F2633"/>
+                </a:solidFill>
+                <a:latin typeface="Arial"/>
+              </a:rPr>
+              <a:t>Limitação: </a:t>
+            </a:r>
+            <a:r>
+              <a:rPr sz="2000" b="0" i="0">
+                <a:solidFill>
+                  <a:srgbClr val="1F2633"/>
+                </a:solidFill>
+                <a:latin typeface="Arial"/>
+              </a:rPr>
+              <a:t>as cheias acima de 20 m (2023–2024) ficaram só no treino; o 4h e o 8h seguem em verificação ao vivo.</a:t>
+            </a:r>
+          </a:p>
+        </p:txBody>
+      </p:sp>
+      <p:sp>
+        <p:nvSpPr>
+          <p:cNvPr id="41" name="Secao OPERAÇÃO EM TEMPO REAL"/>
+          <p:cNvSpPr/>
+          <p:nvPr/>
+        </p:nvSpPr>
+        <p:spPr>
+          <a:xfrm>
+            <a:off x="10944000" y="26388000"/>
+            <a:ext cx="7056000" cy="504000"/>
+          </a:xfrm>
+          <a:prstGeom prst="roundRect">
+            <a:avLst>
+              <a:gd name="adj" fmla="val 50000"/>
+            </a:avLst>
+          </a:prstGeom>
+          <a:solidFill>
+            <a:srgbClr val="2A378D"/>
+          </a:solidFill>
+          <a:ln>
+            <a:noFill/>
+          </a:ln>
+          <a:effectLst/>
+        </p:spPr>
+        <p:style>
+          <a:lnRef idx="1">
+            <a:schemeClr val="accent1"/>
+          </a:lnRef>
+          <a:fillRef idx="3">
+            <a:schemeClr val="accent1"/>
+          </a:fillRef>
+          <a:effectRef idx="2">
+            <a:schemeClr val="accent1"/>
+          </a:effectRef>
+          <a:fontRef idx="minor">
+            <a:schemeClr val="lt1"/>
+          </a:fontRef>
+        </p:style>
+        <p:txBody>
+          <a:bodyPr wrap="none" lIns="252000" tIns="0" rIns="252000" bIns="0" rtlCol="0" anchor="ctr"/>
+          <a:lstStyle/>
+          <a:p>
+            <a:pPr algn="l"/>
+            <a:r>
+              <a:rPr sz="3000" b="1" i="0">
+                <a:solidFill>
+                  <a:srgbClr val="FFFFFF"/>
+                </a:solidFill>
+                <a:latin typeface="Arial"/>
+              </a:rPr>
+              <a:t>OPERAÇÃO EM TEMPO REAL</a:t>
+            </a:r>
+          </a:p>
+        </p:txBody>
+      </p:sp>
+      <p:pic>
+        <p:nvPicPr>
+          <p:cNvPr id="42" name="Operacao ao vivo 2h" descr="ao_vivo_2h.png"/>
+          <p:cNvPicPr>
+            <a:picLocks noChangeAspect="1"/>
+          </p:cNvPicPr>
+          <p:nvPr/>
+        </p:nvPicPr>
+        <p:blipFill>
+          <a:blip r:embed="rId11"/>
+          <a:stretch>
+            <a:fillRect/>
+          </a:stretch>
+        </p:blipFill>
+        <p:spPr>
+          <a:xfrm>
+            <a:off x="10944000" y="27072000"/>
+            <a:ext cx="7056000" cy="3392308"/>
+          </a:xfrm>
+          <a:prstGeom prst="rect">
+            <a:avLst/>
+          </a:prstGeom>
+        </p:spPr>
+      </p:pic>
+      <p:sp>
+        <p:nvSpPr>
+          <p:cNvPr id="43" name="Legenda ao vivo"/>
+          <p:cNvSpPr txBox="1"/>
+          <p:nvPr/>
+        </p:nvSpPr>
+        <p:spPr>
+          <a:xfrm>
+            <a:off x="10944000" y="30569538"/>
+            <a:ext cx="9360000" cy="288000"/>
+          </a:xfrm>
+          <a:prstGeom prst="rect">
+            <a:avLst/>
+          </a:prstGeom>
+          <a:noFill/>
+        </p:spPr>
+        <p:txBody>
+          <a:bodyPr wrap="square" lIns="0" tIns="0" rIns="0" bIns="0" anchor="t">
+            <a:spAutoFit/>
+          </a:bodyPr>
+          <a:lstStyle/>
+          <a:p>
+            <a:pPr algn="l">
               <a:lnSpc>
                 <a:spcPct val="108000"/>
               </a:lnSpc>
@@ -5680,17 +6789,40 @@
               </a:spcAft>
             </a:pPr>
             <a:r>
-              <a:rPr sz="2800" b="1" i="0">
-                <a:solidFill>
-                  <a:srgbClr val="2A378D"/>
-                </a:solidFill>
-                <a:latin typeface="Arial"/>
-              </a:rPr>
-              <a:t>Dashboard</a:t>
-            </a:r>
-          </a:p>
-          <a:p>
-            <a:pPr algn="r">
+              <a:rPr sz="1800" b="0" i="0">
+                <a:solidFill>
+                  <a:srgbClr val="5B6573"/>
+                </a:solidFill>
+                <a:latin typeface="Arial"/>
+              </a:rPr>
+              <a:t>Figura 3 – Previsão ao vivo 2h × telemetria (25/09 a 05/10/2026).</a:t>
+            </a:r>
+          </a:p>
+        </p:txBody>
+      </p:sp>
+      <p:sp>
+        <p:nvSpPr>
+          <p:cNvPr id="44" name="Texto ao vivo"/>
+          <p:cNvSpPr txBox="1"/>
+          <p:nvPr/>
+        </p:nvSpPr>
+        <p:spPr>
+          <a:xfrm>
+            <a:off x="10944000" y="30929538"/>
+            <a:ext cx="9360000" cy="936000"/>
+          </a:xfrm>
+          <a:prstGeom prst="rect">
+            <a:avLst/>
+          </a:prstGeom>
+          <a:noFill/>
+        </p:spPr>
+        <p:txBody>
+          <a:bodyPr wrap="square" lIns="0" tIns="0" rIns="0" bIns="0" anchor="t">
+            <a:spAutoFit/>
+          </a:bodyPr>
+          <a:lstStyle/>
+          <a:p>
+            <a:pPr algn="l">
               <a:lnSpc>
                 <a:spcPct val="108000"/>
               </a:lnSpc>
@@ -5699,27 +6831,63 @@
               </a:spcAft>
             </a:pPr>
             <a:r>
-              <a:rPr sz="2800" b="1" i="0">
+              <a:rPr sz="2000" b="0" i="0">
+                <a:solidFill>
+                  <a:srgbClr val="1F2633"/>
+                </a:solidFill>
+                <a:latin typeface="Arial"/>
+              </a:rPr>
+              <a:t>Robô horário com telemetria SGB/ANA, em paralelo ao alerta oficial: </a:t>
+            </a:r>
+            <a:r>
+              <a:rPr sz="2000" b="1" i="0">
+                <a:solidFill>
+                  <a:srgbClr val="1F2633"/>
+                </a:solidFill>
+                <a:latin typeface="Arial"/>
+              </a:rPr>
+              <a:t>230 previsões auditadas</a:t>
+            </a:r>
+            <a:r>
+              <a:rPr sz="2000" b="0" i="0">
+                <a:solidFill>
+                  <a:srgbClr val="1F2633"/>
+                </a:solidFill>
+                <a:latin typeface="Arial"/>
+              </a:rPr>
+              <a:t>, </a:t>
+            </a:r>
+            <a:r>
+              <a:rPr sz="2000" b="1" i="0">
                 <a:solidFill>
                   <a:srgbClr val="D9661F"/>
                 </a:solidFill>
                 <a:latin typeface="Arial"/>
               </a:rPr>
-              <a:t>em tempo real →</a:t>
-            </a:r>
-          </a:p>
-        </p:txBody>
-      </p:sp>
-      <p:sp>
-        <p:nvSpPr>
-          <p:cNvPr id="52" name="Referencias e agradecimentos"/>
+              <a:t>EAM 9,2 cm</a:t>
+            </a:r>
+            <a:r>
+              <a:rPr sz="2000" b="0" i="0">
+                <a:solidFill>
+                  <a:srgbClr val="1F2633"/>
+                </a:solidFill>
+                <a:latin typeface="Arial"/>
+              </a:rPr>
+              <a:t> (persistência 27,2 cm).</a:t>
+            </a:r>
+          </a:p>
+        </p:txBody>
+      </p:sp>
+      <p:sp>
+        <p:nvSpPr>
+          <p:cNvPr id="45" name="Referencias e agradecimentos"/>
           <p:cNvSpPr txBox="1"/>
           <p:nvPr/>
         </p:nvSpPr>
         <p:spPr>
           <a:xfrm>
-            <a:off x="1080000" y="32796000"/>
-            <a:ext cx="16920000" cy="504000"/>
+            <a:off x="3456000" y="32364000"/>
+            <a:ext cx="16848000" cy="576000"/>
           </a:xfrm>
           <a:prstGeom prst="rect">
             <a:avLst/>
@@ -5727,7 +6895,7 @@
           <a:noFill/>
         </p:spPr>
         <p:txBody>
-          <a:bodyPr wrap="square" lIns="0" rIns="0" tIns="0" bIns="0" anchor="t">
+          <a:bodyPr wrap="square" lIns="0" tIns="0" rIns="0" bIns="0" anchor="t">
             <a:spAutoFit/>
           </a:bodyPr>
           <a:lstStyle/>
@@ -5741,7 +6909,7 @@
               </a:spcAft>
             </a:pPr>
             <a:r>
-              <a:rPr sz="1500" b="1" i="0">
+              <a:rPr sz="1400" b="1" i="0">
                 <a:solidFill>
                   <a:srgbClr val="5B6573"/>
                 </a:solidFill>
@@ -5750,16 +6918,16 @@
               <a:t>Referências: </a:t>
             </a:r>
             <a:r>
-              <a:rPr sz="1500" b="0" i="0">
+              <a:rPr sz="1400" b="0" i="0">
                 <a:solidFill>
                   <a:srgbClr val="5B6573"/>
                 </a:solidFill>
                 <a:latin typeface="Arial"/>
               </a:rPr>
-              <a:t>ALVISI, S. et al. (2006). Hydrology and Earth System Sciences, 10(1), 1-17. · RUMELHART, D. E. et al. (1986). Nature, 323, 533-536. · KUMAR, V. et al. (2023). Sustainability, 15(13), 10543.   </a:t>
-            </a:r>
-            <a:r>
-              <a:rPr sz="1500" b="1" i="0">
+              <a:t>ALVISI, S. et al. (2006). Hydrol. Earth Syst. Sci., 10(1), 1-17 · RUMELHART, D. E. et al. (1986). Nature, 323, 533-536 · KUMAR, V. et al. (2023). Sustainability, 15(13), 10543.  </a:t>
+            </a:r>
+            <a:r>
+              <a:rPr sz="1400" b="1" i="0">
                 <a:solidFill>
                   <a:srgbClr val="5B6573"/>
                 </a:solidFill>
@@ -5768,7 +6936,7 @@
               <a:t>Agradecimentos: </a:t>
             </a:r>
             <a:r>
-              <a:rPr sz="1500" b="0" i="0">
+              <a:rPr sz="1400" b="0" i="0">
                 <a:solidFill>
                   <a:srgbClr val="5B6573"/>
                 </a:solidFill>
@@ -5779,6 +6947,138 @@
           </a:p>
         </p:txBody>
       </p:sp>
+      <p:sp>
+        <p:nvSpPr>
+          <p:cNvPr id="49" name="Chamada QR code">
+            <a:extLst>
+              <a:ext uri="{FF2B5EF4-FFF2-40B4-BE49-F238E27FC236}">
+                <a16:creationId xmlns:a16="http://schemas.microsoft.com/office/drawing/2014/main" id="{B8D035C5-1487-E5C6-9D91-7D3AAB38A358}"/>
+              </a:ext>
+            </a:extLst>
+          </p:cNvPr>
+          <p:cNvSpPr txBox="1"/>
+          <p:nvPr/>
+        </p:nvSpPr>
+        <p:spPr>
+          <a:xfrm>
+            <a:off x="18072000" y="27036000"/>
+            <a:ext cx="2376000" cy="288000"/>
+          </a:xfrm>
+          <a:prstGeom prst="rect">
+            <a:avLst/>
+          </a:prstGeom>
+          <a:noFill/>
+        </p:spPr>
+        <p:txBody>
+          <a:bodyPr wrap="square" lIns="0" tIns="0" rIns="0" bIns="0" anchor="t">
+            <a:spAutoFit/>
+          </a:bodyPr>
+          <a:lstStyle/>
+          <a:p>
+            <a:pPr algn="ctr">
+              <a:lnSpc>
+                <a:spcPct val="108000"/>
+              </a:lnSpc>
+              <a:spcAft>
+                <a:spcPts val="600"/>
+              </a:spcAft>
+            </a:pPr>
+            <a:r>
+              <a:rPr sz="1800" b="1" i="0">
+                <a:solidFill>
+                  <a:srgbClr val="2A378D"/>
+                </a:solidFill>
+                <a:latin typeface="Arial"/>
+              </a:rPr>
+              <a:t>Dashboard ao vivo</a:t>
+            </a:r>
+          </a:p>
+        </p:txBody>
+      </p:sp>
+      <p:pic>
+        <p:nvPicPr>
+          <p:cNvPr id="51" name="Imagem 50">
+            <a:extLst>
+              <a:ext uri="{FF2B5EF4-FFF2-40B4-BE49-F238E27FC236}">
+                <a16:creationId xmlns:a16="http://schemas.microsoft.com/office/drawing/2014/main" id="{AE79BE45-29B1-972B-6490-F38819B75D0A}"/>
+              </a:ext>
+            </a:extLst>
+          </p:cNvPr>
+          <p:cNvPicPr>
+            <a:picLocks noChangeAspect="1"/>
+          </p:cNvPicPr>
+          <p:nvPr/>
+        </p:nvPicPr>
+        <p:blipFill>
+          <a:blip r:embed="rId12">
+            <a:extLst>
+              <a:ext uri="{28A0092B-C50C-407E-A947-70E740481C1C}">
+                <a14:useLocalDpi xmlns:a14="http://schemas.microsoft.com/office/drawing/2010/main" val="0"/>
+              </a:ext>
+            </a:extLst>
+          </a:blip>
+          <a:stretch>
+            <a:fillRect/>
+          </a:stretch>
+        </p:blipFill>
+        <p:spPr>
+          <a:xfrm>
+            <a:off x="18216000" y="27360000"/>
+            <a:ext cx="2088000" cy="2088000"/>
+          </a:xfrm>
+          <a:prstGeom prst="rect">
+            <a:avLst/>
+          </a:prstGeom>
+        </p:spPr>
+      </p:pic>
+      <p:pic>
+        <p:nvPicPr>
+          <p:cNvPr id="52" name="Logo UFRGS" descr="ufrgs.png"/>
+          <p:cNvPicPr>
+            <a:picLocks noChangeAspect="1"/>
+          </p:cNvPicPr>
+          <p:nvPr/>
+        </p:nvPicPr>
+        <p:blipFill>
+          <a:blip r:embed="rId13"/>
+          <a:stretch>
+            <a:fillRect/>
+          </a:stretch>
+        </p:blipFill>
+        <p:spPr>
+          <a:xfrm>
+            <a:off x="1080000" y="32328000"/>
+            <a:ext cx="785937" cy="612000"/>
+          </a:xfrm>
+          <a:prstGeom prst="rect">
+            <a:avLst/>
+          </a:prstGeom>
+        </p:spPr>
+      </p:pic>
+      <p:pic>
+        <p:nvPicPr>
+          <p:cNvPr id="53" name="Logo FAPERGS" descr="fapergs.png"/>
+          <p:cNvPicPr>
+            <a:picLocks noChangeAspect="1"/>
+          </p:cNvPicPr>
+          <p:nvPr/>
+        </p:nvPicPr>
+        <p:blipFill>
+          <a:blip r:embed="rId14"/>
+          <a:stretch>
+            <a:fillRect/>
+          </a:stretch>
+        </p:blipFill>
+        <p:spPr>
+          <a:xfrm>
+            <a:off x="1980000" y="32328000"/>
+            <a:ext cx="1174545" cy="612000"/>
+          </a:xfrm>
+          <a:prstGeom prst="rect">
+            <a:avLst/>
+          </a:prstGeom>
+        </p:spPr>
+      </p:pic>
     </p:spTree>
   </p:cSld>
   <p:clrMapOvr>

</xml_diff>

<commit_message>
Resultados: dispersões empilhadas com PME/EAM/E95, tempo real e conclusões na coluna direita
Co-Authored-By: Claude Opus 5.5 <noreply@anthropic.com>
Claude-Session: https://claude.ai/code/session_01ESHSCPaB7QsPMssmHM5HK7
</commit_message>
<xml_diff>
--- a/poster_vend_2026/poster_VEND_Santa_Tereza_ALT.pptx
+++ b/poster_vend_2026/poster_VEND_Santa_Tereza_ALT.pptx
@@ -5721,30 +5721,6 @@
           </a:p>
         </p:txBody>
       </p:sp>
-      <p:pic>
-        <p:nvPicPr>
-          <p:cNvPr id="35" name="Dispersao previsto x observado" descr="dispersao.png"/>
-          <p:cNvPicPr>
-            <a:picLocks noChangeAspect="1"/>
-          </p:cNvPicPr>
-          <p:nvPr/>
-        </p:nvPicPr>
-        <p:blipFill>
-          <a:blip r:embed="rId10"/>
-          <a:stretch>
-            <a:fillRect/>
-          </a:stretch>
-        </p:blipFill>
-        <p:spPr>
-          <a:xfrm>
-            <a:off x="3276000" y="20853110"/>
-            <a:ext cx="15480000" cy="5110385"/>
-          </a:xfrm>
-          <a:prstGeom prst="rect">
-            <a:avLst/>
-          </a:prstGeom>
-        </p:spPr>
-      </p:pic>
       <p:sp>
         <p:nvSpPr>
           <p:cNvPr id="36" name="Legenda dispersao"/>
@@ -5753,8 +5729,8 @@
         </p:nvSpPr>
         <p:spPr>
           <a:xfrm>
-            <a:off x="1080000" y="25990385"/>
-            <a:ext cx="19224000" cy="288000"/>
+            <a:off x="1080000" y="31538111"/>
+            <a:ext cx="9360000" cy="468000"/>
           </a:xfrm>
           <a:prstGeom prst="rect">
             <a:avLst/>
@@ -5782,695 +5758,7 @@
                 </a:solidFill>
                 <a:latin typeface="Arial"/>
               </a:rPr>
-              <a:t>Figura 2 – Nível previsto × observado em todas as amostras; em laranja, o conjunto de teste (NSE do título).</a:t>
-            </a:r>
-          </a:p>
-        </p:txBody>
-      </p:sp>
-      <p:graphicFrame>
-        <p:nvGraphicFramePr>
-          <p:cNvPr id="37" name="Tabela resultados"/>
-          <p:cNvGraphicFramePr>
-            <a:graphicFrameLocks noGrp="1"/>
-          </p:cNvGraphicFramePr>
-          <p:nvPr/>
-        </p:nvGraphicFramePr>
-        <p:xfrm>
-          <a:off x="1080000" y="26386385"/>
-          <a:ext cx="9360001" cy="1800000"/>
-        </p:xfrm>
-        <a:graphic>
-          <a:graphicData uri="http://schemas.openxmlformats.org/drawingml/2006/table">
-            <a:tbl>
-              <a:tblPr>
-                <a:tableStyleId>{5C22544A-7EE6-4342-B048-85BDC9FD1C3A}</a:tableStyleId>
-              </a:tblPr>
-              <a:tblGrid>
-                <a:gridCol w="1429008">
-                  <a:extLst>
-                    <a:ext uri="{9D8B030D-6E8A-4147-A177-3AD203B41FA5}">
-                      <a16:colId xmlns:a16="http://schemas.microsoft.com/office/drawing/2014/main" val="20000"/>
-                    </a:ext>
-                  </a:extLst>
-                </a:gridCol>
-                <a:gridCol w="1429008">
-                  <a:extLst>
-                    <a:ext uri="{9D8B030D-6E8A-4147-A177-3AD203B41FA5}">
-                      <a16:colId xmlns:a16="http://schemas.microsoft.com/office/drawing/2014/main" val="20001"/>
-                    </a:ext>
-                  </a:extLst>
-                </a:gridCol>
-                <a:gridCol w="1429008">
-                  <a:extLst>
-                    <a:ext uri="{9D8B030D-6E8A-4147-A177-3AD203B41FA5}">
-                      <a16:colId xmlns:a16="http://schemas.microsoft.com/office/drawing/2014/main" val="20002"/>
-                    </a:ext>
-                  </a:extLst>
-                </a:gridCol>
-                <a:gridCol w="1500458">
-                  <a:extLst>
-                    <a:ext uri="{9D8B030D-6E8A-4147-A177-3AD203B41FA5}">
-                      <a16:colId xmlns:a16="http://schemas.microsoft.com/office/drawing/2014/main" val="20003"/>
-                    </a:ext>
-                  </a:extLst>
-                </a:gridCol>
-                <a:gridCol w="1357557">
-                  <a:extLst>
-                    <a:ext uri="{9D8B030D-6E8A-4147-A177-3AD203B41FA5}">
-                      <a16:colId xmlns:a16="http://schemas.microsoft.com/office/drawing/2014/main" val="20004"/>
-                    </a:ext>
-                  </a:extLst>
-                </a:gridCol>
-                <a:gridCol w="2214962">
-                  <a:extLst>
-                    <a:ext uri="{9D8B030D-6E8A-4147-A177-3AD203B41FA5}">
-                      <a16:colId xmlns:a16="http://schemas.microsoft.com/office/drawing/2014/main" val="20005"/>
-                    </a:ext>
-                  </a:extLst>
-                </a:gridCol>
-              </a:tblGrid>
-              <a:tr h="450000">
-                <a:tc>
-                  <a:txBody>
-                    <a:bodyPr/>
-                    <a:lstStyle/>
-                    <a:p>
-                      <a:pPr algn="l"/>
-                      <a:r>
-                        <a:rPr sz="1900" b="1" i="0">
-                          <a:solidFill>
-                            <a:srgbClr val="FFFFFF"/>
-                          </a:solidFill>
-                          <a:latin typeface="Arial"/>
-                        </a:rPr>
-                        <a:t>Teste</a:t>
-                      </a:r>
-                    </a:p>
-                  </a:txBody>
-                  <a:tcPr marL="90000" marR="90000" marT="36000" marB="36000" anchor="ctr">
-                    <a:solidFill>
-                      <a:srgbClr val="2A378D"/>
-                    </a:solidFill>
-                  </a:tcPr>
-                </a:tc>
-                <a:tc>
-                  <a:txBody>
-                    <a:bodyPr/>
-                    <a:lstStyle/>
-                    <a:p>
-                      <a:pPr algn="ctr"/>
-                      <a:r>
-                        <a:rPr sz="1900" b="1" i="0">
-                          <a:solidFill>
-                            <a:srgbClr val="FFFFFF"/>
-                          </a:solidFill>
-                          <a:latin typeface="Arial"/>
-                        </a:rPr>
-                        <a:t>NSE</a:t>
-                      </a:r>
-                    </a:p>
-                  </a:txBody>
-                  <a:tcPr marL="90000" marR="90000" marT="36000" marB="36000" anchor="ctr">
-                    <a:solidFill>
-                      <a:srgbClr val="2A378D"/>
-                    </a:solidFill>
-                  </a:tcPr>
-                </a:tc>
-                <a:tc>
-                  <a:txBody>
-                    <a:bodyPr/>
-                    <a:lstStyle/>
-                    <a:p>
-                      <a:pPr algn="ctr"/>
-                      <a:r>
-                        <a:rPr sz="1900" b="1" i="0">
-                          <a:solidFill>
-                            <a:srgbClr val="FFFFFF"/>
-                          </a:solidFill>
-                          <a:latin typeface="Arial"/>
-                        </a:rPr>
-                        <a:t>PME</a:t>
-                      </a:r>
-                    </a:p>
-                  </a:txBody>
-                  <a:tcPr marL="90000" marR="90000" marT="36000" marB="36000" anchor="ctr">
-                    <a:solidFill>
-                      <a:srgbClr val="2A378D"/>
-                    </a:solidFill>
-                  </a:tcPr>
-                </a:tc>
-                <a:tc>
-                  <a:txBody>
-                    <a:bodyPr/>
-                    <a:lstStyle/>
-                    <a:p>
-                      <a:pPr algn="ctr"/>
-                      <a:r>
-                        <a:rPr sz="1900" b="1" i="0">
-                          <a:solidFill>
-                            <a:srgbClr val="FFFFFF"/>
-                          </a:solidFill>
-                          <a:latin typeface="Arial"/>
-                        </a:rPr>
-                        <a:t>EAM</a:t>
-                      </a:r>
-                    </a:p>
-                  </a:txBody>
-                  <a:tcPr marL="90000" marR="90000" marT="36000" marB="36000" anchor="ctr">
-                    <a:solidFill>
-                      <a:srgbClr val="2A378D"/>
-                    </a:solidFill>
-                  </a:tcPr>
-                </a:tc>
-                <a:tc>
-                  <a:txBody>
-                    <a:bodyPr/>
-                    <a:lstStyle/>
-                    <a:p>
-                      <a:pPr algn="ctr"/>
-                      <a:r>
-                        <a:rPr sz="1900" b="1" i="0">
-                          <a:solidFill>
-                            <a:srgbClr val="FFFFFF"/>
-                          </a:solidFill>
-                          <a:latin typeface="Arial"/>
-                        </a:rPr>
-                        <a:t>E95</a:t>
-                      </a:r>
-                    </a:p>
-                  </a:txBody>
-                  <a:tcPr marL="90000" marR="90000" marT="36000" marB="36000" anchor="ctr">
-                    <a:solidFill>
-                      <a:srgbClr val="2A378D"/>
-                    </a:solidFill>
-                  </a:tcPr>
-                </a:tc>
-                <a:tc>
-                  <a:txBody>
-                    <a:bodyPr/>
-                    <a:lstStyle/>
-                    <a:p>
-                      <a:pPr algn="ctr"/>
-                      <a:r>
-                        <a:rPr sz="1900" b="1" i="0">
-                          <a:solidFill>
-                            <a:srgbClr val="FFFFFF"/>
-                          </a:solidFill>
-                          <a:latin typeface="Arial"/>
-                        </a:rPr>
-                        <a:t>EAM × persist.</a:t>
-                      </a:r>
-                    </a:p>
-                  </a:txBody>
-                  <a:tcPr marL="90000" marR="90000" marT="36000" marB="36000" anchor="ctr">
-                    <a:solidFill>
-                      <a:srgbClr val="2A378D"/>
-                    </a:solidFill>
-                  </a:tcPr>
-                </a:tc>
-                <a:extLst>
-                  <a:ext uri="{0D108BD9-81ED-4DB2-BD59-A6C34878D82A}">
-                    <a16:rowId xmlns:a16="http://schemas.microsoft.com/office/drawing/2014/main" val="10000"/>
-                  </a:ext>
-                </a:extLst>
-              </a:tr>
-              <a:tr h="450000">
-                <a:tc>
-                  <a:txBody>
-                    <a:bodyPr/>
-                    <a:lstStyle/>
-                    <a:p>
-                      <a:pPr algn="l"/>
-                      <a:r>
-                        <a:rPr sz="1900" b="1" i="0">
-                          <a:solidFill>
-                            <a:srgbClr val="1F2633"/>
-                          </a:solidFill>
-                          <a:latin typeface="Arial"/>
-                        </a:rPr>
-                        <a:t>ALT 2h</a:t>
-                      </a:r>
-                    </a:p>
-                  </a:txBody>
-                  <a:tcPr marL="90000" marR="90000" marT="36000" marB="36000" anchor="ctr">
-                    <a:solidFill>
-                      <a:srgbClr val="FFFFFF"/>
-                    </a:solidFill>
-                  </a:tcPr>
-                </a:tc>
-                <a:tc>
-                  <a:txBody>
-                    <a:bodyPr/>
-                    <a:lstStyle/>
-                    <a:p>
-                      <a:pPr algn="ctr"/>
-                      <a:r>
-                        <a:rPr sz="1900" b="0" i="0">
-                          <a:solidFill>
-                            <a:srgbClr val="1F2633"/>
-                          </a:solidFill>
-                          <a:latin typeface="Arial"/>
-                        </a:rPr>
-                        <a:t>0,996</a:t>
-                      </a:r>
-                    </a:p>
-                  </a:txBody>
-                  <a:tcPr marL="90000" marR="90000" marT="36000" marB="36000" anchor="ctr">
-                    <a:solidFill>
-                      <a:srgbClr val="FFFFFF"/>
-                    </a:solidFill>
-                  </a:tcPr>
-                </a:tc>
-                <a:tc>
-                  <a:txBody>
-                    <a:bodyPr/>
-                    <a:lstStyle/>
-                    <a:p>
-                      <a:pPr algn="ctr"/>
-                      <a:r>
-                        <a:rPr sz="1900" b="0" i="0">
-                          <a:solidFill>
-                            <a:srgbClr val="1F2633"/>
-                          </a:solidFill>
-                          <a:latin typeface="Arial"/>
-                        </a:rPr>
-                        <a:t>0,969</a:t>
-                      </a:r>
-                    </a:p>
-                  </a:txBody>
-                  <a:tcPr marL="90000" marR="90000" marT="36000" marB="36000" anchor="ctr">
-                    <a:solidFill>
-                      <a:srgbClr val="FFFFFF"/>
-                    </a:solidFill>
-                  </a:tcPr>
-                </a:tc>
-                <a:tc>
-                  <a:txBody>
-                    <a:bodyPr/>
-                    <a:lstStyle/>
-                    <a:p>
-                      <a:pPr algn="ctr"/>
-                      <a:r>
-                        <a:rPr sz="1900" b="0" i="0">
-                          <a:solidFill>
-                            <a:srgbClr val="1F2633"/>
-                          </a:solidFill>
-                          <a:latin typeface="Arial"/>
-                        </a:rPr>
-                        <a:t>3,5 cm</a:t>
-                      </a:r>
-                    </a:p>
-                  </a:txBody>
-                  <a:tcPr marL="90000" marR="90000" marT="36000" marB="36000" anchor="ctr">
-                    <a:solidFill>
-                      <a:srgbClr val="FFFFFF"/>
-                    </a:solidFill>
-                  </a:tcPr>
-                </a:tc>
-                <a:tc>
-                  <a:txBody>
-                    <a:bodyPr/>
-                    <a:lstStyle/>
-                    <a:p>
-                      <a:pPr algn="ctr"/>
-                      <a:r>
-                        <a:rPr sz="1900" b="0" i="0">
-                          <a:solidFill>
-                            <a:srgbClr val="1F2633"/>
-                          </a:solidFill>
-                          <a:latin typeface="Arial"/>
-                        </a:rPr>
-                        <a:t>10 cm</a:t>
-                      </a:r>
-                    </a:p>
-                  </a:txBody>
-                  <a:tcPr marL="90000" marR="90000" marT="36000" marB="36000" anchor="ctr">
-                    <a:solidFill>
-                      <a:srgbClr val="FFFFFF"/>
-                    </a:solidFill>
-                  </a:tcPr>
-                </a:tc>
-                <a:tc>
-                  <a:txBody>
-                    <a:bodyPr/>
-                    <a:lstStyle/>
-                    <a:p>
-                      <a:pPr algn="ctr"/>
-                      <a:r>
-                        <a:rPr sz="1900" b="0" i="0">
-                          <a:solidFill>
-                            <a:srgbClr val="1F2633"/>
-                          </a:solidFill>
-                          <a:latin typeface="Arial"/>
-                        </a:rPr>
-                        <a:t>−81%</a:t>
-                      </a:r>
-                    </a:p>
-                  </a:txBody>
-                  <a:tcPr marL="90000" marR="90000" marT="36000" marB="36000" anchor="ctr">
-                    <a:solidFill>
-                      <a:srgbClr val="FFFFFF"/>
-                    </a:solidFill>
-                  </a:tcPr>
-                </a:tc>
-                <a:extLst>
-                  <a:ext uri="{0D108BD9-81ED-4DB2-BD59-A6C34878D82A}">
-                    <a16:rowId xmlns:a16="http://schemas.microsoft.com/office/drawing/2014/main" val="10001"/>
-                  </a:ext>
-                </a:extLst>
-              </a:tr>
-              <a:tr h="450000">
-                <a:tc>
-                  <a:txBody>
-                    <a:bodyPr/>
-                    <a:lstStyle/>
-                    <a:p>
-                      <a:pPr algn="l"/>
-                      <a:r>
-                        <a:rPr sz="1900" b="1" i="0">
-                          <a:solidFill>
-                            <a:srgbClr val="1F2633"/>
-                          </a:solidFill>
-                          <a:latin typeface="Arial"/>
-                        </a:rPr>
-                        <a:t>ALT 4h</a:t>
-                      </a:r>
-                    </a:p>
-                  </a:txBody>
-                  <a:tcPr marL="90000" marR="90000" marT="36000" marB="36000" anchor="ctr">
-                    <a:solidFill>
-                      <a:srgbClr val="E6EEF5"/>
-                    </a:solidFill>
-                  </a:tcPr>
-                </a:tc>
-                <a:tc>
-                  <a:txBody>
-                    <a:bodyPr/>
-                    <a:lstStyle/>
-                    <a:p>
-                      <a:pPr algn="ctr"/>
-                      <a:r>
-                        <a:rPr sz="1900" b="0" i="0">
-                          <a:solidFill>
-                            <a:srgbClr val="1F2633"/>
-                          </a:solidFill>
-                          <a:latin typeface="Arial"/>
-                        </a:rPr>
-                        <a:t>0,993</a:t>
-                      </a:r>
-                    </a:p>
-                  </a:txBody>
-                  <a:tcPr marL="90000" marR="90000" marT="36000" marB="36000" anchor="ctr">
-                    <a:solidFill>
-                      <a:srgbClr val="E6EEF5"/>
-                    </a:solidFill>
-                  </a:tcPr>
-                </a:tc>
-                <a:tc>
-                  <a:txBody>
-                    <a:bodyPr/>
-                    <a:lstStyle/>
-                    <a:p>
-                      <a:pPr algn="ctr"/>
-                      <a:r>
-                        <a:rPr sz="1900" b="0" i="0">
-                          <a:solidFill>
-                            <a:srgbClr val="1F2633"/>
-                          </a:solidFill>
-                          <a:latin typeface="Arial"/>
-                        </a:rPr>
-                        <a:t>0,878</a:t>
-                      </a:r>
-                    </a:p>
-                  </a:txBody>
-                  <a:tcPr marL="90000" marR="90000" marT="36000" marB="36000" anchor="ctr">
-                    <a:solidFill>
-                      <a:srgbClr val="E6EEF5"/>
-                    </a:solidFill>
-                  </a:tcPr>
-                </a:tc>
-                <a:tc>
-                  <a:txBody>
-                    <a:bodyPr/>
-                    <a:lstStyle/>
-                    <a:p>
-                      <a:pPr algn="ctr"/>
-                      <a:r>
-                        <a:rPr sz="1900" b="0" i="0">
-                          <a:solidFill>
-                            <a:srgbClr val="1F2633"/>
-                          </a:solidFill>
-                          <a:latin typeface="Arial"/>
-                        </a:rPr>
-                        <a:t>14,0 cm</a:t>
-                      </a:r>
-                    </a:p>
-                  </a:txBody>
-                  <a:tcPr marL="90000" marR="90000" marT="36000" marB="36000" anchor="ctr">
-                    <a:solidFill>
-                      <a:srgbClr val="E6EEF5"/>
-                    </a:solidFill>
-                  </a:tcPr>
-                </a:tc>
-                <a:tc>
-                  <a:txBody>
-                    <a:bodyPr/>
-                    <a:lstStyle/>
-                    <a:p>
-                      <a:pPr algn="ctr"/>
-                      <a:r>
-                        <a:rPr sz="1900" b="0" i="0">
-                          <a:solidFill>
-                            <a:srgbClr val="1F2633"/>
-                          </a:solidFill>
-                          <a:latin typeface="Arial"/>
-                        </a:rPr>
-                        <a:t>59 cm</a:t>
-                      </a:r>
-                    </a:p>
-                  </a:txBody>
-                  <a:tcPr marL="90000" marR="90000" marT="36000" marB="36000" anchor="ctr">
-                    <a:solidFill>
-                      <a:srgbClr val="E6EEF5"/>
-                    </a:solidFill>
-                  </a:tcPr>
-                </a:tc>
-                <a:tc>
-                  <a:txBody>
-                    <a:bodyPr/>
-                    <a:lstStyle/>
-                    <a:p>
-                      <a:pPr algn="ctr"/>
-                      <a:r>
-                        <a:rPr sz="1900" b="0" i="0">
-                          <a:solidFill>
-                            <a:srgbClr val="1F2633"/>
-                          </a:solidFill>
-                          <a:latin typeface="Arial"/>
-                        </a:rPr>
-                        <a:t>−65%</a:t>
-                      </a:r>
-                    </a:p>
-                  </a:txBody>
-                  <a:tcPr marL="90000" marR="90000" marT="36000" marB="36000" anchor="ctr">
-                    <a:solidFill>
-                      <a:srgbClr val="E6EEF5"/>
-                    </a:solidFill>
-                  </a:tcPr>
-                </a:tc>
-                <a:extLst>
-                  <a:ext uri="{0D108BD9-81ED-4DB2-BD59-A6C34878D82A}">
-                    <a16:rowId xmlns:a16="http://schemas.microsoft.com/office/drawing/2014/main" val="10002"/>
-                  </a:ext>
-                </a:extLst>
-              </a:tr>
-              <a:tr h="450000">
-                <a:tc>
-                  <a:txBody>
-                    <a:bodyPr/>
-                    <a:lstStyle/>
-                    <a:p>
-                      <a:pPr algn="l"/>
-                      <a:r>
-                        <a:rPr sz="1900" b="1" i="0">
-                          <a:solidFill>
-                            <a:srgbClr val="1F2633"/>
-                          </a:solidFill>
-                          <a:latin typeface="Arial"/>
-                        </a:rPr>
-                        <a:t>ALT 8h</a:t>
-                      </a:r>
-                    </a:p>
-                  </a:txBody>
-                  <a:tcPr marL="90000" marR="90000" marT="36000" marB="36000" anchor="ctr">
-                    <a:solidFill>
-                      <a:srgbClr val="FFFFFF"/>
-                    </a:solidFill>
-                  </a:tcPr>
-                </a:tc>
-                <a:tc>
-                  <a:txBody>
-                    <a:bodyPr/>
-                    <a:lstStyle/>
-                    <a:p>
-                      <a:pPr algn="ctr"/>
-                      <a:r>
-                        <a:rPr sz="1900" b="0" i="0">
-                          <a:solidFill>
-                            <a:srgbClr val="1F2633"/>
-                          </a:solidFill>
-                          <a:latin typeface="Arial"/>
-                        </a:rPr>
-                        <a:t>0,979</a:t>
-                      </a:r>
-                    </a:p>
-                  </a:txBody>
-                  <a:tcPr marL="90000" marR="90000" marT="36000" marB="36000" anchor="ctr">
-                    <a:solidFill>
-                      <a:srgbClr val="FFFFFF"/>
-                    </a:solidFill>
-                  </a:tcPr>
-                </a:tc>
-                <a:tc>
-                  <a:txBody>
-                    <a:bodyPr/>
-                    <a:lstStyle/>
-                    <a:p>
-                      <a:pPr algn="ctr"/>
-                      <a:r>
-                        <a:rPr sz="1900" b="0" i="0">
-                          <a:solidFill>
-                            <a:srgbClr val="1F2633"/>
-                          </a:solidFill>
-                          <a:latin typeface="Arial"/>
-                        </a:rPr>
-                        <a:t>0,927</a:t>
-                      </a:r>
-                    </a:p>
-                  </a:txBody>
-                  <a:tcPr marL="90000" marR="90000" marT="36000" marB="36000" anchor="ctr">
-                    <a:solidFill>
-                      <a:srgbClr val="FFFFFF"/>
-                    </a:solidFill>
-                  </a:tcPr>
-                </a:tc>
-                <a:tc>
-                  <a:txBody>
-                    <a:bodyPr/>
-                    <a:lstStyle/>
-                    <a:p>
-                      <a:pPr algn="ctr"/>
-                      <a:r>
-                        <a:rPr sz="1900" b="0" i="0">
-                          <a:solidFill>
-                            <a:srgbClr val="1F2633"/>
-                          </a:solidFill>
-                          <a:latin typeface="Arial"/>
-                        </a:rPr>
-                        <a:t>23,3 cm</a:t>
-                      </a:r>
-                    </a:p>
-                  </a:txBody>
-                  <a:tcPr marL="90000" marR="90000" marT="36000" marB="36000" anchor="ctr">
-                    <a:solidFill>
-                      <a:srgbClr val="FFFFFF"/>
-                    </a:solidFill>
-                  </a:tcPr>
-                </a:tc>
-                <a:tc>
-                  <a:txBody>
-                    <a:bodyPr/>
-                    <a:lstStyle/>
-                    <a:p>
-                      <a:pPr algn="ctr"/>
-                      <a:r>
-                        <a:rPr sz="1900" b="0" i="0">
-                          <a:solidFill>
-                            <a:srgbClr val="1F2633"/>
-                          </a:solidFill>
-                          <a:latin typeface="Arial"/>
-                        </a:rPr>
-                        <a:t>64 cm</a:t>
-                      </a:r>
-                    </a:p>
-                  </a:txBody>
-                  <a:tcPr marL="90000" marR="90000" marT="36000" marB="36000" anchor="ctr">
-                    <a:solidFill>
-                      <a:srgbClr val="FFFFFF"/>
-                    </a:solidFill>
-                  </a:tcPr>
-                </a:tc>
-                <a:tc>
-                  <a:txBody>
-                    <a:bodyPr/>
-                    <a:lstStyle/>
-                    <a:p>
-                      <a:pPr algn="ctr"/>
-                      <a:r>
-                        <a:rPr sz="1900" b="0" i="0">
-                          <a:solidFill>
-                            <a:srgbClr val="1F2633"/>
-                          </a:solidFill>
-                          <a:latin typeface="Arial"/>
-                        </a:rPr>
-                        <a:t>−69%</a:t>
-                      </a:r>
-                    </a:p>
-                  </a:txBody>
-                  <a:tcPr marL="90000" marR="90000" marT="36000" marB="36000" anchor="ctr">
-                    <a:solidFill>
-                      <a:srgbClr val="FFFFFF"/>
-                    </a:solidFill>
-                  </a:tcPr>
-                </a:tc>
-                <a:extLst>
-                  <a:ext uri="{0D108BD9-81ED-4DB2-BD59-A6C34878D82A}">
-                    <a16:rowId xmlns:a16="http://schemas.microsoft.com/office/drawing/2014/main" val="10003"/>
-                  </a:ext>
-                </a:extLst>
-              </a:tr>
-            </a:tbl>
-          </a:graphicData>
-        </a:graphic>
-      </p:graphicFrame>
-      <p:sp>
-        <p:nvSpPr>
-          <p:cNvPr id="38" name="Legenda tabela"/>
-          <p:cNvSpPr txBox="1"/>
-          <p:nvPr/>
-        </p:nvSpPr>
-        <p:spPr>
-          <a:xfrm>
-            <a:off x="1080000" y="28260000"/>
-            <a:ext cx="9360000" cy="468000"/>
-          </a:xfrm>
-          <a:prstGeom prst="rect">
-            <a:avLst/>
-          </a:prstGeom>
-          <a:noFill/>
-        </p:spPr>
-        <p:txBody>
-          <a:bodyPr wrap="square" lIns="0" tIns="0" rIns="0" bIns="0" anchor="t">
-            <a:spAutoFit/>
-          </a:bodyPr>
-          <a:lstStyle/>
-          <a:p>
-            <a:pPr algn="l">
-              <a:lnSpc>
-                <a:spcPct val="108000"/>
-              </a:lnSpc>
-              <a:spcAft>
-                <a:spcPts val="600"/>
-              </a:spcAft>
-            </a:pPr>
-            <a:r>
-              <a:rPr sz="1700" b="0" i="0">
-                <a:solidFill>
-                  <a:srgbClr val="5B6573"/>
-                </a:solidFill>
-                <a:latin typeface="Arial"/>
-              </a:rPr>
-              <a:t>Tabela 1 – Teste (eventos fora do treino): 2h – 3 eventos de out/2024 a 2025 (pico 6,2 m); 4h – cheia de jun/2025 (13,3 m); 8h – cheia de jul/2023 (12,5 m).</a:t>
+              <a:t>Figura 2 – Nível previsto × observado (laranja = teste). Teste: 2h – 3 eventos out/2024–2025; 4h – cheia de jun/2025; 8h – cheia de jul/2023.</a:t>
             </a:r>
           </a:p>
         </p:txBody>
@@ -6483,7 +5771,7 @@
         </p:nvSpPr>
         <p:spPr>
           <a:xfrm>
-            <a:off x="1080000" y="28908000"/>
+            <a:off x="10944000" y="26784000"/>
             <a:ext cx="3456000" cy="504000"/>
           </a:xfrm>
           <a:prstGeom prst="roundRect">
@@ -6538,8 +5826,8 @@
         </p:nvSpPr>
         <p:spPr>
           <a:xfrm>
-            <a:off x="1080000" y="29592000"/>
-            <a:ext cx="9360000" cy="2520000"/>
+            <a:off x="10944000" y="27468000"/>
+            <a:ext cx="9360000" cy="2376000"/>
           </a:xfrm>
           <a:prstGeom prst="rect">
             <a:avLst/>
@@ -6687,7 +5975,7 @@
         </p:nvSpPr>
         <p:spPr>
           <a:xfrm>
-            <a:off x="10944000" y="26388000"/>
+            <a:off x="10944000" y="20052000"/>
             <a:ext cx="7056000" cy="504000"/>
           </a:xfrm>
           <a:prstGeom prst="roundRect">
@@ -6750,8 +6038,8 @@
         </p:blipFill>
         <p:spPr>
           <a:xfrm>
-            <a:off x="10944000" y="27072000"/>
-            <a:ext cx="7056000" cy="3392308"/>
+            <a:off x="10944000" y="20700000"/>
+            <a:ext cx="9360000" cy="4500000"/>
           </a:xfrm>
           <a:prstGeom prst="rect">
             <a:avLst/>
@@ -6766,7 +6054,7 @@
         </p:nvSpPr>
         <p:spPr>
           <a:xfrm>
-            <a:off x="10944000" y="30569538"/>
+            <a:off x="10944000" y="25236000"/>
             <a:ext cx="9360000" cy="288000"/>
           </a:xfrm>
           <a:prstGeom prst="rect">
@@ -6808,7 +6096,7 @@
         </p:nvSpPr>
         <p:spPr>
           <a:xfrm>
-            <a:off x="10944000" y="30929538"/>
+            <a:off x="10944000" y="25596000"/>
             <a:ext cx="9360000" cy="936000"/>
           </a:xfrm>
           <a:prstGeom prst="rect">
@@ -6961,8 +6249,8 @@
         </p:nvSpPr>
         <p:spPr>
           <a:xfrm>
-            <a:off x="18072000" y="27036000"/>
-            <a:ext cx="2376000" cy="288000"/>
+            <a:off x="14688000" y="30566111"/>
+            <a:ext cx="3384000" cy="720000"/>
           </a:xfrm>
           <a:prstGeom prst="rect">
             <a:avLst/>
@@ -6975,7 +6263,7 @@
           </a:bodyPr>
           <a:lstStyle/>
           <a:p>
-            <a:pPr algn="ctr">
+            <a:pPr algn="r">
               <a:lnSpc>
                 <a:spcPct val="108000"/>
               </a:lnSpc>
@@ -6984,13 +6272,13 @@
               </a:spcAft>
             </a:pPr>
             <a:r>
-              <a:rPr sz="1800" b="1" i="0">
+              <a:rPr sz="2600" b="1" i="0">
                 <a:solidFill>
                   <a:srgbClr val="2A378D"/>
                 </a:solidFill>
                 <a:latin typeface="Arial"/>
               </a:rPr>
-              <a:t>Dashboard ao vivo</a:t>
+              <a:t>Acompanhe a previsão ao vivo →</a:t>
             </a:r>
           </a:p>
         </p:txBody>
@@ -7023,8 +6311,8 @@
         </p:blipFill>
         <p:spPr>
           <a:xfrm>
-            <a:off x="18216000" y="27360000"/>
-            <a:ext cx="2088000" cy="2088000"/>
+            <a:off x="18288000" y="29918111"/>
+            <a:ext cx="2016000" cy="2016000"/>
           </a:xfrm>
           <a:prstGeom prst="rect">
             <a:avLst/>
@@ -7073,6 +6361,30 @@
           <a:xfrm>
             <a:off x="1980000" y="32328000"/>
             <a:ext cx="1174545" cy="612000"/>
+          </a:xfrm>
+          <a:prstGeom prst="rect">
+            <a:avLst/>
+          </a:prstGeom>
+        </p:spPr>
+      </p:pic>
+      <p:pic>
+        <p:nvPicPr>
+          <p:cNvPr id="54" name="Dispersao empilhada" descr="dispersao_vertical.png"/>
+          <p:cNvPicPr>
+            <a:picLocks noChangeAspect="1"/>
+          </p:cNvPicPr>
+          <p:nvPr/>
+        </p:nvPicPr>
+        <p:blipFill>
+          <a:blip r:embed="rId15"/>
+          <a:stretch>
+            <a:fillRect/>
+          </a:stretch>
+        </p:blipFill>
+        <p:spPr>
+          <a:xfrm>
+            <a:off x="1080000" y="20700000"/>
+            <a:ext cx="9360000" cy="10802111"/>
           </a:xfrm>
           <a:prstGeom prst="rect">
             <a:avLst/>

</xml_diff>

<commit_message>
Tabela de configuração com os códigos das estações
Co-Authored-By: Claude Opus 5.5 <noreply@anthropic.com>
Claude-Session: https://claude.ai/code/session_01ESHSCPaB7QsPMssmHM5HK7
</commit_message>
<xml_diff>
--- a/poster_vend_2026/poster_VEND_Santa_Tereza_ALT.pptx
+++ b/poster_vend_2026/poster_VEND_Santa_Tereza_ALT.pptx
@@ -5153,28 +5153,28 @@
                 <a:tableStyleId>{5C22544A-7EE6-4342-B048-85BDC9FD1C3A}</a:tableStyleId>
               </a:tblPr>
               <a:tblGrid>
-                <a:gridCol w="1376471">
+                <a:gridCol w="1032353">
                   <a:extLst>
                     <a:ext uri="{9D8B030D-6E8A-4147-A177-3AD203B41FA5}">
                       <a16:colId xmlns:a16="http://schemas.microsoft.com/office/drawing/2014/main" val="20000"/>
                     </a:ext>
                   </a:extLst>
                 </a:gridCol>
-                <a:gridCol w="1445294">
+                <a:gridCol w="1307647">
                   <a:extLst>
                     <a:ext uri="{9D8B030D-6E8A-4147-A177-3AD203B41FA5}">
                       <a16:colId xmlns:a16="http://schemas.microsoft.com/office/drawing/2014/main" val="20001"/>
                     </a:ext>
                   </a:extLst>
                 </a:gridCol>
-                <a:gridCol w="1582941">
+                <a:gridCol w="1445294">
                   <a:extLst>
                     <a:ext uri="{9D8B030D-6E8A-4147-A177-3AD203B41FA5}">
                       <a16:colId xmlns:a16="http://schemas.microsoft.com/office/drawing/2014/main" val="20002"/>
                     </a:ext>
                   </a:extLst>
                 </a:gridCol>
-                <a:gridCol w="4955294">
+                <a:gridCol w="5574706">
                   <a:extLst>
                     <a:ext uri="{9D8B030D-6E8A-4147-A177-3AD203B41FA5}">
                       <a16:colId xmlns:a16="http://schemas.microsoft.com/office/drawing/2014/main" val="20003"/>
@@ -5265,7 +5265,7 @@
                           </a:solidFill>
                           <a:latin typeface="Arial"/>
                         </a:rPr>
-                        <a:t>Variáveis de entrada</a:t>
+                        <a:t>Estações (código)</a:t>
                       </a:r>
                     </a:p>
                   </a:txBody>
@@ -5353,18 +5353,18 @@
                 </a:tc>
                 <a:tc>
                   <a:txBody>
-                    <a:bodyPr/>
+                    <a:bodyPr wrap="square"/>
                     <a:lstStyle/>
                     <a:p>
                       <a:pPr algn="l"/>
                       <a:r>
-                        <a:rPr lang="pt-BR" sz="1900" b="0" i="0" dirty="0">
+                        <a:rPr lang="pt-BR" sz="1600" b="0" i="0" dirty="0">
                           <a:solidFill>
                             <a:srgbClr val="1F2633"/>
                           </a:solidFill>
                           <a:latin typeface="Arial"/>
                         </a:rPr>
-                        <a:t>Santa Tereza e Linha José Júlio</a:t>
+                        <a:t>86472600, 86472000</a:t>
                       </a:r>
                     </a:p>
                   </a:txBody>
@@ -5452,45 +5452,18 @@
                 </a:tc>
                 <a:tc>
                   <a:txBody>
-                    <a:bodyPr/>
+                    <a:bodyPr wrap="square"/>
                     <a:lstStyle/>
                     <a:p>
                       <a:pPr algn="l"/>
                       <a:r>
-                        <a:rPr sz="1900" b="0" i="0" dirty="0">
+                        <a:rPr sz="1600" b="0" i="0" dirty="0">
                           <a:solidFill>
                             <a:srgbClr val="1F2633"/>
                           </a:solidFill>
                           <a:latin typeface="Arial"/>
                         </a:rPr>
-                        <a:t>+ 2 </a:t>
-                      </a:r>
-                      <a:r>
-                        <a:rPr sz="1900" b="0" i="0" dirty="0" err="1">
-                          <a:solidFill>
-                            <a:srgbClr val="1F2633"/>
-                          </a:solidFill>
-                          <a:latin typeface="Arial"/>
-                        </a:rPr>
-                        <a:t>postos</a:t>
-                      </a:r>
-                      <a:r>
-                        <a:rPr sz="1900" b="0" i="0" dirty="0">
-                          <a:solidFill>
-                            <a:srgbClr val="1F2633"/>
-                          </a:solidFill>
-                          <a:latin typeface="Arial"/>
-                        </a:rPr>
-                        <a:t> a </a:t>
-                      </a:r>
-                      <a:r>
-                        <a:rPr sz="1900" b="0" i="0" dirty="0" err="1">
-                          <a:solidFill>
-                            <a:srgbClr val="1F2633"/>
-                          </a:solidFill>
-                          <a:latin typeface="Arial"/>
-                        </a:rPr>
-                        <a:t>montante</a:t>
+                        <a:t>86472600, 86472000, 86125500, 86298000</a:t>
                       </a:r>
                       <a:endParaRPr sz="1900" b="0" i="0" dirty="0">
                         <a:solidFill>
@@ -5584,63 +5557,18 @@
                 </a:tc>
                 <a:tc>
                   <a:txBody>
-                    <a:bodyPr/>
+                    <a:bodyPr wrap="square"/>
                     <a:lstStyle/>
                     <a:p>
                       <a:pPr algn="l"/>
                       <a:r>
-                        <a:rPr sz="1900" b="0" i="0" dirty="0">
+                        <a:rPr sz="1600" b="0" i="0" dirty="0">
                           <a:solidFill>
                             <a:srgbClr val="1F2633"/>
                           </a:solidFill>
                           <a:latin typeface="Arial"/>
                         </a:rPr>
-                        <a:t>7 </a:t>
-                      </a:r>
-                      <a:r>
-                        <a:rPr sz="1900" b="0" i="0" dirty="0" err="1">
-                          <a:solidFill>
-                            <a:srgbClr val="1F2633"/>
-                          </a:solidFill>
-                          <a:latin typeface="Arial"/>
-                        </a:rPr>
-                        <a:t>postos</a:t>
-                      </a:r>
-                      <a:r>
-                        <a:rPr sz="1900" b="0" i="0" dirty="0">
-                          <a:solidFill>
-                            <a:srgbClr val="1F2633"/>
-                          </a:solidFill>
-                          <a:latin typeface="Arial"/>
-                        </a:rPr>
-                        <a:t> </a:t>
-                      </a:r>
-                      <a:r>
-                        <a:rPr sz="1900" b="0" i="0" dirty="0" err="1">
-                          <a:solidFill>
-                            <a:srgbClr val="1F2633"/>
-                          </a:solidFill>
-                          <a:latin typeface="Arial"/>
-                        </a:rPr>
-                        <a:t>fluviométricos</a:t>
-                      </a:r>
-                      <a:r>
-                        <a:rPr sz="1900" b="0" i="0" dirty="0">
-                          <a:solidFill>
-                            <a:srgbClr val="1F2633"/>
-                          </a:solidFill>
-                          <a:latin typeface="Arial"/>
-                        </a:rPr>
-                        <a:t> + </a:t>
-                      </a:r>
-                      <a:r>
-                        <a:rPr sz="1900" b="0" i="0" dirty="0" err="1">
-                          <a:solidFill>
-                            <a:srgbClr val="1F2633"/>
-                          </a:solidFill>
-                          <a:latin typeface="Arial"/>
-                        </a:rPr>
-                        <a:t>chuva</a:t>
+                        <a:t>86472600, 86472000, 86125500, 86298000, 86306000, 86430900, 86448000 + chuva</a:t>
                       </a:r>
                       <a:endParaRPr sz="1900" b="0" i="0" dirty="0">
                         <a:solidFill>

</xml_diff>

<commit_message>
Conclusões na largura da coluna, alinhadas à esquerda; QR abaixo (versão v2 da autora)
Co-Authored-By: Claude Opus 5.5 <noreply@anthropic.com>
Claude-Session: https://claude.ai/code/session_01ESHSCPaB7QsPMssmHM5HK7
</commit_message>
<xml_diff>
--- a/poster_vend_2026/poster_VEND_Santa_Tereza_ALT.pptx
+++ b/poster_vend_2026/poster_VEND_Santa_Tereza_ALT.pptx
@@ -315,7 +315,7 @@
             <a:fld id="{1D8BD707-D9CF-40AE-B4C6-C98DA3205C09}" type="datetimeFigureOut">
               <a:rPr lang="en-US" smtClean="0"/>
               <a:pPr/>
-              <a:t>10/5/2026</a:t>
+              <a:t>10/6/2026</a:t>
             </a:fld>
             <a:endParaRPr lang="en-US"/>
           </a:p>
@@ -480,7 +480,7 @@
             <a:fld id="{1D8BD707-D9CF-40AE-B4C6-C98DA3205C09}" type="datetimeFigureOut">
               <a:rPr lang="en-US" smtClean="0"/>
               <a:pPr/>
-              <a:t>10/5/2026</a:t>
+              <a:t>10/6/2026</a:t>
             </a:fld>
             <a:endParaRPr lang="en-US"/>
           </a:p>
@@ -655,7 +655,7 @@
             <a:fld id="{1D8BD707-D9CF-40AE-B4C6-C98DA3205C09}" type="datetimeFigureOut">
               <a:rPr lang="en-US" smtClean="0"/>
               <a:pPr/>
-              <a:t>10/5/2026</a:t>
+              <a:t>10/6/2026</a:t>
             </a:fld>
             <a:endParaRPr lang="en-US"/>
           </a:p>
@@ -820,7 +820,7 @@
             <a:fld id="{1D8BD707-D9CF-40AE-B4C6-C98DA3205C09}" type="datetimeFigureOut">
               <a:rPr lang="en-US" smtClean="0"/>
               <a:pPr/>
-              <a:t>10/5/2026</a:t>
+              <a:t>10/6/2026</a:t>
             </a:fld>
             <a:endParaRPr lang="en-US"/>
           </a:p>
@@ -1062,7 +1062,7 @@
             <a:fld id="{1D8BD707-D9CF-40AE-B4C6-C98DA3205C09}" type="datetimeFigureOut">
               <a:rPr lang="en-US" smtClean="0"/>
               <a:pPr/>
-              <a:t>10/5/2026</a:t>
+              <a:t>10/6/2026</a:t>
             </a:fld>
             <a:endParaRPr lang="en-US"/>
           </a:p>
@@ -1344,7 +1344,7 @@
             <a:fld id="{1D8BD707-D9CF-40AE-B4C6-C98DA3205C09}" type="datetimeFigureOut">
               <a:rPr lang="en-US" smtClean="0"/>
               <a:pPr/>
-              <a:t>10/5/2026</a:t>
+              <a:t>10/6/2026</a:t>
             </a:fld>
             <a:endParaRPr lang="en-US"/>
           </a:p>
@@ -1760,7 +1760,7 @@
             <a:fld id="{1D8BD707-D9CF-40AE-B4C6-C98DA3205C09}" type="datetimeFigureOut">
               <a:rPr lang="en-US" smtClean="0"/>
               <a:pPr/>
-              <a:t>10/5/2026</a:t>
+              <a:t>10/6/2026</a:t>
             </a:fld>
             <a:endParaRPr lang="en-US"/>
           </a:p>
@@ -1874,7 +1874,7 @@
             <a:fld id="{1D8BD707-D9CF-40AE-B4C6-C98DA3205C09}" type="datetimeFigureOut">
               <a:rPr lang="en-US" smtClean="0"/>
               <a:pPr/>
-              <a:t>10/5/2026</a:t>
+              <a:t>10/6/2026</a:t>
             </a:fld>
             <a:endParaRPr lang="en-US"/>
           </a:p>
@@ -1966,7 +1966,7 @@
             <a:fld id="{1D8BD707-D9CF-40AE-B4C6-C98DA3205C09}" type="datetimeFigureOut">
               <a:rPr lang="en-US" smtClean="0"/>
               <a:pPr/>
-              <a:t>10/5/2026</a:t>
+              <a:t>10/6/2026</a:t>
             </a:fld>
             <a:endParaRPr lang="en-US"/>
           </a:p>
@@ -2238,7 +2238,7 @@
             <a:fld id="{1D8BD707-D9CF-40AE-B4C6-C98DA3205C09}" type="datetimeFigureOut">
               <a:rPr lang="en-US" smtClean="0"/>
               <a:pPr/>
-              <a:t>10/5/2026</a:t>
+              <a:t>10/6/2026</a:t>
             </a:fld>
             <a:endParaRPr lang="en-US"/>
           </a:p>
@@ -2487,7 +2487,7 @@
             <a:fld id="{1D8BD707-D9CF-40AE-B4C6-C98DA3205C09}" type="datetimeFigureOut">
               <a:rPr lang="en-US" smtClean="0"/>
               <a:pPr/>
-              <a:t>10/5/2026</a:t>
+              <a:t>10/6/2026</a:t>
             </a:fld>
             <a:endParaRPr lang="en-US"/>
           </a:p>
@@ -2695,7 +2695,7 @@
             <a:fld id="{1D8BD707-D9CF-40AE-B4C6-C98DA3205C09}" type="datetimeFigureOut">
               <a:rPr lang="en-US" smtClean="0"/>
               <a:pPr/>
-              <a:t>10/5/2026</a:t>
+              <a:t>10/6/2026</a:t>
             </a:fld>
             <a:endParaRPr lang="en-US"/>
           </a:p>
@@ -3119,6 +3119,13 @@
             </a:stretch>
           </a:blipFill>
         </p:spPr>
+        <p:txBody>
+          <a:bodyPr/>
+          <a:lstStyle/>
+          <a:p>
+            <a:endParaRPr lang="pt-BR" dirty="0"/>
+          </a:p>
+        </p:txBody>
       </p:sp>
       <p:sp>
         <p:nvSpPr>
@@ -3128,7 +3135,7 @@
         </p:nvSpPr>
         <p:spPr>
           <a:xfrm>
-            <a:off x="0" y="33162109"/>
+            <a:off x="29812" y="33151392"/>
             <a:ext cx="21372000" cy="3774254"/>
           </a:xfrm>
           <a:custGeom>
@@ -3315,7 +3322,7 @@
         <p:spPr>
           <a:xfrm>
             <a:off x="1103812" y="6992298"/>
-            <a:ext cx="19224000" cy="764376"/>
+            <a:ext cx="19224000" cy="430887"/>
           </a:xfrm>
           <a:prstGeom prst="rect">
             <a:avLst/>
@@ -3336,121 +3343,6 @@
                 <a:latin typeface="Arial"/>
               </a:rPr>
               <a:t>Juliana Carolino Reis, Guilherme Garcia de Oliveira, Fernanda Vier Jung e Josiane Leci Vanin Barbieri</a:t>
-            </a:r>
-          </a:p>
-          <a:p>
-            <a:pPr algn="ctr">
-              <a:spcBef>
-                <a:spcPts val="400"/>
-              </a:spcBef>
-            </a:pPr>
-            <a:r>
-              <a:rPr sz="1900" b="0" i="0" dirty="0" err="1">
-                <a:solidFill>
-                  <a:srgbClr val="5B6573"/>
-                </a:solidFill>
-                <a:latin typeface="Arial"/>
-              </a:rPr>
-              <a:t>Universidade</a:t>
-            </a:r>
-            <a:r>
-              <a:rPr sz="1900" b="0" i="0" dirty="0">
-                <a:solidFill>
-                  <a:srgbClr val="5B6573"/>
-                </a:solidFill>
-                <a:latin typeface="Arial"/>
-              </a:rPr>
-              <a:t> Federal do Rio Grande do Sul (UFRGS) – Centro Estadual de </a:t>
-            </a:r>
-            <a:r>
-              <a:rPr sz="1900" b="0" i="0" dirty="0" err="1">
-                <a:solidFill>
-                  <a:srgbClr val="5B6573"/>
-                </a:solidFill>
-                <a:latin typeface="Arial"/>
-              </a:rPr>
-              <a:t>Pesquisas</a:t>
-            </a:r>
-            <a:r>
-              <a:rPr sz="1900" b="0" i="0" dirty="0">
-                <a:solidFill>
-                  <a:srgbClr val="5B6573"/>
-                </a:solidFill>
-                <a:latin typeface="Arial"/>
-              </a:rPr>
-              <a:t> </a:t>
-            </a:r>
-            <a:r>
-              <a:rPr sz="1900" b="0" i="0" dirty="0" err="1">
-                <a:solidFill>
-                  <a:srgbClr val="5B6573"/>
-                </a:solidFill>
-                <a:latin typeface="Arial"/>
-              </a:rPr>
-              <a:t>em</a:t>
-            </a:r>
-            <a:r>
-              <a:rPr sz="1900" b="0" i="0" dirty="0">
-                <a:solidFill>
-                  <a:srgbClr val="5B6573"/>
-                </a:solidFill>
-                <a:latin typeface="Arial"/>
-              </a:rPr>
-              <a:t> </a:t>
-            </a:r>
-            <a:r>
-              <a:rPr sz="1900" b="0" i="0" dirty="0" err="1">
-                <a:solidFill>
-                  <a:srgbClr val="5B6573"/>
-                </a:solidFill>
-                <a:latin typeface="Arial"/>
-              </a:rPr>
-              <a:t>Sensoriamento</a:t>
-            </a:r>
-            <a:r>
-              <a:rPr sz="1900" b="0" i="0" dirty="0">
-                <a:solidFill>
-                  <a:srgbClr val="5B6573"/>
-                </a:solidFill>
-                <a:latin typeface="Arial"/>
-              </a:rPr>
-              <a:t> </a:t>
-            </a:r>
-            <a:r>
-              <a:rPr sz="1900" b="0" i="0" dirty="0" err="1">
-                <a:solidFill>
-                  <a:srgbClr val="5B6573"/>
-                </a:solidFill>
-                <a:latin typeface="Arial"/>
-              </a:rPr>
-              <a:t>Remoto</a:t>
-            </a:r>
-            <a:r>
-              <a:rPr sz="1900" b="0" i="0" dirty="0">
-                <a:solidFill>
-                  <a:srgbClr val="5B6573"/>
-                </a:solidFill>
-                <a:latin typeface="Arial"/>
-              </a:rPr>
-              <a:t> e </a:t>
-            </a:r>
-            <a:r>
-              <a:rPr sz="1900" b="0" i="0" dirty="0" err="1">
-                <a:solidFill>
-                  <a:srgbClr val="5B6573"/>
-                </a:solidFill>
-                <a:latin typeface="Arial"/>
-              </a:rPr>
-              <a:t>Meteorologia</a:t>
-            </a:r>
-            <a:r>
-              <a:rPr sz="1900" b="0" i="0" dirty="0">
-                <a:solidFill>
-                  <a:srgbClr val="5B6573"/>
-                </a:solidFill>
-                <a:latin typeface="Arial"/>
-              </a:rPr>
-              <a:t> (CEPSRM)  ·  julianacarolinoreis@gmail.com</a:t>
             </a:r>
           </a:p>
         </p:txBody>
@@ -3970,8 +3862,8 @@
         </p:nvSpPr>
         <p:spPr>
           <a:xfrm>
-            <a:off x="1080000" y="9206844"/>
-            <a:ext cx="9360000" cy="2585323"/>
+            <a:off x="1080000" y="9357880"/>
+            <a:ext cx="10306961" cy="2490875"/>
           </a:xfrm>
           <a:prstGeom prst="rect">
             <a:avLst/>
@@ -3984,97 +3876,188 @@
           </a:bodyPr>
           <a:lstStyle/>
           <a:p>
-            <a:pPr algn="l">
+            <a:pPr marL="0" marR="0" lvl="0" indent="0" algn="just" defTabSz="914400" rtl="0" eaLnBrk="1" fontAlgn="auto" latinLnBrk="0" hangingPunct="1">
+              <a:lnSpc>
+                <a:spcPct val="114000"/>
+              </a:lnSpc>
+              <a:spcBef>
+                <a:spcPts val="0"/>
+              </a:spcBef>
               <a:spcAft>
                 <a:spcPts val="600"/>
               </a:spcAft>
+              <a:buClrTx/>
+              <a:buSzTx/>
+              <a:buFontTx/>
+              <a:buNone/>
+              <a:tabLst/>
+              <a:defRPr/>
             </a:pPr>
             <a:r>
-              <a:rPr sz="2400" b="0" i="0">
-                <a:solidFill>
-                  <a:srgbClr val="1F2633"/>
-                </a:solidFill>
-                <a:latin typeface="Arial"/>
+              <a:rPr kumimoji="0" lang="pt-BR" sz="2400" b="0" i="0" u="none" strike="noStrike" kern="1200" cap="none" spc="0" normalizeH="0" baseline="0" noProof="0" dirty="0">
+                <a:ln>
+                  <a:noFill/>
+                </a:ln>
+                <a:solidFill>
+                  <a:srgbClr val="1F2633"/>
+                </a:solidFill>
+                <a:effectLst/>
+                <a:uLnTx/>
+                <a:uFillTx/>
+                <a:latin typeface="Arial"/>
+                <a:ea typeface="+mn-ea"/>
+                <a:cs typeface="+mn-cs"/>
               </a:rPr>
               <a:t>As cheias de 2023 e 2024 na bacia do Taquari-Antas mostraram a necessidade de previsões de nível com antecedência útil para o alerta. Este trabalho aplica </a:t>
             </a:r>
             <a:r>
-              <a:rPr sz="2400" b="1" i="0">
-                <a:solidFill>
-                  <a:srgbClr val="1F2633"/>
-                </a:solidFill>
-                <a:latin typeface="Arial"/>
+              <a:rPr kumimoji="0" lang="pt-BR" sz="2400" b="1" i="0" u="none" strike="noStrike" kern="1200" cap="none" spc="0" normalizeH="0" baseline="0" noProof="0" dirty="0">
+                <a:ln>
+                  <a:noFill/>
+                </a:ln>
+                <a:solidFill>
+                  <a:srgbClr val="1F2633"/>
+                </a:solidFill>
+                <a:effectLst/>
+                <a:uLnTx/>
+                <a:uFillTx/>
+                <a:latin typeface="Arial"/>
+                <a:ea typeface="+mn-ea"/>
+                <a:cs typeface="+mn-cs"/>
               </a:rPr>
               <a:t>Redes Neurais Artificiais</a:t>
             </a:r>
             <a:r>
-              <a:rPr sz="2400" b="0" i="0">
-                <a:solidFill>
-                  <a:srgbClr val="1F2633"/>
-                </a:solidFill>
-                <a:latin typeface="Arial"/>
-              </a:rPr>
-              <a:t> do tipo Perceptron Multicamadas (MLP) para prever o nível do rio Taquari em </a:t>
-            </a:r>
-            <a:r>
-              <a:rPr sz="2400" b="1" i="0">
-                <a:solidFill>
-                  <a:srgbClr val="1F2633"/>
-                </a:solidFill>
-                <a:latin typeface="Arial"/>
+              <a:rPr kumimoji="0" lang="pt-BR" sz="2400" b="0" i="0" u="none" strike="noStrike" kern="1200" cap="none" spc="0" normalizeH="0" baseline="0" noProof="0" dirty="0">
+                <a:ln>
+                  <a:noFill/>
+                </a:ln>
+                <a:solidFill>
+                  <a:srgbClr val="1F2633"/>
+                </a:solidFill>
+                <a:effectLst/>
+                <a:uLnTx/>
+                <a:uFillTx/>
+                <a:latin typeface="Arial"/>
+                <a:ea typeface="+mn-ea"/>
+                <a:cs typeface="+mn-cs"/>
+              </a:rPr>
+              <a:t> do tipo </a:t>
+            </a:r>
+            <a:r>
+              <a:rPr kumimoji="0" lang="pt-BR" sz="2400" b="0" i="0" u="none" strike="noStrike" kern="1200" cap="none" spc="0" normalizeH="0" baseline="0" noProof="0" dirty="0" err="1">
+                <a:ln>
+                  <a:noFill/>
+                </a:ln>
+                <a:solidFill>
+                  <a:srgbClr val="1F2633"/>
+                </a:solidFill>
+                <a:effectLst/>
+                <a:uLnTx/>
+                <a:uFillTx/>
+                <a:latin typeface="Arial"/>
+                <a:ea typeface="+mn-ea"/>
+                <a:cs typeface="+mn-cs"/>
+              </a:rPr>
+              <a:t>Perceptron</a:t>
+            </a:r>
+            <a:r>
+              <a:rPr kumimoji="0" lang="pt-BR" sz="2400" b="0" i="0" u="none" strike="noStrike" kern="1200" cap="none" spc="0" normalizeH="0" baseline="0" noProof="0" dirty="0">
+                <a:ln>
+                  <a:noFill/>
+                </a:ln>
+                <a:solidFill>
+                  <a:srgbClr val="1F2633"/>
+                </a:solidFill>
+                <a:effectLst/>
+                <a:uLnTx/>
+                <a:uFillTx/>
+                <a:latin typeface="Arial"/>
+                <a:ea typeface="+mn-ea"/>
+                <a:cs typeface="+mn-cs"/>
+              </a:rPr>
+              <a:t> Multicamadas (MLP) para prever o nível do rio Taquari em </a:t>
+            </a:r>
+            <a:r>
+              <a:rPr kumimoji="0" lang="pt-BR" sz="2400" b="1" i="0" u="none" strike="noStrike" kern="1200" cap="none" spc="0" normalizeH="0" baseline="0" noProof="0" dirty="0">
+                <a:ln>
+                  <a:noFill/>
+                </a:ln>
+                <a:solidFill>
+                  <a:srgbClr val="1F2633"/>
+                </a:solidFill>
+                <a:effectLst/>
+                <a:uLnTx/>
+                <a:uFillTx/>
+                <a:latin typeface="Arial"/>
+                <a:ea typeface="+mn-ea"/>
+                <a:cs typeface="+mn-cs"/>
               </a:rPr>
               <a:t>Santa Tereza</a:t>
             </a:r>
             <a:r>
-              <a:rPr sz="2400" b="0" i="0">
-                <a:solidFill>
-                  <a:srgbClr val="1F2633"/>
-                </a:solidFill>
-                <a:latin typeface="Arial"/>
+              <a:rPr kumimoji="0" lang="pt-BR" sz="2400" b="0" i="0" u="none" strike="noStrike" kern="1200" cap="none" spc="0" normalizeH="0" baseline="0" noProof="0" dirty="0">
+                <a:ln>
+                  <a:noFill/>
+                </a:ln>
+                <a:solidFill>
+                  <a:srgbClr val="1F2633"/>
+                </a:solidFill>
+                <a:effectLst/>
+                <a:uLnTx/>
+                <a:uFillTx/>
+                <a:latin typeface="Arial"/>
+                <a:ea typeface="+mn-ea"/>
+                <a:cs typeface="+mn-cs"/>
               </a:rPr>
               <a:t> com </a:t>
             </a:r>
             <a:r>
-              <a:rPr sz="2400" b="1" i="0">
-                <a:solidFill>
-                  <a:srgbClr val="1F2633"/>
-                </a:solidFill>
-                <a:latin typeface="Arial"/>
+              <a:rPr kumimoji="0" lang="pt-BR" sz="2400" b="1" i="0" u="none" strike="noStrike" kern="1200" cap="none" spc="0" normalizeH="0" baseline="0" noProof="0" dirty="0">
+                <a:ln>
+                  <a:noFill/>
+                </a:ln>
+                <a:solidFill>
+                  <a:srgbClr val="1F2633"/>
+                </a:solidFill>
+                <a:effectLst/>
+                <a:uLnTx/>
+                <a:uFillTx/>
+                <a:latin typeface="Arial"/>
+                <a:ea typeface="+mn-ea"/>
+                <a:cs typeface="+mn-cs"/>
               </a:rPr>
               <a:t>2, 4 e 8 horas</a:t>
             </a:r>
             <a:r>
-              <a:rPr sz="2400" b="0" i="0">
-                <a:solidFill>
-                  <a:srgbClr val="1F2633"/>
-                </a:solidFill>
-                <a:latin typeface="Arial"/>
-              </a:rPr>
-              <a:t> de antecedência, na </a:t>
-            </a:r>
-            <a:r>
-              <a:rPr sz="2400" b="1" i="0">
-                <a:solidFill>
-                  <a:srgbClr val="D9661F"/>
-                </a:solidFill>
-                <a:latin typeface="Arial"/>
-              </a:rPr>
-              <a:t>abordagem alternativa (ALT)</a:t>
-            </a:r>
-            <a:r>
-              <a:rPr sz="2400" b="0" i="0">
-                <a:solidFill>
-                  <a:srgbClr val="1F2633"/>
-                </a:solidFill>
-                <a:latin typeface="Arial"/>
-              </a:rPr>
-              <a:t>: a RNA tem como variável dependente a diferença de nível no horizonte de previsão.</a:t>
-            </a:r>
-            <a:endParaRPr sz="2400" b="0" i="0" dirty="0">
+              <a:rPr kumimoji="0" lang="pt-BR" sz="2400" b="0" i="0" u="none" strike="noStrike" kern="1200" cap="none" spc="0" normalizeH="0" baseline="0" noProof="0" dirty="0">
+                <a:ln>
+                  <a:noFill/>
+                </a:ln>
+                <a:solidFill>
+                  <a:srgbClr val="1F2633"/>
+                </a:solidFill>
+                <a:effectLst/>
+                <a:uLnTx/>
+                <a:uFillTx/>
+                <a:latin typeface="Arial"/>
+                <a:ea typeface="+mn-ea"/>
+                <a:cs typeface="+mn-cs"/>
+              </a:rPr>
+              <a:t> de antecedência. A rede neural tem como variável dependente a diferença de nível entre o nível atual e o horizonte de previsão.</a:t>
+            </a:r>
+            <a:endParaRPr kumimoji="0" lang="pt-BR" sz="2400" b="0" i="0" u="none" strike="noStrike" kern="1200" cap="none" spc="0" normalizeH="0" baseline="0" noProof="0" dirty="0">
+              <a:ln>
+                <a:noFill/>
+              </a:ln>
               <a:solidFill>
                 <a:srgbClr val="1F2633"/>
               </a:solidFill>
+              <a:effectLst/>
+              <a:uLnTx/>
+              <a:uFillTx/>
               <a:latin typeface="Arial" panose="020B0604020202020204" pitchFamily="34" charset="0"/>
+              <a:ea typeface="+mn-ea"/>
               <a:cs typeface="Arial" panose="020B0604020202020204" pitchFamily="34" charset="0"/>
             </a:endParaRPr>
           </a:p>
@@ -4144,7 +4127,7 @@
         <p:spPr>
           <a:xfrm>
             <a:off x="1080000" y="13032000"/>
-            <a:ext cx="9360000" cy="1872000"/>
+            <a:ext cx="9360000" cy="2223750"/>
           </a:xfrm>
           <a:prstGeom prst="rect">
             <a:avLst/>
@@ -4157,9 +4140,9 @@
           </a:bodyPr>
           <a:lstStyle/>
           <a:p>
-            <a:pPr marL="252000" indent="-252000" algn="l">
+            <a:pPr marL="252000" indent="-252000" algn="just">
               <a:lnSpc>
-                <a:spcPct val="108000"/>
+                <a:spcPct val="114000"/>
               </a:lnSpc>
               <a:spcAft>
                 <a:spcPts val="600"/>
@@ -4171,73 +4154,19 @@
               <a:buChar char="■"/>
             </a:pPr>
             <a:r>
-              <a:rPr sz="2400" b="0" i="0" dirty="0">
-                <a:solidFill>
-                  <a:srgbClr val="1F2633"/>
-                </a:solidFill>
-                <a:latin typeface="Arial"/>
-              </a:rPr>
-              <a:t>Bacia do </a:t>
-            </a:r>
-            <a:r>
-              <a:rPr sz="2400" b="0" i="0" dirty="0" err="1">
-                <a:solidFill>
-                  <a:srgbClr val="1F2633"/>
-                </a:solidFill>
-                <a:latin typeface="Arial"/>
-              </a:rPr>
-              <a:t>rio</a:t>
-            </a:r>
-            <a:r>
-              <a:rPr sz="2400" b="0" i="0" dirty="0">
-                <a:solidFill>
-                  <a:srgbClr val="1F2633"/>
-                </a:solidFill>
-                <a:latin typeface="Arial"/>
-              </a:rPr>
-              <a:t> Taquari </a:t>
-            </a:r>
-            <a:r>
-              <a:rPr sz="2400" b="0" i="0" dirty="0" err="1">
-                <a:solidFill>
-                  <a:srgbClr val="1F2633"/>
-                </a:solidFill>
-                <a:latin typeface="Arial"/>
-              </a:rPr>
-              <a:t>até</a:t>
-            </a:r>
-            <a:r>
-              <a:rPr sz="2400" b="0" i="0" dirty="0">
-                <a:solidFill>
-                  <a:srgbClr val="1F2633"/>
-                </a:solidFill>
-                <a:latin typeface="Arial"/>
-              </a:rPr>
-              <a:t> a </a:t>
-            </a:r>
-            <a:r>
-              <a:rPr sz="2400" b="0" i="0" dirty="0" err="1">
-                <a:solidFill>
-                  <a:srgbClr val="1F2633"/>
-                </a:solidFill>
-                <a:latin typeface="Arial"/>
-              </a:rPr>
-              <a:t>estação</a:t>
-            </a:r>
-            <a:r>
-              <a:rPr sz="2400" b="0" i="0" dirty="0">
-                <a:solidFill>
-                  <a:srgbClr val="1F2633"/>
-                </a:solidFill>
-                <a:latin typeface="Arial"/>
-              </a:rPr>
-              <a:t> 86472600 (≈15.800 km²)</a:t>
-            </a:r>
-          </a:p>
-          <a:p>
-            <a:pPr marL="252000" indent="-252000" algn="l">
+              <a:rPr lang="pt-BR" sz="2400" dirty="0">
+                <a:solidFill>
+                  <a:srgbClr val="1F2633"/>
+                </a:solidFill>
+                <a:latin typeface="Arial"/>
+              </a:rPr>
+              <a:t>Bacia do Rio Taquari até a estação 86472600 (≈15.800 km²);</a:t>
+            </a:r>
+          </a:p>
+          <a:p>
+            <a:pPr marL="252000" indent="-252000" algn="just">
               <a:lnSpc>
-                <a:spcPct val="108000"/>
+                <a:spcPct val="114000"/>
               </a:lnSpc>
               <a:spcAft>
                 <a:spcPts val="600"/>
@@ -4249,70 +4178,16 @@
               <a:buChar char="■"/>
             </a:pPr>
             <a:r>
-              <a:rPr sz="2400" b="0" i="0" dirty="0">
-                <a:solidFill>
-                  <a:srgbClr val="1F2633"/>
-                </a:solidFill>
-                <a:latin typeface="Arial"/>
-              </a:rPr>
-              <a:t>Dados </a:t>
-            </a:r>
-            <a:r>
-              <a:rPr sz="2400" b="0" i="0" dirty="0" err="1">
-                <a:solidFill>
-                  <a:srgbClr val="1F2633"/>
-                </a:solidFill>
-                <a:latin typeface="Arial"/>
-              </a:rPr>
-              <a:t>horários</a:t>
-            </a:r>
-            <a:r>
-              <a:rPr sz="2400" b="0" i="0" dirty="0">
-                <a:solidFill>
-                  <a:srgbClr val="1F2633"/>
-                </a:solidFill>
-                <a:latin typeface="Arial"/>
-              </a:rPr>
-              <a:t> de </a:t>
-            </a:r>
-            <a:r>
-              <a:rPr sz="2400" b="0" i="0" dirty="0" err="1">
-                <a:solidFill>
-                  <a:srgbClr val="1F2633"/>
-                </a:solidFill>
-                <a:latin typeface="Arial"/>
-              </a:rPr>
-              <a:t>nível</a:t>
-            </a:r>
-            <a:r>
-              <a:rPr sz="2400" b="0" i="0" dirty="0">
-                <a:solidFill>
-                  <a:srgbClr val="1F2633"/>
-                </a:solidFill>
-                <a:latin typeface="Arial"/>
-              </a:rPr>
-              <a:t> e </a:t>
-            </a:r>
-            <a:r>
-              <a:rPr sz="2400" b="0" i="0" dirty="0" err="1">
-                <a:solidFill>
-                  <a:srgbClr val="1F2633"/>
-                </a:solidFill>
-                <a:latin typeface="Arial"/>
-              </a:rPr>
-              <a:t>chuva</a:t>
-            </a:r>
-            <a:r>
-              <a:rPr sz="2400" b="0" i="0" dirty="0">
-                <a:solidFill>
-                  <a:srgbClr val="1F2633"/>
-                </a:solidFill>
-                <a:latin typeface="Arial"/>
-              </a:rPr>
-              <a:t> (2022–2025) do portal </a:t>
-            </a:r>
-            <a:r>
-              <a:rPr sz="2400" b="0" i="0" dirty="0" err="1">
+              <a:rPr lang="pt-BR" sz="2400" dirty="0">
+                <a:solidFill>
+                  <a:srgbClr val="1F2633"/>
+                </a:solidFill>
+                <a:latin typeface="Arial"/>
+              </a:rPr>
+              <a:t>Dados horários de nível e chuva (2022–2026) do portal </a:t>
+            </a:r>
+            <a:r>
+              <a:rPr lang="pt-BR" sz="2400" dirty="0" err="1">
                 <a:solidFill>
                   <a:srgbClr val="1F2633"/>
                 </a:solidFill>
@@ -4321,19 +4196,19 @@
               <a:t>HidroTelemetria</a:t>
             </a:r>
             <a:r>
-              <a:rPr sz="2400" b="0" i="0" dirty="0">
-                <a:solidFill>
-                  <a:srgbClr val="1F2633"/>
-                </a:solidFill>
-                <a:latin typeface="Arial"/>
-              </a:rPr>
-              <a:t> (ANA/SGB)</a:t>
-            </a:r>
-          </a:p>
-          <a:p>
-            <a:pPr marL="252000" indent="-252000" algn="l">
+              <a:rPr lang="pt-BR" sz="2400" dirty="0">
+                <a:solidFill>
+                  <a:srgbClr val="1F2633"/>
+                </a:solidFill>
+                <a:latin typeface="Arial"/>
+              </a:rPr>
+              <a:t> (ANA);</a:t>
+            </a:r>
+          </a:p>
+          <a:p>
+            <a:pPr marL="252000" indent="-252000" algn="just">
               <a:lnSpc>
-                <a:spcPct val="108000"/>
+                <a:spcPct val="114000"/>
               </a:lnSpc>
               <a:spcAft>
                 <a:spcPts val="600"/>
@@ -4345,166 +4220,31 @@
               <a:buChar char="■"/>
             </a:pPr>
             <a:r>
-              <a:rPr sz="2400" b="0" i="0" dirty="0" err="1">
-                <a:solidFill>
-                  <a:srgbClr val="1F2633"/>
-                </a:solidFill>
-                <a:latin typeface="Arial"/>
-              </a:rPr>
-              <a:t>Amostras</a:t>
-            </a:r>
-            <a:r>
-              <a:rPr sz="2400" b="0" i="0" dirty="0">
-                <a:solidFill>
-                  <a:srgbClr val="1F2633"/>
-                </a:solidFill>
-                <a:latin typeface="Arial"/>
-              </a:rPr>
-              <a:t> </a:t>
-            </a:r>
-            <a:r>
-              <a:rPr sz="2400" b="0" i="0" dirty="0" err="1">
-                <a:solidFill>
-                  <a:srgbClr val="1F2633"/>
-                </a:solidFill>
-                <a:latin typeface="Arial"/>
-              </a:rPr>
-              <a:t>agrupadas</a:t>
-            </a:r>
-            <a:r>
-              <a:rPr sz="2400" b="0" i="0" dirty="0">
-                <a:solidFill>
-                  <a:srgbClr val="1F2633"/>
-                </a:solidFill>
-                <a:latin typeface="Arial"/>
-              </a:rPr>
-              <a:t> </a:t>
-            </a:r>
-            <a:r>
-              <a:rPr sz="2400" b="0" i="0" dirty="0" err="1">
-                <a:solidFill>
-                  <a:srgbClr val="1F2633"/>
-                </a:solidFill>
-                <a:latin typeface="Arial"/>
-              </a:rPr>
-              <a:t>por</a:t>
-            </a:r>
-            <a:r>
-              <a:rPr sz="2400" b="0" i="0" dirty="0">
-                <a:solidFill>
-                  <a:srgbClr val="1F2633"/>
-                </a:solidFill>
-                <a:latin typeface="Arial"/>
-              </a:rPr>
-              <a:t> </a:t>
-            </a:r>
-            <a:r>
-              <a:rPr sz="2400" b="1" i="0" dirty="0" err="1">
-                <a:solidFill>
-                  <a:srgbClr val="1F2633"/>
-                </a:solidFill>
-                <a:latin typeface="Arial"/>
-              </a:rPr>
-              <a:t>eventos</a:t>
-            </a:r>
-            <a:r>
-              <a:rPr sz="2400" b="1" i="0" dirty="0">
-                <a:solidFill>
-                  <a:srgbClr val="1F2633"/>
-                </a:solidFill>
-                <a:latin typeface="Arial"/>
-              </a:rPr>
-              <a:t> de </a:t>
-            </a:r>
-            <a:r>
-              <a:rPr sz="2400" b="1" i="0" dirty="0" err="1">
-                <a:solidFill>
-                  <a:srgbClr val="1F2633"/>
-                </a:solidFill>
-                <a:latin typeface="Arial"/>
-              </a:rPr>
-              <a:t>cheia</a:t>
-            </a:r>
-            <a:r>
-              <a:rPr sz="2400" b="0" i="0" dirty="0">
-                <a:solidFill>
-                  <a:srgbClr val="1F2633"/>
-                </a:solidFill>
-                <a:latin typeface="Arial"/>
-              </a:rPr>
-              <a:t>, </a:t>
-            </a:r>
-            <a:r>
-              <a:rPr sz="2400" b="0" i="0" dirty="0" err="1">
-                <a:solidFill>
-                  <a:srgbClr val="1F2633"/>
-                </a:solidFill>
-                <a:latin typeface="Arial"/>
-              </a:rPr>
-              <a:t>separados</a:t>
-            </a:r>
-            <a:r>
-              <a:rPr sz="2400" b="0" i="0" dirty="0">
-                <a:solidFill>
-                  <a:srgbClr val="1F2633"/>
-                </a:solidFill>
-                <a:latin typeface="Arial"/>
-              </a:rPr>
-              <a:t> </a:t>
-            </a:r>
-            <a:r>
-              <a:rPr sz="2400" b="0" i="0" dirty="0" err="1">
-                <a:solidFill>
-                  <a:srgbClr val="1F2633"/>
-                </a:solidFill>
-                <a:latin typeface="Arial"/>
-              </a:rPr>
-              <a:t>em</a:t>
-            </a:r>
-            <a:r>
-              <a:rPr sz="2400" b="0" i="0" dirty="0">
-                <a:solidFill>
-                  <a:srgbClr val="1F2633"/>
-                </a:solidFill>
-                <a:latin typeface="Arial"/>
-              </a:rPr>
-              <a:t> </a:t>
-            </a:r>
-            <a:r>
-              <a:rPr sz="2400" b="0" i="0" dirty="0" err="1">
-                <a:solidFill>
-                  <a:srgbClr val="1F2633"/>
-                </a:solidFill>
-                <a:latin typeface="Arial"/>
-              </a:rPr>
-              <a:t>treino</a:t>
-            </a:r>
-            <a:r>
-              <a:rPr sz="2400" b="0" i="0" dirty="0">
-                <a:solidFill>
-                  <a:srgbClr val="1F2633"/>
-                </a:solidFill>
-                <a:latin typeface="Arial"/>
-              </a:rPr>
-              <a:t>, </a:t>
-            </a:r>
-            <a:r>
-              <a:rPr sz="2400" b="0" i="0" dirty="0" err="1">
-                <a:solidFill>
-                  <a:srgbClr val="1F2633"/>
-                </a:solidFill>
-                <a:latin typeface="Arial"/>
-              </a:rPr>
-              <a:t>validação</a:t>
-            </a:r>
-            <a:r>
-              <a:rPr sz="2400" b="0" i="0" dirty="0">
-                <a:solidFill>
-                  <a:srgbClr val="1F2633"/>
-                </a:solidFill>
-                <a:latin typeface="Arial"/>
-              </a:rPr>
-              <a:t> e teste</a:t>
+              <a:rPr lang="pt-BR" sz="2400" dirty="0">
+                <a:solidFill>
+                  <a:srgbClr val="1F2633"/>
+                </a:solidFill>
+                <a:latin typeface="Arial"/>
+              </a:rPr>
+              <a:t>Amostras agrupadas por </a:t>
+            </a:r>
+            <a:r>
+              <a:rPr lang="pt-BR" sz="2400" b="1" dirty="0">
+                <a:solidFill>
+                  <a:srgbClr val="1F2633"/>
+                </a:solidFill>
+                <a:latin typeface="Arial"/>
+              </a:rPr>
+              <a:t>eventos de cheia</a:t>
+            </a:r>
+            <a:r>
+              <a:rPr lang="pt-BR" sz="2400" dirty="0">
+                <a:solidFill>
+                  <a:srgbClr val="1F2633"/>
+                </a:solidFill>
+                <a:latin typeface="Arial"/>
+              </a:rPr>
+              <a:t>, separados em treino, validação e teste.</a:t>
             </a:r>
           </a:p>
         </p:txBody>
@@ -4564,13 +4304,94 @@
               </a:spcAft>
             </a:pPr>
             <a:r>
-              <a:rPr sz="1800" b="0" i="0">
+              <a:rPr sz="1800" b="0" i="0" dirty="0" err="1">
                 <a:solidFill>
                   <a:srgbClr val="5B6573"/>
                 </a:solidFill>
                 <a:latin typeface="Arial"/>
               </a:rPr>
-              <a:t>Figura 1 – Bacia do rio Taquari-Antas até Santa Tereza e postos fluviométricos.</a:t>
+              <a:t>Figura</a:t>
+            </a:r>
+            <a:r>
+              <a:rPr sz="1800" b="0" i="0" dirty="0">
+                <a:solidFill>
+                  <a:srgbClr val="5B6573"/>
+                </a:solidFill>
+                <a:latin typeface="Arial"/>
+              </a:rPr>
+              <a:t> 1 – Bacia do </a:t>
+            </a:r>
+            <a:r>
+              <a:rPr lang="pt-BR" sz="1800" b="0" i="0" dirty="0">
+                <a:solidFill>
+                  <a:srgbClr val="5B6573"/>
+                </a:solidFill>
+                <a:latin typeface="Arial"/>
+              </a:rPr>
+              <a:t>R</a:t>
+            </a:r>
+            <a:r>
+              <a:rPr sz="1800" b="0" i="0" dirty="0">
+                <a:solidFill>
+                  <a:srgbClr val="5B6573"/>
+                </a:solidFill>
+                <a:latin typeface="Arial"/>
+              </a:rPr>
+              <a:t>io Taquari-Antas </a:t>
+            </a:r>
+            <a:r>
+              <a:rPr sz="1800" b="0" i="0" dirty="0" err="1">
+                <a:solidFill>
+                  <a:srgbClr val="5B6573"/>
+                </a:solidFill>
+                <a:latin typeface="Arial"/>
+              </a:rPr>
+              <a:t>até</a:t>
+            </a:r>
+            <a:r>
+              <a:rPr sz="1800" b="0" i="0" dirty="0">
+                <a:solidFill>
+                  <a:srgbClr val="5B6573"/>
+                </a:solidFill>
+                <a:latin typeface="Arial"/>
+              </a:rPr>
+              <a:t> Santa Tereza e </a:t>
+            </a:r>
+            <a:r>
+              <a:rPr sz="1800" b="0" i="0" dirty="0" err="1">
+                <a:solidFill>
+                  <a:srgbClr val="5B6573"/>
+                </a:solidFill>
+                <a:latin typeface="Arial"/>
+              </a:rPr>
+              <a:t>postos</a:t>
+            </a:r>
+            <a:r>
+              <a:rPr sz="1800" b="0" i="0" dirty="0">
+                <a:solidFill>
+                  <a:srgbClr val="5B6573"/>
+                </a:solidFill>
+                <a:latin typeface="Arial"/>
+              </a:rPr>
+              <a:t> </a:t>
+            </a:r>
+            <a:r>
+              <a:rPr sz="1800" b="0" i="0" dirty="0" err="1">
+                <a:solidFill>
+                  <a:srgbClr val="5B6573"/>
+                </a:solidFill>
+                <a:latin typeface="Arial"/>
+              </a:rPr>
+              <a:t>fluviométricos</a:t>
+            </a:r>
+            <a:r>
+              <a:rPr sz="1800" b="0" i="0" dirty="0">
+                <a:solidFill>
+                  <a:srgbClr val="5B6573"/>
+                </a:solidFill>
+                <a:latin typeface="Arial"/>
+              </a:rPr>
+              <a:t>.</a:t>
             </a:r>
           </a:p>
         </p:txBody>
@@ -4625,7 +4446,7 @@
                 </a:solidFill>
                 <a:latin typeface="Arial"/>
               </a:rPr>
-              <a:t>METODOLOGIA: ABORDAGEM ALTERNATIVA (ALT)</a:t>
+              <a:t>METODOLOGIA</a:t>
             </a:r>
           </a:p>
         </p:txBody>
@@ -4674,7 +4495,7 @@
           <a:p>
             <a:pPr algn="ctr"/>
             <a:r>
-              <a:rPr sz="2400" b="1" i="0">
+              <a:rPr sz="2400" b="1" i="0" dirty="0">
                 <a:solidFill>
                   <a:srgbClr val="D9661F"/>
                 </a:solidFill>
@@ -4684,15 +4505,19 @@
             </a:r>
           </a:p>
           <a:p>
-            <a:pPr algn="ctr"/>
-            <a:r>
-              <a:rPr sz="1800" b="0" i="0">
-                <a:solidFill>
-                  <a:srgbClr val="1F2633"/>
-                </a:solidFill>
-                <a:latin typeface="Arial"/>
-              </a:rPr>
-              <a:t>níveis, diferenças e acelerações em Santa Tereza e a montante; chuva acumulada</a:t>
+            <a:pPr algn="ctr">
+              <a:lnSpc>
+                <a:spcPct val="114000"/>
+              </a:lnSpc>
+            </a:pPr>
+            <a:r>
+              <a:rPr lang="pt-BR" dirty="0">
+                <a:solidFill>
+                  <a:srgbClr val="1F2633"/>
+                </a:solidFill>
+                <a:latin typeface="Arial"/>
+              </a:rPr>
+              <a:t>Nível absoluto e diferenças de nível em Santa Tereza e a montante; chuva acumulada</a:t>
             </a:r>
           </a:p>
         </p:txBody>
@@ -4786,7 +4611,7 @@
           <a:p>
             <a:pPr algn="ctr"/>
             <a:r>
-              <a:rPr sz="2400" b="1" i="0">
+              <a:rPr sz="2400" b="1" i="0" dirty="0">
                 <a:solidFill>
                   <a:srgbClr val="D9661F"/>
                 </a:solidFill>
@@ -4796,16 +4621,125 @@
             </a:r>
           </a:p>
           <a:p>
-            <a:pPr algn="ctr"/>
-            <a:r>
-              <a:rPr sz="1800" b="0" i="0">
-                <a:solidFill>
-                  <a:srgbClr val="1F2633"/>
-                </a:solidFill>
-                <a:latin typeface="Arial"/>
-              </a:rPr>
-              <a:t>1 camada oculta · sigmoide · retropropagação com gradiente adaptativo</a:t>
-            </a:r>
+            <a:pPr algn="ctr">
+              <a:lnSpc>
+                <a:spcPct val="114000"/>
+              </a:lnSpc>
+            </a:pPr>
+            <a:r>
+              <a:rPr sz="1800" b="0" i="0" dirty="0">
+                <a:solidFill>
+                  <a:srgbClr val="1F2633"/>
+                </a:solidFill>
+                <a:latin typeface="Arial"/>
+              </a:rPr>
+              <a:t>1 </a:t>
+            </a:r>
+            <a:r>
+              <a:rPr sz="1800" b="0" i="0" dirty="0" err="1">
+                <a:solidFill>
+                  <a:srgbClr val="1F2633"/>
+                </a:solidFill>
+                <a:latin typeface="Arial"/>
+              </a:rPr>
+              <a:t>camada</a:t>
+            </a:r>
+            <a:r>
+              <a:rPr sz="1800" b="0" i="0" dirty="0">
+                <a:solidFill>
+                  <a:srgbClr val="1F2633"/>
+                </a:solidFill>
+                <a:latin typeface="Arial"/>
+              </a:rPr>
+              <a:t> </a:t>
+            </a:r>
+            <a:r>
+              <a:rPr sz="1800" b="0" i="0" dirty="0" err="1">
+                <a:solidFill>
+                  <a:srgbClr val="1F2633"/>
+                </a:solidFill>
+                <a:latin typeface="Arial"/>
+              </a:rPr>
+              <a:t>oculta</a:t>
+            </a:r>
+            <a:r>
+              <a:rPr sz="1800" b="0" i="0" dirty="0">
+                <a:solidFill>
+                  <a:srgbClr val="1F2633"/>
+                </a:solidFill>
+                <a:latin typeface="Arial"/>
+              </a:rPr>
+              <a:t> · </a:t>
+            </a:r>
+            <a:r>
+              <a:rPr sz="1800" b="0" i="0" dirty="0" err="1">
+                <a:solidFill>
+                  <a:srgbClr val="1F2633"/>
+                </a:solidFill>
+                <a:latin typeface="Arial"/>
+              </a:rPr>
+              <a:t>sigmoide</a:t>
+            </a:r>
+            <a:r>
+              <a:rPr sz="1800" b="0" i="0" dirty="0">
+                <a:solidFill>
+                  <a:srgbClr val="1F2633"/>
+                </a:solidFill>
+                <a:latin typeface="Arial"/>
+              </a:rPr>
+              <a:t> · </a:t>
+            </a:r>
+            <a:r>
+              <a:rPr sz="1800" b="0" i="0" dirty="0" err="1">
+                <a:solidFill>
+                  <a:srgbClr val="1F2633"/>
+                </a:solidFill>
+                <a:latin typeface="Arial"/>
+              </a:rPr>
+              <a:t>retropropagação</a:t>
+            </a:r>
+            <a:r>
+              <a:rPr sz="1800" b="0" i="0" dirty="0">
+                <a:solidFill>
+                  <a:srgbClr val="1F2633"/>
+                </a:solidFill>
+                <a:latin typeface="Arial"/>
+              </a:rPr>
+              <a:t> com </a:t>
+            </a:r>
+            <a:r>
+              <a:rPr sz="1800" b="0" i="0" dirty="0" err="1">
+                <a:solidFill>
+                  <a:srgbClr val="1F2633"/>
+                </a:solidFill>
+                <a:latin typeface="Arial"/>
+              </a:rPr>
+              <a:t>gradiente</a:t>
+            </a:r>
+            <a:r>
+              <a:rPr sz="1800" b="0" i="0" dirty="0">
+                <a:solidFill>
+                  <a:srgbClr val="1F2633"/>
+                </a:solidFill>
+                <a:latin typeface="Arial"/>
+              </a:rPr>
+              <a:t> </a:t>
+            </a:r>
+            <a:r>
+              <a:rPr sz="1800" b="0" i="0" dirty="0" err="1">
+                <a:solidFill>
+                  <a:srgbClr val="1F2633"/>
+                </a:solidFill>
+                <a:latin typeface="Arial"/>
+              </a:rPr>
+              <a:t>adaptativo</a:t>
+            </a:r>
+            <a:endParaRPr sz="1800" b="0" i="0" dirty="0">
+              <a:solidFill>
+                <a:srgbClr val="1F2633"/>
+              </a:solidFill>
+              <a:latin typeface="Arial"/>
+            </a:endParaRPr>
           </a:p>
         </p:txBody>
       </p:sp>
@@ -4898,25 +4832,79 @@
           <a:p>
             <a:pPr algn="ctr"/>
             <a:r>
-              <a:rPr sz="2400" b="1" i="0">
+              <a:rPr sz="2400" b="1" i="0" dirty="0" err="1">
                 <a:solidFill>
                   <a:srgbClr val="D9661F"/>
                 </a:solidFill>
                 <a:latin typeface="Arial"/>
               </a:rPr>
-              <a:t>Saída da RNA</a:t>
+              <a:t>Saída</a:t>
+            </a:r>
+            <a:r>
+              <a:rPr sz="2400" b="1" i="0" dirty="0">
+                <a:solidFill>
+                  <a:srgbClr val="D9661F"/>
+                </a:solidFill>
+                <a:latin typeface="Arial"/>
+              </a:rPr>
+              <a:t> da RNA</a:t>
             </a:r>
           </a:p>
           <a:p>
             <a:pPr algn="ctr"/>
             <a:r>
-              <a:rPr sz="1800" b="0" i="0">
-                <a:solidFill>
-                  <a:srgbClr val="1F2633"/>
-                </a:solidFill>
-                <a:latin typeface="Arial"/>
-              </a:rPr>
-              <a:t>variação do nível ΔH = H(t+h) − H(t)</a:t>
+              <a:rPr sz="1800" b="0" i="0" dirty="0" err="1">
+                <a:solidFill>
+                  <a:srgbClr val="1F2633"/>
+                </a:solidFill>
+                <a:latin typeface="Arial"/>
+              </a:rPr>
+              <a:t>variação</a:t>
+            </a:r>
+            <a:r>
+              <a:rPr sz="1800" b="0" i="0" dirty="0">
+                <a:solidFill>
+                  <a:srgbClr val="1F2633"/>
+                </a:solidFill>
+                <a:latin typeface="Arial"/>
+              </a:rPr>
+              <a:t> do </a:t>
+            </a:r>
+            <a:r>
+              <a:rPr sz="1800" b="0" i="0" dirty="0" err="1">
+                <a:solidFill>
+                  <a:srgbClr val="1F2633"/>
+                </a:solidFill>
+                <a:latin typeface="Arial"/>
+              </a:rPr>
+              <a:t>nível</a:t>
+            </a:r>
+            <a:r>
+              <a:rPr sz="1800" b="0" i="0" dirty="0">
+                <a:solidFill>
+                  <a:srgbClr val="1F2633"/>
+                </a:solidFill>
+                <a:latin typeface="Arial"/>
+              </a:rPr>
+              <a:t> ΔH = H(</a:t>
+            </a:r>
+            <a:r>
+              <a:rPr sz="1800" b="0" i="0" dirty="0" err="1">
+                <a:solidFill>
+                  <a:srgbClr val="1F2633"/>
+                </a:solidFill>
+                <a:latin typeface="Arial"/>
+              </a:rPr>
+              <a:t>t+h</a:t>
+            </a:r>
+            <a:r>
+              <a:rPr sz="1800" b="0" i="0" dirty="0">
+                <a:solidFill>
+                  <a:srgbClr val="1F2633"/>
+                </a:solidFill>
+                <a:latin typeface="Arial"/>
+              </a:rPr>
+              <a:t>) − H(t)</a:t>
             </a:r>
           </a:p>
         </p:txBody>
@@ -5042,7 +5030,7 @@
         <p:spPr>
           <a:xfrm>
             <a:off x="1080000" y="18036000"/>
-            <a:ext cx="9360000" cy="2232000"/>
+            <a:ext cx="9360000" cy="1827616"/>
           </a:xfrm>
           <a:prstGeom prst="rect">
             <a:avLst/>
@@ -5055,9 +5043,9 @@
           </a:bodyPr>
           <a:lstStyle/>
           <a:p>
-            <a:pPr marL="252000" indent="-252000" algn="l">
+            <a:pPr marL="252000" indent="-252000" algn="just">
               <a:lnSpc>
-                <a:spcPct val="108000"/>
+                <a:spcPct val="114000"/>
               </a:lnSpc>
               <a:spcAft>
                 <a:spcPts val="400"/>
@@ -5069,19 +5057,82 @@
               <a:buChar char="■"/>
             </a:pPr>
             <a:r>
-              <a:rPr sz="2000" b="0" i="0">
-                <a:solidFill>
-                  <a:srgbClr val="1F2633"/>
-                </a:solidFill>
-                <a:latin typeface="Arial"/>
-              </a:rPr>
-              <a:t>Neurônios ocultos ≈ 2 × nº de entradas; 10 inicializações por rede</a:t>
-            </a:r>
-          </a:p>
-          <a:p>
-            <a:pPr marL="252000" indent="-252000" algn="l">
+              <a:rPr sz="2000" b="0" i="0" dirty="0" err="1">
+                <a:solidFill>
+                  <a:srgbClr val="1F2633"/>
+                </a:solidFill>
+                <a:latin typeface="Arial"/>
+              </a:rPr>
+              <a:t>Neurônios</a:t>
+            </a:r>
+            <a:r>
+              <a:rPr sz="2000" b="0" i="0" dirty="0">
+                <a:solidFill>
+                  <a:srgbClr val="1F2633"/>
+                </a:solidFill>
+                <a:latin typeface="Arial"/>
+              </a:rPr>
+              <a:t> </a:t>
+            </a:r>
+            <a:r>
+              <a:rPr sz="2000" b="0" i="0" dirty="0" err="1">
+                <a:solidFill>
+                  <a:srgbClr val="1F2633"/>
+                </a:solidFill>
+                <a:latin typeface="Arial"/>
+              </a:rPr>
+              <a:t>ocultos</a:t>
+            </a:r>
+            <a:r>
+              <a:rPr sz="2000" b="0" i="0" dirty="0">
+                <a:solidFill>
+                  <a:srgbClr val="1F2633"/>
+                </a:solidFill>
+                <a:latin typeface="Arial"/>
+              </a:rPr>
+              <a:t> ≈ 2 × nº de entradas; 10 </a:t>
+            </a:r>
+            <a:r>
+              <a:rPr sz="2000" b="0" i="0" dirty="0" err="1">
+                <a:solidFill>
+                  <a:srgbClr val="1F2633"/>
+                </a:solidFill>
+                <a:latin typeface="Arial"/>
+              </a:rPr>
+              <a:t>inicializações</a:t>
+            </a:r>
+            <a:r>
+              <a:rPr sz="2000" b="0" i="0" dirty="0">
+                <a:solidFill>
+                  <a:srgbClr val="1F2633"/>
+                </a:solidFill>
+                <a:latin typeface="Arial"/>
+              </a:rPr>
+              <a:t> </a:t>
+            </a:r>
+            <a:r>
+              <a:rPr sz="2000" b="0" i="0" dirty="0" err="1">
+                <a:solidFill>
+                  <a:srgbClr val="1F2633"/>
+                </a:solidFill>
+                <a:latin typeface="Arial"/>
+              </a:rPr>
+              <a:t>por</a:t>
+            </a:r>
+            <a:r>
+              <a:rPr sz="2000" b="0" i="0" dirty="0">
+                <a:solidFill>
+                  <a:srgbClr val="1F2633"/>
+                </a:solidFill>
+                <a:latin typeface="Arial"/>
+              </a:rPr>
+              <a:t> rede</a:t>
+            </a:r>
+          </a:p>
+          <a:p>
+            <a:pPr marL="252000" indent="-252000" algn="just">
               <a:lnSpc>
-                <a:spcPct val="108000"/>
+                <a:spcPct val="114000"/>
               </a:lnSpc>
               <a:spcAft>
                 <a:spcPts val="400"/>
@@ -5093,19 +5144,127 @@
               <a:buChar char="■"/>
             </a:pPr>
             <a:r>
-              <a:rPr sz="2000" b="0" i="0">
-                <a:solidFill>
-                  <a:srgbClr val="1F2633"/>
-                </a:solidFill>
-                <a:latin typeface="Arial"/>
-              </a:rPr>
-              <a:t>Entradas escolhidas por algoritmo de busca em Python; redes treinadas no MATLAB</a:t>
-            </a:r>
-          </a:p>
-          <a:p>
-            <a:pPr marL="252000" indent="-252000" algn="l">
+              <a:rPr sz="2000" b="0" i="0" dirty="0">
+                <a:solidFill>
+                  <a:srgbClr val="1F2633"/>
+                </a:solidFill>
+                <a:latin typeface="Arial"/>
+              </a:rPr>
+              <a:t>Entradas </a:t>
+            </a:r>
+            <a:r>
+              <a:rPr sz="2000" b="0" i="0" dirty="0" err="1">
+                <a:solidFill>
+                  <a:srgbClr val="1F2633"/>
+                </a:solidFill>
+                <a:latin typeface="Arial"/>
+              </a:rPr>
+              <a:t>escolhidas</a:t>
+            </a:r>
+            <a:r>
+              <a:rPr sz="2000" b="0" i="0" dirty="0">
+                <a:solidFill>
+                  <a:srgbClr val="1F2633"/>
+                </a:solidFill>
+                <a:latin typeface="Arial"/>
+              </a:rPr>
+              <a:t> </a:t>
+            </a:r>
+            <a:r>
+              <a:rPr sz="2000" b="0" i="0" dirty="0" err="1">
+                <a:solidFill>
+                  <a:srgbClr val="1F2633"/>
+                </a:solidFill>
+                <a:latin typeface="Arial"/>
+              </a:rPr>
+              <a:t>por</a:t>
+            </a:r>
+            <a:r>
+              <a:rPr sz="2000" b="0" i="0" dirty="0">
+                <a:solidFill>
+                  <a:srgbClr val="1F2633"/>
+                </a:solidFill>
+                <a:latin typeface="Arial"/>
+              </a:rPr>
+              <a:t> </a:t>
+            </a:r>
+            <a:r>
+              <a:rPr sz="2000" b="0" i="0" dirty="0" err="1">
+                <a:solidFill>
+                  <a:srgbClr val="1F2633"/>
+                </a:solidFill>
+                <a:latin typeface="Arial"/>
+              </a:rPr>
+              <a:t>algoritmo</a:t>
+            </a:r>
+            <a:r>
+              <a:rPr sz="2000" b="0" i="0" dirty="0">
+                <a:solidFill>
+                  <a:srgbClr val="1F2633"/>
+                </a:solidFill>
+                <a:latin typeface="Arial"/>
+              </a:rPr>
+              <a:t> de </a:t>
+            </a:r>
+            <a:r>
+              <a:rPr sz="2000" b="0" i="0" dirty="0" err="1">
+                <a:solidFill>
+                  <a:srgbClr val="1F2633"/>
+                </a:solidFill>
+                <a:latin typeface="Arial"/>
+              </a:rPr>
+              <a:t>busca</a:t>
+            </a:r>
+            <a:r>
+              <a:rPr sz="2000" b="0" i="0" dirty="0">
+                <a:solidFill>
+                  <a:srgbClr val="1F2633"/>
+                </a:solidFill>
+                <a:latin typeface="Arial"/>
+              </a:rPr>
+              <a:t> </a:t>
+            </a:r>
+            <a:r>
+              <a:rPr sz="2000" b="0" i="0" dirty="0" err="1">
+                <a:solidFill>
+                  <a:srgbClr val="1F2633"/>
+                </a:solidFill>
+                <a:latin typeface="Arial"/>
+              </a:rPr>
+              <a:t>em</a:t>
+            </a:r>
+            <a:r>
+              <a:rPr sz="2000" b="0" i="0" dirty="0">
+                <a:solidFill>
+                  <a:srgbClr val="1F2633"/>
+                </a:solidFill>
+                <a:latin typeface="Arial"/>
+              </a:rPr>
+              <a:t> Python; redes </a:t>
+            </a:r>
+            <a:r>
+              <a:rPr sz="2000" b="0" i="0" dirty="0" err="1">
+                <a:solidFill>
+                  <a:srgbClr val="1F2633"/>
+                </a:solidFill>
+                <a:latin typeface="Arial"/>
+              </a:rPr>
+              <a:t>treinadas</a:t>
+            </a:r>
+            <a:r>
+              <a:rPr sz="2000" b="0" i="0" dirty="0">
+                <a:solidFill>
+                  <a:srgbClr val="1F2633"/>
+                </a:solidFill>
+                <a:latin typeface="Arial"/>
+              </a:rPr>
+              <a:t> no MATLAB</a:t>
+            </a:r>
+          </a:p>
+          <a:p>
+            <a:pPr marL="252000" indent="-252000" algn="just">
               <a:lnSpc>
-                <a:spcPct val="108000"/>
+                <a:spcPct val="114000"/>
               </a:lnSpc>
               <a:spcAft>
                 <a:spcPts val="400"/>
@@ -5117,13 +5276,148 @@
               <a:buChar char="■"/>
             </a:pPr>
             <a:r>
-              <a:rPr sz="2000" b="0" i="0">
-                <a:solidFill>
-                  <a:srgbClr val="1F2633"/>
-                </a:solidFill>
-                <a:latin typeface="Arial"/>
-              </a:rPr>
-              <a:t>Avaliação: NSE, PME (ganho sobre a persistência), EAM e E95 (erro não superado em 95%)</a:t>
+              <a:rPr sz="2000" b="0" i="0" dirty="0" err="1">
+                <a:solidFill>
+                  <a:srgbClr val="1F2633"/>
+                </a:solidFill>
+                <a:latin typeface="Arial"/>
+              </a:rPr>
+              <a:t>Avaliação</a:t>
+            </a:r>
+            <a:r>
+              <a:rPr sz="2000" b="0" i="0" dirty="0">
+                <a:solidFill>
+                  <a:srgbClr val="1F2633"/>
+                </a:solidFill>
+                <a:latin typeface="Arial"/>
+              </a:rPr>
+              <a:t>: NSE, PME (</a:t>
+            </a:r>
+            <a:r>
+              <a:rPr sz="2000" b="0" i="0" dirty="0" err="1">
+                <a:solidFill>
+                  <a:srgbClr val="1F2633"/>
+                </a:solidFill>
+                <a:latin typeface="Arial"/>
+              </a:rPr>
+              <a:t>ganho</a:t>
+            </a:r>
+            <a:r>
+              <a:rPr sz="2000" b="0" i="0" dirty="0">
+                <a:solidFill>
+                  <a:srgbClr val="1F2633"/>
+                </a:solidFill>
+                <a:latin typeface="Arial"/>
+              </a:rPr>
+              <a:t> </a:t>
+            </a:r>
+            <a:r>
+              <a:rPr sz="2000" b="0" i="0" dirty="0" err="1">
+                <a:solidFill>
+                  <a:srgbClr val="1F2633"/>
+                </a:solidFill>
+                <a:latin typeface="Arial"/>
+              </a:rPr>
+              <a:t>sobre</a:t>
+            </a:r>
+            <a:r>
+              <a:rPr sz="2000" b="0" i="0" dirty="0">
+                <a:solidFill>
+                  <a:srgbClr val="1F2633"/>
+                </a:solidFill>
+                <a:latin typeface="Arial"/>
+              </a:rPr>
+              <a:t> a </a:t>
+            </a:r>
+            <a:r>
+              <a:rPr sz="2000" b="0" i="0" dirty="0" err="1">
+                <a:solidFill>
+                  <a:srgbClr val="1F2633"/>
+                </a:solidFill>
+                <a:latin typeface="Arial"/>
+              </a:rPr>
+              <a:t>persistência</a:t>
+            </a:r>
+            <a:r>
+              <a:rPr sz="2000" b="0" i="0" dirty="0">
+                <a:solidFill>
+                  <a:srgbClr val="1F2633"/>
+                </a:solidFill>
+                <a:latin typeface="Arial"/>
+              </a:rPr>
+              <a:t>), EAM e E95 (</a:t>
+            </a:r>
+            <a:r>
+              <a:rPr sz="2000" b="0" i="0" dirty="0" err="1">
+                <a:solidFill>
+                  <a:srgbClr val="1F2633"/>
+                </a:solidFill>
+                <a:latin typeface="Arial"/>
+              </a:rPr>
+              <a:t>erro</a:t>
+            </a:r>
+            <a:r>
+              <a:rPr sz="2000" b="0" i="0" dirty="0">
+                <a:solidFill>
+                  <a:srgbClr val="1F2633"/>
+                </a:solidFill>
+                <a:latin typeface="Arial"/>
+              </a:rPr>
+              <a:t> </a:t>
+            </a:r>
+            <a:r>
+              <a:rPr sz="2000" b="0" i="0" dirty="0" err="1">
+                <a:solidFill>
+                  <a:srgbClr val="1F2633"/>
+                </a:solidFill>
+                <a:latin typeface="Arial"/>
+              </a:rPr>
+              <a:t>não</a:t>
+            </a:r>
+            <a:r>
+              <a:rPr sz="2000" b="0" i="0" dirty="0">
+                <a:solidFill>
+                  <a:srgbClr val="1F2633"/>
+                </a:solidFill>
+                <a:latin typeface="Arial"/>
+              </a:rPr>
+              <a:t> </a:t>
+            </a:r>
+            <a:r>
+              <a:rPr sz="2000" b="0" i="0" dirty="0" err="1">
+                <a:solidFill>
+                  <a:srgbClr val="1F2633"/>
+                </a:solidFill>
+                <a:latin typeface="Arial"/>
+              </a:rPr>
+              <a:t>superado</a:t>
+            </a:r>
+            <a:r>
+              <a:rPr sz="2000" b="0" i="0" dirty="0">
+                <a:solidFill>
+                  <a:srgbClr val="1F2633"/>
+                </a:solidFill>
+                <a:latin typeface="Arial"/>
+              </a:rPr>
+              <a:t> </a:t>
+            </a:r>
+            <a:r>
+              <a:rPr sz="2000" b="0" i="0" dirty="0" err="1">
+                <a:solidFill>
+                  <a:srgbClr val="1F2633"/>
+                </a:solidFill>
+                <a:latin typeface="Arial"/>
+              </a:rPr>
+              <a:t>em</a:t>
+            </a:r>
+            <a:r>
+              <a:rPr sz="2000" b="0" i="0" dirty="0">
+                <a:solidFill>
+                  <a:srgbClr val="1F2633"/>
+                </a:solidFill>
+                <a:latin typeface="Arial"/>
+              </a:rPr>
+              <a:t> 95%)</a:t>
             </a:r>
           </a:p>
         </p:txBody>
@@ -5137,14 +5431,14 @@
           <p:nvPr>
             <p:extLst>
               <p:ext uri="{D42A27DB-BD31-4B8C-83A1-F6EECF244321}">
-                <p14:modId xmlns:p14="http://schemas.microsoft.com/office/powerpoint/2010/main" val="3241285846"/>
+                <p14:modId xmlns:p14="http://schemas.microsoft.com/office/powerpoint/2010/main" val="1612580448"/>
               </p:ext>
             </p:extLst>
           </p:nvPr>
         </p:nvGraphicFramePr>
         <p:xfrm>
           <a:off x="10944000" y="18036000"/>
-          <a:ext cx="9360000" cy="1800000"/>
+          <a:ext cx="9360000" cy="1909680"/>
         </p:xfrm>
         <a:graphic>
           <a:graphicData uri="http://schemas.openxmlformats.org/drawingml/2006/table">
@@ -5353,7 +5647,7 @@
                 </a:tc>
                 <a:tc>
                   <a:txBody>
-                    <a:bodyPr wrap="square"/>
+                    <a:bodyPr/>
                     <a:lstStyle/>
                     <a:p>
                       <a:pPr algn="l"/>
@@ -5452,7 +5746,7 @@
                 </a:tc>
                 <a:tc>
                   <a:txBody>
-                    <a:bodyPr wrap="square"/>
+                    <a:bodyPr/>
                     <a:lstStyle/>
                     <a:p>
                       <a:pPr algn="l"/>
@@ -5557,7 +5851,7 @@
                 </a:tc>
                 <a:tc>
                   <a:txBody>
-                    <a:bodyPr wrap="square"/>
+                    <a:bodyPr/>
                     <a:lstStyle/>
                     <a:p>
                       <a:pPr algn="l"/>
@@ -5568,7 +5862,25 @@
                           </a:solidFill>
                           <a:latin typeface="Arial"/>
                         </a:rPr>
-                        <a:t>86472600, 86472000, 86125500, 86298000, 86306000, 86430900, 86448000 + chuva</a:t>
+                        <a:t>86472600, 86472000, 86125500, 86298000, 86306000, 86430900, 86448000 + </a:t>
+                      </a:r>
+                      <a:r>
+                        <a:rPr lang="pt-BR" sz="1600" b="0" i="0" dirty="0">
+                          <a:solidFill>
+                            <a:srgbClr val="1F2633"/>
+                          </a:solidFill>
+                          <a:latin typeface="Arial"/>
+                        </a:rPr>
+                        <a:t>acumulados de </a:t>
+                      </a:r>
+                      <a:r>
+                        <a:rPr sz="1600" b="0" i="0" dirty="0" err="1">
+                          <a:solidFill>
+                            <a:srgbClr val="1F2633"/>
+                          </a:solidFill>
+                          <a:latin typeface="Arial"/>
+                        </a:rPr>
+                        <a:t>chuva</a:t>
                       </a:r>
                       <a:endParaRPr sz="1900" b="0" i="0" dirty="0">
                         <a:solidFill>
@@ -5657,8 +5969,8 @@
         </p:nvSpPr>
         <p:spPr>
           <a:xfrm>
-            <a:off x="1080000" y="31538111"/>
-            <a:ext cx="9360000" cy="468000"/>
+            <a:off x="1260000" y="33021533"/>
+            <a:ext cx="9360000" cy="952312"/>
           </a:xfrm>
           <a:prstGeom prst="rect">
             <a:avLst/>
@@ -5671,7 +5983,7 @@
           </a:bodyPr>
           <a:lstStyle/>
           <a:p>
-            <a:pPr algn="l">
+            <a:pPr>
               <a:lnSpc>
                 <a:spcPct val="108000"/>
               </a:lnSpc>
@@ -5680,14 +5992,270 @@
               </a:spcAft>
             </a:pPr>
             <a:r>
-              <a:rPr sz="1800" b="0" i="0">
+              <a:rPr sz="1800" b="0" i="0" dirty="0" err="1">
                 <a:solidFill>
                   <a:srgbClr val="5B6573"/>
                 </a:solidFill>
                 <a:latin typeface="Arial"/>
               </a:rPr>
-              <a:t>Figura 2 – Nível previsto × observado (laranja = teste). *Métricas referentes ao conjunto de teste: 2h – 3 eventos out/2024–2025; 4h – cheia de jun/2025; 8h – cheia de jul/2023.</a:t>
-            </a:r>
+              <a:t>Figura</a:t>
+            </a:r>
+            <a:r>
+              <a:rPr sz="1800" b="0" i="0" dirty="0">
+                <a:solidFill>
+                  <a:srgbClr val="5B6573"/>
+                </a:solidFill>
+                <a:latin typeface="Arial"/>
+              </a:rPr>
+              <a:t> 2 – </a:t>
+            </a:r>
+            <a:r>
+              <a:rPr sz="1800" b="0" i="0" dirty="0" err="1">
+                <a:solidFill>
+                  <a:srgbClr val="5B6573"/>
+                </a:solidFill>
+                <a:latin typeface="Arial"/>
+              </a:rPr>
+              <a:t>Nível</a:t>
+            </a:r>
+            <a:r>
+              <a:rPr sz="1800" b="0" i="0" dirty="0">
+                <a:solidFill>
+                  <a:srgbClr val="5B6573"/>
+                </a:solidFill>
+                <a:latin typeface="Arial"/>
+              </a:rPr>
+              <a:t> </a:t>
+            </a:r>
+            <a:r>
+              <a:rPr sz="1800" b="0" i="0" dirty="0" err="1">
+                <a:solidFill>
+                  <a:srgbClr val="5B6573"/>
+                </a:solidFill>
+                <a:latin typeface="Arial"/>
+              </a:rPr>
+              <a:t>previsto</a:t>
+            </a:r>
+            <a:r>
+              <a:rPr sz="1800" b="0" i="0" dirty="0">
+                <a:solidFill>
+                  <a:srgbClr val="5B6573"/>
+                </a:solidFill>
+                <a:latin typeface="Arial"/>
+              </a:rPr>
+              <a:t> × </a:t>
+            </a:r>
+            <a:r>
+              <a:rPr sz="1800" b="0" i="0" dirty="0" err="1">
+                <a:solidFill>
+                  <a:srgbClr val="5B6573"/>
+                </a:solidFill>
+                <a:latin typeface="Arial"/>
+              </a:rPr>
+              <a:t>observado</a:t>
+            </a:r>
+            <a:r>
+              <a:rPr sz="1800" b="0" i="0" dirty="0">
+                <a:solidFill>
+                  <a:srgbClr val="5B6573"/>
+                </a:solidFill>
+                <a:latin typeface="Arial"/>
+              </a:rPr>
+              <a:t> (</a:t>
+            </a:r>
+            <a:r>
+              <a:rPr sz="1800" b="0" i="0" dirty="0" err="1">
+                <a:solidFill>
+                  <a:srgbClr val="5B6573"/>
+                </a:solidFill>
+                <a:latin typeface="Arial"/>
+              </a:rPr>
+              <a:t>laranja</a:t>
+            </a:r>
+            <a:r>
+              <a:rPr sz="1800" b="0" i="0" dirty="0">
+                <a:solidFill>
+                  <a:srgbClr val="5B6573"/>
+                </a:solidFill>
+                <a:latin typeface="Arial"/>
+              </a:rPr>
+              <a:t> = teste). 2h </a:t>
+            </a:r>
+            <a:r>
+              <a:rPr lang="pt-BR" dirty="0">
+                <a:solidFill>
+                  <a:srgbClr val="5B6573"/>
+                </a:solidFill>
+                <a:latin typeface="Arial"/>
+              </a:rPr>
+              <a:t>-</a:t>
+            </a:r>
+            <a:r>
+              <a:rPr sz="1800" b="0" i="0" dirty="0">
+                <a:solidFill>
+                  <a:srgbClr val="5B6573"/>
+                </a:solidFill>
+                <a:latin typeface="Arial"/>
+              </a:rPr>
+              <a:t> 3 </a:t>
+            </a:r>
+            <a:r>
+              <a:rPr sz="1800" b="0" i="0" dirty="0" err="1">
+                <a:solidFill>
+                  <a:srgbClr val="5B6573"/>
+                </a:solidFill>
+                <a:latin typeface="Arial"/>
+              </a:rPr>
+              <a:t>eventos</a:t>
+            </a:r>
+            <a:r>
+              <a:rPr sz="1800" b="0" i="0" dirty="0">
+                <a:solidFill>
+                  <a:srgbClr val="5B6573"/>
+                </a:solidFill>
+                <a:latin typeface="Arial"/>
+              </a:rPr>
+              <a:t> out/2024–2025; 4h </a:t>
+            </a:r>
+            <a:r>
+              <a:rPr lang="pt-BR" sz="1800" b="0" i="0" dirty="0">
+                <a:solidFill>
+                  <a:srgbClr val="5B6573"/>
+                </a:solidFill>
+                <a:latin typeface="Arial"/>
+              </a:rPr>
+              <a:t>-</a:t>
+            </a:r>
+            <a:r>
+              <a:rPr sz="1800" b="0" i="0" dirty="0">
+                <a:solidFill>
+                  <a:srgbClr val="5B6573"/>
+                </a:solidFill>
+                <a:latin typeface="Arial"/>
+              </a:rPr>
+              <a:t> </a:t>
+            </a:r>
+            <a:r>
+              <a:rPr sz="1800" b="0" i="0" dirty="0" err="1">
+                <a:solidFill>
+                  <a:srgbClr val="5B6573"/>
+                </a:solidFill>
+                <a:latin typeface="Arial"/>
+              </a:rPr>
+              <a:t>cheia</a:t>
+            </a:r>
+            <a:r>
+              <a:rPr sz="1800" b="0" i="0" dirty="0">
+                <a:solidFill>
+                  <a:srgbClr val="5B6573"/>
+                </a:solidFill>
+                <a:latin typeface="Arial"/>
+              </a:rPr>
+              <a:t> de </a:t>
+            </a:r>
+            <a:r>
+              <a:rPr sz="1800" b="0" i="0" dirty="0" err="1">
+                <a:solidFill>
+                  <a:srgbClr val="5B6573"/>
+                </a:solidFill>
+                <a:latin typeface="Arial"/>
+              </a:rPr>
+              <a:t>jun</a:t>
+            </a:r>
+            <a:r>
+              <a:rPr sz="1800" b="0" i="0" dirty="0">
+                <a:solidFill>
+                  <a:srgbClr val="5B6573"/>
+                </a:solidFill>
+                <a:latin typeface="Arial"/>
+              </a:rPr>
+              <a:t>/2025; 8h </a:t>
+            </a:r>
+            <a:r>
+              <a:rPr lang="pt-BR" sz="1800" b="0" i="0" dirty="0">
+                <a:solidFill>
+                  <a:srgbClr val="5B6573"/>
+                </a:solidFill>
+                <a:latin typeface="Arial"/>
+              </a:rPr>
+              <a:t>-</a:t>
+            </a:r>
+            <a:r>
+              <a:rPr sz="1800" b="0" i="0" dirty="0">
+                <a:solidFill>
+                  <a:srgbClr val="5B6573"/>
+                </a:solidFill>
+                <a:latin typeface="Arial"/>
+              </a:rPr>
+              <a:t> </a:t>
+            </a:r>
+            <a:r>
+              <a:rPr sz="1800" b="0" i="0" dirty="0" err="1">
+                <a:solidFill>
+                  <a:srgbClr val="5B6573"/>
+                </a:solidFill>
+                <a:latin typeface="Arial"/>
+              </a:rPr>
+              <a:t>cheia</a:t>
+            </a:r>
+            <a:r>
+              <a:rPr sz="1800" b="0" i="0" dirty="0">
+                <a:solidFill>
+                  <a:srgbClr val="5B6573"/>
+                </a:solidFill>
+                <a:latin typeface="Arial"/>
+              </a:rPr>
+              <a:t> de </a:t>
+            </a:r>
+            <a:r>
+              <a:rPr sz="1800" b="0" i="0" dirty="0" err="1">
+                <a:solidFill>
+                  <a:srgbClr val="5B6573"/>
+                </a:solidFill>
+                <a:latin typeface="Arial"/>
+              </a:rPr>
+              <a:t>jul</a:t>
+            </a:r>
+            <a:r>
+              <a:rPr sz="1800" b="0" i="0" dirty="0">
+                <a:solidFill>
+                  <a:srgbClr val="5B6573"/>
+                </a:solidFill>
+                <a:latin typeface="Arial"/>
+              </a:rPr>
+              <a:t>/2023.</a:t>
+            </a:r>
+            <a:endParaRPr lang="pt-BR" sz="1800" b="0" i="0" dirty="0">
+              <a:solidFill>
+                <a:srgbClr val="5B6573"/>
+              </a:solidFill>
+              <a:latin typeface="Arial"/>
+            </a:endParaRPr>
+          </a:p>
+          <a:p>
+            <a:pPr>
+              <a:lnSpc>
+                <a:spcPct val="108000"/>
+              </a:lnSpc>
+              <a:spcAft>
+                <a:spcPts val="600"/>
+              </a:spcAft>
+            </a:pPr>
+            <a:r>
+              <a:rPr lang="pt-BR" dirty="0">
+                <a:solidFill>
+                  <a:srgbClr val="5B6573"/>
+                </a:solidFill>
+                <a:latin typeface="Arial"/>
+              </a:rPr>
+              <a:t>*Métricas referentes ao conjunto de teste</a:t>
+            </a:r>
+            <a:endParaRPr sz="1800" b="0" i="0" dirty="0">
+              <a:solidFill>
+                <a:srgbClr val="5B6573"/>
+              </a:solidFill>
+              <a:latin typeface="Arial"/>
+            </a:endParaRPr>
           </a:p>
         </p:txBody>
       </p:sp>
@@ -5699,7 +6267,7 @@
         </p:nvSpPr>
         <p:spPr>
           <a:xfrm>
-            <a:off x="10944000" y="26784000"/>
+            <a:off x="10944000" y="26352000"/>
             <a:ext cx="3456000" cy="504000"/>
           </a:xfrm>
           <a:prstGeom prst="roundRect">
@@ -5754,8 +6322,8 @@
         </p:nvSpPr>
         <p:spPr>
           <a:xfrm>
-            <a:off x="10944000" y="27468000"/>
-            <a:ext cx="9360000" cy="2376000"/>
+            <a:off x="10944000" y="27036000"/>
+            <a:ext cx="9360000" cy="2232000"/>
           </a:xfrm>
           <a:prstGeom prst="rect">
             <a:avLst/>
@@ -5770,7 +6338,7 @@
           <a:p>
             <a:pPr marL="252000" indent="-252000" algn="l">
               <a:lnSpc>
-                <a:spcPct val="108000"/>
+                <a:spcPct val="100000"/>
               </a:lnSpc>
               <a:spcAft>
                 <a:spcPts val="500"/>
@@ -5782,116 +6350,39 @@
               <a:buChar char="■"/>
             </a:pPr>
             <a:r>
-              <a:rPr sz="2000" b="1" i="0">
-                <a:solidFill>
-                  <a:srgbClr val="1F2633"/>
-                </a:solidFill>
-                <a:latin typeface="Arial"/>
-              </a:rPr>
-              <a:t>NSE ≥ 0,979</a:t>
-            </a:r>
-            <a:r>
-              <a:rPr sz="2000" b="0" i="0">
-                <a:solidFill>
-                  <a:srgbClr val="1F2633"/>
-                </a:solidFill>
-                <a:latin typeface="Arial"/>
-              </a:rPr>
-              <a:t> e </a:t>
-            </a:r>
-            <a:r>
-              <a:rPr sz="2000" b="1" i="0">
-                <a:solidFill>
-                  <a:srgbClr val="1F2633"/>
-                </a:solidFill>
-                <a:latin typeface="Arial"/>
-              </a:rPr>
-              <a:t>PME 0,88–0,97</a:t>
-            </a:r>
-            <a:r>
-              <a:rPr sz="2000" b="0" i="0">
-                <a:solidFill>
-                  <a:srgbClr val="1F2633"/>
-                </a:solidFill>
-                <a:latin typeface="Arial"/>
-              </a:rPr>
-              <a:t> no teste; erro médio 65–81% menor que a persistência.</a:t>
-            </a:r>
-          </a:p>
-          <a:p>
-            <a:pPr marL="252000" indent="-252000" algn="l">
-              <a:lnSpc>
-                <a:spcPct val="108000"/>
-              </a:lnSpc>
-              <a:spcAft>
-                <a:spcPts val="500"/>
-              </a:spcAft>
-              <a:buClr>
-                <a:srgbClr val="D9661F"/>
-              </a:buClr>
-              <a:buFont typeface="Arial"/>
-              <a:buChar char="■"/>
-            </a:pPr>
-            <a:r>
-              <a:rPr sz="2000" b="0" i="0">
-                <a:solidFill>
-                  <a:srgbClr val="1F2633"/>
-                </a:solidFill>
-                <a:latin typeface="Arial"/>
-              </a:rPr>
-              <a:t>Ao vivo, o 2h acompanhou a cheia de set/2026 (13,3 m) com </a:t>
-            </a:r>
-            <a:r>
-              <a:rPr sz="2000" b="1" i="0">
-                <a:solidFill>
-                  <a:srgbClr val="D9661F"/>
-                </a:solidFill>
-                <a:latin typeface="Arial"/>
-              </a:rPr>
-              <a:t>EAM de 9 cm</a:t>
-            </a:r>
-            <a:r>
-              <a:rPr sz="2000" b="0" i="0">
-                <a:solidFill>
-                  <a:srgbClr val="1F2633"/>
-                </a:solidFill>
-                <a:latin typeface="Arial"/>
-              </a:rPr>
-              <a:t>.</a:t>
-            </a:r>
-          </a:p>
-          <a:p>
-            <a:pPr marL="252000" indent="-252000" algn="l">
-              <a:lnSpc>
-                <a:spcPct val="108000"/>
-              </a:lnSpc>
-              <a:spcAft>
-                <a:spcPts val="500"/>
-              </a:spcAft>
-              <a:buClr>
-                <a:srgbClr val="D9661F"/>
-              </a:buClr>
-              <a:buFont typeface="Arial"/>
-              <a:buChar char="■"/>
-            </a:pPr>
-            <a:r>
-              <a:rPr sz="2000" b="1" i="0">
-                <a:solidFill>
-                  <a:srgbClr val="1F2633"/>
-                </a:solidFill>
-                <a:latin typeface="Arial"/>
-              </a:rPr>
-              <a:t>Limitação: </a:t>
-            </a:r>
-            <a:r>
-              <a:rPr sz="2000" b="0" i="0">
-                <a:solidFill>
-                  <a:srgbClr val="1F2633"/>
-                </a:solidFill>
-                <a:latin typeface="Arial"/>
-              </a:rPr>
-              <a:t>as cheias acima de 20 m (2023–2024) ficaram só no treino; o 4h e o 8h seguem em verificação ao vivo.</a:t>
-            </a:r>
+              <a:rPr lang="pt-BR" sz="2000" dirty="0"/>
+              <a:t>Os resultados indicam que as </a:t>
+            </a:r>
+            <a:r>
+              <a:rPr lang="pt-BR" sz="2000" dirty="0" err="1"/>
+              <a:t>RNAs</a:t>
+            </a:r>
+            <a:r>
+              <a:rPr lang="pt-BR" sz="2000" dirty="0"/>
+              <a:t> têm potencial de uso operacional na previsão de curto prazo do nível do rio Taquari, em Santa Tereza. No conjunto de teste, os coeficientes de eficiência mostram que os modelos explicam a variabilidade do nível futuro tanto em relação à média (NSE de 0,996, 0,993 e 0,979 para 2, 4 e 8 h) quanto em relação à persistência do nível atual (PME de 0,969, 0,878 e 0,927). </a:t>
+            </a:r>
+            <a:r>
+              <a:rPr lang="pt-BR" sz="2000" b="1" dirty="0"/>
+              <a:t>Na operação em tempo real</a:t>
+            </a:r>
+            <a:r>
+              <a:rPr lang="pt-BR" sz="2000" dirty="0"/>
+              <a:t> durante a cheia de setembro de 2026 (pico de 13,3 m), o modelo de 2 h </a:t>
+            </a:r>
+            <a:r>
+              <a:rPr lang="pt-BR" sz="2000" b="1" dirty="0"/>
+              <a:t>obteve</a:t>
+            </a:r>
+            <a:r>
+              <a:rPr lang="pt-BR" sz="2000" dirty="0"/>
+              <a:t> erro médio de 9,2 cm e o modelo de 4h, erro de 16,2 cm</a:t>
+            </a:r>
+            <a:endParaRPr sz="2000" b="0" i="0" dirty="0">
+              <a:solidFill>
+                <a:srgbClr val="1F2633"/>
+              </a:solidFill>
+              <a:latin typeface="Arial"/>
+            </a:endParaRPr>
           </a:p>
         </p:txBody>
       </p:sp>
@@ -5959,7 +6450,7 @@
           <p:nvPr/>
         </p:nvPicPr>
         <p:blipFill>
-          <a:blip r:embed="rId11"/>
+          <a:blip r:embed="rId10"/>
           <a:stretch>
             <a:fillRect/>
           </a:stretch>
@@ -6005,13 +6496,76 @@
               </a:spcAft>
             </a:pPr>
             <a:r>
-              <a:rPr sz="1800" b="0" i="0">
+              <a:rPr sz="1800" b="0" i="0" dirty="0" err="1">
                 <a:solidFill>
                   <a:srgbClr val="5B6573"/>
                 </a:solidFill>
                 <a:latin typeface="Arial"/>
               </a:rPr>
-              <a:t>Figura 3 – Previsão ao vivo 2h × telemetria (25/09 a 05/10/2026).</a:t>
+              <a:t>Figura</a:t>
+            </a:r>
+            <a:r>
+              <a:rPr sz="1800" b="0" i="0" dirty="0">
+                <a:solidFill>
+                  <a:srgbClr val="5B6573"/>
+                </a:solidFill>
+                <a:latin typeface="Arial"/>
+              </a:rPr>
+              <a:t> 3 – </a:t>
+            </a:r>
+            <a:r>
+              <a:rPr sz="1800" b="0" i="0" dirty="0" err="1">
+                <a:solidFill>
+                  <a:srgbClr val="5B6573"/>
+                </a:solidFill>
+                <a:latin typeface="Arial"/>
+              </a:rPr>
+              <a:t>Previsão</a:t>
+            </a:r>
+            <a:r>
+              <a:rPr sz="1800" b="0" i="0" dirty="0">
+                <a:solidFill>
+                  <a:srgbClr val="5B6573"/>
+                </a:solidFill>
+                <a:latin typeface="Arial"/>
+              </a:rPr>
+              <a:t> </a:t>
+            </a:r>
+            <a:r>
+              <a:rPr sz="1800" b="0" i="0" dirty="0" err="1">
+                <a:solidFill>
+                  <a:srgbClr val="5B6573"/>
+                </a:solidFill>
+                <a:latin typeface="Arial"/>
+              </a:rPr>
+              <a:t>ao</a:t>
+            </a:r>
+            <a:r>
+              <a:rPr sz="1800" b="0" i="0" dirty="0">
+                <a:solidFill>
+                  <a:srgbClr val="5B6573"/>
+                </a:solidFill>
+                <a:latin typeface="Arial"/>
+              </a:rPr>
+              <a:t> vivo 2h × </a:t>
+            </a:r>
+            <a:r>
+              <a:rPr sz="1800" b="0" i="0" dirty="0" err="1">
+                <a:solidFill>
+                  <a:srgbClr val="5B6573"/>
+                </a:solidFill>
+                <a:latin typeface="Arial"/>
+              </a:rPr>
+              <a:t>telemetria</a:t>
+            </a:r>
+            <a:r>
+              <a:rPr sz="1800" b="0" i="0" dirty="0">
+                <a:solidFill>
+                  <a:srgbClr val="5B6573"/>
+                </a:solidFill>
+                <a:latin typeface="Arial"/>
+              </a:rPr>
+              <a:t> (25/09 a 05/10/2026).</a:t>
             </a:r>
           </a:p>
         </p:txBody>
@@ -6024,8 +6578,8 @@
         </p:nvSpPr>
         <p:spPr>
           <a:xfrm>
-            <a:off x="10944000" y="25596000"/>
-            <a:ext cx="9360000" cy="936000"/>
+            <a:off x="10922613" y="25671110"/>
+            <a:ext cx="9360000" cy="307713"/>
           </a:xfrm>
           <a:prstGeom prst="rect">
             <a:avLst/>
@@ -6047,50 +6601,110 @@
               </a:spcAft>
             </a:pPr>
             <a:r>
-              <a:rPr sz="2000" b="0" i="0">
-                <a:solidFill>
-                  <a:srgbClr val="1F2633"/>
-                </a:solidFill>
-                <a:latin typeface="Arial"/>
-              </a:rPr>
-              <a:t>Robô horário com telemetria SGB/ANA, em paralelo ao alerta oficial: </a:t>
-            </a:r>
-            <a:r>
-              <a:rPr sz="2000" b="1" i="0">
-                <a:solidFill>
-                  <a:srgbClr val="1F2633"/>
-                </a:solidFill>
-                <a:latin typeface="Arial"/>
-              </a:rPr>
-              <a:t>230 previsões auditadas</a:t>
-            </a:r>
-            <a:r>
-              <a:rPr sz="2000" b="0" i="0">
-                <a:solidFill>
-                  <a:srgbClr val="1F2633"/>
-                </a:solidFill>
-                <a:latin typeface="Arial"/>
-              </a:rPr>
-              <a:t>, </a:t>
-            </a:r>
-            <a:r>
-              <a:rPr sz="2000" b="1" i="0">
+              <a:rPr sz="2000" b="0" i="0" dirty="0" err="1">
+                <a:solidFill>
+                  <a:srgbClr val="1F2633"/>
+                </a:solidFill>
+                <a:latin typeface="Arial"/>
+              </a:rPr>
+              <a:t>Robô</a:t>
+            </a:r>
+            <a:r>
+              <a:rPr sz="2000" b="0" i="0" dirty="0">
+                <a:solidFill>
+                  <a:srgbClr val="1F2633"/>
+                </a:solidFill>
+                <a:latin typeface="Arial"/>
+              </a:rPr>
+              <a:t> </a:t>
+            </a:r>
+            <a:r>
+              <a:rPr sz="2000" b="0" i="0" dirty="0" err="1">
+                <a:solidFill>
+                  <a:srgbClr val="1F2633"/>
+                </a:solidFill>
+                <a:latin typeface="Arial"/>
+              </a:rPr>
+              <a:t>horário</a:t>
+            </a:r>
+            <a:r>
+              <a:rPr sz="2000" b="0" i="0" dirty="0">
+                <a:solidFill>
+                  <a:srgbClr val="1F2633"/>
+                </a:solidFill>
+                <a:latin typeface="Arial"/>
+              </a:rPr>
+              <a:t> com </a:t>
+            </a:r>
+            <a:r>
+              <a:rPr sz="2000" b="0" i="0" dirty="0" err="1">
+                <a:solidFill>
+                  <a:srgbClr val="1F2633"/>
+                </a:solidFill>
+                <a:latin typeface="Arial"/>
+              </a:rPr>
+              <a:t>telemetria</a:t>
+            </a:r>
+            <a:r>
+              <a:rPr sz="2000" b="0" i="0" dirty="0">
+                <a:solidFill>
+                  <a:srgbClr val="1F2633"/>
+                </a:solidFill>
+                <a:latin typeface="Arial"/>
+              </a:rPr>
+              <a:t> </a:t>
+            </a:r>
+            <a:r>
+              <a:rPr lang="pt-BR" sz="2000" b="0" i="0" dirty="0">
+                <a:solidFill>
+                  <a:srgbClr val="1F2633"/>
+                </a:solidFill>
+                <a:latin typeface="Arial"/>
+              </a:rPr>
+              <a:t/>
+            </a:r>
+            <a:r>
+              <a:rPr sz="2000" b="0" i="0" dirty="0">
+                <a:solidFill>
+                  <a:srgbClr val="1F2633"/>
+                </a:solidFill>
+                <a:latin typeface="Arial"/>
+              </a:rPr>
+              <a:t>ANA,</a:t>
+            </a:r>
+            <a:r>
+              <a:rPr lang="pt-BR" sz="2000" b="0" i="0" dirty="0">
+                <a:solidFill>
+                  <a:srgbClr val="1F2633"/>
+                </a:solidFill>
+                <a:latin typeface="Arial"/>
+              </a:rPr>
+              <a:t> </a:t>
+            </a:r>
+            <a:r>
+              <a:rPr sz="2000" b="1" i="0" dirty="0">
                 <a:solidFill>
                   <a:srgbClr val="D9661F"/>
                 </a:solidFill>
                 <a:latin typeface="Arial"/>
               </a:rPr>
-              <a:t>EAM 9,2 cm</a:t>
-            </a:r>
-            <a:r>
-              <a:rPr sz="2000" b="0" i="0">
-                <a:solidFill>
-                  <a:srgbClr val="1F2633"/>
-                </a:solidFill>
-                <a:latin typeface="Arial"/>
-              </a:rPr>
-              <a:t> (persistência 27,2 cm).</a:t>
-            </a:r>
+              <a:t>EAM 9,2 c</a:t>
+            </a:r>
+            <a:r>
+              <a:rPr lang="pt-BR" sz="2000" b="1" i="0" dirty="0">
+                <a:solidFill>
+                  <a:srgbClr val="D9661F"/>
+                </a:solidFill>
+                <a:latin typeface="Arial"/>
+              </a:rPr>
+              <a:t>m.</a:t>
+            </a:r>
+            <a:endParaRPr sz="2000" b="0" i="0" dirty="0">
+              <a:solidFill>
+                <a:srgbClr val="1F2633"/>
+              </a:solidFill>
+              <a:latin typeface="Arial"/>
+            </a:endParaRPr>
           </a:p>
         </p:txBody>
       </p:sp>
@@ -6102,8 +6716,8 @@
         </p:nvSpPr>
         <p:spPr>
           <a:xfrm>
-            <a:off x="3456000" y="32364000"/>
-            <a:ext cx="16848000" cy="576000"/>
+            <a:off x="6878463" y="35204295"/>
+            <a:ext cx="6835074" cy="630942"/>
           </a:xfrm>
           <a:prstGeom prst="rect">
             <a:avLst/>
@@ -6116,7 +6730,7 @@
           </a:bodyPr>
           <a:lstStyle/>
           <a:p>
-            <a:pPr algn="l">
+            <a:pPr algn="ctr">
               <a:lnSpc>
                 <a:spcPct val="100000"/>
               </a:lnSpc>
@@ -6125,40 +6739,74 @@
               </a:spcAft>
             </a:pPr>
             <a:r>
-              <a:rPr sz="1400" b="1" i="0">
+              <a:rPr b="1" i="0" dirty="0" err="1">
                 <a:solidFill>
                   <a:srgbClr val="5B6573"/>
                 </a:solidFill>
                 <a:latin typeface="Arial"/>
               </a:rPr>
-              <a:t>Referências: </a:t>
-            </a:r>
-            <a:r>
-              <a:rPr sz="1400" b="0" i="0">
+              <a:t>Agradecimentos</a:t>
+            </a:r>
+            <a:r>
+              <a:rPr b="1" i="0" dirty="0">
                 <a:solidFill>
                   <a:srgbClr val="5B6573"/>
                 </a:solidFill>
                 <a:latin typeface="Arial"/>
               </a:rPr>
-              <a:t>ALVISI, S. et al. (2006). Hydrol. Earth Syst. Sci., 10(1), 1-17 · RUMELHART, D. E. et al. (1986). Nature, 323, 533-536 · KUMAR, V. et al. (2023). Sustainability, 15(13), 10543.  </a:t>
-            </a:r>
-            <a:r>
-              <a:rPr sz="1400" b="1" i="0">
+              <a:t>: </a:t>
+            </a:r>
+            <a:r>
+              <a:rPr b="0" i="0" dirty="0">
                 <a:solidFill>
                   <a:srgbClr val="5B6573"/>
                 </a:solidFill>
                 <a:latin typeface="Arial"/>
               </a:rPr>
-              <a:t>Agradecimentos: </a:t>
-            </a:r>
-            <a:r>
-              <a:rPr sz="1400" b="0" i="0">
+              <a:t>FAPERGS (</a:t>
+            </a:r>
+            <a:r>
+              <a:rPr b="0" i="0" dirty="0" err="1">
                 <a:solidFill>
                   <a:srgbClr val="5B6573"/>
                 </a:solidFill>
                 <a:latin typeface="Arial"/>
               </a:rPr>
-              <a:t>FAPERGS (processos 24/2551-0002124-8 e 25/2551-0002522-2).</a:t>
+              <a:t>processos</a:t>
+            </a:r>
+            <a:r>
+              <a:rPr b="0" i="0" dirty="0">
+                <a:solidFill>
+                  <a:srgbClr val="5B6573"/>
+                </a:solidFill>
+                <a:latin typeface="Arial"/>
+              </a:rPr>
+              <a:t> 24/2551-0002124-8 e</a:t>
+            </a:r>
+            <a:endParaRPr lang="pt-BR" b="0" i="0" dirty="0">
+              <a:solidFill>
+                <a:srgbClr val="5B6573"/>
+              </a:solidFill>
+              <a:latin typeface="Arial"/>
+            </a:endParaRPr>
+          </a:p>
+          <a:p>
+            <a:pPr algn="ctr">
+              <a:lnSpc>
+                <a:spcPct val="100000"/>
+              </a:lnSpc>
+              <a:spcAft>
+                <a:spcPts val="600"/>
+              </a:spcAft>
+            </a:pPr>
+            <a:r>
+              <a:rPr b="0" i="0" dirty="0">
+                <a:solidFill>
+                  <a:srgbClr val="5B6573"/>
+                </a:solidFill>
+                <a:latin typeface="Arial"/>
+              </a:rPr>
+              <a:t> 25/2551-0002522-2).</a:t>
             </a:r>
           </a:p>
         </p:txBody>
@@ -6177,8 +6825,8 @@
         </p:nvSpPr>
         <p:spPr>
           <a:xfrm>
-            <a:off x="14688000" y="30566111"/>
-            <a:ext cx="3384000" cy="720000"/>
+            <a:off x="14112000" y="30780000"/>
+            <a:ext cx="3744000" cy="864000"/>
           </a:xfrm>
           <a:prstGeom prst="rect">
             <a:avLst/>
@@ -6200,53 +6848,62 @@
               </a:spcAft>
             </a:pPr>
             <a:r>
-              <a:rPr sz="2600" b="1" i="0">
+              <a:rPr sz="2600" b="1" i="0" dirty="0" err="1">
                 <a:solidFill>
                   <a:srgbClr val="2A378D"/>
                 </a:solidFill>
                 <a:latin typeface="Arial"/>
               </a:rPr>
-              <a:t>Acompanhe a previsão ao vivo →</a:t>
-            </a:r>
-          </a:p>
-        </p:txBody>
-      </p:sp>
-      <p:pic>
-        <p:nvPicPr>
-          <p:cNvPr id="51" name="Imagem 50">
-            <a:extLst>
-              <a:ext uri="{FF2B5EF4-FFF2-40B4-BE49-F238E27FC236}">
-                <a16:creationId xmlns:a16="http://schemas.microsoft.com/office/drawing/2014/main" id="{AE79BE45-29B1-972B-6490-F38819B75D0A}"/>
-              </a:ext>
-            </a:extLst>
-          </p:cNvPr>
-          <p:cNvPicPr>
-            <a:picLocks noChangeAspect="1"/>
-          </p:cNvPicPr>
-          <p:nvPr/>
-        </p:nvPicPr>
-        <p:blipFill>
-          <a:blip r:embed="rId12">
-            <a:extLst>
-              <a:ext uri="{28A0092B-C50C-407E-A947-70E740481C1C}">
-                <a14:useLocalDpi xmlns:a14="http://schemas.microsoft.com/office/drawing/2010/main" val="0"/>
-              </a:ext>
-            </a:extLst>
-          </a:blip>
-          <a:stretch>
-            <a:fillRect/>
-          </a:stretch>
-        </p:blipFill>
-        <p:spPr>
-          <a:xfrm>
-            <a:off x="18288000" y="29918111"/>
-            <a:ext cx="2016000" cy="2016000"/>
-          </a:xfrm>
-          <a:prstGeom prst="rect">
-            <a:avLst/>
-          </a:prstGeom>
-        </p:spPr>
-      </p:pic>
+              <a:t>Acompanhe</a:t>
+            </a:r>
+            <a:r>
+              <a:rPr sz="2600" b="1" i="0" dirty="0">
+                <a:solidFill>
+                  <a:srgbClr val="2A378D"/>
+                </a:solidFill>
+                <a:latin typeface="Arial"/>
+              </a:rPr>
+              <a:t> a </a:t>
+            </a:r>
+            <a:r>
+              <a:rPr sz="2600" b="1" i="0" dirty="0" err="1">
+                <a:solidFill>
+                  <a:srgbClr val="2A378D"/>
+                </a:solidFill>
+                <a:latin typeface="Arial"/>
+              </a:rPr>
+              <a:t>previsão</a:t>
+            </a:r>
+            <a:r>
+              <a:rPr sz="2600" b="1" i="0" dirty="0">
+                <a:solidFill>
+                  <a:srgbClr val="2A378D"/>
+                </a:solidFill>
+                <a:latin typeface="Arial"/>
+              </a:rPr>
+              <a:t> </a:t>
+            </a:r>
+            <a:r>
+              <a:rPr sz="2600" b="1" i="0" dirty="0" err="1">
+                <a:solidFill>
+                  <a:srgbClr val="2A378D"/>
+                </a:solidFill>
+                <a:latin typeface="Arial"/>
+              </a:rPr>
+              <a:t>ao</a:t>
+            </a:r>
+            <a:r>
+              <a:rPr sz="2600" b="1" i="0" dirty="0">
+                <a:solidFill>
+                  <a:srgbClr val="2A378D"/>
+                </a:solidFill>
+                <a:latin typeface="Arial"/>
+              </a:rPr>
+              <a:t> vivo →</a:t>
+            </a:r>
+          </a:p>
+        </p:txBody>
+      </p:sp>
       <p:pic>
         <p:nvPicPr>
           <p:cNvPr id="52" name="Logo UFRGS" descr="ufrgs.png"/>
@@ -6256,15 +6913,15 @@
           <p:nvPr/>
         </p:nvPicPr>
         <p:blipFill>
-          <a:blip r:embed="rId13"/>
+          <a:blip r:embed="rId11"/>
           <a:stretch>
             <a:fillRect/>
           </a:stretch>
         </p:blipFill>
         <p:spPr>
           <a:xfrm>
-            <a:off x="1080000" y="32328000"/>
-            <a:ext cx="785937" cy="612000"/>
+            <a:off x="7282871" y="33880698"/>
+            <a:ext cx="1487867" cy="1158585"/>
           </a:xfrm>
           <a:prstGeom prst="rect">
             <a:avLst/>
@@ -6280,15 +6937,15 @@
           <p:nvPr/>
         </p:nvPicPr>
         <p:blipFill>
-          <a:blip r:embed="rId14"/>
+          <a:blip r:embed="rId12"/>
           <a:stretch>
             <a:fillRect/>
           </a:stretch>
         </p:blipFill>
         <p:spPr>
           <a:xfrm>
-            <a:off x="1980000" y="32328000"/>
-            <a:ext cx="1174545" cy="612000"/>
+            <a:off x="12145127" y="34069427"/>
+            <a:ext cx="1676400" cy="969856"/>
           </a:xfrm>
           <a:prstGeom prst="rect">
             <a:avLst/>
@@ -6304,7 +6961,7 @@
           <p:nvPr/>
         </p:nvPicPr>
         <p:blipFill>
-          <a:blip r:embed="rId15"/>
+          <a:blip r:embed="rId13"/>
           <a:stretch>
             <a:fillRect/>
           </a:stretch>
@@ -6312,7 +6969,79 @@
         <p:spPr>
           <a:xfrm>
             <a:off x="1080000" y="20700000"/>
-            <a:ext cx="9360000" cy="10802111"/>
+            <a:ext cx="9360000" cy="11800509"/>
+          </a:xfrm>
+          <a:prstGeom prst="rect">
+            <a:avLst/>
+          </a:prstGeom>
+        </p:spPr>
+      </p:pic>
+      <p:pic>
+        <p:nvPicPr>
+          <p:cNvPr id="37" name="Imagem 36">
+            <a:extLst>
+              <a:ext uri="{FF2B5EF4-FFF2-40B4-BE49-F238E27FC236}">
+                <a16:creationId xmlns:a16="http://schemas.microsoft.com/office/drawing/2014/main" id="{4028472C-B290-6389-ECEF-C554BAE9486D}"/>
+              </a:ext>
+            </a:extLst>
+          </p:cNvPr>
+          <p:cNvPicPr>
+            <a:picLocks noChangeAspect="1"/>
+          </p:cNvPicPr>
+          <p:nvPr/>
+        </p:nvPicPr>
+        <p:blipFill>
+          <a:blip r:embed="rId14" cstate="print">
+            <a:extLst>
+              <a:ext uri="{28A0092B-C50C-407E-A947-70E740481C1C}">
+                <a14:useLocalDpi xmlns:a14="http://schemas.microsoft.com/office/drawing/2010/main" val="0"/>
+              </a:ext>
+            </a:extLst>
+          </a:blip>
+          <a:stretch>
+            <a:fillRect/>
+          </a:stretch>
+        </p:blipFill>
+        <p:spPr>
+          <a:xfrm>
+            <a:off x="9630527" y="33555014"/>
+            <a:ext cx="2052944" cy="2052944"/>
+          </a:xfrm>
+          <a:prstGeom prst="rect">
+            <a:avLst/>
+          </a:prstGeom>
+        </p:spPr>
+      </p:pic>
+      <p:pic>
+        <p:nvPicPr>
+          <p:cNvPr id="46" name="Imagem 45">
+            <a:extLst>
+              <a:ext uri="{FF2B5EF4-FFF2-40B4-BE49-F238E27FC236}">
+                <a16:creationId xmlns:a16="http://schemas.microsoft.com/office/drawing/2014/main" id="{5034EF39-D899-46BD-3D02-0F88AD5D45F1}"/>
+              </a:ext>
+            </a:extLst>
+          </p:cNvPr>
+          <p:cNvPicPr>
+            <a:picLocks noChangeAspect="1"/>
+          </p:cNvPicPr>
+          <p:nvPr/>
+        </p:nvPicPr>
+        <p:blipFill>
+          <a:blip r:embed="rId15">
+            <a:extLst>
+              <a:ext uri="{28A0092B-C50C-407E-A947-70E740481C1C}">
+                <a14:useLocalDpi xmlns:a14="http://schemas.microsoft.com/office/drawing/2010/main" val="0"/>
+              </a:ext>
+            </a:extLst>
+          </a:blip>
+          <a:stretch>
+            <a:fillRect/>
+          </a:stretch>
+        </p:blipFill>
+        <p:spPr>
+          <a:xfrm>
+            <a:off x="18072000" y="30096000"/>
+            <a:ext cx="2232000" cy="2232000"/>
           </a:xfrm>
           <a:prstGeom prst="rect">
             <a:avLst/>

</xml_diff>